<commit_message>
Add trace slide and related-work line; drop AV2 and slide 7 note
Co-Authored-By: Claude Sonnet 5.5 <noreply@anthropic.com>
Claude-Session: https://claude.ai/code/session_01FjZonbKdsyoySM9nwRFtHf
</commit_message>
<xml_diff>
--- a/apresentacao/apresentacao.pptx
+++ b/apresentacao/apresentacao.pptx
@@ -2005,7 +2005,7 @@
           <a:lstStyle/>
           <a:p>
             <a:r>
-              <a:t>[1:15] Contexto de futebol: a final da Copa de 2022, Argentina contra França, decidida nos pênaltis. Os dados de eventos registram cada ação, com jogador, momento e posição no campo. As três perguntas do slide são do conjunto do trabalho e nenhuma tem a resposta em um único evento: é preciso juntar vários. O modelo precisa receber os dados da partida, e há mais de uma forma de fazer isso. Perguntas de pesquisa: qual abordagem acerta mais, como o acerto muda de um modelo para outro e quanto cada uma custa em tokens e tempo. O aprendizado em contexto é usado em sentido amplo: o modelo não é treinado de novo e o que entra no contexto são os dados. Contribuições: o conjunto de perguntas com gabarito por código e a comparação sob as mesmas perguntas, o mesmo prompt e a mesma saída.</a:t>
+              <a:t>[1:15] Contexto de futebol: a final da Copa de 2022, Argentina contra França, decidida nos pênaltis. Os dados de eventos registram cada ação, com jogador, momento e posição no campo. As três perguntas do slide são do conjunto do trabalho e nenhuma tem a resposta em um único evento: é preciso juntar vários. O modelo precisa receber os dados da partida, e há mais de uma forma de fazer isso. Perguntas de pesquisa: qual abordagem acerta mais, como o acerto muda de um modelo para outro e quanto cada uma custa em tokens e tempo. O aprendizado em contexto é usado em sentido amplo: o modelo não é treinado de novo e o que entra no contexto são os dados. Contribuições: o conjunto de perguntas com gabarito por código e a comparação sob as mesmas perguntas, o mesmo prompt e a mesma saída. Trabalhos relacionados: no esporte, SoccerRAG, SPORTSQL e Tzikas et al. avaliam cada um uma única forma de recuperação; fora do esporte, Li et al. e LOFT comparam formas de recuperação sem dados de futebol. Não foram encontrados trabalhos que comparem formas de recuperação em perguntas encadeadas sobre eventos de futebol, com conferência por código contra um gabarito por código.</a:t>
             </a:r>
           </a:p>
         </p:txBody>
@@ -2355,7 +2355,7 @@
           <a:lstStyle/>
           <a:p>
             <a:r>
-              <a:t>[2:00] Ordem de complexidade do que existe entre a pergunta e o modelo. Sem dados: só a pergunta, linha de base. Contexto longo: a tabela inteira de 2.585 ações no prompt. Estatísticas resumidas: a súmula, com totais por jogador e por time. Busca vetorial: as 30 linhas mais parecidas com a pergunta, como em geração aumentada por recuperação. Consulta escrita pelo modelo: o modelo recebe o esquema do grafo e escreve a consulta Cypher. Ferramentas sobre o grafo: 8 ferramentas com a consulta já escrita; o modelo só escolhe qual chamar e com quais argumentos. As duas últimas consultam o mesmo grafo e têm o mesmo limite de 12 chamadas por pergunta: muda quem escreve a consulta. Duas diferenças a declarar: a Consulta não tem a biblioteca de algoritmos de grafos nem os nós de padrões prontos, e as ferramentas foram ajustadas olhando erros, enquanto a Consulta é o primeiro contato. Todas usam o mesmo prompt de sistema e a mesma saída estruturada.</a:t>
+              <a:t>[1:30] Ordem de complexidade do que existe entre a pergunta e o modelo. Sem dados: só a pergunta, linha de base. Contexto longo: a tabela inteira de 2.585 ações no prompt. Estatísticas resumidas: a súmula, com totais por jogador e por time. Busca vetorial: as 30 linhas mais parecidas com a pergunta, como em geração aumentada por recuperação. Consulta escrita pelo modelo: o modelo recebe o esquema do grafo e escreve a consulta Cypher. Ferramentas sobre o grafo: 8 ferramentas com a consulta já escrita; o modelo só escolhe qual chamar e com quais argumentos. As duas últimas consultam o mesmo grafo e têm o mesmo limite de 12 chamadas por pergunta: muda quem escreve a consulta. Duas diferenças a declarar: a Consulta não tem a biblioteca de algoritmos de grafos nem os nós de padrões prontos, e as ferramentas foram ajustadas olhando erros, enquanto a Consulta é o primeiro contato. Todas usam o mesmo prompt de sistema e a mesma saída estruturada.</a:t>
             </a:r>
           </a:p>
         </p:txBody>
@@ -2425,7 +2425,7 @@
           <a:lstStyle/>
           <a:p>
             <a:r>
-              <a:t>[0:45] Quatro modelos, dois menores e dois maiores, agrupados pela faixa de preço por token, já que nem todo fabricante divulga o número de parâmetros. Em cada grupo há um modelo de código fechado e um de pesos abertos. Os menores rodaram sem raciocínio estendido e com temperatura zero; os maiores, com raciocínio estendido ligado. São 52 perguntas em 6 abordagens: 312 execuções por modelo, com 1 repetição por pergunta. Acerto com intervalo de Wilson de 95%. Ponto de honestidade: como é uma repetição, as diferenças são lidas como indícios.</a:t>
+              <a:t>[1:15] Registro real de uma execução em cada abordagem com agente, pergunta a01, Claude Haiku 5.5. Na Consulta escrita pelo modelo, ele chama run_cypher com a consulta Cypher que escreveu, inclusive os filtros de time, ação, sucesso e terço do campo; a ferramenta executa a consulta no grafo e devolve o resultado. Nas Ferramentas sobre o grafo, o modelo escolhe query_actions e preenche os argumentos; a consulta já está no código e a ferramenta a executa com esses filtros. As duas consultam o mesmo grafo, com o mesmo limite de 12 chamadas por pergunta; muda quem escreve a consulta. Nesta pergunta, uma chamada bastou nas duas. As 8 ferramentas: listar jogadores, contar ações, listar ações, contar posses, rede de passes, métrica da rede, ligações da rede e sequências de passes. Diferenças a declarar: a Consulta não tem a biblioteca de algoritmos de grafos nem os nós de padrões prontos, e as ferramentas foram ajustadas olhando erros, enquanto a Consulta é o primeiro contato. A consulta, os argumentos e a resposta vêm de data/benchmark/final_results.jsonl; os valores devolvidos pela ferramenta (24 e 18) estão só no trace e foram copiados da figura do artigo.</a:t>
             </a:r>
           </a:p>
         </p:txBody>
@@ -2495,7 +2495,7 @@
           <a:lstStyle/>
           <a:p>
             <a:r>
-              <a:t>[2:00] Acerto nas 47 perguntas com resposta. A barra azul é Ferramentas sobre o grafo: 83% a 89% em todos os modelos. Consulta escrita pelo modelo: 57% a 70% nos menores e 89% a 94% nos maiores. Contexto longo: 40% a 45% nos menores e 72% a 85% nos maiores. As outras três ficam baixas: Busca vetorial 9% a 17%, Estatísticas resumidas 0% a 9%, e Sem dados 0%, porque se abstém. Nos maiores, Consulta empata com Ferramentas no Sonnet e fica à frente no Kimi; os intervalos se sobrepõem.</a:t>
+              <a:t>[2:15] Acerto nas 47 perguntas com resposta. A barra azul é Ferramentas sobre o grafo: 83% a 89% em todos os modelos. Consulta escrita pelo modelo: 57% a 70% nos menores e 89% a 94% nos maiores. Contexto longo: 40% a 45% nos menores e 72% a 85% nos maiores. As outras três ficam baixas: Busca vetorial 9% a 17%, Estatísticas resumidas 0% a 9%, e Sem dados 0%, porque se abstém. Nos maiores, Consulta empata com Ferramentas no Sonnet e fica à frente no Kimi; os intervalos se sobrepõem. Setup: quatro modelos, dois menores (Haiku e Qwen, sem raciocínio estendido, temperatura zero) e dois maiores (Sonnet e Kimi, com raciocínio estendido), agrupados pela faixa de preço por token; 52 perguntas em 6 abordagens, 312 execuções por modelo, 1 repetição por pergunta; intervalo de Wilson de 95%; diferenças lidas como indícios.</a:t>
             </a:r>
           </a:p>
         </p:txBody>
@@ -5695,22 +5695,6 @@
                 <a:latin typeface="Arial"/>
               </a:rPr>
               <a:t>Pós-graduação em Inteligência Artificial Aplicada, UniSENAI</a:t>
-            </a:r>
-          </a:p>
-          <a:p>
-            <a:pPr algn="l">
-              <a:spcAft>
-                <a:spcPts val="400"/>
-              </a:spcAft>
-            </a:pPr>
-            <a:r>
-              <a:rPr sz="1600" b="0">
-                <a:solidFill>
-                  <a:srgbClr val="BBBBBB"/>
-                </a:solidFill>
-                <a:latin typeface="Arial"/>
-              </a:rPr>
-              <a:t>AV2, 2026</a:t>
             </a:r>
           </a:p>
         </p:txBody>
@@ -9494,7 +9478,7 @@
         <p:spPr>
           <a:xfrm>
             <a:off x="640080" y="2103120"/>
-            <a:ext cx="5120640" cy="2377440"/>
+            <a:ext cx="5120640" cy="2103120"/>
           </a:xfrm>
           <a:prstGeom prst="rect">
             <a:avLst/>
@@ -9509,11 +9493,11 @@
           <a:p>
             <a:pPr>
               <a:spcAft>
-                <a:spcPts val="1200"/>
+                <a:spcPts val="800"/>
               </a:spcAft>
             </a:pPr>
             <a:r>
-              <a:rPr sz="2000" b="1">
+              <a:rPr sz="1800" b="1">
                 <a:solidFill>
                   <a:srgbClr val="1F5C99"/>
                 </a:solidFill>
@@ -9522,7 +9506,7 @@
               <a:t>• </a:t>
             </a:r>
             <a:r>
-              <a:rPr sz="2000" b="0">
+              <a:rPr sz="1800" b="0">
                 <a:solidFill>
                   <a:srgbClr val="222222"/>
                 </a:solidFill>
@@ -9534,11 +9518,11 @@
           <a:p>
             <a:pPr>
               <a:spcAft>
-                <a:spcPts val="1200"/>
+                <a:spcPts val="800"/>
               </a:spcAft>
             </a:pPr>
             <a:r>
-              <a:rPr sz="2000" b="1">
+              <a:rPr sz="1800" b="1">
                 <a:solidFill>
                   <a:srgbClr val="1F5C99"/>
                 </a:solidFill>
@@ -9547,7 +9531,7 @@
               <a:t>• </a:t>
             </a:r>
             <a:r>
-              <a:rPr sz="2000" b="0">
+              <a:rPr sz="1800" b="0">
                 <a:solidFill>
                   <a:srgbClr val="222222"/>
                 </a:solidFill>
@@ -9559,11 +9543,11 @@
           <a:p>
             <a:pPr>
               <a:spcAft>
-                <a:spcPts val="1200"/>
+                <a:spcPts val="800"/>
               </a:spcAft>
             </a:pPr>
             <a:r>
-              <a:rPr sz="2000" b="1">
+              <a:rPr sz="1800" b="1">
                 <a:solidFill>
                   <a:srgbClr val="1F5C99"/>
                 </a:solidFill>
@@ -9572,7 +9556,7 @@
               <a:t>• </a:t>
             </a:r>
             <a:r>
-              <a:rPr sz="2000" b="0">
+              <a:rPr sz="1800" b="0">
                 <a:solidFill>
                   <a:srgbClr val="222222"/>
                 </a:solidFill>
@@ -9591,8 +9575,8 @@
         </p:nvSpPr>
         <p:spPr>
           <a:xfrm>
-            <a:off x="640080" y="4480560"/>
-            <a:ext cx="5120640" cy="1645920"/>
+            <a:off x="640080" y="4023360"/>
+            <a:ext cx="5120640" cy="1737360"/>
           </a:xfrm>
           <a:prstGeom prst="rect">
             <a:avLst/>
@@ -9635,8 +9619,8 @@
         </p:nvSpPr>
         <p:spPr>
           <a:xfrm>
-            <a:off x="777240" y="4526280"/>
-            <a:ext cx="4846320" cy="1554480"/>
+            <a:off x="777240" y="4050791"/>
+            <a:ext cx="4846320" cy="1691640"/>
           </a:xfrm>
           <a:prstGeom prst="rect">
             <a:avLst/>
@@ -9746,7 +9730,7 @@
         <p:spPr>
           <a:xfrm>
             <a:off x="6217920" y="2103120"/>
-            <a:ext cx="5303520" cy="1234440"/>
+            <a:ext cx="5303520" cy="1097280"/>
           </a:xfrm>
           <a:prstGeom prst="rect">
             <a:avLst/>
@@ -9789,8 +9773,8 @@
         </p:nvSpPr>
         <p:spPr>
           <a:xfrm>
-            <a:off x="6355080" y="2148839"/>
-            <a:ext cx="5029200" cy="1188720"/>
+            <a:off x="6355080" y="2130551"/>
+            <a:ext cx="5029200" cy="1051560"/>
           </a:xfrm>
           <a:prstGeom prst="rect">
             <a:avLst/>
@@ -9805,7 +9789,7 @@
           <a:p>
             <a:pPr algn="l">
               <a:spcAft>
-                <a:spcPts val="300"/>
+                <a:spcPts val="200"/>
               </a:spcAft>
             </a:pPr>
             <a:r>
@@ -9821,11 +9805,11 @@
           <a:p>
             <a:pPr algn="l">
               <a:spcAft>
-                <a:spcPts val="300"/>
+                <a:spcPts val="200"/>
               </a:spcAft>
             </a:pPr>
             <a:r>
-              <a:rPr sz="1600" b="0">
+              <a:rPr sz="1500" b="0">
                 <a:solidFill>
                   <a:srgbClr val="222222"/>
                 </a:solidFill>
@@ -9844,8 +9828,8 @@
         </p:nvSpPr>
         <p:spPr>
           <a:xfrm>
-            <a:off x="6217920" y="3474720"/>
-            <a:ext cx="5303520" cy="1234440"/>
+            <a:off x="6217920" y="3337560"/>
+            <a:ext cx="5303520" cy="1097280"/>
           </a:xfrm>
           <a:prstGeom prst="rect">
             <a:avLst/>
@@ -9888,8 +9872,8 @@
         </p:nvSpPr>
         <p:spPr>
           <a:xfrm>
-            <a:off x="6355080" y="3520439"/>
-            <a:ext cx="5029200" cy="1188720"/>
+            <a:off x="6355080" y="3364991"/>
+            <a:ext cx="5029200" cy="1051560"/>
           </a:xfrm>
           <a:prstGeom prst="rect">
             <a:avLst/>
@@ -9904,7 +9888,7 @@
           <a:p>
             <a:pPr algn="l">
               <a:spcAft>
-                <a:spcPts val="300"/>
+                <a:spcPts val="200"/>
               </a:spcAft>
             </a:pPr>
             <a:r>
@@ -9920,11 +9904,11 @@
           <a:p>
             <a:pPr algn="l">
               <a:spcAft>
-                <a:spcPts val="300"/>
+                <a:spcPts val="200"/>
               </a:spcAft>
             </a:pPr>
             <a:r>
-              <a:rPr sz="1600" b="0">
+              <a:rPr sz="1500" b="0">
                 <a:solidFill>
                   <a:srgbClr val="222222"/>
                 </a:solidFill>
@@ -9943,8 +9927,8 @@
         </p:nvSpPr>
         <p:spPr>
           <a:xfrm>
-            <a:off x="6217920" y="4846320"/>
-            <a:ext cx="5303520" cy="1234440"/>
+            <a:off x="6217920" y="4572000"/>
+            <a:ext cx="5303520" cy="1097280"/>
           </a:xfrm>
           <a:prstGeom prst="rect">
             <a:avLst/>
@@ -9987,8 +9971,8 @@
         </p:nvSpPr>
         <p:spPr>
           <a:xfrm>
-            <a:off x="6355080" y="4892040"/>
-            <a:ext cx="5029200" cy="1188720"/>
+            <a:off x="6355080" y="4599432"/>
+            <a:ext cx="5029200" cy="1051560"/>
           </a:xfrm>
           <a:prstGeom prst="rect">
             <a:avLst/>
@@ -10003,7 +9987,7 @@
           <a:p>
             <a:pPr algn="l">
               <a:spcAft>
-                <a:spcPts val="300"/>
+                <a:spcPts val="200"/>
               </a:spcAft>
             </a:pPr>
             <a:r>
@@ -10019,17 +10003,100 @@
           <a:p>
             <a:pPr algn="l">
               <a:spcAft>
-                <a:spcPts val="300"/>
+                <a:spcPts val="200"/>
               </a:spcAft>
             </a:pPr>
             <a:r>
-              <a:rPr sz="1600" b="0">
+              <a:rPr sz="1500" b="0">
                 <a:solidFill>
                   <a:srgbClr val="222222"/>
                 </a:solidFill>
                 <a:latin typeface="Arial"/>
               </a:rPr>
               <a:t>Depois que Dembélé foi substituído no primeiro tempo, qual companheiro mais passou a bola para Mbappé?</a:t>
+            </a:r>
+          </a:p>
+        </p:txBody>
+      </p:sp>
+      <p:sp>
+        <p:nvSpPr>
+          <p:cNvPr id="16" name="Rectangle 15"/>
+          <p:cNvSpPr/>
+          <p:nvPr/>
+        </p:nvSpPr>
+        <p:spPr>
+          <a:xfrm>
+            <a:off x="640080" y="5852160"/>
+            <a:ext cx="10881360" cy="502920"/>
+          </a:xfrm>
+          <a:prstGeom prst="rect">
+            <a:avLst/>
+          </a:prstGeom>
+          <a:solidFill>
+            <a:srgbClr val="F2F2F2"/>
+          </a:solidFill>
+          <a:ln>
+            <a:noFill/>
+          </a:ln>
+          <a:effectLst/>
+        </p:spPr>
+        <p:style>
+          <a:lnRef idx="1">
+            <a:schemeClr val="accent1"/>
+          </a:lnRef>
+          <a:fillRef idx="3">
+            <a:schemeClr val="accent1"/>
+          </a:fillRef>
+          <a:effectRef idx="2">
+            <a:schemeClr val="accent1"/>
+          </a:effectRef>
+          <a:fontRef idx="minor">
+            <a:schemeClr val="lt1"/>
+          </a:fontRef>
+        </p:style>
+        <p:txBody>
+          <a:bodyPr rtlCol="0" anchor="ctr"/>
+          <a:lstStyle/>
+          <a:p>
+            <a:pPr algn="ctr"/>
+          </a:p>
+        </p:txBody>
+      </p:sp>
+      <p:sp>
+        <p:nvSpPr>
+          <p:cNvPr id="17" name="TextBox 16"/>
+          <p:cNvSpPr txBox="1"/>
+          <p:nvPr/>
+        </p:nvSpPr>
+        <p:spPr>
+          <a:xfrm>
+            <a:off x="777240" y="5870448"/>
+            <a:ext cx="10607040" cy="457200"/>
+          </a:xfrm>
+          <a:prstGeom prst="rect">
+            <a:avLst/>
+          </a:prstGeom>
+          <a:noFill/>
+        </p:spPr>
+        <p:txBody>
+          <a:bodyPr wrap="square" anchor="ctr" lIns="45720" rIns="45720">
+            <a:spAutoFit/>
+          </a:bodyPr>
+          <a:lstStyle/>
+          <a:p>
+            <a:pPr algn="l">
+              <a:spcAft>
+                <a:spcPts val="600"/>
+              </a:spcAft>
+            </a:pPr>
+            <a:r>
+              <a:rPr sz="1200" b="0">
+                <a:solidFill>
+                  <a:srgbClr val="222222"/>
+                </a:solidFill>
+                <a:latin typeface="Arial"/>
+              </a:rPr>
+              <a:t>Relacionados: no esporte, cada trabalho avalia uma única forma de recuperação (SoccerRAG, SPORTSQL, Tzikas et al.); fora dele, as formas são comparadas sem dados de futebol (Li et al., LOFT).</a:t>
             </a:r>
           </a:p>
         </p:txBody>
@@ -13917,61 +13984,6 @@
           </a:graphicData>
         </a:graphic>
       </p:graphicFrame>
-      <p:sp>
-        <p:nvSpPr>
-          <p:cNvPr id="6" name="TextBox 5"/>
-          <p:cNvSpPr txBox="1"/>
-          <p:nvPr/>
-        </p:nvSpPr>
-        <p:spPr>
-          <a:xfrm>
-            <a:off x="640080" y="5440680"/>
-            <a:ext cx="10881360" cy="914400"/>
-          </a:xfrm>
-          <a:prstGeom prst="rect">
-            <a:avLst/>
-          </a:prstGeom>
-          <a:noFill/>
-        </p:spPr>
-        <p:txBody>
-          <a:bodyPr wrap="square" anchor="t" lIns="45720" rIns="45720">
-            <a:spAutoFit/>
-          </a:bodyPr>
-          <a:lstStyle/>
-          <a:p>
-            <a:pPr algn="l">
-              <a:spcAft>
-                <a:spcPts val="400"/>
-              </a:spcAft>
-            </a:pPr>
-            <a:r>
-              <a:rPr sz="1600" b="1">
-                <a:solidFill>
-                  <a:srgbClr val="222222"/>
-                </a:solidFill>
-                <a:latin typeface="Arial"/>
-              </a:rPr>
-              <a:t>As duas últimas consultam o mesmo grafo, com o mesmo limite de 12 chamadas: muda quem escreve a consulta.</a:t>
-            </a:r>
-          </a:p>
-          <a:p>
-            <a:pPr algn="l">
-              <a:spcAft>
-                <a:spcPts val="400"/>
-              </a:spcAft>
-            </a:pPr>
-            <a:r>
-              <a:rPr sz="1400" b="0">
-                <a:solidFill>
-                  <a:srgbClr val="666666"/>
-                </a:solidFill>
-                <a:latin typeface="Arial"/>
-              </a:rPr>
-              <a:t>A Consulta não tem a biblioteca de algoritmos (GDS) nem os nós de padrões prontos. As Ferramentas foram ajustadas olhando erros; a Consulta é o primeiro contato.</a:t>
-            </a:r>
-          </a:p>
-        </p:txBody>
-      </p:sp>
     </p:spTree>
   </p:cSld>
   <p:clrMapOvr>
@@ -14018,7 +14030,7 @@
                 </a:solidFill>
                 <a:latin typeface="Arial"/>
               </a:rPr>
-              <a:t>4 modelos em duas faixas, 312 execuções por modelo</a:t>
+              <a:t>Mesmo grafo, duas formas de consultar: o modelo escreve a consulta ou escolhe a ferramenta</a:t>
             </a:r>
           </a:p>
         </p:txBody>
@@ -14107,14 +14119,136 @@
       </p:sp>
       <p:sp>
         <p:nvSpPr>
-          <p:cNvPr id="5" name="Rectangle 4"/>
+          <p:cNvPr id="5" name="TextBox 4"/>
+          <p:cNvSpPr txBox="1"/>
+          <p:nvPr/>
+        </p:nvSpPr>
+        <p:spPr>
+          <a:xfrm>
+            <a:off x="640080" y="6400800"/>
+            <a:ext cx="9144000" cy="320040"/>
+          </a:xfrm>
+          <a:prstGeom prst="rect">
+            <a:avLst/>
+          </a:prstGeom>
+          <a:noFill/>
+        </p:spPr>
+        <p:txBody>
+          <a:bodyPr wrap="square" anchor="t" lIns="45720" rIns="45720">
+            <a:spAutoFit/>
+          </a:bodyPr>
+          <a:lstStyle/>
+          <a:p>
+            <a:pPr algn="l">
+              <a:spcAft>
+                <a:spcPts val="600"/>
+              </a:spcAft>
+            </a:pPr>
+            <a:r>
+              <a:rPr sz="1200" b="0">
+                <a:solidFill>
+                  <a:srgbClr val="666666"/>
+                </a:solidFill>
+                <a:latin typeface="Arial"/>
+              </a:rPr>
+              <a:t>Registro real (Claude Haiku 5.5, a01); trechos abreviados com [...]. Uma chamada bastou nas duas; limite de 12 chamadas.</a:t>
+            </a:r>
+          </a:p>
+        </p:txBody>
+      </p:sp>
+      <p:sp>
+        <p:nvSpPr>
+          <p:cNvPr id="6" name="Rectangle 5"/>
           <p:cNvSpPr/>
           <p:nvPr/>
         </p:nvSpPr>
         <p:spPr>
           <a:xfrm>
-            <a:off x="640080" y="1645920"/>
-            <a:ext cx="5303520" cy="3291840"/>
+            <a:off x="640080" y="1417320"/>
+            <a:ext cx="10881360" cy="502920"/>
+          </a:xfrm>
+          <a:prstGeom prst="rect">
+            <a:avLst/>
+          </a:prstGeom>
+          <a:solidFill>
+            <a:srgbClr val="E6EEF6"/>
+          </a:solidFill>
+          <a:ln>
+            <a:noFill/>
+          </a:ln>
+          <a:effectLst/>
+        </p:spPr>
+        <p:style>
+          <a:lnRef idx="1">
+            <a:schemeClr val="accent1"/>
+          </a:lnRef>
+          <a:fillRef idx="3">
+            <a:schemeClr val="accent1"/>
+          </a:fillRef>
+          <a:effectRef idx="2">
+            <a:schemeClr val="accent1"/>
+          </a:effectRef>
+          <a:fontRef idx="minor">
+            <a:schemeClr val="lt1"/>
+          </a:fontRef>
+        </p:style>
+        <p:txBody>
+          <a:bodyPr rtlCol="0" anchor="ctr"/>
+          <a:lstStyle/>
+          <a:p>
+            <a:pPr algn="ctr"/>
+          </a:p>
+        </p:txBody>
+      </p:sp>
+      <p:sp>
+        <p:nvSpPr>
+          <p:cNvPr id="7" name="TextBox 6"/>
+          <p:cNvSpPr txBox="1"/>
+          <p:nvPr/>
+        </p:nvSpPr>
+        <p:spPr>
+          <a:xfrm>
+            <a:off x="777240" y="1444752"/>
+            <a:ext cx="10607040" cy="457200"/>
+          </a:xfrm>
+          <a:prstGeom prst="rect">
+            <a:avLst/>
+          </a:prstGeom>
+          <a:noFill/>
+        </p:spPr>
+        <p:txBody>
+          <a:bodyPr wrap="square" anchor="ctr" lIns="45720" rIns="45720">
+            <a:spAutoFit/>
+          </a:bodyPr>
+          <a:lstStyle/>
+          <a:p>
+            <a:pPr algn="l">
+              <a:spcAft>
+                <a:spcPts val="600"/>
+              </a:spcAft>
+            </a:pPr>
+            <a:r>
+              <a:rPr sz="1600" b="1">
+                <a:solidFill>
+                  <a:srgbClr val="222222"/>
+                </a:solidFill>
+                <a:latin typeface="Arial"/>
+              </a:rPr>
+              <a:t>Pergunta a01: Quem deu mais passes certos no terço final do campo pela Argentina?</a:t>
+            </a:r>
+          </a:p>
+        </p:txBody>
+      </p:sp>
+      <p:sp>
+        <p:nvSpPr>
+          <p:cNvPr id="8" name="Rectangle 7"/>
+          <p:cNvSpPr/>
+          <p:nvPr/>
+        </p:nvSpPr>
+        <p:spPr>
+          <a:xfrm>
+            <a:off x="640080" y="2057400"/>
+            <a:ext cx="5349240" cy="4251960"/>
           </a:xfrm>
           <a:prstGeom prst="rect">
             <a:avLst/>
@@ -14151,14 +14285,14 @@
       </p:sp>
       <p:sp>
         <p:nvSpPr>
-          <p:cNvPr id="6" name="TextBox 5"/>
+          <p:cNvPr id="9" name="TextBox 8"/>
           <p:cNvSpPr txBox="1"/>
           <p:nvPr/>
         </p:nvSpPr>
         <p:spPr>
           <a:xfrm>
-            <a:off x="822960" y="1737360"/>
-            <a:ext cx="4937760" cy="3108960"/>
+            <a:off x="777240" y="2103120"/>
+            <a:ext cx="5029200" cy="365760"/>
           </a:xfrm>
           <a:prstGeom prst="rect">
             <a:avLst/>
@@ -14173,111 +14307,31 @@
           <a:p>
             <a:pPr algn="l">
               <a:spcAft>
-                <a:spcPts val="800"/>
+                <a:spcPts val="600"/>
               </a:spcAft>
             </a:pPr>
             <a:r>
-              <a:rPr sz="2000" b="1">
-                <a:solidFill>
-                  <a:srgbClr val="1F5C99"/>
-                </a:solidFill>
-                <a:latin typeface="Arial"/>
-              </a:rPr>
-              <a:t>Modelos menores</a:t>
-            </a:r>
-          </a:p>
-          <a:p>
-            <a:pPr algn="l">
-              <a:spcAft>
-                <a:spcPts val="800"/>
-              </a:spcAft>
-            </a:pPr>
-            <a:r>
-              <a:rPr sz="1800" b="0">
+              <a:rPr sz="1700" b="1">
                 <a:solidFill>
                   <a:srgbClr val="222222"/>
                 </a:solidFill>
                 <a:latin typeface="Arial"/>
               </a:rPr>
-              <a:t>Claude Haiku 5.5 e Qwen3.8-flash</a:t>
-            </a:r>
-          </a:p>
-          <a:p>
-            <a:pPr algn="l">
-              <a:spcAft>
-                <a:spcPts val="800"/>
-              </a:spcAft>
-            </a:pPr>
-            <a:r>
-              <a:rPr sz="1600" b="0">
-                <a:solidFill>
-                  <a:srgbClr val="666666"/>
-                </a:solidFill>
-                <a:latin typeface="Arial"/>
-              </a:rPr>
-              <a:t>sem raciocínio estendido, temperatura zero</a:t>
-            </a:r>
-          </a:p>
-          <a:p>
-            <a:pPr algn="l">
-              <a:spcAft>
-                <a:spcPts val="800"/>
-              </a:spcAft>
-            </a:pPr>
-            <a:r>
-              <a:rPr sz="2000" b="1">
-                <a:solidFill>
-                  <a:srgbClr val="1F5C99"/>
-                </a:solidFill>
-                <a:latin typeface="Arial"/>
-              </a:rPr>
-              <a:t>Modelos maiores</a:t>
-            </a:r>
-          </a:p>
-          <a:p>
-            <a:pPr algn="l">
-              <a:spcAft>
-                <a:spcPts val="800"/>
-              </a:spcAft>
-            </a:pPr>
-            <a:r>
-              <a:rPr sz="1800" b="0">
-                <a:solidFill>
-                  <a:srgbClr val="222222"/>
-                </a:solidFill>
-                <a:latin typeface="Arial"/>
-              </a:rPr>
-              <a:t>Claude Sonnet 4.6 e Kimi K3</a:t>
-            </a:r>
-          </a:p>
-          <a:p>
-            <a:pPr algn="l">
-              <a:spcAft>
-                <a:spcPts val="800"/>
-              </a:spcAft>
-            </a:pPr>
-            <a:r>
-              <a:rPr sz="1600" b="0">
-                <a:solidFill>
-                  <a:srgbClr val="666666"/>
-                </a:solidFill>
-                <a:latin typeface="Arial"/>
-              </a:rPr>
-              <a:t>com raciocínio estendido</a:t>
-            </a:r>
-          </a:p>
-        </p:txBody>
-      </p:sp>
-      <p:sp>
-        <p:nvSpPr>
-          <p:cNvPr id="7" name="TextBox 6"/>
+              <a:t>Consulta escrita pelo modelo</a:t>
+            </a:r>
+          </a:p>
+        </p:txBody>
+      </p:sp>
+      <p:sp>
+        <p:nvSpPr>
+          <p:cNvPr id="10" name="TextBox 9"/>
           <p:cNvSpPr txBox="1"/>
           <p:nvPr/>
         </p:nvSpPr>
         <p:spPr>
           <a:xfrm>
-            <a:off x="6400800" y="1645920"/>
-            <a:ext cx="5120640" cy="4114800"/>
+            <a:off x="777240" y="2487168"/>
+            <a:ext cx="5074920" cy="320040"/>
           </a:xfrm>
           <a:prstGeom prst="rect">
             <a:avLst/>
@@ -14285,108 +14339,779 @@
           <a:noFill/>
         </p:spPr>
         <p:txBody>
+          <a:bodyPr wrap="square" anchor="t" lIns="45720" rIns="45720">
+            <a:spAutoFit/>
+          </a:bodyPr>
+          <a:lstStyle/>
+          <a:p>
+            <a:pPr algn="l">
+              <a:spcAft>
+                <a:spcPts val="600"/>
+              </a:spcAft>
+            </a:pPr>
+            <a:r>
+              <a:rPr sz="1200" b="0">
+                <a:solidFill>
+                  <a:srgbClr val="222222"/>
+                </a:solidFill>
+                <a:latin typeface="Arial"/>
+              </a:rPr>
+              <a:t>Modelo chama run_cypher com a consulta que escreveu:</a:t>
+            </a:r>
+          </a:p>
+        </p:txBody>
+      </p:sp>
+      <p:sp>
+        <p:nvSpPr>
+          <p:cNvPr id="11" name="Rectangle 10"/>
+          <p:cNvSpPr/>
+          <p:nvPr/>
+        </p:nvSpPr>
+        <p:spPr>
+          <a:xfrm>
+            <a:off x="777240" y="2807208"/>
+            <a:ext cx="5074920" cy="1783080"/>
+          </a:xfrm>
+          <a:prstGeom prst="rect">
+            <a:avLst/>
+          </a:prstGeom>
+          <a:solidFill>
+            <a:srgbClr val="2B2B2B"/>
+          </a:solidFill>
+          <a:ln>
+            <a:noFill/>
+          </a:ln>
+          <a:effectLst/>
+        </p:spPr>
+        <p:style>
+          <a:lnRef idx="1">
+            <a:schemeClr val="accent1"/>
+          </a:lnRef>
+          <a:fillRef idx="3">
+            <a:schemeClr val="accent1"/>
+          </a:fillRef>
+          <a:effectRef idx="2">
+            <a:schemeClr val="accent1"/>
+          </a:effectRef>
+          <a:fontRef idx="minor">
+            <a:schemeClr val="lt1"/>
+          </a:fontRef>
+        </p:style>
+        <p:txBody>
+          <a:bodyPr rtlCol="0" anchor="ctr"/>
+          <a:lstStyle/>
+          <a:p>
+            <a:pPr algn="ctr"/>
+          </a:p>
+        </p:txBody>
+      </p:sp>
+      <p:sp>
+        <p:nvSpPr>
+          <p:cNvPr id="12" name="TextBox 11"/>
+          <p:cNvSpPr txBox="1"/>
+          <p:nvPr/>
+        </p:nvSpPr>
+        <p:spPr>
+          <a:xfrm>
+            <a:off x="868680" y="2852927"/>
+            <a:ext cx="4892040" cy="1691639"/>
+          </a:xfrm>
+          <a:prstGeom prst="rect">
+            <a:avLst/>
+          </a:prstGeom>
+          <a:noFill/>
+        </p:spPr>
+        <p:txBody>
           <a:bodyPr wrap="square">
             <a:spAutoFit/>
           </a:bodyPr>
           <a:lstStyle/>
           <a:p>
-            <a:pPr>
+            <a:r>
+              <a:rPr sz="1100">
+                <a:solidFill>
+                  <a:srgbClr val="E8E8E8"/>
+                </a:solidFill>
+                <a:latin typeface="Courier New"/>
+              </a:rPr>
+              <a:t>MATCH (j:Jogador)-[r:REALIZOU]-&gt;</a:t>
+            </a:r>
+          </a:p>
+          <a:p>
+            <a:r>
+              <a:rPr sz="1100">
+                <a:solidFill>
+                  <a:srgbClr val="E8E8E8"/>
+                </a:solidFill>
+                <a:latin typeface="Courier New"/>
+              </a:rPr>
+              <a:t>  (p:Partida [...])</a:t>
+            </a:r>
+          </a:p>
+          <a:p>
+            <a:r>
+              <a:rPr sz="1100">
+                <a:solidFill>
+                  <a:srgbClr val="E8E8E8"/>
+                </a:solidFill>
+                <a:latin typeface="Courier New"/>
+              </a:rPr>
+              <a:t>WHERE j.time = 'Argentina'</a:t>
+            </a:r>
+          </a:p>
+          <a:p>
+            <a:r>
+              <a:rPr sz="1100">
+                <a:solidFill>
+                  <a:srgbClr val="E8E8E8"/>
+                </a:solidFill>
+                <a:latin typeface="Courier New"/>
+              </a:rPr>
+              <a:t>  AND r.acao = 'passe'</a:t>
+            </a:r>
+          </a:p>
+          <a:p>
+            <a:r>
+              <a:rPr sz="1100">
+                <a:solidFill>
+                  <a:srgbClr val="E8E8E8"/>
+                </a:solidFill>
+                <a:latin typeface="Courier New"/>
+              </a:rPr>
+              <a:t>  AND r.sucesso = true</a:t>
+            </a:r>
+          </a:p>
+          <a:p>
+            <a:r>
+              <a:rPr sz="1100">
+                <a:solidFill>
+                  <a:srgbClr val="E8E8E8"/>
+                </a:solidFill>
+                <a:latin typeface="Courier New"/>
+              </a:rPr>
+              <a:t>  AND r.terco = 'ataque' [...]</a:t>
+            </a:r>
+          </a:p>
+          <a:p>
+            <a:r>
+              <a:rPr sz="1100">
+                <a:solidFill>
+                  <a:srgbClr val="E8E8E8"/>
+                </a:solidFill>
+                <a:latin typeface="Courier New"/>
+              </a:rPr>
+              <a:t>RETURN j.nome AS jogador,</a:t>
+            </a:r>
+          </a:p>
+          <a:p>
+            <a:r>
+              <a:rPr sz="1100">
+                <a:solidFill>
+                  <a:srgbClr val="E8E8E8"/>
+                </a:solidFill>
+                <a:latin typeface="Courier New"/>
+              </a:rPr>
+              <a:t>  count(r) AS passes_certos_terco_final</a:t>
+            </a:r>
+          </a:p>
+          <a:p>
+            <a:r>
+              <a:rPr sz="1100">
+                <a:solidFill>
+                  <a:srgbClr val="E8E8E8"/>
+                </a:solidFill>
+                <a:latin typeface="Courier New"/>
+              </a:rPr>
+              <a:t>ORDER BY passes_certos_terco_final DESC</a:t>
+            </a:r>
+          </a:p>
+          <a:p>
+            <a:r>
+              <a:rPr sz="1100">
+                <a:solidFill>
+                  <a:srgbClr val="E8E8E8"/>
+                </a:solidFill>
+                <a:latin typeface="Courier New"/>
+              </a:rPr>
+              <a:t>LIMIT 10</a:t>
+            </a:r>
+          </a:p>
+        </p:txBody>
+      </p:sp>
+      <p:sp>
+        <p:nvSpPr>
+          <p:cNvPr id="13" name="TextBox 12"/>
+          <p:cNvSpPr txBox="1"/>
+          <p:nvPr/>
+        </p:nvSpPr>
+        <p:spPr>
+          <a:xfrm>
+            <a:off x="777240" y="4636008"/>
+            <a:ext cx="5074920" cy="365760"/>
+          </a:xfrm>
+          <a:prstGeom prst="rect">
+            <a:avLst/>
+          </a:prstGeom>
+          <a:noFill/>
+        </p:spPr>
+        <p:txBody>
+          <a:bodyPr wrap="square" anchor="t" lIns="45720" rIns="45720">
+            <a:spAutoFit/>
+          </a:bodyPr>
+          <a:lstStyle/>
+          <a:p>
+            <a:pPr algn="l">
               <a:spcAft>
-                <a:spcPts val="1400"/>
+                <a:spcPts val="600"/>
               </a:spcAft>
             </a:pPr>
             <a:r>
-              <a:rPr sz="1900" b="1">
-                <a:solidFill>
-                  <a:srgbClr val="1F5C99"/>
-                </a:solidFill>
-                <a:latin typeface="Arial"/>
-              </a:rPr>
-              <a:t>• </a:t>
-            </a:r>
-            <a:r>
-              <a:rPr sz="1900" b="0">
+              <a:rPr sz="1200" b="0">
                 <a:solidFill>
                   <a:srgbClr val="222222"/>
                 </a:solidFill>
                 <a:latin typeface="Arial"/>
               </a:rPr>
-              <a:t>52 perguntas × 6 abordagens = 312 execuções por modelo</a:t>
-            </a:r>
-          </a:p>
-          <a:p>
-            <a:pPr>
+              <a:t>Ferramenta executa essa consulta no grafo e devolve:</a:t>
+            </a:r>
+          </a:p>
+        </p:txBody>
+      </p:sp>
+      <p:sp>
+        <p:nvSpPr>
+          <p:cNvPr id="14" name="Rectangle 13"/>
+          <p:cNvSpPr/>
+          <p:nvPr/>
+        </p:nvSpPr>
+        <p:spPr>
+          <a:xfrm>
+            <a:off x="777240" y="5001768"/>
+            <a:ext cx="5074920" cy="594360"/>
+          </a:xfrm>
+          <a:prstGeom prst="rect">
+            <a:avLst/>
+          </a:prstGeom>
+          <a:solidFill>
+            <a:srgbClr val="2B2B2B"/>
+          </a:solidFill>
+          <a:ln>
+            <a:noFill/>
+          </a:ln>
+          <a:effectLst/>
+        </p:spPr>
+        <p:style>
+          <a:lnRef idx="1">
+            <a:schemeClr val="accent1"/>
+          </a:lnRef>
+          <a:fillRef idx="3">
+            <a:schemeClr val="accent1"/>
+          </a:fillRef>
+          <a:effectRef idx="2">
+            <a:schemeClr val="accent1"/>
+          </a:effectRef>
+          <a:fontRef idx="minor">
+            <a:schemeClr val="lt1"/>
+          </a:fontRef>
+        </p:style>
+        <p:txBody>
+          <a:bodyPr rtlCol="0" anchor="ctr"/>
+          <a:lstStyle/>
+          <a:p>
+            <a:pPr algn="ctr"/>
+          </a:p>
+        </p:txBody>
+      </p:sp>
+      <p:sp>
+        <p:nvSpPr>
+          <p:cNvPr id="15" name="TextBox 14"/>
+          <p:cNvSpPr txBox="1"/>
+          <p:nvPr/>
+        </p:nvSpPr>
+        <p:spPr>
+          <a:xfrm>
+            <a:off x="868680" y="5047488"/>
+            <a:ext cx="4892040" cy="502920"/>
+          </a:xfrm>
+          <a:prstGeom prst="rect">
+            <a:avLst/>
+          </a:prstGeom>
+          <a:noFill/>
+        </p:spPr>
+        <p:txBody>
+          <a:bodyPr wrap="square">
+            <a:spAutoFit/>
+          </a:bodyPr>
+          <a:lstStyle/>
+          <a:p>
+            <a:r>
+              <a:rPr sz="1100">
+                <a:solidFill>
+                  <a:srgbClr val="E8E8E8"/>
+                </a:solidFill>
+                <a:latin typeface="Courier New"/>
+              </a:rPr>
+              <a:t>Lionel Andrés Messi Cuccittini: 24</a:t>
+            </a:r>
+          </a:p>
+          <a:p>
+            <a:r>
+              <a:rPr sz="1100">
+                <a:solidFill>
+                  <a:srgbClr val="E8E8E8"/>
+                </a:solidFill>
+                <a:latin typeface="Courier New"/>
+              </a:rPr>
+              <a:t>Alexis Mac Allister: 18 [...]</a:t>
+            </a:r>
+          </a:p>
+        </p:txBody>
+      </p:sp>
+      <p:sp>
+        <p:nvSpPr>
+          <p:cNvPr id="16" name="TextBox 15"/>
+          <p:cNvSpPr txBox="1"/>
+          <p:nvPr/>
+        </p:nvSpPr>
+        <p:spPr>
+          <a:xfrm>
+            <a:off x="777240" y="5715000"/>
+            <a:ext cx="5074920" cy="502920"/>
+          </a:xfrm>
+          <a:prstGeom prst="rect">
+            <a:avLst/>
+          </a:prstGeom>
+          <a:noFill/>
+        </p:spPr>
+        <p:txBody>
+          <a:bodyPr wrap="square" anchor="ctr" lIns="45720" rIns="45720">
+            <a:spAutoFit/>
+          </a:bodyPr>
+          <a:lstStyle/>
+          <a:p>
+            <a:pPr algn="l">
               <a:spcAft>
-                <a:spcPts val="1400"/>
+                <a:spcPts val="600"/>
               </a:spcAft>
             </a:pPr>
             <a:r>
-              <a:rPr sz="1900" b="1">
-                <a:solidFill>
-                  <a:srgbClr val="1F5C99"/>
-                </a:solidFill>
-                <a:latin typeface="Arial"/>
-              </a:rPr>
-              <a:t>• </a:t>
-            </a:r>
-            <a:r>
-              <a:rPr sz="1900" b="0">
+              <a:rPr sz="1300" b="1">
                 <a:solidFill>
                   <a:srgbClr val="222222"/>
                 </a:solidFill>
                 <a:latin typeface="Arial"/>
               </a:rPr>
-              <a:t>1 repetição por pergunta</a:t>
-            </a:r>
-          </a:p>
-          <a:p>
-            <a:pPr>
+              <a:t>Modelo responde: Lionel Andrés Messi Cuccittini</a:t>
+            </a:r>
+          </a:p>
+        </p:txBody>
+      </p:sp>
+      <p:sp>
+        <p:nvSpPr>
+          <p:cNvPr id="17" name="Rectangle 16"/>
+          <p:cNvSpPr/>
+          <p:nvPr/>
+        </p:nvSpPr>
+        <p:spPr>
+          <a:xfrm>
+            <a:off x="6172200" y="2057400"/>
+            <a:ext cx="5349240" cy="4251960"/>
+          </a:xfrm>
+          <a:prstGeom prst="rect">
+            <a:avLst/>
+          </a:prstGeom>
+          <a:solidFill>
+            <a:srgbClr val="E6EEF6"/>
+          </a:solidFill>
+          <a:ln>
+            <a:noFill/>
+          </a:ln>
+          <a:effectLst/>
+        </p:spPr>
+        <p:style>
+          <a:lnRef idx="1">
+            <a:schemeClr val="accent1"/>
+          </a:lnRef>
+          <a:fillRef idx="3">
+            <a:schemeClr val="accent1"/>
+          </a:fillRef>
+          <a:effectRef idx="2">
+            <a:schemeClr val="accent1"/>
+          </a:effectRef>
+          <a:fontRef idx="minor">
+            <a:schemeClr val="lt1"/>
+          </a:fontRef>
+        </p:style>
+        <p:txBody>
+          <a:bodyPr rtlCol="0" anchor="ctr"/>
+          <a:lstStyle/>
+          <a:p>
+            <a:pPr algn="ctr"/>
+          </a:p>
+        </p:txBody>
+      </p:sp>
+      <p:sp>
+        <p:nvSpPr>
+          <p:cNvPr id="18" name="TextBox 17"/>
+          <p:cNvSpPr txBox="1"/>
+          <p:nvPr/>
+        </p:nvSpPr>
+        <p:spPr>
+          <a:xfrm>
+            <a:off x="6309360" y="2103120"/>
+            <a:ext cx="5029200" cy="365760"/>
+          </a:xfrm>
+          <a:prstGeom prst="rect">
+            <a:avLst/>
+          </a:prstGeom>
+          <a:noFill/>
+        </p:spPr>
+        <p:txBody>
+          <a:bodyPr wrap="square" anchor="t" lIns="45720" rIns="45720">
+            <a:spAutoFit/>
+          </a:bodyPr>
+          <a:lstStyle/>
+          <a:p>
+            <a:pPr algn="l">
               <a:spcAft>
-                <a:spcPts val="1400"/>
+                <a:spcPts val="600"/>
               </a:spcAft>
             </a:pPr>
             <a:r>
-              <a:rPr sz="1900" b="1">
+              <a:rPr sz="1700" b="1">
                 <a:solidFill>
                   <a:srgbClr val="1F5C99"/>
                 </a:solidFill>
                 <a:latin typeface="Arial"/>
               </a:rPr>
-              <a:t>• </a:t>
-            </a:r>
-            <a:r>
-              <a:rPr sz="1900" b="0">
-                <a:solidFill>
-                  <a:srgbClr val="222222"/>
-                </a:solidFill>
-                <a:latin typeface="Arial"/>
-              </a:rPr>
-              <a:t>Acerto com intervalo de Wilson de 95%</a:t>
-            </a:r>
-          </a:p>
-          <a:p>
-            <a:pPr>
+              <a:t>Ferramentas sobre o grafo</a:t>
+            </a:r>
+          </a:p>
+        </p:txBody>
+      </p:sp>
+      <p:sp>
+        <p:nvSpPr>
+          <p:cNvPr id="19" name="TextBox 18"/>
+          <p:cNvSpPr txBox="1"/>
+          <p:nvPr/>
+        </p:nvSpPr>
+        <p:spPr>
+          <a:xfrm>
+            <a:off x="6309360" y="2487168"/>
+            <a:ext cx="5074920" cy="320040"/>
+          </a:xfrm>
+          <a:prstGeom prst="rect">
+            <a:avLst/>
+          </a:prstGeom>
+          <a:noFill/>
+        </p:spPr>
+        <p:txBody>
+          <a:bodyPr wrap="square" anchor="t" lIns="45720" rIns="45720">
+            <a:spAutoFit/>
+          </a:bodyPr>
+          <a:lstStyle/>
+          <a:p>
+            <a:pPr algn="l">
               <a:spcAft>
-                <a:spcPts val="1400"/>
+                <a:spcPts val="600"/>
               </a:spcAft>
             </a:pPr>
             <a:r>
-              <a:rPr sz="1900" b="1">
-                <a:solidFill>
-                  <a:srgbClr val="1F5C99"/>
-                </a:solidFill>
-                <a:latin typeface="Arial"/>
-              </a:rPr>
-              <a:t>• </a:t>
-            </a:r>
-            <a:r>
-              <a:rPr sz="1900" b="0">
+              <a:rPr sz="1200" b="0">
                 <a:solidFill>
                   <a:srgbClr val="222222"/>
                 </a:solidFill>
                 <a:latin typeface="Arial"/>
               </a:rPr>
-              <a:t>Diferenças lidas como indícios, não como demonstração</a:t>
+              <a:t>Modelo escolhe query_actions e preenche os argumentos:</a:t>
+            </a:r>
+          </a:p>
+        </p:txBody>
+      </p:sp>
+      <p:sp>
+        <p:nvSpPr>
+          <p:cNvPr id="20" name="Rectangle 19"/>
+          <p:cNvSpPr/>
+          <p:nvPr/>
+        </p:nvSpPr>
+        <p:spPr>
+          <a:xfrm>
+            <a:off x="6309360" y="2807208"/>
+            <a:ext cx="5074920" cy="1783080"/>
+          </a:xfrm>
+          <a:prstGeom prst="rect">
+            <a:avLst/>
+          </a:prstGeom>
+          <a:solidFill>
+            <a:srgbClr val="2B2B2B"/>
+          </a:solidFill>
+          <a:ln>
+            <a:noFill/>
+          </a:ln>
+          <a:effectLst/>
+        </p:spPr>
+        <p:style>
+          <a:lnRef idx="1">
+            <a:schemeClr val="accent1"/>
+          </a:lnRef>
+          <a:fillRef idx="3">
+            <a:schemeClr val="accent1"/>
+          </a:fillRef>
+          <a:effectRef idx="2">
+            <a:schemeClr val="accent1"/>
+          </a:effectRef>
+          <a:fontRef idx="minor">
+            <a:schemeClr val="lt1"/>
+          </a:fontRef>
+        </p:style>
+        <p:txBody>
+          <a:bodyPr rtlCol="0" anchor="ctr"/>
+          <a:lstStyle/>
+          <a:p>
+            <a:pPr algn="ctr"/>
+          </a:p>
+        </p:txBody>
+      </p:sp>
+      <p:sp>
+        <p:nvSpPr>
+          <p:cNvPr id="21" name="TextBox 20"/>
+          <p:cNvSpPr txBox="1"/>
+          <p:nvPr/>
+        </p:nvSpPr>
+        <p:spPr>
+          <a:xfrm>
+            <a:off x="6400800" y="2852927"/>
+            <a:ext cx="4892040" cy="1691639"/>
+          </a:xfrm>
+          <a:prstGeom prst="rect">
+            <a:avLst/>
+          </a:prstGeom>
+          <a:noFill/>
+        </p:spPr>
+        <p:txBody>
+          <a:bodyPr wrap="square">
+            <a:spAutoFit/>
+          </a:bodyPr>
+          <a:lstStyle/>
+          <a:p>
+            <a:r>
+              <a:rPr sz="1100">
+                <a:solidFill>
+                  <a:srgbClr val="E8E8E8"/>
+                </a:solidFill>
+                <a:latin typeface="Courier New"/>
+              </a:rPr>
+              <a:t>filters: {team: "Argentina",</a:t>
+            </a:r>
+          </a:p>
+          <a:p>
+            <a:r>
+              <a:rPr sz="1100">
+                <a:solidFill>
+                  <a:srgbClr val="E8E8E8"/>
+                </a:solidFill>
+                <a:latin typeface="Courier New"/>
+              </a:rPr>
+              <a:t>  action: ["passe"], success: true,</a:t>
+            </a:r>
+          </a:p>
+          <a:p>
+            <a:r>
+              <a:rPr sz="1100">
+                <a:solidFill>
+                  <a:srgbClr val="E8E8E8"/>
+                </a:solidFill>
+                <a:latin typeface="Courier New"/>
+              </a:rPr>
+              <a:t>  third: "attacking"},</a:t>
+            </a:r>
+          </a:p>
+          <a:p>
+            <a:r>
+              <a:rPr sz="1100">
+                <a:solidFill>
+                  <a:srgbClr val="E8E8E8"/>
+                </a:solidFill>
+                <a:latin typeface="Courier New"/>
+              </a:rPr>
+              <a:t>group_by: ["player"], metric: "count",</a:t>
+            </a:r>
+          </a:p>
+          <a:p>
+            <a:r>
+              <a:rPr sz="1100">
+                <a:solidFill>
+                  <a:srgbClr val="E8E8E8"/>
+                </a:solidFill>
+                <a:latin typeface="Courier New"/>
+              </a:rPr>
+              <a:t>top: 5</a:t>
+            </a:r>
+          </a:p>
+        </p:txBody>
+      </p:sp>
+      <p:sp>
+        <p:nvSpPr>
+          <p:cNvPr id="22" name="TextBox 21"/>
+          <p:cNvSpPr txBox="1"/>
+          <p:nvPr/>
+        </p:nvSpPr>
+        <p:spPr>
+          <a:xfrm>
+            <a:off x="6309360" y="4636008"/>
+            <a:ext cx="5074920" cy="365760"/>
+          </a:xfrm>
+          <a:prstGeom prst="rect">
+            <a:avLst/>
+          </a:prstGeom>
+          <a:noFill/>
+        </p:spPr>
+        <p:txBody>
+          <a:bodyPr wrap="square" anchor="t" lIns="45720" rIns="45720">
+            <a:spAutoFit/>
+          </a:bodyPr>
+          <a:lstStyle/>
+          <a:p>
+            <a:pPr algn="l">
+              <a:spcAft>
+                <a:spcPts val="600"/>
+              </a:spcAft>
+            </a:pPr>
+            <a:r>
+              <a:rPr sz="1200" b="0">
+                <a:solidFill>
+                  <a:srgbClr val="222222"/>
+                </a:solidFill>
+                <a:latin typeface="Arial"/>
+              </a:rPr>
+              <a:t>Ferramenta executa a consulta fixa do código e devolve:</a:t>
+            </a:r>
+          </a:p>
+        </p:txBody>
+      </p:sp>
+      <p:sp>
+        <p:nvSpPr>
+          <p:cNvPr id="23" name="Rectangle 22"/>
+          <p:cNvSpPr/>
+          <p:nvPr/>
+        </p:nvSpPr>
+        <p:spPr>
+          <a:xfrm>
+            <a:off x="6309360" y="5001768"/>
+            <a:ext cx="5074920" cy="594360"/>
+          </a:xfrm>
+          <a:prstGeom prst="rect">
+            <a:avLst/>
+          </a:prstGeom>
+          <a:solidFill>
+            <a:srgbClr val="2B2B2B"/>
+          </a:solidFill>
+          <a:ln>
+            <a:noFill/>
+          </a:ln>
+          <a:effectLst/>
+        </p:spPr>
+        <p:style>
+          <a:lnRef idx="1">
+            <a:schemeClr val="accent1"/>
+          </a:lnRef>
+          <a:fillRef idx="3">
+            <a:schemeClr val="accent1"/>
+          </a:fillRef>
+          <a:effectRef idx="2">
+            <a:schemeClr val="accent1"/>
+          </a:effectRef>
+          <a:fontRef idx="minor">
+            <a:schemeClr val="lt1"/>
+          </a:fontRef>
+        </p:style>
+        <p:txBody>
+          <a:bodyPr rtlCol="0" anchor="ctr"/>
+          <a:lstStyle/>
+          <a:p>
+            <a:pPr algn="ctr"/>
+          </a:p>
+        </p:txBody>
+      </p:sp>
+      <p:sp>
+        <p:nvSpPr>
+          <p:cNvPr id="24" name="TextBox 23"/>
+          <p:cNvSpPr txBox="1"/>
+          <p:nvPr/>
+        </p:nvSpPr>
+        <p:spPr>
+          <a:xfrm>
+            <a:off x="6400800" y="5047488"/>
+            <a:ext cx="4892040" cy="502920"/>
+          </a:xfrm>
+          <a:prstGeom prst="rect">
+            <a:avLst/>
+          </a:prstGeom>
+          <a:noFill/>
+        </p:spPr>
+        <p:txBody>
+          <a:bodyPr wrap="square">
+            <a:spAutoFit/>
+          </a:bodyPr>
+          <a:lstStyle/>
+          <a:p>
+            <a:r>
+              <a:rPr sz="1100">
+                <a:solidFill>
+                  <a:srgbClr val="E8E8E8"/>
+                </a:solidFill>
+                <a:latin typeface="Courier New"/>
+              </a:rPr>
+              <a:t>Lionel Andrés Messi Cuccittini: 24</a:t>
+            </a:r>
+          </a:p>
+          <a:p>
+            <a:r>
+              <a:rPr sz="1100">
+                <a:solidFill>
+                  <a:srgbClr val="E8E8E8"/>
+                </a:solidFill>
+                <a:latin typeface="Courier New"/>
+              </a:rPr>
+              <a:t>Alexis Mac Allister: 18 [...]</a:t>
+            </a:r>
+          </a:p>
+        </p:txBody>
+      </p:sp>
+      <p:sp>
+        <p:nvSpPr>
+          <p:cNvPr id="25" name="TextBox 24"/>
+          <p:cNvSpPr txBox="1"/>
+          <p:nvPr/>
+        </p:nvSpPr>
+        <p:spPr>
+          <a:xfrm>
+            <a:off x="6309360" y="5715000"/>
+            <a:ext cx="5074920" cy="502920"/>
+          </a:xfrm>
+          <a:prstGeom prst="rect">
+            <a:avLst/>
+          </a:prstGeom>
+          <a:noFill/>
+        </p:spPr>
+        <p:txBody>
+          <a:bodyPr wrap="square" anchor="ctr" lIns="45720" rIns="45720">
+            <a:spAutoFit/>
+          </a:bodyPr>
+          <a:lstStyle/>
+          <a:p>
+            <a:pPr algn="l">
+              <a:spcAft>
+                <a:spcPts val="600"/>
+              </a:spcAft>
+            </a:pPr>
+            <a:r>
+              <a:rPr sz="1300" b="1">
+                <a:solidFill>
+                  <a:srgbClr val="222222"/>
+                </a:solidFill>
+                <a:latin typeface="Arial"/>
+              </a:rPr>
+              <a:t>Modelo responde: Lionel Andrés Messi Cuccittini</a:t>
             </a:r>
           </a:p>
         </p:txBody>
@@ -14563,17 +15288,72 @@
           </a:p>
         </p:txBody>
       </p:sp>
+      <p:sp>
+        <p:nvSpPr>
+          <p:cNvPr id="6" name="TextBox 5"/>
+          <p:cNvSpPr txBox="1"/>
+          <p:nvPr/>
+        </p:nvSpPr>
+        <p:spPr>
+          <a:xfrm>
+            <a:off x="640080" y="1325880"/>
+            <a:ext cx="10881360" cy="822960"/>
+          </a:xfrm>
+          <a:prstGeom prst="rect">
+            <a:avLst/>
+          </a:prstGeom>
+          <a:noFill/>
+        </p:spPr>
+        <p:txBody>
+          <a:bodyPr wrap="square" anchor="t" lIns="45720" rIns="45720">
+            <a:spAutoFit/>
+          </a:bodyPr>
+          <a:lstStyle/>
+          <a:p>
+            <a:pPr algn="l">
+              <a:spcAft>
+                <a:spcPts val="200"/>
+              </a:spcAft>
+            </a:pPr>
+            <a:r>
+              <a:rPr sz="1300" b="0">
+                <a:solidFill>
+                  <a:srgbClr val="666666"/>
+                </a:solidFill>
+                <a:latin typeface="Arial"/>
+              </a:rPr>
+              <a:t>4 modelos: Claude Haiku 5.5 e Qwen3.8-flash (menores, sem raciocínio estendido, temperatura zero); Claude Sonnet 4.6 e Kimi K3 (maiores, com raciocínio estendido).</a:t>
+            </a:r>
+          </a:p>
+          <a:p>
+            <a:pPr algn="l">
+              <a:spcAft>
+                <a:spcPts val="200"/>
+              </a:spcAft>
+            </a:pPr>
+            <a:r>
+              <a:rPr sz="1300" b="0">
+                <a:solidFill>
+                  <a:srgbClr val="666666"/>
+                </a:solidFill>
+                <a:latin typeface="Arial"/>
+              </a:rPr>
+              <a:t>52 perguntas × 6 abordagens = 312 execuções por modelo, 1 repetição por pergunta. Intervalo de Wilson de 95%; diferenças lidas como indícios.</a:t>
+            </a:r>
+          </a:p>
+        </p:txBody>
+      </p:sp>
       <p:graphicFrame>
         <p:nvGraphicFramePr>
-          <p:cNvPr id="6" name="Chart 5"/>
+          <p:cNvPr id="7" name="Chart 6"/>
           <p:cNvGraphicFramePr>
             <a:graphicFrameLocks noGrp="1"/>
           </p:cNvGraphicFramePr>
           <p:nvPr/>
         </p:nvGraphicFramePr>
         <p:xfrm>
-          <a:off x="457200" y="1371600"/>
-          <a:ext cx="11247120" cy="4937760"/>
+          <a:off x="457200" y="2103120"/>
+          <a:ext cx="11247120" cy="4251960"/>
         </p:xfrm>
         <a:graphic>
           <a:graphicData uri="http://schemas.openxmlformats.org/drawingml/2006/chart">

</xml_diff>

<commit_message>
Replace cost table with cards and chart for larger models
Co-Authored-By: Claude Sonnet 5.5 <noreply@anthropic.com>
Claude-Session: https://claude.ai/code/session_01FjZonbKdsyoySM9nwRFtHf
</commit_message>
<xml_diff>
--- a/apresentacao/apresentacao.pptx
+++ b/apresentacao/apresentacao.pptx
@@ -1120,6 +1120,348 @@
 </c:chartSpace>
 </file>
 
+<file path=ppt/charts/chart3.xml><?xml version="1.0" encoding="utf-8"?>
+<c:chartSpace xmlns:c="http://schemas.openxmlformats.org/drawingml/2006/chart" xmlns:a="http://schemas.openxmlformats.org/drawingml/2006/main" xmlns:r="http://schemas.openxmlformats.org/officeDocument/2006/relationships">
+  <c:date1904 val="0"/>
+  <c:chart>
+    <c:autoTitleDeleted val="0"/>
+    <c:plotArea>
+      <c:barChart>
+        <c:barDir val="col"/>
+        <c:grouping val="clustered"/>
+        <c:ser>
+          <c:idx val="0"/>
+          <c:order val="0"/>
+          <c:tx>
+            <c:strRef>
+              <c:f>Sheet1!$B$1</c:f>
+              <c:strCache>
+                <c:ptCount val="1"/>
+                <c:pt idx="0">
+                  <c:v>Contexto longo</c:v>
+                </c:pt>
+              </c:strCache>
+            </c:strRef>
+          </c:tx>
+          <c:spPr>
+            <a:solidFill>
+              <a:srgbClr val="A6A6A6"/>
+            </a:solidFill>
+          </c:spPr>
+          <c:dLbls>
+            <c:numFmt formatCode="0" sourceLinked="0"/>
+            <c:txPr>
+              <a:bodyPr/>
+              <a:lstStyle/>
+              <a:p>
+                <a:pPr>
+                  <a:defRPr sz="1200"/>
+                </a:pPr>
+              </a:p>
+            </c:txPr>
+            <c:dLblPos val="outEnd"/>
+            <c:showLegendKey val="0"/>
+            <c:showVal val="1"/>
+            <c:showCatName val="0"/>
+            <c:showSerName val="0"/>
+            <c:showPercent val="0"/>
+            <c:showBubbleSize val="0"/>
+            <c:showLeaderLines val="1"/>
+          </c:dLbls>
+          <c:cat>
+            <c:strRef>
+              <c:f>Sheet1!$A$2:$A$3</c:f>
+              <c:strCache>
+                <c:ptCount val="2"/>
+                <c:pt idx="0">
+                  <c:v>Sonnet 4.6 (maior)</c:v>
+                </c:pt>
+                <c:pt idx="1">
+                  <c:v>Kimi K3 (maior)</c:v>
+                </c:pt>
+              </c:strCache>
+            </c:strRef>
+          </c:cat>
+          <c:val>
+            <c:numRef>
+              <c:f>Sheet1!$B$2:$B$3</c:f>
+              <c:numCache>
+                <c:formatCode>General</c:formatCode>
+                <c:ptCount val="2"/>
+                <c:pt idx="0">
+                  <c:v>37.0</c:v>
+                </c:pt>
+                <c:pt idx="1">
+                  <c:v>81.0</c:v>
+                </c:pt>
+              </c:numCache>
+            </c:numRef>
+          </c:val>
+        </c:ser>
+        <c:ser>
+          <c:idx val="1"/>
+          <c:order val="1"/>
+          <c:tx>
+            <c:strRef>
+              <c:f>Sheet1!$C$1</c:f>
+              <c:strCache>
+                <c:ptCount val="1"/>
+                <c:pt idx="0">
+                  <c:v>Consulta escrita pelo modelo</c:v>
+                </c:pt>
+              </c:strCache>
+            </c:strRef>
+          </c:tx>
+          <c:spPr>
+            <a:solidFill>
+              <a:srgbClr val="5E5E5E"/>
+            </a:solidFill>
+          </c:spPr>
+          <c:dLbls>
+            <c:numFmt formatCode="0" sourceLinked="0"/>
+            <c:txPr>
+              <a:bodyPr/>
+              <a:lstStyle/>
+              <a:p>
+                <a:pPr>
+                  <a:defRPr sz="1200"/>
+                </a:pPr>
+              </a:p>
+            </c:txPr>
+            <c:dLblPos val="outEnd"/>
+            <c:showLegendKey val="0"/>
+            <c:showVal val="1"/>
+            <c:showCatName val="0"/>
+            <c:showSerName val="0"/>
+            <c:showPercent val="0"/>
+            <c:showBubbleSize val="0"/>
+            <c:showLeaderLines val="1"/>
+          </c:dLbls>
+          <c:cat>
+            <c:strRef>
+              <c:f>Sheet1!$A$2:$A$3</c:f>
+              <c:strCache>
+                <c:ptCount val="2"/>
+                <c:pt idx="0">
+                  <c:v>Sonnet 4.6 (maior)</c:v>
+                </c:pt>
+                <c:pt idx="1">
+                  <c:v>Kimi K3 (maior)</c:v>
+                </c:pt>
+              </c:strCache>
+            </c:strRef>
+          </c:cat>
+          <c:val>
+            <c:numRef>
+              <c:f>Sheet1!$C$2:$C$3</c:f>
+              <c:numCache>
+                <c:formatCode>General</c:formatCode>
+                <c:ptCount val="2"/>
+                <c:pt idx="0">
+                  <c:v>13.0</c:v>
+                </c:pt>
+                <c:pt idx="1">
+                  <c:v>24.0</c:v>
+                </c:pt>
+              </c:numCache>
+            </c:numRef>
+          </c:val>
+        </c:ser>
+        <c:ser>
+          <c:idx val="2"/>
+          <c:order val="2"/>
+          <c:tx>
+            <c:strRef>
+              <c:f>Sheet1!$D$1</c:f>
+              <c:strCache>
+                <c:ptCount val="1"/>
+                <c:pt idx="0">
+                  <c:v>Ferramentas sobre o grafo</c:v>
+                </c:pt>
+              </c:strCache>
+            </c:strRef>
+          </c:tx>
+          <c:spPr>
+            <a:solidFill>
+              <a:srgbClr val="1F5C99"/>
+            </a:solidFill>
+          </c:spPr>
+          <c:dLbls>
+            <c:numFmt formatCode="0" sourceLinked="0"/>
+            <c:txPr>
+              <a:bodyPr/>
+              <a:lstStyle/>
+              <a:p>
+                <a:pPr>
+                  <a:defRPr sz="1200"/>
+                </a:pPr>
+              </a:p>
+            </c:txPr>
+            <c:dLblPos val="outEnd"/>
+            <c:showLegendKey val="0"/>
+            <c:showVal val="1"/>
+            <c:showCatName val="0"/>
+            <c:showSerName val="0"/>
+            <c:showPercent val="0"/>
+            <c:showBubbleSize val="0"/>
+            <c:showLeaderLines val="1"/>
+          </c:dLbls>
+          <c:cat>
+            <c:strRef>
+              <c:f>Sheet1!$A$2:$A$3</c:f>
+              <c:strCache>
+                <c:ptCount val="2"/>
+                <c:pt idx="0">
+                  <c:v>Sonnet 4.6 (maior)</c:v>
+                </c:pt>
+                <c:pt idx="1">
+                  <c:v>Kimi K3 (maior)</c:v>
+                </c:pt>
+              </c:strCache>
+            </c:strRef>
+          </c:cat>
+          <c:val>
+            <c:numRef>
+              <c:f>Sheet1!$D$2:$D$3</c:f>
+              <c:numCache>
+                <c:formatCode>General</c:formatCode>
+                <c:ptCount val="2"/>
+                <c:pt idx="0">
+                  <c:v>10.0</c:v>
+                </c:pt>
+                <c:pt idx="1">
+                  <c:v>15.0</c:v>
+                </c:pt>
+              </c:numCache>
+            </c:numRef>
+          </c:val>
+        </c:ser>
+        <c:gapWidth val="80"/>
+        <c:overlap val="-5"/>
+        <c:axId val="-2068027336"/>
+        <c:axId val="-2113994440"/>
+      </c:barChart>
+      <c:catAx>
+        <c:axId val="-2068027336"/>
+        <c:scaling>
+          <c:orientation val="minMax"/>
+        </c:scaling>
+        <c:delete val="0"/>
+        <c:axPos val="b"/>
+        <c:majorTickMark val="out"/>
+        <c:minorTickMark val="none"/>
+        <c:tickLblPos val="nextTo"/>
+        <c:spPr>
+          <a:ln>
+            <a:solidFill>
+              <a:srgbClr val="D0D0D0"/>
+            </a:solidFill>
+          </a:ln>
+        </c:spPr>
+        <c:txPr>
+          <a:bodyPr/>
+          <a:lstStyle/>
+          <a:p>
+            <a:pPr>
+              <a:defRPr sz="1400"/>
+            </a:pPr>
+          </a:p>
+        </c:txPr>
+        <c:crossAx val="-2113994440"/>
+        <c:crosses val="autoZero"/>
+        <c:auto val="1"/>
+        <c:lblAlgn val="ctr"/>
+        <c:lblOffset val="100"/>
+        <c:noMultiLvlLbl val="0"/>
+      </c:catAx>
+      <c:valAx>
+        <c:axId val="-2113994440"/>
+        <c:scaling>
+          <c:max val="100.0"/>
+          <c:min val="0.0"/>
+        </c:scaling>
+        <c:delete val="0"/>
+        <c:axPos val="l"/>
+        <c:majorGridlines>
+          <c:spPr>
+            <a:ln>
+              <a:solidFill>
+                <a:srgbClr val="D0D0D0"/>
+              </a:solidFill>
+            </a:ln>
+          </c:spPr>
+        </c:majorGridlines>
+        <c:title>
+          <c:tx>
+            <c:rich>
+              <a:bodyPr/>
+              <a:lstStyle/>
+              <a:p>
+                <a:r>
+                  <a:rPr sz="1400" b="0"/>
+                  <a:t>Latência mediana (s)</a:t>
+                </a:r>
+              </a:p>
+            </c:rich>
+          </c:tx>
+          <c:layout/>
+          <c:overlay val="0"/>
+        </c:title>
+        <c:majorTickMark val="out"/>
+        <c:minorTickMark val="none"/>
+        <c:tickLblPos val="nextTo"/>
+        <c:spPr>
+          <a:ln>
+            <a:noFill/>
+          </a:ln>
+        </c:spPr>
+        <c:txPr>
+          <a:bodyPr/>
+          <a:lstStyle/>
+          <a:p>
+            <a:pPr>
+              <a:defRPr sz="1400"/>
+            </a:pPr>
+          </a:p>
+        </c:txPr>
+        <c:crossAx val="-2068027336"/>
+        <c:crosses val="autoZero"/>
+        <c:majorUnit val="25.0"/>
+      </c:valAx>
+    </c:plotArea>
+    <c:legend>
+      <c:legendPos val="b"/>
+      <c:overlay val="0"/>
+      <c:txPr>
+        <a:bodyPr/>
+        <a:lstStyle/>
+        <a:p>
+          <a:pPr>
+            <a:defRPr sz="1400"/>
+          </a:pPr>
+        </a:p>
+      </c:txPr>
+    </c:legend>
+    <c:dispBlanksAs val="gap"/>
+  </c:chart>
+  <c:txPr>
+    <a:bodyPr/>
+    <a:lstStyle/>
+    <a:p>
+      <a:pPr>
+        <a:defRPr sz="1400">
+          <a:latin typeface="Arial"/>
+        </a:defRPr>
+      </a:pPr>
+      <a:endParaRPr lang="en-US"/>
+    </a:p>
+  </c:txPr>
+  <c:externalData r:id="rId1">
+    <c:autoUpdate val="0"/>
+  </c:externalData>
+</c:chartSpace>
+</file>
+
 <file path=ppt/notesMasters/notesMaster1.xml><?xml version="1.0" encoding="utf-8"?>
 <p:notesMaster xmlns:a="http://schemas.openxmlformats.org/drawingml/2006/main" xmlns:p="http://schemas.openxmlformats.org/presentationml/2006/main" xmlns:r="http://schemas.openxmlformats.org/officeDocument/2006/relationships">
   <p:cSld>
@@ -6681,14 +7023,58 @@
       </p:sp>
       <p:sp>
         <p:nvSpPr>
-          <p:cNvPr id="5" name="TextBox 4"/>
+          <p:cNvPr id="5" name="Rectangle 4"/>
+          <p:cNvSpPr/>
+          <p:nvPr/>
+        </p:nvSpPr>
+        <p:spPr>
+          <a:xfrm>
+            <a:off x="640080" y="1554480"/>
+            <a:ext cx="3840480" cy="2103120"/>
+          </a:xfrm>
+          <a:prstGeom prst="rect">
+            <a:avLst/>
+          </a:prstGeom>
+          <a:solidFill>
+            <a:srgbClr val="E6EEF6"/>
+          </a:solidFill>
+          <a:ln>
+            <a:noFill/>
+          </a:ln>
+          <a:effectLst/>
+        </p:spPr>
+        <p:style>
+          <a:lnRef idx="1">
+            <a:schemeClr val="accent1"/>
+          </a:lnRef>
+          <a:fillRef idx="3">
+            <a:schemeClr val="accent1"/>
+          </a:fillRef>
+          <a:effectRef idx="2">
+            <a:schemeClr val="accent1"/>
+          </a:effectRef>
+          <a:fontRef idx="minor">
+            <a:schemeClr val="lt1"/>
+          </a:fontRef>
+        </p:style>
+        <p:txBody>
+          <a:bodyPr rtlCol="0" anchor="ctr"/>
+          <a:lstStyle/>
+          <a:p>
+            <a:pPr algn="ctr"/>
+          </a:p>
+        </p:txBody>
+      </p:sp>
+      <p:sp>
+        <p:nvSpPr>
+          <p:cNvPr id="6" name="TextBox 5"/>
           <p:cNvSpPr txBox="1"/>
           <p:nvPr/>
         </p:nvSpPr>
         <p:spPr>
           <a:xfrm>
-            <a:off x="640080" y="6400800"/>
-            <a:ext cx="9144000" cy="320040"/>
+            <a:off x="777240" y="1691640"/>
+            <a:ext cx="3566160" cy="1828800"/>
           </a:xfrm>
           <a:prstGeom prst="rect">
             <a:avLst/>
@@ -6707,1213 +7093,179 @@
               </a:spcAft>
             </a:pPr>
             <a:r>
-              <a:rPr sz="1200" b="0">
+              <a:rPr sz="4000" b="1">
+                <a:solidFill>
+                  <a:srgbClr val="1F5C99"/>
+                </a:solidFill>
+                <a:latin typeface="Arial"/>
+              </a:rPr>
+              <a:t>37 s e 81 s</a:t>
+            </a:r>
+          </a:p>
+          <a:p>
+            <a:pPr algn="l">
+              <a:spcAft>
+                <a:spcPts val="600"/>
+              </a:spcAft>
+            </a:pPr>
+            <a:r>
+              <a:rPr sz="1800" b="0">
+                <a:solidFill>
+                  <a:srgbClr val="222222"/>
+                </a:solidFill>
+                <a:latin typeface="Arial"/>
+              </a:rPr>
+              <a:t>latência por pergunta</a:t>
+            </a:r>
+          </a:p>
+          <a:p>
+            <a:pPr algn="l">
+              <a:spcAft>
+                <a:spcPts val="600"/>
+              </a:spcAft>
+            </a:pPr>
+            <a:r>
+              <a:rPr sz="1300" b="0">
                 <a:solidFill>
                   <a:srgbClr val="666666"/>
                 </a:solidFill>
                 <a:latin typeface="Arial"/>
               </a:rPr>
-              <a:t>Mediana por execução. Os tokens de entrada incluem os lidos do cache do prompt.</a:t>
+              <a:t>Contexto longo, modelos maiores (Sonnet e Kimi)</a:t>
+            </a:r>
+          </a:p>
+        </p:txBody>
+      </p:sp>
+      <p:sp>
+        <p:nvSpPr>
+          <p:cNvPr id="7" name="Rectangle 6"/>
+          <p:cNvSpPr/>
+          <p:nvPr/>
+        </p:nvSpPr>
+        <p:spPr>
+          <a:xfrm>
+            <a:off x="640080" y="3840480"/>
+            <a:ext cx="3840480" cy="2103120"/>
+          </a:xfrm>
+          <a:prstGeom prst="rect">
+            <a:avLst/>
+          </a:prstGeom>
+          <a:solidFill>
+            <a:srgbClr val="E6EEF6"/>
+          </a:solidFill>
+          <a:ln>
+            <a:noFill/>
+          </a:ln>
+          <a:effectLst/>
+        </p:spPr>
+        <p:style>
+          <a:lnRef idx="1">
+            <a:schemeClr val="accent1"/>
+          </a:lnRef>
+          <a:fillRef idx="3">
+            <a:schemeClr val="accent1"/>
+          </a:fillRef>
+          <a:effectRef idx="2">
+            <a:schemeClr val="accent1"/>
+          </a:effectRef>
+          <a:fontRef idx="minor">
+            <a:schemeClr val="lt1"/>
+          </a:fontRef>
+        </p:style>
+        <p:txBody>
+          <a:bodyPr rtlCol="0" anchor="ctr"/>
+          <a:lstStyle/>
+          <a:p>
+            <a:pPr algn="ctr"/>
+          </a:p>
+        </p:txBody>
+      </p:sp>
+      <p:sp>
+        <p:nvSpPr>
+          <p:cNvPr id="8" name="TextBox 7"/>
+          <p:cNvSpPr txBox="1"/>
+          <p:nvPr/>
+        </p:nvSpPr>
+        <p:spPr>
+          <a:xfrm>
+            <a:off x="777240" y="3977639"/>
+            <a:ext cx="3566160" cy="1828800"/>
+          </a:xfrm>
+          <a:prstGeom prst="rect">
+            <a:avLst/>
+          </a:prstGeom>
+          <a:noFill/>
+        </p:spPr>
+        <p:txBody>
+          <a:bodyPr wrap="square" anchor="t" lIns="45720" rIns="45720">
+            <a:spAutoFit/>
+          </a:bodyPr>
+          <a:lstStyle/>
+          <a:p>
+            <a:pPr algn="l">
+              <a:spcAft>
+                <a:spcPts val="600"/>
+              </a:spcAft>
+            </a:pPr>
+            <a:r>
+              <a:rPr sz="4000" b="1">
+                <a:solidFill>
+                  <a:srgbClr val="1F5C99"/>
+                </a:solidFill>
+                <a:latin typeface="Arial"/>
+              </a:rPr>
+              <a:t>4,4 e 12,2 mil</a:t>
+            </a:r>
+          </a:p>
+          <a:p>
+            <a:pPr algn="l">
+              <a:spcAft>
+                <a:spcPts val="600"/>
+              </a:spcAft>
+            </a:pPr>
+            <a:r>
+              <a:rPr sz="1800" b="0">
+                <a:solidFill>
+                  <a:srgbClr val="222222"/>
+                </a:solidFill>
+                <a:latin typeface="Arial"/>
+              </a:rPr>
+              <a:t>tokens de saída por pergunta</a:t>
+            </a:r>
+          </a:p>
+          <a:p>
+            <a:pPr algn="l">
+              <a:spcAft>
+                <a:spcPts val="600"/>
+              </a:spcAft>
+            </a:pPr>
+            <a:r>
+              <a:rPr sz="1300" b="0">
+                <a:solidFill>
+                  <a:srgbClr val="666666"/>
+                </a:solidFill>
+                <a:latin typeface="Arial"/>
+              </a:rPr>
+              <a:t>Contexto longo, modelos maiores (Sonnet e Kimi)</a:t>
             </a:r>
           </a:p>
         </p:txBody>
       </p:sp>
       <p:graphicFrame>
         <p:nvGraphicFramePr>
-          <p:cNvPr id="6" name="Table 5"/>
+          <p:cNvPr id="9" name="Chart 8"/>
           <p:cNvGraphicFramePr>
             <a:graphicFrameLocks noGrp="1"/>
           </p:cNvGraphicFramePr>
           <p:nvPr/>
         </p:nvGraphicFramePr>
         <p:xfrm>
-          <a:off x="640080" y="1554480"/>
-          <a:ext cx="10881360" cy="4480560"/>
+          <a:off x="4754880" y="1417320"/>
+          <a:ext cx="7040880" cy="4846320"/>
         </p:xfrm>
         <a:graphic>
-          <a:graphicData uri="http://schemas.openxmlformats.org/drawingml/2006/table">
-            <a:tbl>
-              <a:tblPr firstRow="0" bandRow="0">
-                <a:tableStyleId>{5C22544A-7EE6-4342-B048-85BDC9FD1C3A}</a:tableStyleId>
-              </a:tblPr>
-              <a:tblGrid>
-                <a:gridCol w="4297680"/>
-                <a:gridCol w="1645920"/>
-                <a:gridCol w="1737360"/>
-                <a:gridCol w="1554480"/>
-                <a:gridCol w="1645920"/>
-              </a:tblGrid>
-              <a:tr h="448056">
-                <a:tc>
-                  <a:txBody>
-                    <a:bodyPr wrap="square"/>
-                    <a:lstStyle/>
-                    <a:p>
-                      <a:pPr algn="l"/>
-                      <a:r>
-                        <a:rPr sz="1400" b="1">
-                          <a:solidFill>
-                            <a:srgbClr val="FFFFFF"/>
-                          </a:solidFill>
-                          <a:latin typeface="Arial"/>
-                        </a:rPr>
-                        <a:t>Abordagem / medida</a:t>
-                      </a:r>
-                    </a:p>
-                  </a:txBody>
-                  <a:tcPr anchor="ctr">
-                    <a:solidFill>
-                      <a:srgbClr val="222222"/>
-                    </a:solidFill>
-                  </a:tcPr>
-                </a:tc>
-                <a:tc>
-                  <a:txBody>
-                    <a:bodyPr wrap="square"/>
-                    <a:lstStyle/>
-                    <a:p>
-                      <a:pPr algn="ctr"/>
-                      <a:r>
-                        <a:rPr sz="1400" b="1">
-                          <a:solidFill>
-                            <a:srgbClr val="FFFFFF"/>
-                          </a:solidFill>
-                          <a:latin typeface="Arial"/>
-                        </a:rPr>
-                        <a:t>Haiku 5.5</a:t>
-                      </a:r>
-                    </a:p>
-                  </a:txBody>
-                  <a:tcPr anchor="ctr">
-                    <a:solidFill>
-                      <a:srgbClr val="222222"/>
-                    </a:solidFill>
-                  </a:tcPr>
-                </a:tc>
-                <a:tc>
-                  <a:txBody>
-                    <a:bodyPr wrap="square"/>
-                    <a:lstStyle/>
-                    <a:p>
-                      <a:pPr algn="ctr"/>
-                      <a:r>
-                        <a:rPr sz="1400" b="1">
-                          <a:solidFill>
-                            <a:srgbClr val="FFFFFF"/>
-                          </a:solidFill>
-                          <a:latin typeface="Arial"/>
-                        </a:rPr>
-                        <a:t>Qwen3.8-flash</a:t>
-                      </a:r>
-                    </a:p>
-                  </a:txBody>
-                  <a:tcPr anchor="ctr">
-                    <a:solidFill>
-                      <a:srgbClr val="222222"/>
-                    </a:solidFill>
-                  </a:tcPr>
-                </a:tc>
-                <a:tc>
-                  <a:txBody>
-                    <a:bodyPr wrap="square"/>
-                    <a:lstStyle/>
-                    <a:p>
-                      <a:pPr algn="ctr"/>
-                      <a:r>
-                        <a:rPr sz="1400" b="1">
-                          <a:solidFill>
-                            <a:srgbClr val="FFFFFF"/>
-                          </a:solidFill>
-                          <a:latin typeface="Arial"/>
-                        </a:rPr>
-                        <a:t>Sonnet 4.6</a:t>
-                      </a:r>
-                    </a:p>
-                  </a:txBody>
-                  <a:tcPr anchor="ctr">
-                    <a:solidFill>
-                      <a:srgbClr val="222222"/>
-                    </a:solidFill>
-                  </a:tcPr>
-                </a:tc>
-                <a:tc>
-                  <a:txBody>
-                    <a:bodyPr wrap="square"/>
-                    <a:lstStyle/>
-                    <a:p>
-                      <a:pPr algn="ctr"/>
-                      <a:r>
-                        <a:rPr sz="1400" b="1">
-                          <a:solidFill>
-                            <a:srgbClr val="FFFFFF"/>
-                          </a:solidFill>
-                          <a:latin typeface="Arial"/>
-                        </a:rPr>
-                        <a:t>Kimi K3</a:t>
-                      </a:r>
-                    </a:p>
-                  </a:txBody>
-                  <a:tcPr anchor="ctr">
-                    <a:solidFill>
-                      <a:srgbClr val="222222"/>
-                    </a:solidFill>
-                  </a:tcPr>
-                </a:tc>
-              </a:tr>
-              <a:tr h="448056">
-                <a:tc>
-                  <a:txBody>
-                    <a:bodyPr wrap="square"/>
-                    <a:lstStyle/>
-                    <a:p>
-                      <a:pPr algn="l"/>
-                      <a:r>
-                        <a:rPr sz="1400" b="1">
-                          <a:solidFill>
-                            <a:srgbClr val="222222"/>
-                          </a:solidFill>
-                          <a:latin typeface="Arial"/>
-                        </a:rPr>
-                        <a:t>Contexto, saída (mil tokens)</a:t>
-                      </a:r>
-                    </a:p>
-                  </a:txBody>
-                  <a:tcPr anchor="ctr">
-                    <a:solidFill>
-                      <a:srgbClr val="FFFFFF"/>
-                    </a:solidFill>
-                  </a:tcPr>
-                </a:tc>
-                <a:tc>
-                  <a:txBody>
-                    <a:bodyPr wrap="square"/>
-                    <a:lstStyle/>
-                    <a:p>
-                      <a:pPr algn="ctr"/>
-                      <a:r>
-                        <a:rPr sz="1400" b="0">
-                          <a:solidFill>
-                            <a:srgbClr val="222222"/>
-                          </a:solidFill>
-                          <a:latin typeface="Arial"/>
-                        </a:rPr>
-                        <a:t>0,5</a:t>
-                      </a:r>
-                    </a:p>
-                  </a:txBody>
-                  <a:tcPr anchor="ctr">
-                    <a:solidFill>
-                      <a:srgbClr val="FFFFFF"/>
-                    </a:solidFill>
-                  </a:tcPr>
-                </a:tc>
-                <a:tc>
-                  <a:txBody>
-                    <a:bodyPr wrap="square"/>
-                    <a:lstStyle/>
-                    <a:p>
-                      <a:pPr algn="ctr"/>
-                      <a:r>
-                        <a:rPr sz="1400" b="0">
-                          <a:solidFill>
-                            <a:srgbClr val="222222"/>
-                          </a:solidFill>
-                          <a:latin typeface="Arial"/>
-                        </a:rPr>
-                        <a:t>0,4</a:t>
-                      </a:r>
-                    </a:p>
-                  </a:txBody>
-                  <a:tcPr anchor="ctr">
-                    <a:solidFill>
-                      <a:srgbClr val="FFFFFF"/>
-                    </a:solidFill>
-                  </a:tcPr>
-                </a:tc>
-                <a:tc>
-                  <a:txBody>
-                    <a:bodyPr wrap="square"/>
-                    <a:lstStyle/>
-                    <a:p>
-                      <a:pPr algn="ctr"/>
-                      <a:r>
-                        <a:rPr sz="1400" b="0">
-                          <a:solidFill>
-                            <a:srgbClr val="222222"/>
-                          </a:solidFill>
-                          <a:latin typeface="Arial"/>
-                        </a:rPr>
-                        <a:t>4,4</a:t>
-                      </a:r>
-                    </a:p>
-                  </a:txBody>
-                  <a:tcPr anchor="ctr">
-                    <a:solidFill>
-                      <a:srgbClr val="FFFFFF"/>
-                    </a:solidFill>
-                  </a:tcPr>
-                </a:tc>
-                <a:tc>
-                  <a:txBody>
-                    <a:bodyPr wrap="square"/>
-                    <a:lstStyle/>
-                    <a:p>
-                      <a:pPr algn="ctr"/>
-                      <a:r>
-                        <a:rPr sz="1400" b="0">
-                          <a:solidFill>
-                            <a:srgbClr val="222222"/>
-                          </a:solidFill>
-                          <a:latin typeface="Arial"/>
-                        </a:rPr>
-                        <a:t>12,2</a:t>
-                      </a:r>
-                    </a:p>
-                  </a:txBody>
-                  <a:tcPr anchor="ctr">
-                    <a:solidFill>
-                      <a:srgbClr val="FFFFFF"/>
-                    </a:solidFill>
-                  </a:tcPr>
-                </a:tc>
-              </a:tr>
-              <a:tr h="448056">
-                <a:tc>
-                  <a:txBody>
-                    <a:bodyPr wrap="square"/>
-                    <a:lstStyle/>
-                    <a:p>
-                      <a:pPr algn="l"/>
-                      <a:r>
-                        <a:rPr sz="1400" b="1">
-                          <a:solidFill>
-                            <a:srgbClr val="222222"/>
-                          </a:solidFill>
-                          <a:latin typeface="Arial"/>
-                        </a:rPr>
-                        <a:t>Consulta, saída (mil tokens)</a:t>
-                      </a:r>
-                    </a:p>
-                  </a:txBody>
-                  <a:tcPr anchor="ctr">
-                    <a:solidFill>
-                      <a:srgbClr val="F2F2F2"/>
-                    </a:solidFill>
-                  </a:tcPr>
-                </a:tc>
-                <a:tc>
-                  <a:txBody>
-                    <a:bodyPr wrap="square"/>
-                    <a:lstStyle/>
-                    <a:p>
-                      <a:pPr algn="ctr"/>
-                      <a:r>
-                        <a:rPr sz="1400" b="0">
-                          <a:solidFill>
-                            <a:srgbClr val="222222"/>
-                          </a:solidFill>
-                          <a:latin typeface="Arial"/>
-                        </a:rPr>
-                        <a:t>0,8</a:t>
-                      </a:r>
-                    </a:p>
-                  </a:txBody>
-                  <a:tcPr anchor="ctr">
-                    <a:solidFill>
-                      <a:srgbClr val="F2F2F2"/>
-                    </a:solidFill>
-                  </a:tcPr>
-                </a:tc>
-                <a:tc>
-                  <a:txBody>
-                    <a:bodyPr wrap="square"/>
-                    <a:lstStyle/>
-                    <a:p>
-                      <a:pPr algn="ctr"/>
-                      <a:r>
-                        <a:rPr sz="1400" b="0">
-                          <a:solidFill>
-                            <a:srgbClr val="222222"/>
-                          </a:solidFill>
-                          <a:latin typeface="Arial"/>
-                        </a:rPr>
-                        <a:t>1,6</a:t>
-                      </a:r>
-                    </a:p>
-                  </a:txBody>
-                  <a:tcPr anchor="ctr">
-                    <a:solidFill>
-                      <a:srgbClr val="F2F2F2"/>
-                    </a:solidFill>
-                  </a:tcPr>
-                </a:tc>
-                <a:tc>
-                  <a:txBody>
-                    <a:bodyPr wrap="square"/>
-                    <a:lstStyle/>
-                    <a:p>
-                      <a:pPr algn="ctr"/>
-                      <a:r>
-                        <a:rPr sz="1400" b="0">
-                          <a:solidFill>
-                            <a:srgbClr val="222222"/>
-                          </a:solidFill>
-                          <a:latin typeface="Arial"/>
-                        </a:rPr>
-                        <a:t>0,7</a:t>
-                      </a:r>
-                    </a:p>
-                  </a:txBody>
-                  <a:tcPr anchor="ctr">
-                    <a:solidFill>
-                      <a:srgbClr val="F2F2F2"/>
-                    </a:solidFill>
-                  </a:tcPr>
-                </a:tc>
-                <a:tc>
-                  <a:txBody>
-                    <a:bodyPr wrap="square"/>
-                    <a:lstStyle/>
-                    <a:p>
-                      <a:pPr algn="ctr"/>
-                      <a:r>
-                        <a:rPr sz="1400" b="0">
-                          <a:solidFill>
-                            <a:srgbClr val="222222"/>
-                          </a:solidFill>
-                          <a:latin typeface="Arial"/>
-                        </a:rPr>
-                        <a:t>1,9</a:t>
-                      </a:r>
-                    </a:p>
-                  </a:txBody>
-                  <a:tcPr anchor="ctr">
-                    <a:solidFill>
-                      <a:srgbClr val="F2F2F2"/>
-                    </a:solidFill>
-                  </a:tcPr>
-                </a:tc>
-              </a:tr>
-              <a:tr h="448056">
-                <a:tc>
-                  <a:txBody>
-                    <a:bodyPr wrap="square"/>
-                    <a:lstStyle/>
-                    <a:p>
-                      <a:pPr algn="l"/>
-                      <a:r>
-                        <a:rPr sz="1400" b="1">
-                          <a:solidFill>
-                            <a:srgbClr val="222222"/>
-                          </a:solidFill>
-                          <a:latin typeface="Arial"/>
-                        </a:rPr>
-                        <a:t>Ferramentas, saída (mil tokens)</a:t>
-                      </a:r>
-                    </a:p>
-                  </a:txBody>
-                  <a:tcPr anchor="ctr">
-                    <a:solidFill>
-                      <a:srgbClr val="E6EEF6"/>
-                    </a:solidFill>
-                  </a:tcPr>
-                </a:tc>
-                <a:tc>
-                  <a:txBody>
-                    <a:bodyPr wrap="square"/>
-                    <a:lstStyle/>
-                    <a:p>
-                      <a:pPr algn="ctr"/>
-                      <a:r>
-                        <a:rPr sz="1400" b="0">
-                          <a:solidFill>
-                            <a:srgbClr val="222222"/>
-                          </a:solidFill>
-                          <a:latin typeface="Arial"/>
-                        </a:rPr>
-                        <a:t>0,4</a:t>
-                      </a:r>
-                    </a:p>
-                  </a:txBody>
-                  <a:tcPr anchor="ctr">
-                    <a:solidFill>
-                      <a:srgbClr val="E6EEF6"/>
-                    </a:solidFill>
-                  </a:tcPr>
-                </a:tc>
-                <a:tc>
-                  <a:txBody>
-                    <a:bodyPr wrap="square"/>
-                    <a:lstStyle/>
-                    <a:p>
-                      <a:pPr algn="ctr"/>
-                      <a:r>
-                        <a:rPr sz="1400" b="0">
-                          <a:solidFill>
-                            <a:srgbClr val="222222"/>
-                          </a:solidFill>
-                          <a:latin typeface="Arial"/>
-                        </a:rPr>
-                        <a:t>0,4</a:t>
-                      </a:r>
-                    </a:p>
-                  </a:txBody>
-                  <a:tcPr anchor="ctr">
-                    <a:solidFill>
-                      <a:srgbClr val="E6EEF6"/>
-                    </a:solidFill>
-                  </a:tcPr>
-                </a:tc>
-                <a:tc>
-                  <a:txBody>
-                    <a:bodyPr wrap="square"/>
-                    <a:lstStyle/>
-                    <a:p>
-                      <a:pPr algn="ctr"/>
-                      <a:r>
-                        <a:rPr sz="1400" b="0">
-                          <a:solidFill>
-                            <a:srgbClr val="222222"/>
-                          </a:solidFill>
-                          <a:latin typeface="Arial"/>
-                        </a:rPr>
-                        <a:t>0,4</a:t>
-                      </a:r>
-                    </a:p>
-                  </a:txBody>
-                  <a:tcPr anchor="ctr">
-                    <a:solidFill>
-                      <a:srgbClr val="E6EEF6"/>
-                    </a:solidFill>
-                  </a:tcPr>
-                </a:tc>
-                <a:tc>
-                  <a:txBody>
-                    <a:bodyPr wrap="square"/>
-                    <a:lstStyle/>
-                    <a:p>
-                      <a:pPr algn="ctr"/>
-                      <a:r>
-                        <a:rPr sz="1400" b="0">
-                          <a:solidFill>
-                            <a:srgbClr val="222222"/>
-                          </a:solidFill>
-                          <a:latin typeface="Arial"/>
-                        </a:rPr>
-                        <a:t>0,9</a:t>
-                      </a:r>
-                    </a:p>
-                  </a:txBody>
-                  <a:tcPr anchor="ctr">
-                    <a:solidFill>
-                      <a:srgbClr val="E6EEF6"/>
-                    </a:solidFill>
-                  </a:tcPr>
-                </a:tc>
-              </a:tr>
-              <a:tr h="448056">
-                <a:tc>
-                  <a:txBody>
-                    <a:bodyPr wrap="square"/>
-                    <a:lstStyle/>
-                    <a:p>
-                      <a:pPr algn="l"/>
-                      <a:r>
-                        <a:rPr sz="1400" b="1">
-                          <a:solidFill>
-                            <a:srgbClr val="222222"/>
-                          </a:solidFill>
-                          <a:latin typeface="Arial"/>
-                        </a:rPr>
-                        <a:t>Contexto, latência (s)</a:t>
-                      </a:r>
-                    </a:p>
-                  </a:txBody>
-                  <a:tcPr anchor="ctr">
-                    <a:solidFill>
-                      <a:srgbClr val="F2F2F2"/>
-                    </a:solidFill>
-                  </a:tcPr>
-                </a:tc>
-                <a:tc>
-                  <a:txBody>
-                    <a:bodyPr wrap="square"/>
-                    <a:lstStyle/>
-                    <a:p>
-                      <a:pPr algn="ctr"/>
-                      <a:r>
-                        <a:rPr sz="1400" b="0">
-                          <a:solidFill>
-                            <a:srgbClr val="222222"/>
-                          </a:solidFill>
-                          <a:latin typeface="Arial"/>
-                        </a:rPr>
-                        <a:t>4</a:t>
-                      </a:r>
-                    </a:p>
-                  </a:txBody>
-                  <a:tcPr anchor="ctr">
-                    <a:solidFill>
-                      <a:srgbClr val="F2F2F2"/>
-                    </a:solidFill>
-                  </a:tcPr>
-                </a:tc>
-                <a:tc>
-                  <a:txBody>
-                    <a:bodyPr wrap="square"/>
-                    <a:lstStyle/>
-                    <a:p>
-                      <a:pPr algn="ctr"/>
-                      <a:r>
-                        <a:rPr sz="1400" b="0">
-                          <a:solidFill>
-                            <a:srgbClr val="222222"/>
-                          </a:solidFill>
-                          <a:latin typeface="Arial"/>
-                        </a:rPr>
-                        <a:t>12</a:t>
-                      </a:r>
-                    </a:p>
-                  </a:txBody>
-                  <a:tcPr anchor="ctr">
-                    <a:solidFill>
-                      <a:srgbClr val="F2F2F2"/>
-                    </a:solidFill>
-                  </a:tcPr>
-                </a:tc>
-                <a:tc>
-                  <a:txBody>
-                    <a:bodyPr wrap="square"/>
-                    <a:lstStyle/>
-                    <a:p>
-                      <a:pPr algn="ctr"/>
-                      <a:r>
-                        <a:rPr sz="1400" b="0">
-                          <a:solidFill>
-                            <a:srgbClr val="222222"/>
-                          </a:solidFill>
-                          <a:latin typeface="Arial"/>
-                        </a:rPr>
-                        <a:t>37</a:t>
-                      </a:r>
-                    </a:p>
-                  </a:txBody>
-                  <a:tcPr anchor="ctr">
-                    <a:solidFill>
-                      <a:srgbClr val="F2F2F2"/>
-                    </a:solidFill>
-                  </a:tcPr>
-                </a:tc>
-                <a:tc>
-                  <a:txBody>
-                    <a:bodyPr wrap="square"/>
-                    <a:lstStyle/>
-                    <a:p>
-                      <a:pPr algn="ctr"/>
-                      <a:r>
-                        <a:rPr sz="1400" b="0">
-                          <a:solidFill>
-                            <a:srgbClr val="222222"/>
-                          </a:solidFill>
-                          <a:latin typeface="Arial"/>
-                        </a:rPr>
-                        <a:t>81</a:t>
-                      </a:r>
-                    </a:p>
-                  </a:txBody>
-                  <a:tcPr anchor="ctr">
-                    <a:solidFill>
-                      <a:srgbClr val="F2F2F2"/>
-                    </a:solidFill>
-                  </a:tcPr>
-                </a:tc>
-              </a:tr>
-              <a:tr h="448056">
-                <a:tc>
-                  <a:txBody>
-                    <a:bodyPr wrap="square"/>
-                    <a:lstStyle/>
-                    <a:p>
-                      <a:pPr algn="l"/>
-                      <a:r>
-                        <a:rPr sz="1400" b="1">
-                          <a:solidFill>
-                            <a:srgbClr val="222222"/>
-                          </a:solidFill>
-                          <a:latin typeface="Arial"/>
-                        </a:rPr>
-                        <a:t>Consulta, latência (s)</a:t>
-                      </a:r>
-                    </a:p>
-                  </a:txBody>
-                  <a:tcPr anchor="ctr">
-                    <a:solidFill>
-                      <a:srgbClr val="FFFFFF"/>
-                    </a:solidFill>
-                  </a:tcPr>
-                </a:tc>
-                <a:tc>
-                  <a:txBody>
-                    <a:bodyPr wrap="square"/>
-                    <a:lstStyle/>
-                    <a:p>
-                      <a:pPr algn="ctr"/>
-                      <a:r>
-                        <a:rPr sz="1400" b="0">
-                          <a:solidFill>
-                            <a:srgbClr val="222222"/>
-                          </a:solidFill>
-                          <a:latin typeface="Arial"/>
-                        </a:rPr>
-                        <a:t>7</a:t>
-                      </a:r>
-                    </a:p>
-                  </a:txBody>
-                  <a:tcPr anchor="ctr">
-                    <a:solidFill>
-                      <a:srgbClr val="FFFFFF"/>
-                    </a:solidFill>
-                  </a:tcPr>
-                </a:tc>
-                <a:tc>
-                  <a:txBody>
-                    <a:bodyPr wrap="square"/>
-                    <a:lstStyle/>
-                    <a:p>
-                      <a:pPr algn="ctr"/>
-                      <a:r>
-                        <a:rPr sz="1400" b="0">
-                          <a:solidFill>
-                            <a:srgbClr val="222222"/>
-                          </a:solidFill>
-                          <a:latin typeface="Arial"/>
-                        </a:rPr>
-                        <a:t>49</a:t>
-                      </a:r>
-                    </a:p>
-                  </a:txBody>
-                  <a:tcPr anchor="ctr">
-                    <a:solidFill>
-                      <a:srgbClr val="FFFFFF"/>
-                    </a:solidFill>
-                  </a:tcPr>
-                </a:tc>
-                <a:tc>
-                  <a:txBody>
-                    <a:bodyPr wrap="square"/>
-                    <a:lstStyle/>
-                    <a:p>
-                      <a:pPr algn="ctr"/>
-                      <a:r>
-                        <a:rPr sz="1400" b="0">
-                          <a:solidFill>
-                            <a:srgbClr val="222222"/>
-                          </a:solidFill>
-                          <a:latin typeface="Arial"/>
-                        </a:rPr>
-                        <a:t>13</a:t>
-                      </a:r>
-                    </a:p>
-                  </a:txBody>
-                  <a:tcPr anchor="ctr">
-                    <a:solidFill>
-                      <a:srgbClr val="FFFFFF"/>
-                    </a:solidFill>
-                  </a:tcPr>
-                </a:tc>
-                <a:tc>
-                  <a:txBody>
-                    <a:bodyPr wrap="square"/>
-                    <a:lstStyle/>
-                    <a:p>
-                      <a:pPr algn="ctr"/>
-                      <a:r>
-                        <a:rPr sz="1400" b="0">
-                          <a:solidFill>
-                            <a:srgbClr val="222222"/>
-                          </a:solidFill>
-                          <a:latin typeface="Arial"/>
-                        </a:rPr>
-                        <a:t>24</a:t>
-                      </a:r>
-                    </a:p>
-                  </a:txBody>
-                  <a:tcPr anchor="ctr">
-                    <a:solidFill>
-                      <a:srgbClr val="FFFFFF"/>
-                    </a:solidFill>
-                  </a:tcPr>
-                </a:tc>
-              </a:tr>
-              <a:tr h="448056">
-                <a:tc>
-                  <a:txBody>
-                    <a:bodyPr wrap="square"/>
-                    <a:lstStyle/>
-                    <a:p>
-                      <a:pPr algn="l"/>
-                      <a:r>
-                        <a:rPr sz="1400" b="1">
-                          <a:solidFill>
-                            <a:srgbClr val="222222"/>
-                          </a:solidFill>
-                          <a:latin typeface="Arial"/>
-                        </a:rPr>
-                        <a:t>Ferramentas, latência (s)</a:t>
-                      </a:r>
-                    </a:p>
-                  </a:txBody>
-                  <a:tcPr anchor="ctr">
-                    <a:solidFill>
-                      <a:srgbClr val="E6EEF6"/>
-                    </a:solidFill>
-                  </a:tcPr>
-                </a:tc>
-                <a:tc>
-                  <a:txBody>
-                    <a:bodyPr wrap="square"/>
-                    <a:lstStyle/>
-                    <a:p>
-                      <a:pPr algn="ctr"/>
-                      <a:r>
-                        <a:rPr sz="1400" b="0">
-                          <a:solidFill>
-                            <a:srgbClr val="222222"/>
-                          </a:solidFill>
-                          <a:latin typeface="Arial"/>
-                        </a:rPr>
-                        <a:t>5</a:t>
-                      </a:r>
-                    </a:p>
-                  </a:txBody>
-                  <a:tcPr anchor="ctr">
-                    <a:solidFill>
-                      <a:srgbClr val="E6EEF6"/>
-                    </a:solidFill>
-                  </a:tcPr>
-                </a:tc>
-                <a:tc>
-                  <a:txBody>
-                    <a:bodyPr wrap="square"/>
-                    <a:lstStyle/>
-                    <a:p>
-                      <a:pPr algn="ctr"/>
-                      <a:r>
-                        <a:rPr sz="1400" b="0">
-                          <a:solidFill>
-                            <a:srgbClr val="222222"/>
-                          </a:solidFill>
-                          <a:latin typeface="Arial"/>
-                        </a:rPr>
-                        <a:t>23</a:t>
-                      </a:r>
-                    </a:p>
-                  </a:txBody>
-                  <a:tcPr anchor="ctr">
-                    <a:solidFill>
-                      <a:srgbClr val="E6EEF6"/>
-                    </a:solidFill>
-                  </a:tcPr>
-                </a:tc>
-                <a:tc>
-                  <a:txBody>
-                    <a:bodyPr wrap="square"/>
-                    <a:lstStyle/>
-                    <a:p>
-                      <a:pPr algn="ctr"/>
-                      <a:r>
-                        <a:rPr sz="1400" b="0">
-                          <a:solidFill>
-                            <a:srgbClr val="222222"/>
-                          </a:solidFill>
-                          <a:latin typeface="Arial"/>
-                        </a:rPr>
-                        <a:t>10</a:t>
-                      </a:r>
-                    </a:p>
-                  </a:txBody>
-                  <a:tcPr anchor="ctr">
-                    <a:solidFill>
-                      <a:srgbClr val="E6EEF6"/>
-                    </a:solidFill>
-                  </a:tcPr>
-                </a:tc>
-                <a:tc>
-                  <a:txBody>
-                    <a:bodyPr wrap="square"/>
-                    <a:lstStyle/>
-                    <a:p>
-                      <a:pPr algn="ctr"/>
-                      <a:r>
-                        <a:rPr sz="1400" b="0">
-                          <a:solidFill>
-                            <a:srgbClr val="222222"/>
-                          </a:solidFill>
-                          <a:latin typeface="Arial"/>
-                        </a:rPr>
-                        <a:t>15</a:t>
-                      </a:r>
-                    </a:p>
-                  </a:txBody>
-                  <a:tcPr anchor="ctr">
-                    <a:solidFill>
-                      <a:srgbClr val="E6EEF6"/>
-                    </a:solidFill>
-                  </a:tcPr>
-                </a:tc>
-              </a:tr>
-              <a:tr h="448056">
-                <a:tc>
-                  <a:txBody>
-                    <a:bodyPr wrap="square"/>
-                    <a:lstStyle/>
-                    <a:p>
-                      <a:pPr algn="l"/>
-                      <a:r>
-                        <a:rPr sz="1400" b="1">
-                          <a:solidFill>
-                            <a:srgbClr val="222222"/>
-                          </a:solidFill>
-                          <a:latin typeface="Arial"/>
-                        </a:rPr>
-                        <a:t>Contexto, entrada (mil tokens)</a:t>
-                      </a:r>
-                    </a:p>
-                  </a:txBody>
-                  <a:tcPr anchor="ctr">
-                    <a:solidFill>
-                      <a:srgbClr val="FFFFFF"/>
-                    </a:solidFill>
-                  </a:tcPr>
-                </a:tc>
-                <a:tc>
-                  <a:txBody>
-                    <a:bodyPr wrap="square"/>
-                    <a:lstStyle/>
-                    <a:p>
-                      <a:pPr algn="ctr"/>
-                      <a:r>
-                        <a:rPr sz="1400" b="0">
-                          <a:solidFill>
-                            <a:srgbClr val="222222"/>
-                          </a:solidFill>
-                          <a:latin typeface="Arial"/>
-                        </a:rPr>
-                        <a:t>111</a:t>
-                      </a:r>
-                    </a:p>
-                  </a:txBody>
-                  <a:tcPr anchor="ctr">
-                    <a:solidFill>
-                      <a:srgbClr val="FFFFFF"/>
-                    </a:solidFill>
-                  </a:tcPr>
-                </a:tc>
-                <a:tc>
-                  <a:txBody>
-                    <a:bodyPr wrap="square"/>
-                    <a:lstStyle/>
-                    <a:p>
-                      <a:pPr algn="ctr"/>
-                      <a:r>
-                        <a:rPr sz="1400" b="0">
-                          <a:solidFill>
-                            <a:srgbClr val="222222"/>
-                          </a:solidFill>
-                          <a:latin typeface="Arial"/>
-                        </a:rPr>
-                        <a:t>91</a:t>
-                      </a:r>
-                    </a:p>
-                  </a:txBody>
-                  <a:tcPr anchor="ctr">
-                    <a:solidFill>
-                      <a:srgbClr val="FFFFFF"/>
-                    </a:solidFill>
-                  </a:tcPr>
-                </a:tc>
-                <a:tc>
-                  <a:txBody>
-                    <a:bodyPr wrap="square"/>
-                    <a:lstStyle/>
-                    <a:p>
-                      <a:pPr algn="ctr"/>
-                      <a:r>
-                        <a:rPr sz="1400" b="0">
-                          <a:solidFill>
-                            <a:srgbClr val="222222"/>
-                          </a:solidFill>
-                          <a:latin typeface="Arial"/>
-                        </a:rPr>
-                        <a:t>90</a:t>
-                      </a:r>
-                    </a:p>
-                  </a:txBody>
-                  <a:tcPr anchor="ctr">
-                    <a:solidFill>
-                      <a:srgbClr val="FFFFFF"/>
-                    </a:solidFill>
-                  </a:tcPr>
-                </a:tc>
-                <a:tc>
-                  <a:txBody>
-                    <a:bodyPr wrap="square"/>
-                    <a:lstStyle/>
-                    <a:p>
-                      <a:pPr algn="ctr"/>
-                      <a:r>
-                        <a:rPr sz="1400" b="0">
-                          <a:solidFill>
-                            <a:srgbClr val="222222"/>
-                          </a:solidFill>
-                          <a:latin typeface="Arial"/>
-                        </a:rPr>
-                        <a:t>82</a:t>
-                      </a:r>
-                    </a:p>
-                  </a:txBody>
-                  <a:tcPr anchor="ctr">
-                    <a:solidFill>
-                      <a:srgbClr val="FFFFFF"/>
-                    </a:solidFill>
-                  </a:tcPr>
-                </a:tc>
-              </a:tr>
-              <a:tr h="448056">
-                <a:tc>
-                  <a:txBody>
-                    <a:bodyPr wrap="square"/>
-                    <a:lstStyle/>
-                    <a:p>
-                      <a:pPr algn="l"/>
-                      <a:r>
-                        <a:rPr sz="1400" b="1">
-                          <a:solidFill>
-                            <a:srgbClr val="222222"/>
-                          </a:solidFill>
-                          <a:latin typeface="Arial"/>
-                        </a:rPr>
-                        <a:t>Consulta, entrada (mil tokens)</a:t>
-                      </a:r>
-                    </a:p>
-                  </a:txBody>
-                  <a:tcPr anchor="ctr">
-                    <a:solidFill>
-                      <a:srgbClr val="F2F2F2"/>
-                    </a:solidFill>
-                  </a:tcPr>
-                </a:tc>
-                <a:tc>
-                  <a:txBody>
-                    <a:bodyPr wrap="square"/>
-                    <a:lstStyle/>
-                    <a:p>
-                      <a:pPr algn="ctr"/>
-                      <a:r>
-                        <a:rPr sz="1400" b="0">
-                          <a:solidFill>
-                            <a:srgbClr val="222222"/>
-                          </a:solidFill>
-                          <a:latin typeface="Arial"/>
-                        </a:rPr>
-                        <a:t>31</a:t>
-                      </a:r>
-                    </a:p>
-                  </a:txBody>
-                  <a:tcPr anchor="ctr">
-                    <a:solidFill>
-                      <a:srgbClr val="F2F2F2"/>
-                    </a:solidFill>
-                  </a:tcPr>
-                </a:tc>
-                <a:tc>
-                  <a:txBody>
-                    <a:bodyPr wrap="square"/>
-                    <a:lstStyle/>
-                    <a:p>
-                      <a:pPr algn="ctr"/>
-                      <a:r>
-                        <a:rPr sz="1400" b="0">
-                          <a:solidFill>
-                            <a:srgbClr val="222222"/>
-                          </a:solidFill>
-                          <a:latin typeface="Arial"/>
-                        </a:rPr>
-                        <a:t>97</a:t>
-                      </a:r>
-                    </a:p>
-                  </a:txBody>
-                  <a:tcPr anchor="ctr">
-                    <a:solidFill>
-                      <a:srgbClr val="F2F2F2"/>
-                    </a:solidFill>
-                  </a:tcPr>
-                </a:tc>
-                <a:tc>
-                  <a:txBody>
-                    <a:bodyPr wrap="square"/>
-                    <a:lstStyle/>
-                    <a:p>
-                      <a:pPr algn="ctr"/>
-                      <a:r>
-                        <a:rPr sz="1400" b="0">
-                          <a:solidFill>
-                            <a:srgbClr val="222222"/>
-                          </a:solidFill>
-                          <a:latin typeface="Arial"/>
-                        </a:rPr>
-                        <a:t>15</a:t>
-                      </a:r>
-                    </a:p>
-                  </a:txBody>
-                  <a:tcPr anchor="ctr">
-                    <a:solidFill>
-                      <a:srgbClr val="F2F2F2"/>
-                    </a:solidFill>
-                  </a:tcPr>
-                </a:tc>
-                <a:tc>
-                  <a:txBody>
-                    <a:bodyPr wrap="square"/>
-                    <a:lstStyle/>
-                    <a:p>
-                      <a:pPr algn="ctr"/>
-                      <a:r>
-                        <a:rPr sz="1400" b="0">
-                          <a:solidFill>
-                            <a:srgbClr val="222222"/>
-                          </a:solidFill>
-                          <a:latin typeface="Arial"/>
-                        </a:rPr>
-                        <a:t>15</a:t>
-                      </a:r>
-                    </a:p>
-                  </a:txBody>
-                  <a:tcPr anchor="ctr">
-                    <a:solidFill>
-                      <a:srgbClr val="F2F2F2"/>
-                    </a:solidFill>
-                  </a:tcPr>
-                </a:tc>
-              </a:tr>
-              <a:tr h="448056">
-                <a:tc>
-                  <a:txBody>
-                    <a:bodyPr wrap="square"/>
-                    <a:lstStyle/>
-                    <a:p>
-                      <a:pPr algn="l"/>
-                      <a:r>
-                        <a:rPr sz="1400" b="1">
-                          <a:solidFill>
-                            <a:srgbClr val="222222"/>
-                          </a:solidFill>
-                          <a:latin typeface="Arial"/>
-                        </a:rPr>
-                        <a:t>Ferramentas, entrada (mil tokens)</a:t>
-                      </a:r>
-                    </a:p>
-                  </a:txBody>
-                  <a:tcPr anchor="ctr">
-                    <a:solidFill>
-                      <a:srgbClr val="E6EEF6"/>
-                    </a:solidFill>
-                  </a:tcPr>
-                </a:tc>
-                <a:tc>
-                  <a:txBody>
-                    <a:bodyPr wrap="square"/>
-                    <a:lstStyle/>
-                    <a:p>
-                      <a:pPr algn="ctr"/>
-                      <a:r>
-                        <a:rPr sz="1400" b="0">
-                          <a:solidFill>
-                            <a:srgbClr val="222222"/>
-                          </a:solidFill>
-                          <a:latin typeface="Arial"/>
-                        </a:rPr>
-                        <a:t>41</a:t>
-                      </a:r>
-                    </a:p>
-                  </a:txBody>
-                  <a:tcPr anchor="ctr">
-                    <a:solidFill>
-                      <a:srgbClr val="E6EEF6"/>
-                    </a:solidFill>
-                  </a:tcPr>
-                </a:tc>
-                <a:tc>
-                  <a:txBody>
-                    <a:bodyPr wrap="square"/>
-                    <a:lstStyle/>
-                    <a:p>
-                      <a:pPr algn="ctr"/>
-                      <a:r>
-                        <a:rPr sz="1400" b="0">
-                          <a:solidFill>
-                            <a:srgbClr val="222222"/>
-                          </a:solidFill>
-                          <a:latin typeface="Arial"/>
-                        </a:rPr>
-                        <a:t>47</a:t>
-                      </a:r>
-                    </a:p>
-                  </a:txBody>
-                  <a:tcPr anchor="ctr">
-                    <a:solidFill>
-                      <a:srgbClr val="E6EEF6"/>
-                    </a:solidFill>
-                  </a:tcPr>
-                </a:tc>
-                <a:tc>
-                  <a:txBody>
-                    <a:bodyPr wrap="square"/>
-                    <a:lstStyle/>
-                    <a:p>
-                      <a:pPr algn="ctr"/>
-                      <a:r>
-                        <a:rPr sz="1400" b="0">
-                          <a:solidFill>
-                            <a:srgbClr val="222222"/>
-                          </a:solidFill>
-                          <a:latin typeface="Arial"/>
-                        </a:rPr>
-                        <a:t>22</a:t>
-                      </a:r>
-                    </a:p>
-                  </a:txBody>
-                  <a:tcPr anchor="ctr">
-                    <a:solidFill>
-                      <a:srgbClr val="E6EEF6"/>
-                    </a:solidFill>
-                  </a:tcPr>
-                </a:tc>
-                <a:tc>
-                  <a:txBody>
-                    <a:bodyPr wrap="square"/>
-                    <a:lstStyle/>
-                    <a:p>
-                      <a:pPr algn="ctr"/>
-                      <a:r>
-                        <a:rPr sz="1400" b="0">
-                          <a:solidFill>
-                            <a:srgbClr val="222222"/>
-                          </a:solidFill>
-                          <a:latin typeface="Arial"/>
-                        </a:rPr>
-                        <a:t>27</a:t>
-                      </a:r>
-                    </a:p>
-                  </a:txBody>
-                  <a:tcPr anchor="ctr">
-                    <a:solidFill>
-                      <a:srgbClr val="E6EEF6"/>
-                    </a:solidFill>
-                  </a:tcPr>
-                </a:tc>
-              </a:tr>
-            </a:tbl>
+          <a:graphicData uri="http://schemas.openxmlformats.org/drawingml/2006/chart">
+            <c:chart xmlns:c="http://schemas.openxmlformats.org/drawingml/2006/chart" r:id="rId3"/>
           </a:graphicData>
         </a:graphic>
       </p:graphicFrame>

</xml_diff>

<commit_message>
Rework next steps slide: general, industrial data as one point
Co-Authored-By: Claude Sonnet 5.5 <noreply@anthropic.com>
Claude-Session: https://claude.ai/code/session_01FjZonbKdsyoySM9nwRFtHf
</commit_message>
<xml_diff>
--- a/apresentacao/apresentacao.pptx
+++ b/apresentacao/apresentacao.pptx
@@ -2207,7 +2207,7 @@
           <a:lstStyle/>
           <a:p>
             <a:r>
-              <a:t>[1:15] Fecho. Parte dos dados industriais tem a forma dos dados de futebol: registros de eventos com agente, momento e local, ligados entre si, como as paradas, os alertas e as movimentações de uma linha de produção ou de uma frota. Como o resultado do futebol mostra que a forma de levar os dados ao contexto pesa tanto quanto o modelo, testar as seis abordagens nesses dados é o passo natural para uma pós em IA aplicada à indústria. O que não transfere de graça: a preparação dos dados, o grafo e as ferramentas dependem das perguntas que se quer responder, então exige implementação própria para o domínio. A tabela de correspondência é uma proposta de analogia, não um resultado.</a:t>
+              <a:t>[1:15] Fecho. Três frentes, todas ligadas às limitações. Primeira, mais evidência: repetir as execuções mede a variação entre rodadas e permite testar as diferenças entre abordagens, e estender as perguntas a várias partidas tira a dependência de uma só. Segunda, separar efeitos: avaliar modelos maiores sem raciocínio estendido separa o efeito do tamanho do efeito do raciocínio; aplicar as mesmas ferramentas a uma tabela, sem o grafo, separa o efeito das ferramentas do efeito do grafo; e testar uma busca vetorial em que cada trecho traga também os eventos vizinhos, como em Tzikas et al., responde à lacuna da Busca vetorial. Terceira, outros domínios, entre eles os dados industriais: parte deles tem a forma dos dados de futebol, registros de eventos com agente, momento e local, ligados entre si, como as paradas, os alertas e as movimentações de uma linha de produção ou de uma frota. Testar as mesmas abordagens ali é um próximo passo natural para uma pós em IA aplicada à indústria, mas exige implementação própria: a preparação dos dados, o grafo e as ferramentas dependem das perguntas que se quer responder.</a:t>
             </a:r>
           </a:p>
         </p:txBody>
@@ -7878,7 +7878,7 @@
                 </a:solidFill>
                 <a:latin typeface="Arial"/>
               </a:rPr>
-              <a:t>Próximo passo: testar as mesmas abordagens em dados industriais</a:t>
+              <a:t>Próximos passos: mais evidência, efeitos separados e outros domínios</a:t>
             </a:r>
           </a:p>
         </p:txBody>
@@ -7965,330 +7965,353 @@
           </a:p>
         </p:txBody>
       </p:sp>
-      <p:graphicFrame>
-        <p:nvGraphicFramePr>
-          <p:cNvPr id="5" name="Table 4"/>
-          <p:cNvGraphicFramePr>
-            <a:graphicFrameLocks noGrp="1"/>
-          </p:cNvGraphicFramePr>
-          <p:nvPr/>
-        </p:nvGraphicFramePr>
-        <p:xfrm>
-          <a:off x="640080" y="1554480"/>
-          <a:ext cx="6766560" cy="3840480"/>
-        </p:xfrm>
-        <a:graphic>
-          <a:graphicData uri="http://schemas.openxmlformats.org/drawingml/2006/table">
-            <a:tbl>
-              <a:tblPr firstRow="0" bandRow="0">
-                <a:tableStyleId>{5C22544A-7EE6-4342-B048-85BDC9FD1C3A}</a:tableStyleId>
-              </a:tblPr>
-              <a:tblGrid>
-                <a:gridCol w="2743200"/>
-                <a:gridCol w="4023360"/>
-              </a:tblGrid>
-              <a:tr h="640080">
-                <a:tc>
-                  <a:txBody>
-                    <a:bodyPr wrap="square"/>
-                    <a:lstStyle/>
-                    <a:p>
-                      <a:pPr algn="l"/>
-                      <a:r>
-                        <a:rPr sz="1700" b="1">
-                          <a:solidFill>
-                            <a:srgbClr val="FFFFFF"/>
-                          </a:solidFill>
-                          <a:latin typeface="Arial"/>
-                        </a:rPr>
-                        <a:t>No futebol</a:t>
-                      </a:r>
-                    </a:p>
-                  </a:txBody>
-                  <a:tcPr anchor="ctr">
-                    <a:solidFill>
-                      <a:srgbClr val="222222"/>
-                    </a:solidFill>
-                  </a:tcPr>
-                </a:tc>
-                <a:tc>
-                  <a:txBody>
-                    <a:bodyPr wrap="square"/>
-                    <a:lstStyle/>
-                    <a:p>
-                      <a:pPr algn="l"/>
-                      <a:r>
-                        <a:rPr sz="1700" b="1">
-                          <a:solidFill>
-                            <a:srgbClr val="FFFFFF"/>
-                          </a:solidFill>
-                          <a:latin typeface="Arial"/>
-                        </a:rPr>
-                        <a:t>Em dados industriais (proposta)</a:t>
-                      </a:r>
-                    </a:p>
-                  </a:txBody>
-                  <a:tcPr anchor="ctr">
-                    <a:solidFill>
-                      <a:srgbClr val="222222"/>
-                    </a:solidFill>
-                  </a:tcPr>
-                </a:tc>
-              </a:tr>
-              <a:tr h="640080">
-                <a:tc>
-                  <a:txBody>
-                    <a:bodyPr wrap="square"/>
-                    <a:lstStyle/>
-                    <a:p>
-                      <a:pPr algn="l"/>
-                      <a:r>
-                        <a:rPr sz="1700" b="1">
-                          <a:solidFill>
-                            <a:srgbClr val="222222"/>
-                          </a:solidFill>
-                          <a:latin typeface="Arial"/>
-                        </a:rPr>
-                        <a:t>Jogador</a:t>
-                      </a:r>
-                    </a:p>
-                  </a:txBody>
-                  <a:tcPr anchor="ctr">
-                    <a:solidFill>
-                      <a:srgbClr val="FFFFFF"/>
-                    </a:solidFill>
-                  </a:tcPr>
-                </a:tc>
-                <a:tc>
-                  <a:txBody>
-                    <a:bodyPr wrap="square"/>
-                    <a:lstStyle/>
-                    <a:p>
-                      <a:pPr algn="l"/>
-                      <a:r>
-                        <a:rPr sz="1700" b="0">
-                          <a:solidFill>
-                            <a:srgbClr val="222222"/>
-                          </a:solidFill>
-                          <a:latin typeface="Arial"/>
-                        </a:rPr>
-                        <a:t>máquina, operador ou veículo</a:t>
-                      </a:r>
-                    </a:p>
-                  </a:txBody>
-                  <a:tcPr anchor="ctr">
-                    <a:solidFill>
-                      <a:srgbClr val="FFFFFF"/>
-                    </a:solidFill>
-                  </a:tcPr>
-                </a:tc>
-              </a:tr>
-              <a:tr h="640080">
-                <a:tc>
-                  <a:txBody>
-                    <a:bodyPr wrap="square"/>
-                    <a:lstStyle/>
-                    <a:p>
-                      <a:pPr algn="l"/>
-                      <a:r>
-                        <a:rPr sz="1700" b="1">
-                          <a:solidFill>
-                            <a:srgbClr val="222222"/>
-                          </a:solidFill>
-                          <a:latin typeface="Arial"/>
-                        </a:rPr>
-                        <a:t>Minuto da partida</a:t>
-                      </a:r>
-                    </a:p>
-                  </a:txBody>
-                  <a:tcPr anchor="ctr">
-                    <a:solidFill>
-                      <a:srgbClr val="F2F2F2"/>
-                    </a:solidFill>
-                  </a:tcPr>
-                </a:tc>
-                <a:tc>
-                  <a:txBody>
-                    <a:bodyPr wrap="square"/>
-                    <a:lstStyle/>
-                    <a:p>
-                      <a:pPr algn="l"/>
-                      <a:r>
-                        <a:rPr sz="1700" b="0">
-                          <a:solidFill>
-                            <a:srgbClr val="222222"/>
-                          </a:solidFill>
-                          <a:latin typeface="Arial"/>
-                        </a:rPr>
-                        <a:t>carimbo de tempo do registro</a:t>
-                      </a:r>
-                    </a:p>
-                  </a:txBody>
-                  <a:tcPr anchor="ctr">
-                    <a:solidFill>
-                      <a:srgbClr val="F2F2F2"/>
-                    </a:solidFill>
-                  </a:tcPr>
-                </a:tc>
-              </a:tr>
-              <a:tr h="640080">
-                <a:tc>
-                  <a:txBody>
-                    <a:bodyPr wrap="square"/>
-                    <a:lstStyle/>
-                    <a:p>
-                      <a:pPr algn="l"/>
-                      <a:r>
-                        <a:rPr sz="1700" b="1">
-                          <a:solidFill>
-                            <a:srgbClr val="222222"/>
-                          </a:solidFill>
-                          <a:latin typeface="Arial"/>
-                        </a:rPr>
-                        <a:t>Zona do campo</a:t>
-                      </a:r>
-                    </a:p>
-                  </a:txBody>
-                  <a:tcPr anchor="ctr">
-                    <a:solidFill>
-                      <a:srgbClr val="FFFFFF"/>
-                    </a:solidFill>
-                  </a:tcPr>
-                </a:tc>
-                <a:tc>
-                  <a:txBody>
-                    <a:bodyPr wrap="square"/>
-                    <a:lstStyle/>
-                    <a:p>
-                      <a:pPr algn="l"/>
-                      <a:r>
-                        <a:rPr sz="1700" b="0">
-                          <a:solidFill>
-                            <a:srgbClr val="222222"/>
-                          </a:solidFill>
-                          <a:latin typeface="Arial"/>
-                        </a:rPr>
-                        <a:t>posto, linha ou rota</a:t>
-                      </a:r>
-                    </a:p>
-                  </a:txBody>
-                  <a:tcPr anchor="ctr">
-                    <a:solidFill>
-                      <a:srgbClr val="FFFFFF"/>
-                    </a:solidFill>
-                  </a:tcPr>
-                </a:tc>
-              </a:tr>
-              <a:tr h="640080">
-                <a:tc>
-                  <a:txBody>
-                    <a:bodyPr wrap="square"/>
-                    <a:lstStyle/>
-                    <a:p>
-                      <a:pPr algn="l"/>
-                      <a:r>
-                        <a:rPr sz="1700" b="1">
-                          <a:solidFill>
-                            <a:srgbClr val="222222"/>
-                          </a:solidFill>
-                          <a:latin typeface="Arial"/>
-                        </a:rPr>
-                        <a:t>Passe entre dois jogadores</a:t>
-                      </a:r>
-                    </a:p>
-                  </a:txBody>
-                  <a:tcPr anchor="ctr">
-                    <a:solidFill>
-                      <a:srgbClr val="F2F2F2"/>
-                    </a:solidFill>
-                  </a:tcPr>
-                </a:tc>
-                <a:tc>
-                  <a:txBody>
-                    <a:bodyPr wrap="square"/>
-                    <a:lstStyle/>
-                    <a:p>
-                      <a:pPr algn="l"/>
-                      <a:r>
-                        <a:rPr sz="1700" b="0">
-                          <a:solidFill>
-                            <a:srgbClr val="222222"/>
-                          </a:solidFill>
-                          <a:latin typeface="Arial"/>
-                        </a:rPr>
-                        <a:t>evento que liga dois agentes (parada, alerta, movimentação)</a:t>
-                      </a:r>
-                    </a:p>
-                  </a:txBody>
-                  <a:tcPr anchor="ctr">
-                    <a:solidFill>
-                      <a:srgbClr val="F2F2F2"/>
-                    </a:solidFill>
-                  </a:tcPr>
-                </a:tc>
-              </a:tr>
-              <a:tr h="640080">
-                <a:tc>
-                  <a:txBody>
-                    <a:bodyPr wrap="square"/>
-                    <a:lstStyle/>
-                    <a:p>
-                      <a:pPr algn="l"/>
-                      <a:r>
-                        <a:rPr sz="1700" b="1">
-                          <a:solidFill>
-                            <a:srgbClr val="222222"/>
-                          </a:solidFill>
-                          <a:latin typeface="Arial"/>
-                        </a:rPr>
-                        <a:t>Jogada: sequência de ações</a:t>
-                      </a:r>
-                    </a:p>
-                  </a:txBody>
-                  <a:tcPr anchor="ctr">
-                    <a:solidFill>
-                      <a:srgbClr val="FFFFFF"/>
-                    </a:solidFill>
-                  </a:tcPr>
-                </a:tc>
-                <a:tc>
-                  <a:txBody>
-                    <a:bodyPr wrap="square"/>
-                    <a:lstStyle/>
-                    <a:p>
-                      <a:pPr algn="l"/>
-                      <a:r>
-                        <a:rPr sz="1700" b="0">
-                          <a:solidFill>
-                            <a:srgbClr val="222222"/>
-                          </a:solidFill>
-                          <a:latin typeface="Arial"/>
-                        </a:rPr>
-                        <a:t>sequência de eventos até uma parada ou falha</a:t>
-                      </a:r>
-                    </a:p>
-                  </a:txBody>
-                  <a:tcPr anchor="ctr">
-                    <a:solidFill>
-                      <a:srgbClr val="FFFFFF"/>
-                    </a:solidFill>
-                  </a:tcPr>
-                </a:tc>
-              </a:tr>
-            </a:tbl>
-          </a:graphicData>
-        </a:graphic>
-      </p:graphicFrame>
-      <p:sp>
-        <p:nvSpPr>
-          <p:cNvPr id="6" name="Rectangle 5"/>
+      <p:sp>
+        <p:nvSpPr>
+          <p:cNvPr id="5" name="Rectangle 4"/>
           <p:cNvSpPr/>
           <p:nvPr/>
         </p:nvSpPr>
         <p:spPr>
           <a:xfrm>
-            <a:off x="7680960" y="1554480"/>
-            <a:ext cx="3840480" cy="3840480"/>
+            <a:off x="640080" y="1554480"/>
+            <a:ext cx="3474720" cy="4206240"/>
+          </a:xfrm>
+          <a:prstGeom prst="rect">
+            <a:avLst/>
+          </a:prstGeom>
+          <a:solidFill>
+            <a:srgbClr val="F2F2F2"/>
+          </a:solidFill>
+          <a:ln>
+            <a:noFill/>
+          </a:ln>
+          <a:effectLst/>
+        </p:spPr>
+        <p:style>
+          <a:lnRef idx="1">
+            <a:schemeClr val="accent1"/>
+          </a:lnRef>
+          <a:fillRef idx="3">
+            <a:schemeClr val="accent1"/>
+          </a:fillRef>
+          <a:effectRef idx="2">
+            <a:schemeClr val="accent1"/>
+          </a:effectRef>
+          <a:fontRef idx="minor">
+            <a:schemeClr val="lt1"/>
+          </a:fontRef>
+        </p:style>
+        <p:txBody>
+          <a:bodyPr rtlCol="0" anchor="ctr"/>
+          <a:lstStyle/>
+          <a:p>
+            <a:pPr algn="ctr"/>
+          </a:p>
+        </p:txBody>
+      </p:sp>
+      <p:sp>
+        <p:nvSpPr>
+          <p:cNvPr id="6" name="TextBox 5"/>
+          <p:cNvSpPr txBox="1"/>
+          <p:nvPr/>
+        </p:nvSpPr>
+        <p:spPr>
+          <a:xfrm>
+            <a:off x="777240" y="1645920"/>
+            <a:ext cx="3200400" cy="457200"/>
+          </a:xfrm>
+          <a:prstGeom prst="rect">
+            <a:avLst/>
+          </a:prstGeom>
+          <a:noFill/>
+        </p:spPr>
+        <p:txBody>
+          <a:bodyPr wrap="square" anchor="t" lIns="45720" rIns="45720">
+            <a:spAutoFit/>
+          </a:bodyPr>
+          <a:lstStyle/>
+          <a:p>
+            <a:pPr algn="l">
+              <a:spcAft>
+                <a:spcPts val="600"/>
+              </a:spcAft>
+            </a:pPr>
+            <a:r>
+              <a:rPr sz="2000" b="1">
+                <a:solidFill>
+                  <a:srgbClr val="1F5C99"/>
+                </a:solidFill>
+                <a:latin typeface="Arial"/>
+              </a:rPr>
+              <a:t>Mais evidência</a:t>
+            </a:r>
+          </a:p>
+        </p:txBody>
+      </p:sp>
+      <p:sp>
+        <p:nvSpPr>
+          <p:cNvPr id="7" name="TextBox 6"/>
+          <p:cNvSpPr txBox="1"/>
+          <p:nvPr/>
+        </p:nvSpPr>
+        <p:spPr>
+          <a:xfrm>
+            <a:off x="777240" y="2240280"/>
+            <a:ext cx="3200400" cy="3474720"/>
+          </a:xfrm>
+          <a:prstGeom prst="rect">
+            <a:avLst/>
+          </a:prstGeom>
+          <a:noFill/>
+        </p:spPr>
+        <p:txBody>
+          <a:bodyPr wrap="square">
+            <a:spAutoFit/>
+          </a:bodyPr>
+          <a:lstStyle/>
+          <a:p>
+            <a:pPr>
+              <a:spcAft>
+                <a:spcPts val="1400"/>
+              </a:spcAft>
+            </a:pPr>
+            <a:r>
+              <a:rPr sz="1800" b="1">
+                <a:solidFill>
+                  <a:srgbClr val="1F5C99"/>
+                </a:solidFill>
+                <a:latin typeface="Arial"/>
+              </a:rPr>
+              <a:t>• </a:t>
+            </a:r>
+            <a:r>
+              <a:rPr sz="1800" b="0">
+                <a:solidFill>
+                  <a:srgbClr val="222222"/>
+                </a:solidFill>
+                <a:latin typeface="Arial"/>
+              </a:rPr>
+              <a:t>Repetir as execuções: medir a variação entre rodadas e testar as diferenças entre abordagens.</a:t>
+            </a:r>
+          </a:p>
+          <a:p>
+            <a:pPr>
+              <a:spcAft>
+                <a:spcPts val="1400"/>
+              </a:spcAft>
+            </a:pPr>
+            <a:r>
+              <a:rPr sz="1800" b="1">
+                <a:solidFill>
+                  <a:srgbClr val="1F5C99"/>
+                </a:solidFill>
+                <a:latin typeface="Arial"/>
+              </a:rPr>
+              <a:t>• </a:t>
+            </a:r>
+            <a:r>
+              <a:rPr sz="1800" b="0">
+                <a:solidFill>
+                  <a:srgbClr val="222222"/>
+                </a:solidFill>
+                <a:latin typeface="Arial"/>
+              </a:rPr>
+              <a:t>Estender as perguntas a várias partidas.</a:t>
+            </a:r>
+          </a:p>
+        </p:txBody>
+      </p:sp>
+      <p:sp>
+        <p:nvSpPr>
+          <p:cNvPr id="8" name="Rectangle 7"/>
+          <p:cNvSpPr/>
+          <p:nvPr/>
+        </p:nvSpPr>
+        <p:spPr>
+          <a:xfrm>
+            <a:off x="4343400" y="1554480"/>
+            <a:ext cx="3474720" cy="4206240"/>
+          </a:xfrm>
+          <a:prstGeom prst="rect">
+            <a:avLst/>
+          </a:prstGeom>
+          <a:solidFill>
+            <a:srgbClr val="F2F2F2"/>
+          </a:solidFill>
+          <a:ln>
+            <a:noFill/>
+          </a:ln>
+          <a:effectLst/>
+        </p:spPr>
+        <p:style>
+          <a:lnRef idx="1">
+            <a:schemeClr val="accent1"/>
+          </a:lnRef>
+          <a:fillRef idx="3">
+            <a:schemeClr val="accent1"/>
+          </a:fillRef>
+          <a:effectRef idx="2">
+            <a:schemeClr val="accent1"/>
+          </a:effectRef>
+          <a:fontRef idx="minor">
+            <a:schemeClr val="lt1"/>
+          </a:fontRef>
+        </p:style>
+        <p:txBody>
+          <a:bodyPr rtlCol="0" anchor="ctr"/>
+          <a:lstStyle/>
+          <a:p>
+            <a:pPr algn="ctr"/>
+          </a:p>
+        </p:txBody>
+      </p:sp>
+      <p:sp>
+        <p:nvSpPr>
+          <p:cNvPr id="9" name="TextBox 8"/>
+          <p:cNvSpPr txBox="1"/>
+          <p:nvPr/>
+        </p:nvSpPr>
+        <p:spPr>
+          <a:xfrm>
+            <a:off x="4480560" y="1645920"/>
+            <a:ext cx="3200400" cy="457200"/>
+          </a:xfrm>
+          <a:prstGeom prst="rect">
+            <a:avLst/>
+          </a:prstGeom>
+          <a:noFill/>
+        </p:spPr>
+        <p:txBody>
+          <a:bodyPr wrap="square" anchor="t" lIns="45720" rIns="45720">
+            <a:spAutoFit/>
+          </a:bodyPr>
+          <a:lstStyle/>
+          <a:p>
+            <a:pPr algn="l">
+              <a:spcAft>
+                <a:spcPts val="600"/>
+              </a:spcAft>
+            </a:pPr>
+            <a:r>
+              <a:rPr sz="2000" b="1">
+                <a:solidFill>
+                  <a:srgbClr val="1F5C99"/>
+                </a:solidFill>
+                <a:latin typeface="Arial"/>
+              </a:rPr>
+              <a:t>Separar os efeitos</a:t>
+            </a:r>
+          </a:p>
+        </p:txBody>
+      </p:sp>
+      <p:sp>
+        <p:nvSpPr>
+          <p:cNvPr id="10" name="TextBox 9"/>
+          <p:cNvSpPr txBox="1"/>
+          <p:nvPr/>
+        </p:nvSpPr>
+        <p:spPr>
+          <a:xfrm>
+            <a:off x="4480560" y="2240280"/>
+            <a:ext cx="3200400" cy="3474720"/>
+          </a:xfrm>
+          <a:prstGeom prst="rect">
+            <a:avLst/>
+          </a:prstGeom>
+          <a:noFill/>
+        </p:spPr>
+        <p:txBody>
+          <a:bodyPr wrap="square">
+            <a:spAutoFit/>
+          </a:bodyPr>
+          <a:lstStyle/>
+          <a:p>
+            <a:pPr>
+              <a:spcAft>
+                <a:spcPts val="1400"/>
+              </a:spcAft>
+            </a:pPr>
+            <a:r>
+              <a:rPr sz="1800" b="1">
+                <a:solidFill>
+                  <a:srgbClr val="1F5C99"/>
+                </a:solidFill>
+                <a:latin typeface="Arial"/>
+              </a:rPr>
+              <a:t>• </a:t>
+            </a:r>
+            <a:r>
+              <a:rPr sz="1800" b="0">
+                <a:solidFill>
+                  <a:srgbClr val="222222"/>
+                </a:solidFill>
+                <a:latin typeface="Arial"/>
+              </a:rPr>
+              <a:t>Modelos maiores sem raciocínio estendido: tamanho ou raciocínio?</a:t>
+            </a:r>
+          </a:p>
+          <a:p>
+            <a:pPr>
+              <a:spcAft>
+                <a:spcPts val="1400"/>
+              </a:spcAft>
+            </a:pPr>
+            <a:r>
+              <a:rPr sz="1800" b="1">
+                <a:solidFill>
+                  <a:srgbClr val="1F5C99"/>
+                </a:solidFill>
+                <a:latin typeface="Arial"/>
+              </a:rPr>
+              <a:t>• </a:t>
+            </a:r>
+            <a:r>
+              <a:rPr sz="1800" b="0">
+                <a:solidFill>
+                  <a:srgbClr val="222222"/>
+                </a:solidFill>
+                <a:latin typeface="Arial"/>
+              </a:rPr>
+              <a:t>As mesmas ferramentas sobre uma tabela, sem o grafo: ferramentas ou grafo?</a:t>
+            </a:r>
+          </a:p>
+          <a:p>
+            <a:pPr>
+              <a:spcAft>
+                <a:spcPts val="1400"/>
+              </a:spcAft>
+            </a:pPr>
+            <a:r>
+              <a:rPr sz="1800" b="1">
+                <a:solidFill>
+                  <a:srgbClr val="1F5C99"/>
+                </a:solidFill>
+                <a:latin typeface="Arial"/>
+              </a:rPr>
+              <a:t>• </a:t>
+            </a:r>
+            <a:r>
+              <a:rPr sz="1800" b="0">
+                <a:solidFill>
+                  <a:srgbClr val="222222"/>
+                </a:solidFill>
+                <a:latin typeface="Arial"/>
+              </a:rPr>
+              <a:t>Busca vetorial com os eventos vizinhos em cada trecho.</a:t>
+            </a:r>
+          </a:p>
+        </p:txBody>
+      </p:sp>
+      <p:sp>
+        <p:nvSpPr>
+          <p:cNvPr id="11" name="Rectangle 10"/>
+          <p:cNvSpPr/>
+          <p:nvPr/>
+        </p:nvSpPr>
+        <p:spPr>
+          <a:xfrm>
+            <a:off x="8046720" y="1554480"/>
+            <a:ext cx="3474720" cy="4206240"/>
           </a:xfrm>
           <a:prstGeom prst="rect">
             <a:avLst/>
@@ -8325,101 +8348,14 @@
       </p:sp>
       <p:sp>
         <p:nvSpPr>
-          <p:cNvPr id="7" name="TextBox 6"/>
+          <p:cNvPr id="12" name="TextBox 11"/>
           <p:cNvSpPr txBox="1"/>
           <p:nvPr/>
         </p:nvSpPr>
         <p:spPr>
           <a:xfrm>
-            <a:off x="7818120" y="1645920"/>
-            <a:ext cx="3566160" cy="3657600"/>
-          </a:xfrm>
-          <a:prstGeom prst="rect">
-            <a:avLst/>
-          </a:prstGeom>
-          <a:noFill/>
-        </p:spPr>
-        <p:txBody>
-          <a:bodyPr wrap="square" anchor="t" lIns="45720" rIns="45720">
-            <a:spAutoFit/>
-          </a:bodyPr>
-          <a:lstStyle/>
-          <a:p>
-            <a:pPr algn="l">
-              <a:spcAft>
-                <a:spcPts val="1000"/>
-              </a:spcAft>
-            </a:pPr>
-            <a:r>
-              <a:rPr sz="2000" b="1">
-                <a:solidFill>
-                  <a:srgbClr val="1F5C99"/>
-                </a:solidFill>
-                <a:latin typeface="Arial"/>
-              </a:rPr>
-              <a:t>O que testar</a:t>
-            </a:r>
-          </a:p>
-          <a:p>
-            <a:pPr algn="l">
-              <a:spcAft>
-                <a:spcPts val="1000"/>
-              </a:spcAft>
-            </a:pPr>
-            <a:r>
-              <a:rPr sz="1700" b="0">
-                <a:solidFill>
-                  <a:srgbClr val="222222"/>
-                </a:solidFill>
-                <a:latin typeface="Arial"/>
-              </a:rPr>
-              <a:t>As 6 abordagens, nos mesmos moldes.</a:t>
-            </a:r>
-          </a:p>
-          <a:p>
-            <a:pPr algn="l">
-              <a:spcAft>
-                <a:spcPts val="1000"/>
-              </a:spcAft>
-            </a:pPr>
-            <a:r>
-              <a:rPr sz="1700" b="0">
-                <a:solidFill>
-                  <a:srgbClr val="222222"/>
-                </a:solidFill>
-                <a:latin typeface="Arial"/>
-              </a:rPr>
-              <a:t>Exige preparação dos dados, grafo e ferramentas próprios do domínio.</a:t>
-            </a:r>
-          </a:p>
-          <a:p>
-            <a:pPr algn="l">
-              <a:spcAft>
-                <a:spcPts val="1000"/>
-              </a:spcAft>
-            </a:pPr>
-            <a:r>
-              <a:rPr sz="1700" b="0">
-                <a:solidFill>
-                  <a:srgbClr val="222222"/>
-                </a:solidFill>
-                <a:latin typeface="Arial"/>
-              </a:rPr>
-              <a:t>A forma de levar os dados ao modelo pode pesar tanto quanto pesou no futebol.</a:t>
-            </a:r>
-          </a:p>
-        </p:txBody>
-      </p:sp>
-      <p:sp>
-        <p:nvSpPr>
-          <p:cNvPr id="8" name="TextBox 7"/>
-          <p:cNvSpPr txBox="1"/>
-          <p:nvPr/>
-        </p:nvSpPr>
-        <p:spPr>
-          <a:xfrm>
-            <a:off x="640080" y="5577840"/>
-            <a:ext cx="10881360" cy="640080"/>
+            <a:off x="8183880" y="1645920"/>
+            <a:ext cx="3200400" cy="457200"/>
           </a:xfrm>
           <a:prstGeom prst="rect">
             <a:avLst/>
@@ -8438,13 +8374,86 @@
               </a:spcAft>
             </a:pPr>
             <a:r>
-              <a:rPr sz="1400" b="0">
-                <a:solidFill>
-                  <a:srgbClr val="666666"/>
-                </a:solidFill>
-                <a:latin typeface="Arial"/>
-              </a:rPr>
-              <a:t>Também: várias partidas, repetições, modelos maiores sem raciocínio estendido, ferramentas sobre tabela e busca vetorial com eventos vizinhos.</a:t>
+              <a:rPr sz="2000" b="1">
+                <a:solidFill>
+                  <a:srgbClr val="1F5C99"/>
+                </a:solidFill>
+                <a:latin typeface="Arial"/>
+              </a:rPr>
+              <a:t>Outros domínios</a:t>
+            </a:r>
+          </a:p>
+        </p:txBody>
+      </p:sp>
+      <p:sp>
+        <p:nvSpPr>
+          <p:cNvPr id="13" name="TextBox 12"/>
+          <p:cNvSpPr txBox="1"/>
+          <p:nvPr/>
+        </p:nvSpPr>
+        <p:spPr>
+          <a:xfrm>
+            <a:off x="8183880" y="2240280"/>
+            <a:ext cx="3200400" cy="3474720"/>
+          </a:xfrm>
+          <a:prstGeom prst="rect">
+            <a:avLst/>
+          </a:prstGeom>
+          <a:noFill/>
+        </p:spPr>
+        <p:txBody>
+          <a:bodyPr wrap="square">
+            <a:spAutoFit/>
+          </a:bodyPr>
+          <a:lstStyle/>
+          <a:p>
+            <a:pPr>
+              <a:spcAft>
+                <a:spcPts val="1400"/>
+              </a:spcAft>
+            </a:pPr>
+            <a:r>
+              <a:rPr sz="1800" b="1">
+                <a:solidFill>
+                  <a:srgbClr val="1F5C99"/>
+                </a:solidFill>
+                <a:latin typeface="Arial"/>
+              </a:rPr>
+              <a:t>• </a:t>
+            </a:r>
+            <a:r>
+              <a:rPr sz="1800" b="0">
+                <a:solidFill>
+                  <a:srgbClr val="222222"/>
+                </a:solidFill>
+                <a:latin typeface="Arial"/>
+              </a:rPr>
+              <a:t>Dados industriais: registros de eventos com agente, momento e local, como paradas, alertas e movimentações.</a:t>
+            </a:r>
+          </a:p>
+          <a:p>
+            <a:pPr>
+              <a:spcAft>
+                <a:spcPts val="1400"/>
+              </a:spcAft>
+            </a:pPr>
+            <a:r>
+              <a:rPr sz="1800" b="1">
+                <a:solidFill>
+                  <a:srgbClr val="1F5C99"/>
+                </a:solidFill>
+                <a:latin typeface="Arial"/>
+              </a:rPr>
+              <a:t>• </a:t>
+            </a:r>
+            <a:r>
+              <a:rPr sz="1800" b="0">
+                <a:solidFill>
+                  <a:srgbClr val="222222"/>
+                </a:solidFill>
+                <a:latin typeface="Arial"/>
+              </a:rPr>
+              <a:t>Exige preparação dos dados, grafo e ferramentas próprios do domínio.</a:t>
             </a:r>
           </a:p>
         </p:txBody>

</xml_diff>

<commit_message>
Improve deck legibility: larger fonts, field figure, CI bars
Co-Authored-By: Claude Sonnet 5.5 <noreply@anthropic.com>
Claude-Session: https://claude.ai/code/session_01FjZonbKdsyoySM9nwRFtHf
</commit_message>
<xml_diff>
--- a/apresentacao/apresentacao.pptx
+++ b/apresentacao/apresentacao.pptx
@@ -139,14 +139,14 @@
               <c:strCache>
                 <c:ptCount val="1"/>
                 <c:pt idx="0">
-                  <c:v>Sem dados</c:v>
+                  <c:v>Contexto longo</c:v>
                 </c:pt>
               </c:strCache>
             </c:strRef>
           </c:tx>
           <c:spPr>
             <a:solidFill>
-              <a:srgbClr val="DADADA"/>
+              <a:srgbClr val="A6A6A6"/>
             </a:solidFill>
           </c:spPr>
           <c:dLbls>
@@ -156,11 +156,15 @@
               <a:lstStyle/>
               <a:p>
                 <a:pPr>
-                  <a:defRPr sz="1100"/>
+                  <a:defRPr sz="1400" b="1">
+                    <a:solidFill>
+                      <a:srgbClr val="222222"/>
+                    </a:solidFill>
+                  </a:defRPr>
                 </a:pPr>
               </a:p>
             </c:txPr>
-            <c:dLblPos val="outEnd"/>
+            <c:dLblPos val="inBase"/>
             <c:showLegendKey val="0"/>
             <c:showVal val="1"/>
             <c:showCatName val="0"/>
@@ -169,6 +173,55 @@
             <c:showBubbleSize val="0"/>
             <c:showLeaderLines val="1"/>
           </c:dLbls>
+          <c:errBars>
+            <c:errDir val="y"/>
+            <c:errBarType val="both"/>
+            <c:errValType val="cust"/>
+            <c:noEndCap val="0"/>
+            <c:plus>
+              <c:numLit>
+                <c:formatCode>General</c:formatCode>
+                <c:ptCount val="4"/>
+                <c:pt idx="0">
+                  <c:v>14</c:v>
+                </c:pt>
+                <c:pt idx="1">
+                  <c:v>15</c:v>
+                </c:pt>
+                <c:pt idx="2">
+                  <c:v>11</c:v>
+                </c:pt>
+                <c:pt idx="3">
+                  <c:v>8</c:v>
+                </c:pt>
+              </c:numLit>
+            </c:plus>
+            <c:minus>
+              <c:numLit>
+                <c:formatCode>General</c:formatCode>
+                <c:ptCount val="4"/>
+                <c:pt idx="0">
+                  <c:v>14</c:v>
+                </c:pt>
+                <c:pt idx="1">
+                  <c:v>12</c:v>
+                </c:pt>
+                <c:pt idx="2">
+                  <c:v>14</c:v>
+                </c:pt>
+                <c:pt idx="3">
+                  <c:v>13</c:v>
+                </c:pt>
+              </c:numLit>
+            </c:minus>
+            <c:spPr>
+              <a:ln w="15875">
+                <a:solidFill>
+                  <a:srgbClr val="222222"/>
+                </a:solidFill>
+              </a:ln>
+            </c:spPr>
+          </c:errBars>
           <c:cat>
             <c:strRef>
               <c:f>Sheet1!$A$2:$A$5</c:f>
@@ -196,16 +249,16 @@
                 <c:formatCode>General</c:formatCode>
                 <c:ptCount val="4"/>
                 <c:pt idx="0">
-                  <c:v>0</c:v>
+                  <c:v>45</c:v>
                 </c:pt>
                 <c:pt idx="1">
-                  <c:v>0</c:v>
+                  <c:v>40</c:v>
                 </c:pt>
                 <c:pt idx="2">
-                  <c:v>0</c:v>
+                  <c:v>72</c:v>
                 </c:pt>
                 <c:pt idx="3">
-                  <c:v>0</c:v>
+                  <c:v>85</c:v>
                 </c:pt>
               </c:numCache>
             </c:numRef>
@@ -220,14 +273,14 @@
               <c:strCache>
                 <c:ptCount val="1"/>
                 <c:pt idx="0">
-                  <c:v>Estatísticas resumidas</c:v>
+                  <c:v>Consulta escrita pelo modelo</c:v>
                 </c:pt>
               </c:strCache>
             </c:strRef>
           </c:tx>
           <c:spPr>
             <a:solidFill>
-              <a:srgbClr val="C0C0C0"/>
+              <a:srgbClr val="5E5E5E"/>
             </a:solidFill>
           </c:spPr>
           <c:dLbls>
@@ -237,11 +290,15 @@
               <a:lstStyle/>
               <a:p>
                 <a:pPr>
-                  <a:defRPr sz="1100"/>
+                  <a:defRPr sz="1400" b="1">
+                    <a:solidFill>
+                      <a:srgbClr val="FFFFFF"/>
+                    </a:solidFill>
+                  </a:defRPr>
                 </a:pPr>
               </a:p>
             </c:txPr>
-            <c:dLblPos val="outEnd"/>
+            <c:dLblPos val="inBase"/>
             <c:showLegendKey val="0"/>
             <c:showVal val="1"/>
             <c:showCatName val="0"/>
@@ -250,6 +307,55 @@
             <c:showBubbleSize val="0"/>
             <c:showLeaderLines val="1"/>
           </c:dLbls>
+          <c:errBars>
+            <c:errDir val="y"/>
+            <c:errBarType val="both"/>
+            <c:errValType val="cust"/>
+            <c:noEndCap val="0"/>
+            <c:plus>
+              <c:numLit>
+                <c:formatCode>General</c:formatCode>
+                <c:ptCount val="4"/>
+                <c:pt idx="0">
+                  <c:v>11</c:v>
+                </c:pt>
+                <c:pt idx="1">
+                  <c:v>13</c:v>
+                </c:pt>
+                <c:pt idx="2">
+                  <c:v>6</c:v>
+                </c:pt>
+                <c:pt idx="3">
+                  <c:v>4</c:v>
+                </c:pt>
+              </c:numLit>
+            </c:plus>
+            <c:minus>
+              <c:numLit>
+                <c:formatCode>General</c:formatCode>
+                <c:ptCount val="4"/>
+                <c:pt idx="0">
+                  <c:v>14</c:v>
+                </c:pt>
+                <c:pt idx="1">
+                  <c:v>14</c:v>
+                </c:pt>
+                <c:pt idx="2">
+                  <c:v>12</c:v>
+                </c:pt>
+                <c:pt idx="3">
+                  <c:v>11</c:v>
+                </c:pt>
+              </c:numLit>
+            </c:minus>
+            <c:spPr>
+              <a:ln w="15875">
+                <a:solidFill>
+                  <a:srgbClr val="222222"/>
+                </a:solidFill>
+              </a:ln>
+            </c:spPr>
+          </c:errBars>
           <c:cat>
             <c:strRef>
               <c:f>Sheet1!$A$2:$A$5</c:f>
@@ -277,16 +383,16 @@
                 <c:formatCode>General</c:formatCode>
                 <c:ptCount val="4"/>
                 <c:pt idx="0">
-                  <c:v>0</c:v>
+                  <c:v>70</c:v>
                 </c:pt>
                 <c:pt idx="1">
-                  <c:v>4</c:v>
+                  <c:v>57</c:v>
                 </c:pt>
                 <c:pt idx="2">
-                  <c:v>9</c:v>
+                  <c:v>89</c:v>
                 </c:pt>
                 <c:pt idx="3">
-                  <c:v>6</c:v>
+                  <c:v>94</c:v>
                 </c:pt>
               </c:numCache>
             </c:numRef>
@@ -301,14 +407,14 @@
               <c:strCache>
                 <c:ptCount val="1"/>
                 <c:pt idx="0">
-                  <c:v>Busca vetorial</c:v>
+                  <c:v>Ferramentas sobre o grafo</c:v>
                 </c:pt>
               </c:strCache>
             </c:strRef>
           </c:tx>
           <c:spPr>
             <a:solidFill>
-              <a:srgbClr val="A6A6A6"/>
+              <a:srgbClr val="1F5C99"/>
             </a:solidFill>
           </c:spPr>
           <c:dLbls>
@@ -318,11 +424,15 @@
               <a:lstStyle/>
               <a:p>
                 <a:pPr>
-                  <a:defRPr sz="1100"/>
+                  <a:defRPr sz="1400" b="1">
+                    <a:solidFill>
+                      <a:srgbClr val="FFFFFF"/>
+                    </a:solidFill>
+                  </a:defRPr>
                 </a:pPr>
               </a:p>
             </c:txPr>
-            <c:dLblPos val="outEnd"/>
+            <c:dLblPos val="inBase"/>
             <c:showLegendKey val="0"/>
             <c:showVal val="1"/>
             <c:showCatName val="0"/>
@@ -331,6 +441,55 @@
             <c:showBubbleSize val="0"/>
             <c:showLeaderLines val="1"/>
           </c:dLbls>
+          <c:errBars>
+            <c:errDir val="y"/>
+            <c:errBarType val="both"/>
+            <c:errValType val="cust"/>
+            <c:noEndCap val="0"/>
+            <c:plus>
+              <c:numLit>
+                <c:formatCode>General</c:formatCode>
+                <c:ptCount val="4"/>
+                <c:pt idx="0">
+                  <c:v>7</c:v>
+                </c:pt>
+                <c:pt idx="1">
+                  <c:v>8</c:v>
+                </c:pt>
+                <c:pt idx="2">
+                  <c:v>6</c:v>
+                </c:pt>
+                <c:pt idx="3">
+                  <c:v>6</c:v>
+                </c:pt>
+              </c:numLit>
+            </c:plus>
+            <c:minus>
+              <c:numLit>
+                <c:formatCode>General</c:formatCode>
+                <c:ptCount val="4"/>
+                <c:pt idx="0">
+                  <c:v>12</c:v>
+                </c:pt>
+                <c:pt idx="1">
+                  <c:v>13</c:v>
+                </c:pt>
+                <c:pt idx="2">
+                  <c:v>12</c:v>
+                </c:pt>
+                <c:pt idx="3">
+                  <c:v>12</c:v>
+                </c:pt>
+              </c:numLit>
+            </c:minus>
+            <c:spPr>
+              <a:ln w="15875">
+                <a:solidFill>
+                  <a:srgbClr val="222222"/>
+                </a:solidFill>
+              </a:ln>
+            </c:spPr>
+          </c:errBars>
           <c:cat>
             <c:strRef>
               <c:f>Sheet1!$A$2:$A$5</c:f>
@@ -358,249 +517,6 @@
                 <c:formatCode>General</c:formatCode>
                 <c:ptCount val="4"/>
                 <c:pt idx="0">
-                  <c:v>11</c:v>
-                </c:pt>
-                <c:pt idx="1">
-                  <c:v>9</c:v>
-                </c:pt>
-                <c:pt idx="2">
-                  <c:v>15</c:v>
-                </c:pt>
-                <c:pt idx="3">
-                  <c:v>17</c:v>
-                </c:pt>
-              </c:numCache>
-            </c:numRef>
-          </c:val>
-        </c:ser>
-        <c:ser>
-          <c:idx val="3"/>
-          <c:order val="3"/>
-          <c:tx>
-            <c:strRef>
-              <c:f>Sheet1!$E$1</c:f>
-              <c:strCache>
-                <c:ptCount val="1"/>
-                <c:pt idx="0">
-                  <c:v>Contexto longo</c:v>
-                </c:pt>
-              </c:strCache>
-            </c:strRef>
-          </c:tx>
-          <c:spPr>
-            <a:solidFill>
-              <a:srgbClr val="8C8C8C"/>
-            </a:solidFill>
-          </c:spPr>
-          <c:dLbls>
-            <c:numFmt formatCode="0" sourceLinked="0"/>
-            <c:txPr>
-              <a:bodyPr/>
-              <a:lstStyle/>
-              <a:p>
-                <a:pPr>
-                  <a:defRPr sz="1100"/>
-                </a:pPr>
-              </a:p>
-            </c:txPr>
-            <c:dLblPos val="outEnd"/>
-            <c:showLegendKey val="0"/>
-            <c:showVal val="1"/>
-            <c:showCatName val="0"/>
-            <c:showSerName val="0"/>
-            <c:showPercent val="0"/>
-            <c:showBubbleSize val="0"/>
-            <c:showLeaderLines val="1"/>
-          </c:dLbls>
-          <c:cat>
-            <c:strRef>
-              <c:f>Sheet1!$A$2:$A$5</c:f>
-              <c:strCache>
-                <c:ptCount val="4"/>
-                <c:pt idx="0">
-                  <c:v>Haiku 5.5 (menor)</c:v>
-                </c:pt>
-                <c:pt idx="1">
-                  <c:v>Qwen3.8-flash (menor)</c:v>
-                </c:pt>
-                <c:pt idx="2">
-                  <c:v>Sonnet 4.6 (maior)</c:v>
-                </c:pt>
-                <c:pt idx="3">
-                  <c:v>Kimi K3 (maior)</c:v>
-                </c:pt>
-              </c:strCache>
-            </c:strRef>
-          </c:cat>
-          <c:val>
-            <c:numRef>
-              <c:f>Sheet1!$E$2:$E$5</c:f>
-              <c:numCache>
-                <c:formatCode>General</c:formatCode>
-                <c:ptCount val="4"/>
-                <c:pt idx="0">
-                  <c:v>45</c:v>
-                </c:pt>
-                <c:pt idx="1">
-                  <c:v>40</c:v>
-                </c:pt>
-                <c:pt idx="2">
-                  <c:v>72</c:v>
-                </c:pt>
-                <c:pt idx="3">
-                  <c:v>85</c:v>
-                </c:pt>
-              </c:numCache>
-            </c:numRef>
-          </c:val>
-        </c:ser>
-        <c:ser>
-          <c:idx val="4"/>
-          <c:order val="4"/>
-          <c:tx>
-            <c:strRef>
-              <c:f>Sheet1!$F$1</c:f>
-              <c:strCache>
-                <c:ptCount val="1"/>
-                <c:pt idx="0">
-                  <c:v>Consulta escrita pelo modelo</c:v>
-                </c:pt>
-              </c:strCache>
-            </c:strRef>
-          </c:tx>
-          <c:spPr>
-            <a:solidFill>
-              <a:srgbClr val="5E5E5E"/>
-            </a:solidFill>
-          </c:spPr>
-          <c:dLbls>
-            <c:numFmt formatCode="0" sourceLinked="0"/>
-            <c:txPr>
-              <a:bodyPr/>
-              <a:lstStyle/>
-              <a:p>
-                <a:pPr>
-                  <a:defRPr sz="1100"/>
-                </a:pPr>
-              </a:p>
-            </c:txPr>
-            <c:dLblPos val="outEnd"/>
-            <c:showLegendKey val="0"/>
-            <c:showVal val="1"/>
-            <c:showCatName val="0"/>
-            <c:showSerName val="0"/>
-            <c:showPercent val="0"/>
-            <c:showBubbleSize val="0"/>
-            <c:showLeaderLines val="1"/>
-          </c:dLbls>
-          <c:cat>
-            <c:strRef>
-              <c:f>Sheet1!$A$2:$A$5</c:f>
-              <c:strCache>
-                <c:ptCount val="4"/>
-                <c:pt idx="0">
-                  <c:v>Haiku 5.5 (menor)</c:v>
-                </c:pt>
-                <c:pt idx="1">
-                  <c:v>Qwen3.8-flash (menor)</c:v>
-                </c:pt>
-                <c:pt idx="2">
-                  <c:v>Sonnet 4.6 (maior)</c:v>
-                </c:pt>
-                <c:pt idx="3">
-                  <c:v>Kimi K3 (maior)</c:v>
-                </c:pt>
-              </c:strCache>
-            </c:strRef>
-          </c:cat>
-          <c:val>
-            <c:numRef>
-              <c:f>Sheet1!$F$2:$F$5</c:f>
-              <c:numCache>
-                <c:formatCode>General</c:formatCode>
-                <c:ptCount val="4"/>
-                <c:pt idx="0">
-                  <c:v>70</c:v>
-                </c:pt>
-                <c:pt idx="1">
-                  <c:v>57</c:v>
-                </c:pt>
-                <c:pt idx="2">
-                  <c:v>89</c:v>
-                </c:pt>
-                <c:pt idx="3">
-                  <c:v>94</c:v>
-                </c:pt>
-              </c:numCache>
-            </c:numRef>
-          </c:val>
-        </c:ser>
-        <c:ser>
-          <c:idx val="5"/>
-          <c:order val="5"/>
-          <c:tx>
-            <c:strRef>
-              <c:f>Sheet1!$G$1</c:f>
-              <c:strCache>
-                <c:ptCount val="1"/>
-                <c:pt idx="0">
-                  <c:v>Ferramentas sobre o grafo</c:v>
-                </c:pt>
-              </c:strCache>
-            </c:strRef>
-          </c:tx>
-          <c:spPr>
-            <a:solidFill>
-              <a:srgbClr val="1F5C99"/>
-            </a:solidFill>
-          </c:spPr>
-          <c:dLbls>
-            <c:numFmt formatCode="0" sourceLinked="0"/>
-            <c:txPr>
-              <a:bodyPr/>
-              <a:lstStyle/>
-              <a:p>
-                <a:pPr>
-                  <a:defRPr sz="1100"/>
-                </a:pPr>
-              </a:p>
-            </c:txPr>
-            <c:dLblPos val="outEnd"/>
-            <c:showLegendKey val="0"/>
-            <c:showVal val="1"/>
-            <c:showCatName val="0"/>
-            <c:showSerName val="0"/>
-            <c:showPercent val="0"/>
-            <c:showBubbleSize val="0"/>
-            <c:showLeaderLines val="1"/>
-          </c:dLbls>
-          <c:cat>
-            <c:strRef>
-              <c:f>Sheet1!$A$2:$A$5</c:f>
-              <c:strCache>
-                <c:ptCount val="4"/>
-                <c:pt idx="0">
-                  <c:v>Haiku 5.5 (menor)</c:v>
-                </c:pt>
-                <c:pt idx="1">
-                  <c:v>Qwen3.8-flash (menor)</c:v>
-                </c:pt>
-                <c:pt idx="2">
-                  <c:v>Sonnet 4.6 (maior)</c:v>
-                </c:pt>
-                <c:pt idx="3">
-                  <c:v>Kimi K3 (maior)</c:v>
-                </c:pt>
-              </c:strCache>
-            </c:strRef>
-          </c:cat>
-          <c:val>
-            <c:numRef>
-              <c:f>Sheet1!$G$2:$G$5</c:f>
-              <c:numCache>
-                <c:formatCode>General</c:formatCode>
-                <c:ptCount val="4"/>
-                <c:pt idx="0">
                   <c:v>87</c:v>
                 </c:pt>
                 <c:pt idx="1">
@@ -616,7 +532,7 @@
             </c:numRef>
           </c:val>
         </c:ser>
-        <c:gapWidth val="60"/>
+        <c:gapWidth val="70"/>
         <c:overlap val="-5"/>
         <c:axId val="-2068027336"/>
         <c:axId val="-2113994440"/>
@@ -643,7 +559,7 @@
           <a:lstStyle/>
           <a:p>
             <a:pPr>
-              <a:defRPr sz="1300"/>
+              <a:defRPr sz="1400"/>
             </a:pPr>
           </a:p>
         </c:txPr>
@@ -678,7 +594,7 @@
               <a:lstStyle/>
               <a:p>
                 <a:r>
-                  <a:rPr sz="1300" b="0"/>
+                  <a:rPr sz="1400" b="0"/>
                   <a:t>Acerto (%)</a:t>
                 </a:r>
               </a:p>
@@ -700,7 +616,7 @@
           <a:lstStyle/>
           <a:p>
             <a:pPr>
-              <a:defRPr sz="1300"/>
+              <a:defRPr sz="1400"/>
             </a:pPr>
           </a:p>
         </c:txPr>
@@ -717,7 +633,7 @@
         <a:lstStyle/>
         <a:p>
           <a:pPr>
-            <a:defRPr sz="1300"/>
+            <a:defRPr sz="1400"/>
           </a:pPr>
         </a:p>
       </c:txPr>
@@ -729,7 +645,7 @@
     <a:lstStyle/>
     <a:p>
       <a:pPr>
-        <a:defRPr sz="1300">
+        <a:defRPr sz="1400">
           <a:latin typeface="Arial"/>
         </a:defRPr>
       </a:pPr>
@@ -2487,7 +2403,7 @@
           <a:lstStyle/>
           <a:p>
             <a:r>
-              <a:t>[1:30] Os eventos da partida, sem a disputa de pênaltis, foram convertidos com a biblioteca socceraction para o formato SPADL, que guarda só as ações com bola, em um vocabulário fechado e com os mesmos campos em todas. Os 4.407 eventos viram 2.585 ações. Sobre essa tabela foram acrescentadas colunas de contexto: direção de ataque, zona em uma grade de 96 zonas, fase de posse (537 fases na final), recebedor do passe, placar e minuto. É essa tabela que o Contexto longo entrega ao modelo. O SPADL perde o desfecho da finalização e o cartão sem falta, que foram recuperados do JSON. Nenhuma etapa usa modelo de linguagem.</a:t>
+              <a:t>[1:30] Os eventos da partida, sem a disputa de pênaltis, foram convertidos com a biblioteca socceraction para o formato SPADL, que guarda só as ações com bola, em um vocabulário fechado e com os mesmos campos em todas. Os 4.407 eventos viram 2.585 ações. Sobre essa tabela foram acrescentadas colunas de contexto: direção de ataque, zona em uma grade de 96 zonas, fase de posse (537 fases na final), recebedor do passe, placar e minuto. A figura mostra a grade de 12 por 8 zonas e o passe de Mac Allister para Di María, da zona 74 para a 92, como na Figura 1 do artigo (zonas copiadas dela, não recalculadas). É essa tabela que o Contexto longo entrega ao modelo. O SPADL perde o desfecho da finalização e o cartão sem falta, que foram recuperados do JSON; os rótulos das ações foram traduzidos para o português. Nenhuma etapa usa modelo de linguagem.</a:t>
             </a:r>
           </a:p>
         </p:txBody>
@@ -2837,7 +2753,7 @@
           <a:lstStyle/>
           <a:p>
             <a:r>
-              <a:t>[2:15] Acerto nas 47 perguntas com resposta. A barra azul é Ferramentas sobre o grafo: 83% a 89% em todos os modelos. Consulta escrita pelo modelo: 57% a 70% nos menores e 89% a 94% nos maiores. Contexto longo: 40% a 45% nos menores e 72% a 85% nos maiores. As outras três ficam baixas: Busca vetorial 9% a 17%, Estatísticas resumidas 0% a 9%, e Sem dados 0%, porque se abstém. Nos maiores, Consulta empata com Ferramentas no Sonnet e fica à frente no Kimi; os intervalos se sobrepõem. Setup: quatro modelos, dois menores (Haiku e Qwen, sem raciocínio estendido, temperatura zero) e dois maiores (Sonnet e Kimi, com raciocínio estendido), agrupados pela faixa de preço por token; 52 perguntas em 6 abordagens, 312 execuções por modelo, 1 repetição por pergunta; intervalo de Wilson de 95%; diferenças lidas como indícios.</a:t>
+              <a:t>[2:15] Acerto nas 47 perguntas com resposta, das três abordagens que leem os dados, com o intervalo de Wilson de 95%. A barra azul é Ferramentas sobre o grafo: 83% a 89% em todos os modelos. Consulta escrita pelo modelo: 57% a 70% nos menores e 89% a 94% nos maiores. Contexto longo: 40% a 45% nos menores e 72% a 85% nos maiores. As outras três ficam baixas e estão no slide 11: Busca vetorial 9% a 17%, Estatísticas resumidas 0% a 9% e Sem dados 0%, porque se abstém. Nos maiores, Consulta empata com Ferramentas no Sonnet e fica à frente no Kimi; os intervalos se sobrepõem. Setup: quatro modelos, dois menores (Haiku e Qwen, sem raciocínio estendido, temperatura zero) e dois maiores (Sonnet e Kimi, com raciocínio estendido), agrupados pela faixa de preço por token; 52 perguntas em 6 abordagens, 312 execuções por modelo, 1 repetição por pergunta; diferenças lidas como indícios.</a:t>
             </a:r>
           </a:p>
         </p:txBody>
@@ -7125,7 +7041,7 @@
               </a:spcAft>
             </a:pPr>
             <a:r>
-              <a:rPr sz="1300" b="0">
+              <a:rPr sz="1400" b="0">
                 <a:solidFill>
                   <a:srgbClr val="666666"/>
                 </a:solidFill>
@@ -7240,7 +7156,7 @@
               </a:spcAft>
             </a:pPr>
             <a:r>
-              <a:rPr sz="1300" b="0">
+              <a:rPr sz="1400" b="0">
                 <a:solidFill>
                   <a:srgbClr val="666666"/>
                 </a:solidFill>
@@ -8704,7 +8620,7 @@
                 </a:solidFill>
                 <a:latin typeface="Arial"/>
               </a:rPr>
-              <a:t>Perguntas de futebol exigem ligar eventos: qual forma de dar os dados ao modelo funciona melhor?</a:t>
+              <a:t>Qual forma de dar os dados de uma partida ao modelo funciona melhor?</a:t>
             </a:r>
           </a:p>
         </p:txBody>
@@ -8839,7 +8755,7 @@
         <p:spPr>
           <a:xfrm>
             <a:off x="640080" y="2103120"/>
-            <a:ext cx="5120640" cy="2103120"/>
+            <a:ext cx="5120640" cy="1920240"/>
           </a:xfrm>
           <a:prstGeom prst="rect">
             <a:avLst/>
@@ -8936,8 +8852,8 @@
         </p:nvSpPr>
         <p:spPr>
           <a:xfrm>
-            <a:off x="640080" y="4023360"/>
-            <a:ext cx="5120640" cy="1737360"/>
+            <a:off x="640080" y="4114800"/>
+            <a:ext cx="5120640" cy="1600200"/>
           </a:xfrm>
           <a:prstGeom prst="rect">
             <a:avLst/>
@@ -8980,8 +8896,8 @@
         </p:nvSpPr>
         <p:spPr>
           <a:xfrm>
-            <a:off x="777240" y="4050791"/>
-            <a:ext cx="4846320" cy="1691640"/>
+            <a:off x="777240" y="4142232"/>
+            <a:ext cx="4846320" cy="1554480"/>
           </a:xfrm>
           <a:prstGeom prst="rect">
             <a:avLst/>
@@ -9022,7 +8938,7 @@
                 </a:solidFill>
                 <a:latin typeface="Arial"/>
               </a:rPr>
-              <a:t>52 perguntas sobre a final, com gabarito calculado por código, fora do grafo.</a:t>
+              <a:t>52 perguntas com gabarito calculado por código.</a:t>
             </a:r>
           </a:p>
           <a:p>
@@ -9038,7 +8954,7 @@
                 </a:solidFill>
                 <a:latin typeface="Arial"/>
               </a:rPr>
-              <a:t>Comparação de 6 abordagens com as mesmas perguntas, o mesmo prompt e a mesma saída, em 4 modelos.</a:t>
+              <a:t>6 abordagens em 4 modelos, com as mesmas perguntas, prompt e saída.</a:t>
             </a:r>
           </a:p>
         </p:txBody>
@@ -9091,7 +9007,7 @@
         <p:spPr>
           <a:xfrm>
             <a:off x="6217920" y="2103120"/>
-            <a:ext cx="5303520" cy="1097280"/>
+            <a:ext cx="5303520" cy="1188720"/>
           </a:xfrm>
           <a:prstGeom prst="rect">
             <a:avLst/>
@@ -9135,7 +9051,7 @@
         <p:spPr>
           <a:xfrm>
             <a:off x="6355080" y="2130551"/>
-            <a:ext cx="5029200" cy="1051560"/>
+            <a:ext cx="5029200" cy="1143000"/>
           </a:xfrm>
           <a:prstGeom prst="rect">
             <a:avLst/>
@@ -9190,7 +9106,7 @@
         <p:spPr>
           <a:xfrm>
             <a:off x="6217920" y="3337560"/>
-            <a:ext cx="5303520" cy="1097280"/>
+            <a:ext cx="5303520" cy="1188720"/>
           </a:xfrm>
           <a:prstGeom prst="rect">
             <a:avLst/>
@@ -9234,7 +9150,7 @@
         <p:spPr>
           <a:xfrm>
             <a:off x="6355080" y="3364991"/>
-            <a:ext cx="5029200" cy="1051560"/>
+            <a:ext cx="5029200" cy="1143000"/>
           </a:xfrm>
           <a:prstGeom prst="rect">
             <a:avLst/>
@@ -9289,7 +9205,7 @@
         <p:spPr>
           <a:xfrm>
             <a:off x="6217920" y="4572000"/>
-            <a:ext cx="5303520" cy="1097280"/>
+            <a:ext cx="5303520" cy="1188720"/>
           </a:xfrm>
           <a:prstGeom prst="rect">
             <a:avLst/>
@@ -9333,7 +9249,7 @@
         <p:spPr>
           <a:xfrm>
             <a:off x="6355080" y="4599432"/>
-            <a:ext cx="5029200" cy="1051560"/>
+            <a:ext cx="5029200" cy="1143000"/>
           </a:xfrm>
           <a:prstGeom prst="rect">
             <a:avLst/>
@@ -9387,8 +9303,8 @@
         </p:nvSpPr>
         <p:spPr>
           <a:xfrm>
-            <a:off x="640080" y="5852160"/>
-            <a:ext cx="10881360" cy="502920"/>
+            <a:off x="640080" y="5806440"/>
+            <a:ext cx="10881360" cy="566928"/>
           </a:xfrm>
           <a:prstGeom prst="rect">
             <a:avLst/>
@@ -9431,8 +9347,8 @@
         </p:nvSpPr>
         <p:spPr>
           <a:xfrm>
-            <a:off x="777240" y="5870448"/>
-            <a:ext cx="10607040" cy="457200"/>
+            <a:off x="777240" y="5824728"/>
+            <a:ext cx="10607040" cy="530352"/>
           </a:xfrm>
           <a:prstGeom prst="rect">
             <a:avLst/>
@@ -9451,7 +9367,7 @@
               </a:spcAft>
             </a:pPr>
             <a:r>
-              <a:rPr sz="1200" b="0">
+              <a:rPr sz="1400" b="0">
                 <a:solidFill>
                   <a:srgbClr val="222222"/>
                 </a:solidFill>
@@ -9643,7 +9559,7 @@
         <p:spPr>
           <a:xfrm>
             <a:off x="640080" y="1554480"/>
-            <a:ext cx="6492240" cy="2651760"/>
+            <a:ext cx="6492240" cy="3017520"/>
           </a:xfrm>
           <a:prstGeom prst="rect">
             <a:avLst/>
@@ -9687,7 +9603,7 @@
         <p:spPr>
           <a:xfrm>
             <a:off x="822960" y="1691640"/>
-            <a:ext cx="6217920" cy="3108960"/>
+            <a:ext cx="6217920" cy="3200400"/>
           </a:xfrm>
           <a:prstGeom prst="rect">
             <a:avLst/>
@@ -9701,7 +9617,7 @@
           <a:lstStyle/>
           <a:p>
             <a:r>
-              <a:rPr sz="1200">
+              <a:rPr sz="1400">
                 <a:solidFill>
                   <a:srgbClr val="E8E8E8"/>
                 </a:solidFill>
@@ -9712,7 +9628,7 @@
           </a:p>
           <a:p>
             <a:r>
-              <a:rPr sz="1200">
+              <a:rPr sz="1400">
                 <a:solidFill>
                   <a:srgbClr val="E8E8E8"/>
                 </a:solidFill>
@@ -9723,7 +9639,7 @@
           </a:p>
           <a:p>
             <a:r>
-              <a:rPr sz="1200">
+              <a:rPr sz="1400">
                 <a:solidFill>
                   <a:srgbClr val="E8E8E8"/>
                 </a:solidFill>
@@ -9734,7 +9650,7 @@
           </a:p>
           <a:p>
             <a:r>
-              <a:rPr sz="1200">
+              <a:rPr sz="1400">
                 <a:solidFill>
                   <a:srgbClr val="E8E8E8"/>
                 </a:solidFill>
@@ -9745,7 +9661,7 @@
           </a:p>
           <a:p>
             <a:r>
-              <a:rPr sz="1200">
+              <a:rPr sz="1400">
                 <a:solidFill>
                   <a:srgbClr val="E8E8E8"/>
                 </a:solidFill>
@@ -9756,7 +9672,7 @@
           </a:p>
           <a:p>
             <a:r>
-              <a:rPr sz="1200">
+              <a:rPr sz="1400">
                 <a:solidFill>
                   <a:srgbClr val="E8E8E8"/>
                 </a:solidFill>
@@ -9767,7 +9683,7 @@
           </a:p>
           <a:p>
             <a:r>
-              <a:rPr sz="1200">
+              <a:rPr sz="1400">
                 <a:solidFill>
                   <a:srgbClr val="E8E8E8"/>
                 </a:solidFill>
@@ -9778,7 +9694,7 @@
           </a:p>
           <a:p>
             <a:r>
-              <a:rPr sz="1200">
+              <a:rPr sz="1400">
                 <a:solidFill>
                   <a:srgbClr val="E8E8E8"/>
                 </a:solidFill>
@@ -9789,7 +9705,7 @@
           </a:p>
           <a:p>
             <a:r>
-              <a:rPr sz="1200">
+              <a:rPr sz="1400">
                 <a:solidFill>
                   <a:srgbClr val="E8E8E8"/>
                 </a:solidFill>
@@ -9800,7 +9716,7 @@
           </a:p>
           <a:p>
             <a:r>
-              <a:rPr sz="1200">
+              <a:rPr sz="1400">
                 <a:solidFill>
                   <a:srgbClr val="E8E8E8"/>
                 </a:solidFill>
@@ -9835,7 +9751,7 @@
           <a:p>
             <a:pPr>
               <a:spcAft>
-                <a:spcPts val="900"/>
+                <a:spcPts val="1000"/>
               </a:spcAft>
             </a:pPr>
             <a:r>
@@ -9869,7 +9785,7 @@
           <a:p>
             <a:pPr>
               <a:spcAft>
-                <a:spcPts val="900"/>
+                <a:spcPts val="1000"/>
               </a:spcAft>
             </a:pPr>
             <a:r>
@@ -9903,7 +9819,7 @@
           <a:p>
             <a:pPr>
               <a:spcAft>
-                <a:spcPts val="900"/>
+                <a:spcPts val="1000"/>
               </a:spcAft>
             </a:pPr>
             <a:r>
@@ -9937,7 +9853,7 @@
           <a:p>
             <a:pPr>
               <a:spcAft>
-                <a:spcPts val="900"/>
+                <a:spcPts val="1000"/>
               </a:spcAft>
             </a:pPr>
             <a:r>
@@ -9971,7 +9887,7 @@
           <a:p>
             <a:pPr>
               <a:spcAft>
-                <a:spcPts val="900"/>
+                <a:spcPts val="1000"/>
               </a:spcAft>
             </a:pPr>
             <a:r>
@@ -10461,8 +10377,8 @@
           <p:nvPr/>
         </p:nvGraphicFramePr>
         <p:xfrm>
-          <a:off x="640080" y="2377440"/>
-          <a:ext cx="10881359" cy="3840480"/>
+          <a:off x="640080" y="2468880"/>
+          <a:ext cx="6675120" cy="3291840"/>
         </p:xfrm>
         <a:graphic>
           <a:graphicData uri="http://schemas.openxmlformats.org/drawingml/2006/table">
@@ -10471,11 +10387,10 @@
                 <a:tableStyleId>{5C22544A-7EE6-4342-B048-85BDC9FD1C3A}</a:tableStyleId>
               </a:tblPr>
               <a:tblGrid>
-                <a:gridCol w="2834640"/>
+                <a:gridCol w="2377440"/>
                 <a:gridCol w="4297680"/>
-                <a:gridCol w="3749039"/>
               </a:tblGrid>
-              <a:tr h="480060">
+              <a:tr h="548640">
                 <a:tc>
                   <a:txBody>
                     <a:bodyPr wrap="square"/>
@@ -10483,7 +10398,7 @@
                     <a:p>
                       <a:pPr algn="l"/>
                       <a:r>
-                        <a:rPr sz="1400" b="1">
+                        <a:rPr sz="1600" b="1">
                           <a:solidFill>
                             <a:srgbClr val="FFFFFF"/>
                           </a:solidFill>
@@ -10506,7 +10421,7 @@
                     <a:p>
                       <a:pPr algn="l"/>
                       <a:r>
-                        <a:rPr sz="1400" b="1">
+                        <a:rPr sz="1600" b="1">
                           <a:solidFill>
                             <a:srgbClr val="FFFFFF"/>
                           </a:solidFill>
@@ -10522,6 +10437,8 @@
                     </a:solidFill>
                   </a:tcPr>
                 </a:tc>
+              </a:tr>
+              <a:tr h="548640">
                 <a:tc>
                   <a:txBody>
                     <a:bodyPr wrap="square"/>
@@ -10529,32 +10446,7 @@
                     <a:p>
                       <a:pPr algn="l"/>
                       <a:r>
-                        <a:rPr sz="1400" b="1">
-                          <a:solidFill>
-                            <a:srgbClr val="FFFFFF"/>
-                          </a:solidFill>
-                          <a:latin typeface="Arial"/>
-                        </a:rPr>
-                        <a:t>Motivo</a:t>
-                      </a:r>
-                    </a:p>
-                  </a:txBody>
-                  <a:tcPr anchor="ctr">
-                    <a:solidFill>
-                      <a:srgbClr val="222222"/>
-                    </a:solidFill>
-                  </a:tcPr>
-                </a:tc>
-              </a:tr>
-              <a:tr h="480060">
-                <a:tc>
-                  <a:txBody>
-                    <a:bodyPr wrap="square"/>
-                    <a:lstStyle/>
-                    <a:p>
-                      <a:pPr algn="l"/>
-                      <a:r>
-                        <a:rPr sz="1400" b="1">
+                        <a:rPr sz="1600" b="1">
                           <a:solidFill>
                             <a:srgbClr val="222222"/>
                           </a:solidFill>
@@ -10577,7 +10469,7 @@
                     <a:p>
                       <a:pPr algn="l"/>
                       <a:r>
-                        <a:rPr sz="1400" b="0">
+                        <a:rPr sz="1600" b="0">
                           <a:solidFill>
                             <a:srgbClr val="222222"/>
                           </a:solidFill>
@@ -10593,6 +10485,8 @@
                     </a:solidFill>
                   </a:tcPr>
                 </a:tc>
+              </a:tr>
+              <a:tr h="548640">
                 <a:tc>
                   <a:txBody>
                     <a:bodyPr wrap="square"/>
@@ -10600,38 +10494,13 @@
                     <a:p>
                       <a:pPr algn="l"/>
                       <a:r>
-                        <a:rPr sz="1400" b="0">
+                        <a:rPr sz="1600" b="1">
                           <a:solidFill>
                             <a:srgbClr val="222222"/>
                           </a:solidFill>
                           <a:latin typeface="Arial"/>
                         </a:rPr>
-                        <a:t>mesmo sentido do campo para os dois times</a:t>
-                      </a:r>
-                    </a:p>
-                  </a:txBody>
-                  <a:tcPr anchor="ctr">
-                    <a:solidFill>
-                      <a:srgbClr val="FFFFFF"/>
-                    </a:solidFill>
-                  </a:tcPr>
-                </a:tc>
-              </a:tr>
-              <a:tr h="480060">
-                <a:tc>
-                  <a:txBody>
-                    <a:bodyPr wrap="square"/>
-                    <a:lstStyle/>
-                    <a:p>
-                      <a:pPr algn="l"/>
-                      <a:r>
-                        <a:rPr sz="1400" b="1">
-                          <a:solidFill>
-                            <a:srgbClr val="222222"/>
-                          </a:solidFill>
-                          <a:latin typeface="Arial"/>
-                        </a:rPr>
-                        <a:t>Zona, terço e corredor</a:t>
+                        <a:t>Zona do campo</a:t>
                       </a:r>
                     </a:p>
                   </a:txBody>
@@ -10648,7 +10517,7 @@
                     <a:p>
                       <a:pPr algn="l"/>
                       <a:r>
-                        <a:rPr sz="1400" b="0">
+                        <a:rPr sz="1600" b="0">
                           <a:solidFill>
                             <a:srgbClr val="222222"/>
                           </a:solidFill>
@@ -10664,6 +10533,8 @@
                     </a:solidFill>
                   </a:tcPr>
                 </a:tc>
+              </a:tr>
+              <a:tr h="548640">
                 <a:tc>
                   <a:txBody>
                     <a:bodyPr wrap="square"/>
@@ -10671,32 +10542,7 @@
                     <a:p>
                       <a:pPr algn="l"/>
                       <a:r>
-                        <a:rPr sz="1400" b="0">
-                          <a:solidFill>
-                            <a:srgbClr val="222222"/>
-                          </a:solidFill>
-                          <a:latin typeface="Arial"/>
-                        </a:rPr>
-                        <a:t>localizar a ação no campo</a:t>
-                      </a:r>
-                    </a:p>
-                  </a:txBody>
-                  <a:tcPr anchor="ctr">
-                    <a:solidFill>
-                      <a:srgbClr val="F2F2F2"/>
-                    </a:solidFill>
-                  </a:tcPr>
-                </a:tc>
-              </a:tr>
-              <a:tr h="480060">
-                <a:tc>
-                  <a:txBody>
-                    <a:bodyPr wrap="square"/>
-                    <a:lstStyle/>
-                    <a:p>
-                      <a:pPr algn="l"/>
-                      <a:r>
-                        <a:rPr sz="1400" b="1">
+                        <a:rPr sz="1600" b="1">
                           <a:solidFill>
                             <a:srgbClr val="222222"/>
                           </a:solidFill>
@@ -10719,7 +10565,7 @@
                     <a:p>
                       <a:pPr algn="l"/>
                       <a:r>
-                        <a:rPr sz="1400" b="0">
+                        <a:rPr sz="1600" b="0">
                           <a:solidFill>
                             <a:srgbClr val="222222"/>
                           </a:solidFill>
@@ -10735,6 +10581,8 @@
                     </a:solidFill>
                   </a:tcPr>
                 </a:tc>
+              </a:tr>
+              <a:tr h="548640">
                 <a:tc>
                   <a:txBody>
                     <a:bodyPr wrap="square"/>
@@ -10742,32 +10590,7 @@
                     <a:p>
                       <a:pPr algn="l"/>
                       <a:r>
-                        <a:rPr sz="1400" b="0">
-                          <a:solidFill>
-                            <a:srgbClr val="222222"/>
-                          </a:solidFill>
-                          <a:latin typeface="Arial"/>
-                        </a:rPr>
-                        <a:t>saber quem passou para quem</a:t>
-                      </a:r>
-                    </a:p>
-                  </a:txBody>
-                  <a:tcPr anchor="ctr">
-                    <a:solidFill>
-                      <a:srgbClr val="FFFFFF"/>
-                    </a:solidFill>
-                  </a:tcPr>
-                </a:tc>
-              </a:tr>
-              <a:tr h="480060">
-                <a:tc>
-                  <a:txBody>
-                    <a:bodyPr wrap="square"/>
-                    <a:lstStyle/>
-                    <a:p>
-                      <a:pPr algn="l"/>
-                      <a:r>
-                        <a:rPr sz="1400" b="1">
+                        <a:rPr sz="1600" b="1">
                           <a:solidFill>
                             <a:srgbClr val="222222"/>
                           </a:solidFill>
@@ -10790,7 +10613,7 @@
                     <a:p>
                       <a:pPr algn="l"/>
                       <a:r>
-                        <a:rPr sz="1400" b="0">
+                        <a:rPr sz="1600" b="0">
                           <a:solidFill>
                             <a:srgbClr val="222222"/>
                           </a:solidFill>
@@ -10806,6 +10629,8 @@
                     </a:solidFill>
                   </a:tcPr>
                 </a:tc>
+              </a:tr>
+              <a:tr h="548640">
                 <a:tc>
                   <a:txBody>
                     <a:bodyPr wrap="square"/>
@@ -10813,38 +10638,13 @@
                     <a:p>
                       <a:pPr algn="l"/>
                       <a:r>
-                        <a:rPr sz="1400" b="0">
+                        <a:rPr sz="1600" b="1">
                           <a:solidFill>
                             <a:srgbClr val="222222"/>
                           </a:solidFill>
                           <a:latin typeface="Arial"/>
                         </a:rPr>
-                        <a:t>identificar as jogadas</a:t>
-                      </a:r>
-                    </a:p>
-                  </a:txBody>
-                  <a:tcPr anchor="ctr">
-                    <a:solidFill>
-                      <a:srgbClr val="F2F2F2"/>
-                    </a:solidFill>
-                  </a:tcPr>
-                </a:tc>
-              </a:tr>
-              <a:tr h="480060">
-                <a:tc>
-                  <a:txBody>
-                    <a:bodyPr wrap="square"/>
-                    <a:lstStyle/>
-                    <a:p>
-                      <a:pPr algn="l"/>
-                      <a:r>
-                        <a:rPr sz="1400" b="1">
-                          <a:solidFill>
-                            <a:srgbClr val="222222"/>
-                          </a:solidFill>
-                          <a:latin typeface="Arial"/>
-                        </a:rPr>
-                        <a:t>Placar, minuto e período</a:t>
+                        <a:t>Placar e minuto</a:t>
                       </a:r>
                     </a:p>
                   </a:txBody>
@@ -10861,7 +10661,7 @@
                     <a:p>
                       <a:pPr algn="l"/>
                       <a:r>
-                        <a:rPr sz="1400" b="0">
+                        <a:rPr sz="1600" b="0">
                           <a:solidFill>
                             <a:srgbClr val="222222"/>
                           </a:solidFill>
@@ -10877,176 +10677,893 @@
                     </a:solidFill>
                   </a:tcPr>
                 </a:tc>
-                <a:tc>
-                  <a:txBody>
-                    <a:bodyPr wrap="square"/>
-                    <a:lstStyle/>
-                    <a:p>
-                      <a:pPr algn="l"/>
-                      <a:r>
-                        <a:rPr sz="1400" b="0">
-                          <a:solidFill>
-                            <a:srgbClr val="222222"/>
-                          </a:solidFill>
-                          <a:latin typeface="Arial"/>
-                        </a:rPr>
-                        <a:t>situar a ação antes ou depois de um momento</a:t>
-                      </a:r>
-                    </a:p>
-                  </a:txBody>
-                  <a:tcPr anchor="ctr">
-                    <a:solidFill>
-                      <a:srgbClr val="FFFFFF"/>
-                    </a:solidFill>
-                  </a:tcPr>
-                </a:tc>
-              </a:tr>
-              <a:tr h="480060">
-                <a:tc>
-                  <a:txBody>
-                    <a:bodyPr wrap="square"/>
-                    <a:lstStyle/>
-                    <a:p>
-                      <a:pPr algn="l"/>
-                      <a:r>
-                        <a:rPr sz="1400" b="1">
-                          <a:solidFill>
-                            <a:srgbClr val="222222"/>
-                          </a:solidFill>
-                          <a:latin typeface="Arial"/>
-                        </a:rPr>
-                        <a:t>Dados recuperados do JSON</a:t>
-                      </a:r>
-                    </a:p>
-                  </a:txBody>
-                  <a:tcPr anchor="ctr">
-                    <a:solidFill>
-                      <a:srgbClr val="F2F2F2"/>
-                    </a:solidFill>
-                  </a:tcPr>
-                </a:tc>
-                <a:tc>
-                  <a:txBody>
-                    <a:bodyPr wrap="square"/>
-                    <a:lstStyle/>
-                    <a:p>
-                      <a:pPr algn="l"/>
-                      <a:r>
-                        <a:rPr sz="1400" b="0">
-                          <a:solidFill>
-                            <a:srgbClr val="222222"/>
-                          </a:solidFill>
-                          <a:latin typeface="Arial"/>
-                        </a:rPr>
-                        <a:t>desfecho da finalização e cartão sem falta</a:t>
-                      </a:r>
-                    </a:p>
-                  </a:txBody>
-                  <a:tcPr anchor="ctr">
-                    <a:solidFill>
-                      <a:srgbClr val="F2F2F2"/>
-                    </a:solidFill>
-                  </a:tcPr>
-                </a:tc>
-                <a:tc>
-                  <a:txBody>
-                    <a:bodyPr wrap="square"/>
-                    <a:lstStyle/>
-                    <a:p>
-                      <a:pPr algn="l"/>
-                      <a:r>
-                        <a:rPr sz="1400" b="0">
-                          <a:solidFill>
-                            <a:srgbClr val="222222"/>
-                          </a:solidFill>
-                          <a:latin typeface="Arial"/>
-                        </a:rPr>
-                        <a:t>o SPADL perde essas informações</a:t>
-                      </a:r>
-                    </a:p>
-                  </a:txBody>
-                  <a:tcPr anchor="ctr">
-                    <a:solidFill>
-                      <a:srgbClr val="F2F2F2"/>
-                    </a:solidFill>
-                  </a:tcPr>
-                </a:tc>
-              </a:tr>
-              <a:tr h="480060">
-                <a:tc>
-                  <a:txBody>
-                    <a:bodyPr wrap="square"/>
-                    <a:lstStyle/>
-                    <a:p>
-                      <a:pPr algn="l"/>
-                      <a:r>
-                        <a:rPr sz="1400" b="1">
-                          <a:solidFill>
-                            <a:srgbClr val="222222"/>
-                          </a:solidFill>
-                          <a:latin typeface="Arial"/>
-                        </a:rPr>
-                        <a:t>Rótulos em português</a:t>
-                      </a:r>
-                    </a:p>
-                  </a:txBody>
-                  <a:tcPr anchor="ctr">
-                    <a:solidFill>
-                      <a:srgbClr val="FFFFFF"/>
-                    </a:solidFill>
-                  </a:tcPr>
-                </a:tc>
-                <a:tc>
-                  <a:txBody>
-                    <a:bodyPr wrap="square"/>
-                    <a:lstStyle/>
-                    <a:p>
-                      <a:pPr algn="l"/>
-                      <a:r>
-                        <a:rPr sz="1400" b="0">
-                          <a:solidFill>
-                            <a:srgbClr val="222222"/>
-                          </a:solidFill>
-                          <a:latin typeface="Arial"/>
-                        </a:rPr>
-                        <a:t>passe, condução, drible</a:t>
-                      </a:r>
-                    </a:p>
-                  </a:txBody>
-                  <a:tcPr anchor="ctr">
-                    <a:solidFill>
-                      <a:srgbClr val="FFFFFF"/>
-                    </a:solidFill>
-                  </a:tcPr>
-                </a:tc>
-                <a:tc>
-                  <a:txBody>
-                    <a:bodyPr wrap="square"/>
-                    <a:lstStyle/>
-                    <a:p>
-                      <a:pPr algn="l"/>
-                      <a:r>
-                        <a:rPr sz="1400" b="0">
-                          <a:solidFill>
-                            <a:srgbClr val="222222"/>
-                          </a:solidFill>
-                          <a:latin typeface="Arial"/>
-                        </a:rPr>
-                        <a:t>o SPADL chama a condução de dribble</a:t>
-                      </a:r>
-                    </a:p>
-                  </a:txBody>
-                  <a:tcPr anchor="ctr">
-                    <a:solidFill>
-                      <a:srgbClr val="FFFFFF"/>
-                    </a:solidFill>
-                  </a:tcPr>
-                </a:tc>
               </a:tr>
             </a:tbl>
           </a:graphicData>
         </a:graphic>
       </p:graphicFrame>
+      <p:sp>
+        <p:nvSpPr>
+          <p:cNvPr id="13" name="TextBox 12"/>
+          <p:cNvSpPr txBox="1"/>
+          <p:nvPr/>
+        </p:nvSpPr>
+        <p:spPr>
+          <a:xfrm>
+            <a:off x="7635240" y="2423160"/>
+            <a:ext cx="4023360" cy="365760"/>
+          </a:xfrm>
+          <a:prstGeom prst="rect">
+            <a:avLst/>
+          </a:prstGeom>
+          <a:noFill/>
+        </p:spPr>
+        <p:txBody>
+          <a:bodyPr wrap="square" anchor="t" lIns="45720" rIns="45720">
+            <a:spAutoFit/>
+          </a:bodyPr>
+          <a:lstStyle/>
+          <a:p>
+            <a:pPr algn="ctr">
+              <a:spcAft>
+                <a:spcPts val="600"/>
+              </a:spcAft>
+            </a:pPr>
+            <a:r>
+              <a:rPr sz="1400" b="0">
+                <a:solidFill>
+                  <a:srgbClr val="666666"/>
+                </a:solidFill>
+                <a:latin typeface="Arial"/>
+              </a:rPr>
+              <a:t>Ataque: da esquerda para a direita →</a:t>
+            </a:r>
+          </a:p>
+        </p:txBody>
+      </p:sp>
+      <p:sp>
+        <p:nvSpPr>
+          <p:cNvPr id="14" name="Rectangle 13"/>
+          <p:cNvSpPr/>
+          <p:nvPr/>
+        </p:nvSpPr>
+        <p:spPr>
+          <a:xfrm>
+            <a:off x="7726679" y="2880360"/>
+            <a:ext cx="3840480" cy="2487168"/>
+          </a:xfrm>
+          <a:prstGeom prst="rect">
+            <a:avLst/>
+          </a:prstGeom>
+          <a:solidFill>
+            <a:srgbClr val="FFFFFF"/>
+          </a:solidFill>
+          <a:ln w="25400">
+            <a:solidFill>
+              <a:srgbClr val="666666"/>
+            </a:solidFill>
+          </a:ln>
+          <a:effectLst/>
+        </p:spPr>
+        <p:style>
+          <a:lnRef idx="1">
+            <a:schemeClr val="accent1"/>
+          </a:lnRef>
+          <a:fillRef idx="3">
+            <a:schemeClr val="accent1"/>
+          </a:fillRef>
+          <a:effectRef idx="2">
+            <a:schemeClr val="accent1"/>
+          </a:effectRef>
+          <a:fontRef idx="minor">
+            <a:schemeClr val="lt1"/>
+          </a:fontRef>
+        </p:style>
+        <p:txBody>
+          <a:bodyPr rtlCol="0" anchor="ctr"/>
+          <a:lstStyle/>
+          <a:p>
+            <a:pPr algn="ctr"/>
+          </a:p>
+        </p:txBody>
+      </p:sp>
+      <p:cxnSp>
+        <p:nvCxnSpPr>
+          <p:cNvPr id="15" name="Connector 14"/>
+          <p:cNvCxnSpPr/>
+          <p:nvPr/>
+        </p:nvCxnSpPr>
+        <p:spPr>
+          <a:xfrm>
+            <a:off x="8046719" y="2880360"/>
+            <a:ext cx="0" cy="2487168"/>
+          </a:xfrm>
+          <a:prstGeom prst="line">
+            <a:avLst/>
+          </a:prstGeom>
+          <a:ln w="9525">
+            <a:solidFill>
+              <a:srgbClr val="D0D0D0"/>
+            </a:solidFill>
+          </a:ln>
+        </p:spPr>
+        <p:style>
+          <a:lnRef idx="2">
+            <a:schemeClr val="accent1"/>
+          </a:lnRef>
+          <a:fillRef idx="0">
+            <a:schemeClr val="accent1"/>
+          </a:fillRef>
+          <a:effectRef idx="1">
+            <a:schemeClr val="accent1"/>
+          </a:effectRef>
+          <a:fontRef idx="minor">
+            <a:schemeClr val="tx1"/>
+          </a:fontRef>
+        </p:style>
+      </p:cxnSp>
+      <p:cxnSp>
+        <p:nvCxnSpPr>
+          <p:cNvPr id="16" name="Connector 15"/>
+          <p:cNvCxnSpPr/>
+          <p:nvPr/>
+        </p:nvCxnSpPr>
+        <p:spPr>
+          <a:xfrm>
+            <a:off x="8366759" y="2880360"/>
+            <a:ext cx="0" cy="2487168"/>
+          </a:xfrm>
+          <a:prstGeom prst="line">
+            <a:avLst/>
+          </a:prstGeom>
+          <a:ln w="9525">
+            <a:solidFill>
+              <a:srgbClr val="D0D0D0"/>
+            </a:solidFill>
+          </a:ln>
+        </p:spPr>
+        <p:style>
+          <a:lnRef idx="2">
+            <a:schemeClr val="accent1"/>
+          </a:lnRef>
+          <a:fillRef idx="0">
+            <a:schemeClr val="accent1"/>
+          </a:fillRef>
+          <a:effectRef idx="1">
+            <a:schemeClr val="accent1"/>
+          </a:effectRef>
+          <a:fontRef idx="minor">
+            <a:schemeClr val="tx1"/>
+          </a:fontRef>
+        </p:style>
+      </p:cxnSp>
+      <p:cxnSp>
+        <p:nvCxnSpPr>
+          <p:cNvPr id="17" name="Connector 16"/>
+          <p:cNvCxnSpPr/>
+          <p:nvPr/>
+        </p:nvCxnSpPr>
+        <p:spPr>
+          <a:xfrm>
+            <a:off x="8686800" y="2880360"/>
+            <a:ext cx="0" cy="2487168"/>
+          </a:xfrm>
+          <a:prstGeom prst="line">
+            <a:avLst/>
+          </a:prstGeom>
+          <a:ln w="9525">
+            <a:solidFill>
+              <a:srgbClr val="D0D0D0"/>
+            </a:solidFill>
+          </a:ln>
+        </p:spPr>
+        <p:style>
+          <a:lnRef idx="2">
+            <a:schemeClr val="accent1"/>
+          </a:lnRef>
+          <a:fillRef idx="0">
+            <a:schemeClr val="accent1"/>
+          </a:fillRef>
+          <a:effectRef idx="1">
+            <a:schemeClr val="accent1"/>
+          </a:effectRef>
+          <a:fontRef idx="minor">
+            <a:schemeClr val="tx1"/>
+          </a:fontRef>
+        </p:style>
+      </p:cxnSp>
+      <p:cxnSp>
+        <p:nvCxnSpPr>
+          <p:cNvPr id="18" name="Connector 17"/>
+          <p:cNvCxnSpPr/>
+          <p:nvPr/>
+        </p:nvCxnSpPr>
+        <p:spPr>
+          <a:xfrm>
+            <a:off x="9006840" y="2880360"/>
+            <a:ext cx="0" cy="2487168"/>
+          </a:xfrm>
+          <a:prstGeom prst="line">
+            <a:avLst/>
+          </a:prstGeom>
+          <a:ln w="9525">
+            <a:solidFill>
+              <a:srgbClr val="D0D0D0"/>
+            </a:solidFill>
+          </a:ln>
+        </p:spPr>
+        <p:style>
+          <a:lnRef idx="2">
+            <a:schemeClr val="accent1"/>
+          </a:lnRef>
+          <a:fillRef idx="0">
+            <a:schemeClr val="accent1"/>
+          </a:fillRef>
+          <a:effectRef idx="1">
+            <a:schemeClr val="accent1"/>
+          </a:effectRef>
+          <a:fontRef idx="minor">
+            <a:schemeClr val="tx1"/>
+          </a:fontRef>
+        </p:style>
+      </p:cxnSp>
+      <p:cxnSp>
+        <p:nvCxnSpPr>
+          <p:cNvPr id="19" name="Connector 18"/>
+          <p:cNvCxnSpPr/>
+          <p:nvPr/>
+        </p:nvCxnSpPr>
+        <p:spPr>
+          <a:xfrm>
+            <a:off x="9326880" y="2880360"/>
+            <a:ext cx="0" cy="2487168"/>
+          </a:xfrm>
+          <a:prstGeom prst="line">
+            <a:avLst/>
+          </a:prstGeom>
+          <a:ln w="9525">
+            <a:solidFill>
+              <a:srgbClr val="D0D0D0"/>
+            </a:solidFill>
+          </a:ln>
+        </p:spPr>
+        <p:style>
+          <a:lnRef idx="2">
+            <a:schemeClr val="accent1"/>
+          </a:lnRef>
+          <a:fillRef idx="0">
+            <a:schemeClr val="accent1"/>
+          </a:fillRef>
+          <a:effectRef idx="1">
+            <a:schemeClr val="accent1"/>
+          </a:effectRef>
+          <a:fontRef idx="minor">
+            <a:schemeClr val="tx1"/>
+          </a:fontRef>
+        </p:style>
+      </p:cxnSp>
+      <p:cxnSp>
+        <p:nvCxnSpPr>
+          <p:cNvPr id="20" name="Connector 19"/>
+          <p:cNvCxnSpPr/>
+          <p:nvPr/>
+        </p:nvCxnSpPr>
+        <p:spPr>
+          <a:xfrm>
+            <a:off x="9646919" y="2880360"/>
+            <a:ext cx="0" cy="2487168"/>
+          </a:xfrm>
+          <a:prstGeom prst="line">
+            <a:avLst/>
+          </a:prstGeom>
+          <a:ln w="9525">
+            <a:solidFill>
+              <a:srgbClr val="D0D0D0"/>
+            </a:solidFill>
+          </a:ln>
+        </p:spPr>
+        <p:style>
+          <a:lnRef idx="2">
+            <a:schemeClr val="accent1"/>
+          </a:lnRef>
+          <a:fillRef idx="0">
+            <a:schemeClr val="accent1"/>
+          </a:fillRef>
+          <a:effectRef idx="1">
+            <a:schemeClr val="accent1"/>
+          </a:effectRef>
+          <a:fontRef idx="minor">
+            <a:schemeClr val="tx1"/>
+          </a:fontRef>
+        </p:style>
+      </p:cxnSp>
+      <p:cxnSp>
+        <p:nvCxnSpPr>
+          <p:cNvPr id="21" name="Connector 20"/>
+          <p:cNvCxnSpPr/>
+          <p:nvPr/>
+        </p:nvCxnSpPr>
+        <p:spPr>
+          <a:xfrm>
+            <a:off x="9966959" y="2880360"/>
+            <a:ext cx="0" cy="2487168"/>
+          </a:xfrm>
+          <a:prstGeom prst="line">
+            <a:avLst/>
+          </a:prstGeom>
+          <a:ln w="9525">
+            <a:solidFill>
+              <a:srgbClr val="D0D0D0"/>
+            </a:solidFill>
+          </a:ln>
+        </p:spPr>
+        <p:style>
+          <a:lnRef idx="2">
+            <a:schemeClr val="accent1"/>
+          </a:lnRef>
+          <a:fillRef idx="0">
+            <a:schemeClr val="accent1"/>
+          </a:fillRef>
+          <a:effectRef idx="1">
+            <a:schemeClr val="accent1"/>
+          </a:effectRef>
+          <a:fontRef idx="minor">
+            <a:schemeClr val="tx1"/>
+          </a:fontRef>
+        </p:style>
+      </p:cxnSp>
+      <p:cxnSp>
+        <p:nvCxnSpPr>
+          <p:cNvPr id="22" name="Connector 21"/>
+          <p:cNvCxnSpPr/>
+          <p:nvPr/>
+        </p:nvCxnSpPr>
+        <p:spPr>
+          <a:xfrm>
+            <a:off x="10287000" y="2880360"/>
+            <a:ext cx="0" cy="2487168"/>
+          </a:xfrm>
+          <a:prstGeom prst="line">
+            <a:avLst/>
+          </a:prstGeom>
+          <a:ln w="9525">
+            <a:solidFill>
+              <a:srgbClr val="D0D0D0"/>
+            </a:solidFill>
+          </a:ln>
+        </p:spPr>
+        <p:style>
+          <a:lnRef idx="2">
+            <a:schemeClr val="accent1"/>
+          </a:lnRef>
+          <a:fillRef idx="0">
+            <a:schemeClr val="accent1"/>
+          </a:fillRef>
+          <a:effectRef idx="1">
+            <a:schemeClr val="accent1"/>
+          </a:effectRef>
+          <a:fontRef idx="minor">
+            <a:schemeClr val="tx1"/>
+          </a:fontRef>
+        </p:style>
+      </p:cxnSp>
+      <p:cxnSp>
+        <p:nvCxnSpPr>
+          <p:cNvPr id="23" name="Connector 22"/>
+          <p:cNvCxnSpPr/>
+          <p:nvPr/>
+        </p:nvCxnSpPr>
+        <p:spPr>
+          <a:xfrm>
+            <a:off x="10607040" y="2880360"/>
+            <a:ext cx="0" cy="2487168"/>
+          </a:xfrm>
+          <a:prstGeom prst="line">
+            <a:avLst/>
+          </a:prstGeom>
+          <a:ln w="9525">
+            <a:solidFill>
+              <a:srgbClr val="D0D0D0"/>
+            </a:solidFill>
+          </a:ln>
+        </p:spPr>
+        <p:style>
+          <a:lnRef idx="2">
+            <a:schemeClr val="accent1"/>
+          </a:lnRef>
+          <a:fillRef idx="0">
+            <a:schemeClr val="accent1"/>
+          </a:fillRef>
+          <a:effectRef idx="1">
+            <a:schemeClr val="accent1"/>
+          </a:effectRef>
+          <a:fontRef idx="minor">
+            <a:schemeClr val="tx1"/>
+          </a:fontRef>
+        </p:style>
+      </p:cxnSp>
+      <p:cxnSp>
+        <p:nvCxnSpPr>
+          <p:cNvPr id="24" name="Connector 23"/>
+          <p:cNvCxnSpPr/>
+          <p:nvPr/>
+        </p:nvCxnSpPr>
+        <p:spPr>
+          <a:xfrm>
+            <a:off x="10927080" y="2880360"/>
+            <a:ext cx="0" cy="2487168"/>
+          </a:xfrm>
+          <a:prstGeom prst="line">
+            <a:avLst/>
+          </a:prstGeom>
+          <a:ln w="9525">
+            <a:solidFill>
+              <a:srgbClr val="D0D0D0"/>
+            </a:solidFill>
+          </a:ln>
+        </p:spPr>
+        <p:style>
+          <a:lnRef idx="2">
+            <a:schemeClr val="accent1"/>
+          </a:lnRef>
+          <a:fillRef idx="0">
+            <a:schemeClr val="accent1"/>
+          </a:fillRef>
+          <a:effectRef idx="1">
+            <a:schemeClr val="accent1"/>
+          </a:effectRef>
+          <a:fontRef idx="minor">
+            <a:schemeClr val="tx1"/>
+          </a:fontRef>
+        </p:style>
+      </p:cxnSp>
+      <p:cxnSp>
+        <p:nvCxnSpPr>
+          <p:cNvPr id="25" name="Connector 24"/>
+          <p:cNvCxnSpPr/>
+          <p:nvPr/>
+        </p:nvCxnSpPr>
+        <p:spPr>
+          <a:xfrm>
+            <a:off x="11247120" y="2880360"/>
+            <a:ext cx="0" cy="2487168"/>
+          </a:xfrm>
+          <a:prstGeom prst="line">
+            <a:avLst/>
+          </a:prstGeom>
+          <a:ln w="9525">
+            <a:solidFill>
+              <a:srgbClr val="D0D0D0"/>
+            </a:solidFill>
+          </a:ln>
+        </p:spPr>
+        <p:style>
+          <a:lnRef idx="2">
+            <a:schemeClr val="accent1"/>
+          </a:lnRef>
+          <a:fillRef idx="0">
+            <a:schemeClr val="accent1"/>
+          </a:fillRef>
+          <a:effectRef idx="1">
+            <a:schemeClr val="accent1"/>
+          </a:effectRef>
+          <a:fontRef idx="minor">
+            <a:schemeClr val="tx1"/>
+          </a:fontRef>
+        </p:style>
+      </p:cxnSp>
+      <p:cxnSp>
+        <p:nvCxnSpPr>
+          <p:cNvPr id="26" name="Connector 25"/>
+          <p:cNvCxnSpPr/>
+          <p:nvPr/>
+        </p:nvCxnSpPr>
+        <p:spPr>
+          <a:xfrm>
+            <a:off x="7726679" y="3191256"/>
+            <a:ext cx="3840480" cy="0"/>
+          </a:xfrm>
+          <a:prstGeom prst="line">
+            <a:avLst/>
+          </a:prstGeom>
+          <a:ln w="9525">
+            <a:solidFill>
+              <a:srgbClr val="D0D0D0"/>
+            </a:solidFill>
+          </a:ln>
+        </p:spPr>
+        <p:style>
+          <a:lnRef idx="2">
+            <a:schemeClr val="accent1"/>
+          </a:lnRef>
+          <a:fillRef idx="0">
+            <a:schemeClr val="accent1"/>
+          </a:fillRef>
+          <a:effectRef idx="1">
+            <a:schemeClr val="accent1"/>
+          </a:effectRef>
+          <a:fontRef idx="minor">
+            <a:schemeClr val="tx1"/>
+          </a:fontRef>
+        </p:style>
+      </p:cxnSp>
+      <p:cxnSp>
+        <p:nvCxnSpPr>
+          <p:cNvPr id="27" name="Connector 26"/>
+          <p:cNvCxnSpPr/>
+          <p:nvPr/>
+        </p:nvCxnSpPr>
+        <p:spPr>
+          <a:xfrm>
+            <a:off x="7726679" y="3502152"/>
+            <a:ext cx="3840480" cy="0"/>
+          </a:xfrm>
+          <a:prstGeom prst="line">
+            <a:avLst/>
+          </a:prstGeom>
+          <a:ln w="9525">
+            <a:solidFill>
+              <a:srgbClr val="D0D0D0"/>
+            </a:solidFill>
+          </a:ln>
+        </p:spPr>
+        <p:style>
+          <a:lnRef idx="2">
+            <a:schemeClr val="accent1"/>
+          </a:lnRef>
+          <a:fillRef idx="0">
+            <a:schemeClr val="accent1"/>
+          </a:fillRef>
+          <a:effectRef idx="1">
+            <a:schemeClr val="accent1"/>
+          </a:effectRef>
+          <a:fontRef idx="minor">
+            <a:schemeClr val="tx1"/>
+          </a:fontRef>
+        </p:style>
+      </p:cxnSp>
+      <p:cxnSp>
+        <p:nvCxnSpPr>
+          <p:cNvPr id="28" name="Connector 27"/>
+          <p:cNvCxnSpPr/>
+          <p:nvPr/>
+        </p:nvCxnSpPr>
+        <p:spPr>
+          <a:xfrm>
+            <a:off x="7726679" y="3813048"/>
+            <a:ext cx="3840480" cy="0"/>
+          </a:xfrm>
+          <a:prstGeom prst="line">
+            <a:avLst/>
+          </a:prstGeom>
+          <a:ln w="9525">
+            <a:solidFill>
+              <a:srgbClr val="D0D0D0"/>
+            </a:solidFill>
+          </a:ln>
+        </p:spPr>
+        <p:style>
+          <a:lnRef idx="2">
+            <a:schemeClr val="accent1"/>
+          </a:lnRef>
+          <a:fillRef idx="0">
+            <a:schemeClr val="accent1"/>
+          </a:fillRef>
+          <a:effectRef idx="1">
+            <a:schemeClr val="accent1"/>
+          </a:effectRef>
+          <a:fontRef idx="minor">
+            <a:schemeClr val="tx1"/>
+          </a:fontRef>
+        </p:style>
+      </p:cxnSp>
+      <p:cxnSp>
+        <p:nvCxnSpPr>
+          <p:cNvPr id="29" name="Connector 28"/>
+          <p:cNvCxnSpPr/>
+          <p:nvPr/>
+        </p:nvCxnSpPr>
+        <p:spPr>
+          <a:xfrm>
+            <a:off x="7726679" y="4123944"/>
+            <a:ext cx="3840480" cy="0"/>
+          </a:xfrm>
+          <a:prstGeom prst="line">
+            <a:avLst/>
+          </a:prstGeom>
+          <a:ln w="9525">
+            <a:solidFill>
+              <a:srgbClr val="D0D0D0"/>
+            </a:solidFill>
+          </a:ln>
+        </p:spPr>
+        <p:style>
+          <a:lnRef idx="2">
+            <a:schemeClr val="accent1"/>
+          </a:lnRef>
+          <a:fillRef idx="0">
+            <a:schemeClr val="accent1"/>
+          </a:fillRef>
+          <a:effectRef idx="1">
+            <a:schemeClr val="accent1"/>
+          </a:effectRef>
+          <a:fontRef idx="minor">
+            <a:schemeClr val="tx1"/>
+          </a:fontRef>
+        </p:style>
+      </p:cxnSp>
+      <p:cxnSp>
+        <p:nvCxnSpPr>
+          <p:cNvPr id="30" name="Connector 29"/>
+          <p:cNvCxnSpPr/>
+          <p:nvPr/>
+        </p:nvCxnSpPr>
+        <p:spPr>
+          <a:xfrm>
+            <a:off x="7726679" y="4434840"/>
+            <a:ext cx="3840480" cy="0"/>
+          </a:xfrm>
+          <a:prstGeom prst="line">
+            <a:avLst/>
+          </a:prstGeom>
+          <a:ln w="9525">
+            <a:solidFill>
+              <a:srgbClr val="D0D0D0"/>
+            </a:solidFill>
+          </a:ln>
+        </p:spPr>
+        <p:style>
+          <a:lnRef idx="2">
+            <a:schemeClr val="accent1"/>
+          </a:lnRef>
+          <a:fillRef idx="0">
+            <a:schemeClr val="accent1"/>
+          </a:fillRef>
+          <a:effectRef idx="1">
+            <a:schemeClr val="accent1"/>
+          </a:effectRef>
+          <a:fontRef idx="minor">
+            <a:schemeClr val="tx1"/>
+          </a:fontRef>
+        </p:style>
+      </p:cxnSp>
+      <p:cxnSp>
+        <p:nvCxnSpPr>
+          <p:cNvPr id="31" name="Connector 30"/>
+          <p:cNvCxnSpPr/>
+          <p:nvPr/>
+        </p:nvCxnSpPr>
+        <p:spPr>
+          <a:xfrm>
+            <a:off x="7726679" y="4745736"/>
+            <a:ext cx="3840480" cy="0"/>
+          </a:xfrm>
+          <a:prstGeom prst="line">
+            <a:avLst/>
+          </a:prstGeom>
+          <a:ln w="9525">
+            <a:solidFill>
+              <a:srgbClr val="D0D0D0"/>
+            </a:solidFill>
+          </a:ln>
+        </p:spPr>
+        <p:style>
+          <a:lnRef idx="2">
+            <a:schemeClr val="accent1"/>
+          </a:lnRef>
+          <a:fillRef idx="0">
+            <a:schemeClr val="accent1"/>
+          </a:fillRef>
+          <a:effectRef idx="1">
+            <a:schemeClr val="accent1"/>
+          </a:effectRef>
+          <a:fontRef idx="minor">
+            <a:schemeClr val="tx1"/>
+          </a:fontRef>
+        </p:style>
+      </p:cxnSp>
+      <p:cxnSp>
+        <p:nvCxnSpPr>
+          <p:cNvPr id="32" name="Connector 31"/>
+          <p:cNvCxnSpPr/>
+          <p:nvPr/>
+        </p:nvCxnSpPr>
+        <p:spPr>
+          <a:xfrm>
+            <a:off x="7726679" y="5056632"/>
+            <a:ext cx="3840480" cy="0"/>
+          </a:xfrm>
+          <a:prstGeom prst="line">
+            <a:avLst/>
+          </a:prstGeom>
+          <a:ln w="9525">
+            <a:solidFill>
+              <a:srgbClr val="D0D0D0"/>
+            </a:solidFill>
+          </a:ln>
+        </p:spPr>
+        <p:style>
+          <a:lnRef idx="2">
+            <a:schemeClr val="accent1"/>
+          </a:lnRef>
+          <a:fillRef idx="0">
+            <a:schemeClr val="accent1"/>
+          </a:fillRef>
+          <a:effectRef idx="1">
+            <a:schemeClr val="accent1"/>
+          </a:effectRef>
+          <a:fontRef idx="minor">
+            <a:schemeClr val="tx1"/>
+          </a:fontRef>
+        </p:style>
+      </p:cxnSp>
+      <p:sp>
+        <p:nvSpPr>
+          <p:cNvPr id="33" name="Rectangle 32"/>
+          <p:cNvSpPr/>
+          <p:nvPr/>
+        </p:nvSpPr>
+        <p:spPr>
+          <a:xfrm>
+            <a:off x="10607040" y="3502152"/>
+            <a:ext cx="320040" cy="310896"/>
+          </a:xfrm>
+          <a:prstGeom prst="rect">
+            <a:avLst/>
+          </a:prstGeom>
+          <a:solidFill>
+            <a:srgbClr val="E6EEF6"/>
+          </a:solidFill>
+          <a:ln w="19050">
+            <a:solidFill>
+              <a:srgbClr val="1F5C99"/>
+            </a:solidFill>
+          </a:ln>
+          <a:effectLst/>
+        </p:spPr>
+        <p:style>
+          <a:lnRef idx="1">
+            <a:schemeClr val="accent1"/>
+          </a:lnRef>
+          <a:fillRef idx="3">
+            <a:schemeClr val="accent1"/>
+          </a:fillRef>
+          <a:effectRef idx="2">
+            <a:schemeClr val="accent1"/>
+          </a:effectRef>
+          <a:fontRef idx="minor">
+            <a:schemeClr val="lt1"/>
+          </a:fontRef>
+        </p:style>
+        <p:txBody>
+          <a:bodyPr rtlCol="0" anchor="ctr"/>
+          <a:lstStyle/>
+          <a:p>
+            <a:pPr algn="ctr"/>
+          </a:p>
+        </p:txBody>
+      </p:sp>
+      <p:sp>
+        <p:nvSpPr>
+          <p:cNvPr id="34" name="Rectangle 33"/>
+          <p:cNvSpPr/>
+          <p:nvPr/>
+        </p:nvSpPr>
+        <p:spPr>
+          <a:xfrm>
+            <a:off x="11247120" y="4123944"/>
+            <a:ext cx="320040" cy="310896"/>
+          </a:xfrm>
+          <a:prstGeom prst="rect">
+            <a:avLst/>
+          </a:prstGeom>
+          <a:solidFill>
+            <a:srgbClr val="E6EEF6"/>
+          </a:solidFill>
+          <a:ln w="19050">
+            <a:solidFill>
+              <a:srgbClr val="1F5C99"/>
+            </a:solidFill>
+          </a:ln>
+          <a:effectLst/>
+        </p:spPr>
+        <p:style>
+          <a:lnRef idx="1">
+            <a:schemeClr val="accent1"/>
+          </a:lnRef>
+          <a:fillRef idx="3">
+            <a:schemeClr val="accent1"/>
+          </a:fillRef>
+          <a:effectRef idx="2">
+            <a:schemeClr val="accent1"/>
+          </a:effectRef>
+          <a:fontRef idx="minor">
+            <a:schemeClr val="lt1"/>
+          </a:fontRef>
+        </p:style>
+        <p:txBody>
+          <a:bodyPr rtlCol="0" anchor="ctr"/>
+          <a:lstStyle/>
+          <a:p>
+            <a:pPr algn="ctr"/>
+          </a:p>
+        </p:txBody>
+      </p:sp>
+      <p:cxnSp>
+        <p:nvCxnSpPr>
+          <p:cNvPr id="35" name="Connector 34"/>
+          <p:cNvCxnSpPr/>
+          <p:nvPr/>
+        </p:nvCxnSpPr>
+        <p:spPr>
+          <a:xfrm>
+            <a:off x="10767059" y="3657600"/>
+            <a:ext cx="640081" cy="621792"/>
+          </a:xfrm>
+          <a:prstGeom prst="line">
+            <a:avLst/>
+          </a:prstGeom>
+          <a:ln w="38100">
+            <a:solidFill>
+              <a:srgbClr val="1F5C99"/>
+            </a:solidFill>
+            <a:tailEnd type="triangle"/>
+          </a:ln>
+        </p:spPr>
+        <p:style>
+          <a:lnRef idx="2">
+            <a:schemeClr val="accent1"/>
+          </a:lnRef>
+          <a:fillRef idx="0">
+            <a:schemeClr val="accent1"/>
+          </a:fillRef>
+          <a:effectRef idx="1">
+            <a:schemeClr val="accent1"/>
+          </a:effectRef>
+          <a:fontRef idx="minor">
+            <a:schemeClr val="tx1"/>
+          </a:fontRef>
+        </p:style>
+      </p:cxnSp>
+      <p:sp>
+        <p:nvSpPr>
+          <p:cNvPr id="36" name="TextBox 35"/>
+          <p:cNvSpPr txBox="1"/>
+          <p:nvPr/>
+        </p:nvSpPr>
+        <p:spPr>
+          <a:xfrm>
+            <a:off x="7635240" y="5413248"/>
+            <a:ext cx="4023360" cy="640080"/>
+          </a:xfrm>
+          <a:prstGeom prst="rect">
+            <a:avLst/>
+          </a:prstGeom>
+          <a:noFill/>
+        </p:spPr>
+        <p:txBody>
+          <a:bodyPr wrap="square" anchor="t" lIns="45720" rIns="45720">
+            <a:spAutoFit/>
+          </a:bodyPr>
+          <a:lstStyle/>
+          <a:p>
+            <a:pPr algn="ctr">
+              <a:spcAft>
+                <a:spcPts val="600"/>
+              </a:spcAft>
+            </a:pPr>
+            <a:r>
+              <a:rPr sz="1400" b="0">
+                <a:solidFill>
+                  <a:srgbClr val="222222"/>
+                </a:solidFill>
+                <a:latin typeface="Arial"/>
+              </a:rPr>
+              <a:t>Grade de 96 zonas; passe da zona 74 para a 92</a:t>
+            </a:r>
+          </a:p>
+        </p:txBody>
+      </p:sp>
     </p:spTree>
   </p:cSld>
   <p:clrMapOvr>
@@ -11262,7 +11779,7 @@
         </p:nvSpPr>
         <p:spPr>
           <a:xfrm>
-            <a:off x="1600200" y="3108960"/>
+            <a:off x="1600200" y="3090672"/>
             <a:ext cx="1097280" cy="274320"/>
           </a:xfrm>
           <a:prstGeom prst="rect">
@@ -11284,13 +11801,13 @@
               </a:spcAft>
             </a:pPr>
             <a:r>
-              <a:rPr sz="1000" b="0">
+              <a:rPr sz="1400" b="0">
                 <a:solidFill>
                   <a:srgbClr val="666666"/>
                 </a:solidFill>
                 <a:latin typeface="Arial"/>
               </a:rPr>
-              <a:t>MEMBRO_DE</a:t>
+              <a:t>membro de</a:t>
             </a:r>
           </a:p>
         </p:txBody>
@@ -11338,8 +11855,8 @@
         </p:nvSpPr>
         <p:spPr>
           <a:xfrm>
-            <a:off x="4434840" y="3108960"/>
-            <a:ext cx="1097280" cy="274320"/>
+            <a:off x="4572000" y="3090672"/>
+            <a:ext cx="960120" cy="274320"/>
           </a:xfrm>
           <a:prstGeom prst="rect">
             <a:avLst/>
@@ -11360,13 +11877,13 @@
               </a:spcAft>
             </a:pPr>
             <a:r>
-              <a:rPr sz="1000" b="0">
+              <a:rPr sz="1400" b="0">
                 <a:solidFill>
                   <a:srgbClr val="666666"/>
                 </a:solidFill>
                 <a:latin typeface="Arial"/>
               </a:rPr>
-              <a:t>REALIZOU</a:t>
+              <a:t>realizou</a:t>
             </a:r>
           </a:p>
         </p:txBody>
@@ -11414,8 +11931,8 @@
         </p:nvSpPr>
         <p:spPr>
           <a:xfrm>
-            <a:off x="1280160" y="4297680"/>
-            <a:ext cx="1463040" cy="274320"/>
+            <a:off x="1097280" y="4206240"/>
+            <a:ext cx="1371600" cy="274320"/>
           </a:xfrm>
           <a:prstGeom prst="rect">
             <a:avLst/>
@@ -11436,13 +11953,13 @@
               </a:spcAft>
             </a:pPr>
             <a:r>
-              <a:rPr sz="1000" b="0">
+              <a:rPr sz="1400" b="0">
                 <a:solidFill>
                   <a:srgbClr val="666666"/>
                 </a:solidFill>
                 <a:latin typeface="Arial"/>
               </a:rPr>
-              <a:t>PARTICIPOU_DE</a:t>
+              <a:t>participou de</a:t>
             </a:r>
           </a:p>
         </p:txBody>
@@ -11490,8 +12007,8 @@
         </p:nvSpPr>
         <p:spPr>
           <a:xfrm>
-            <a:off x="2926080" y="4206240"/>
-            <a:ext cx="1463040" cy="274320"/>
+            <a:off x="2926080" y="4069080"/>
+            <a:ext cx="1508760" cy="274320"/>
           </a:xfrm>
           <a:prstGeom prst="rect">
             <a:avLst/>
@@ -11512,13 +12029,13 @@
               </a:spcAft>
             </a:pPr>
             <a:r>
-              <a:rPr sz="1000" b="0">
+              <a:rPr sz="1400" b="0">
                 <a:solidFill>
                   <a:srgbClr val="666666"/>
                 </a:solidFill>
                 <a:latin typeface="Arial"/>
               </a:rPr>
-              <a:t>TEM_ESTATISTICA</a:t>
+              <a:t>tem estatística</a:t>
             </a:r>
           </a:p>
         </p:txBody>
@@ -11566,8 +12083,8 @@
         </p:nvSpPr>
         <p:spPr>
           <a:xfrm>
-            <a:off x="4572000" y="4297680"/>
-            <a:ext cx="1097280" cy="274320"/>
+            <a:off x="4663440" y="4206240"/>
+            <a:ext cx="960120" cy="274320"/>
           </a:xfrm>
           <a:prstGeom prst="rect">
             <a:avLst/>
@@ -11588,13 +12105,13 @@
               </a:spcAft>
             </a:pPr>
             <a:r>
-              <a:rPr sz="1000" b="0">
+              <a:rPr sz="1400" b="0">
                 <a:solidFill>
                   <a:srgbClr val="666666"/>
                 </a:solidFill>
                 <a:latin typeface="Arial"/>
               </a:rPr>
-              <a:t>ATUOU_EM</a:t>
+              <a:t>atuou em</a:t>
             </a:r>
           </a:p>
         </p:txBody>
@@ -11710,7 +12227,7 @@
           <a:p>
             <a:pPr algn="ctr"/>
             <a:r>
-              <a:rPr sz="1200" b="0">
+              <a:rPr sz="1400" b="0">
                 <a:solidFill>
                   <a:srgbClr val="666666"/>
                 </a:solidFill>
@@ -11832,7 +12349,7 @@
           <a:p>
             <a:pPr algn="ctr"/>
             <a:r>
-              <a:rPr sz="1200" b="0">
+              <a:rPr sz="1400" b="0">
                 <a:solidFill>
                   <a:srgbClr val="666666"/>
                 </a:solidFill>
@@ -11899,13 +12416,13 @@
           <a:p>
             <a:pPr algn="ctr"/>
             <a:r>
-              <a:rPr sz="1200" b="0">
+              <a:rPr sz="1400" b="0">
                 <a:solidFill>
                   <a:srgbClr val="666666"/>
                 </a:solidFill>
                 <a:latin typeface="Arial"/>
               </a:rPr>
-              <a:t>por jogador e time</a:t>
+              <a:t>jogador e time</a:t>
             </a:r>
           </a:p>
         </p:txBody>
@@ -11966,7 +12483,7 @@
           <a:p>
             <a:pPr algn="ctr"/>
             <a:r>
-              <a:rPr sz="1200" b="0">
+              <a:rPr sz="1400" b="0">
                 <a:solidFill>
                   <a:srgbClr val="666666"/>
                 </a:solidFill>
@@ -12005,13 +12522,13 @@
               </a:spcAft>
             </a:pPr>
             <a:r>
-              <a:rPr sz="1200" b="0">
+              <a:rPr sz="1400" b="0">
                 <a:solidFill>
                   <a:srgbClr val="666666"/>
                 </a:solidFill>
                 <a:latin typeface="Arial"/>
               </a:rPr>
-              <a:t>Entre jogadores: PASSOU_PARA, DEU_ASSISTENCIA, PRESSIONOU</a:t>
+              <a:t>Entre jogadores: passou para, deu assistência, pressionou</a:t>
             </a:r>
           </a:p>
           <a:p>
@@ -12021,13 +12538,13 @@
               </a:spcAft>
             </a:pPr>
             <a:r>
-              <a:rPr sz="1200" b="0">
+              <a:rPr sz="1400" b="0">
                 <a:solidFill>
                   <a:srgbClr val="666666"/>
                 </a:solidFill>
                 <a:latin typeface="Arial"/>
               </a:rPr>
-              <a:t>Entre zonas: PROGREDIU_PARA</a:t>
+              <a:t>Entre zonas: progrediu para</a:t>
             </a:r>
           </a:p>
         </p:txBody>
@@ -13391,7 +13908,7 @@
                 </a:solidFill>
                 <a:latin typeface="Arial"/>
               </a:rPr>
-              <a:t>Mesmo grafo, duas formas de consultar: o modelo escreve a consulta ou escolhe a ferramenta</a:t>
+              <a:t>Mesmo grafo, duas formas de consultar</a:t>
             </a:r>
           </a:p>
         </p:txBody>
@@ -13691,7 +14208,7 @@
         </p:nvSpPr>
         <p:spPr>
           <a:xfrm>
-            <a:off x="777240" y="2487168"/>
+            <a:off x="777240" y="2468880"/>
             <a:ext cx="5074920" cy="320040"/>
           </a:xfrm>
           <a:prstGeom prst="rect">
@@ -13711,7 +14228,7 @@
               </a:spcAft>
             </a:pPr>
             <a:r>
-              <a:rPr sz="1200" b="0">
+              <a:rPr sz="1400" b="0">
                 <a:solidFill>
                   <a:srgbClr val="222222"/>
                 </a:solidFill>
@@ -13731,7 +14248,7 @@
         <p:spPr>
           <a:xfrm>
             <a:off x="777240" y="2807208"/>
-            <a:ext cx="5074920" cy="1783080"/>
+            <a:ext cx="5074920" cy="2148840"/>
           </a:xfrm>
           <a:prstGeom prst="rect">
             <a:avLst/>
@@ -13775,7 +14292,7 @@
         <p:spPr>
           <a:xfrm>
             <a:off x="868680" y="2852927"/>
-            <a:ext cx="4892040" cy="1691639"/>
+            <a:ext cx="4892040" cy="2057400"/>
           </a:xfrm>
           <a:prstGeom prst="rect">
             <a:avLst/>
@@ -13789,7 +14306,7 @@
           <a:lstStyle/>
           <a:p>
             <a:r>
-              <a:rPr sz="1100">
+              <a:rPr sz="1300">
                 <a:solidFill>
                   <a:srgbClr val="E8E8E8"/>
                 </a:solidFill>
@@ -13800,7 +14317,7 @@
           </a:p>
           <a:p>
             <a:r>
-              <a:rPr sz="1100">
+              <a:rPr sz="1300">
                 <a:solidFill>
                   <a:srgbClr val="E8E8E8"/>
                 </a:solidFill>
@@ -13811,7 +14328,7 @@
           </a:p>
           <a:p>
             <a:r>
-              <a:rPr sz="1100">
+              <a:rPr sz="1300">
                 <a:solidFill>
                   <a:srgbClr val="E8E8E8"/>
                 </a:solidFill>
@@ -13822,7 +14339,7 @@
           </a:p>
           <a:p>
             <a:r>
-              <a:rPr sz="1100">
+              <a:rPr sz="1300">
                 <a:solidFill>
                   <a:srgbClr val="E8E8E8"/>
                 </a:solidFill>
@@ -13833,7 +14350,7 @@
           </a:p>
           <a:p>
             <a:r>
-              <a:rPr sz="1100">
+              <a:rPr sz="1300">
                 <a:solidFill>
                   <a:srgbClr val="E8E8E8"/>
                 </a:solidFill>
@@ -13844,7 +14361,7 @@
           </a:p>
           <a:p>
             <a:r>
-              <a:rPr sz="1100">
+              <a:rPr sz="1300">
                 <a:solidFill>
                   <a:srgbClr val="E8E8E8"/>
                 </a:solidFill>
@@ -13855,7 +14372,7 @@
           </a:p>
           <a:p>
             <a:r>
-              <a:rPr sz="1100">
+              <a:rPr sz="1300">
                 <a:solidFill>
                   <a:srgbClr val="E8E8E8"/>
                 </a:solidFill>
@@ -13866,7 +14383,7 @@
           </a:p>
           <a:p>
             <a:r>
-              <a:rPr sz="1100">
+              <a:rPr sz="1300">
                 <a:solidFill>
                   <a:srgbClr val="E8E8E8"/>
                 </a:solidFill>
@@ -13877,7 +14394,7 @@
           </a:p>
           <a:p>
             <a:r>
-              <a:rPr sz="1100">
+              <a:rPr sz="1300">
                 <a:solidFill>
                   <a:srgbClr val="E8E8E8"/>
                 </a:solidFill>
@@ -13888,7 +14405,7 @@
           </a:p>
           <a:p>
             <a:r>
-              <a:rPr sz="1100">
+              <a:rPr sz="1300">
                 <a:solidFill>
                   <a:srgbClr val="E8E8E8"/>
                 </a:solidFill>
@@ -13907,7 +14424,7 @@
         </p:nvSpPr>
         <p:spPr>
           <a:xfrm>
-            <a:off x="777240" y="4636008"/>
+            <a:off x="777240" y="4983480"/>
             <a:ext cx="5074920" cy="365760"/>
           </a:xfrm>
           <a:prstGeom prst="rect">
@@ -13927,13 +14444,13 @@
               </a:spcAft>
             </a:pPr>
             <a:r>
-              <a:rPr sz="1200" b="0">
+              <a:rPr sz="1400" b="0">
                 <a:solidFill>
                   <a:srgbClr val="222222"/>
                 </a:solidFill>
                 <a:latin typeface="Arial"/>
               </a:rPr>
-              <a:t>Ferramenta executa essa consulta no grafo e devolve:</a:t>
+              <a:t>Ferramenta executa no grafo e devolve:</a:t>
             </a:r>
           </a:p>
         </p:txBody>
@@ -13946,8 +14463,8 @@
         </p:nvSpPr>
         <p:spPr>
           <a:xfrm>
-            <a:off x="777240" y="5001768"/>
-            <a:ext cx="5074920" cy="594360"/>
+            <a:off x="777240" y="5349240"/>
+            <a:ext cx="5074920" cy="548640"/>
           </a:xfrm>
           <a:prstGeom prst="rect">
             <a:avLst/>
@@ -13990,8 +14507,8 @@
         </p:nvSpPr>
         <p:spPr>
           <a:xfrm>
-            <a:off x="868680" y="5047488"/>
-            <a:ext cx="4892040" cy="502920"/>
+            <a:off x="868680" y="5394959"/>
+            <a:ext cx="4892040" cy="457200"/>
           </a:xfrm>
           <a:prstGeom prst="rect">
             <a:avLst/>
@@ -14005,7 +14522,7 @@
           <a:lstStyle/>
           <a:p>
             <a:r>
-              <a:rPr sz="1100">
+              <a:rPr sz="1300">
                 <a:solidFill>
                   <a:srgbClr val="E8E8E8"/>
                 </a:solidFill>
@@ -14016,7 +14533,7 @@
           </a:p>
           <a:p>
             <a:r>
-              <a:rPr sz="1100">
+              <a:rPr sz="1300">
                 <a:solidFill>
                   <a:srgbClr val="E8E8E8"/>
                 </a:solidFill>
@@ -14035,8 +14552,8 @@
         </p:nvSpPr>
         <p:spPr>
           <a:xfrm>
-            <a:off x="777240" y="5715000"/>
-            <a:ext cx="5074920" cy="502920"/>
+            <a:off x="777240" y="5916168"/>
+            <a:ext cx="5074920" cy="365760"/>
           </a:xfrm>
           <a:prstGeom prst="rect">
             <a:avLst/>
@@ -14055,7 +14572,7 @@
               </a:spcAft>
             </a:pPr>
             <a:r>
-              <a:rPr sz="1300" b="1">
+              <a:rPr sz="1400" b="1">
                 <a:solidFill>
                   <a:srgbClr val="222222"/>
                 </a:solidFill>
@@ -14157,7 +14674,7 @@
         </p:nvSpPr>
         <p:spPr>
           <a:xfrm>
-            <a:off x="6309360" y="2487168"/>
+            <a:off x="6309360" y="2468880"/>
             <a:ext cx="5074920" cy="320040"/>
           </a:xfrm>
           <a:prstGeom prst="rect">
@@ -14177,7 +14694,7 @@
               </a:spcAft>
             </a:pPr>
             <a:r>
-              <a:rPr sz="1200" b="0">
+              <a:rPr sz="1400" b="0">
                 <a:solidFill>
                   <a:srgbClr val="222222"/>
                 </a:solidFill>
@@ -14197,7 +14714,7 @@
         <p:spPr>
           <a:xfrm>
             <a:off x="6309360" y="2807208"/>
-            <a:ext cx="5074920" cy="1783080"/>
+            <a:ext cx="5074920" cy="2148840"/>
           </a:xfrm>
           <a:prstGeom prst="rect">
             <a:avLst/>
@@ -14241,7 +14758,7 @@
         <p:spPr>
           <a:xfrm>
             <a:off x="6400800" y="2852927"/>
-            <a:ext cx="4892040" cy="1691639"/>
+            <a:ext cx="4892040" cy="2057400"/>
           </a:xfrm>
           <a:prstGeom prst="rect">
             <a:avLst/>
@@ -14255,7 +14772,7 @@
           <a:lstStyle/>
           <a:p>
             <a:r>
-              <a:rPr sz="1100">
+              <a:rPr sz="1300">
                 <a:solidFill>
                   <a:srgbClr val="E8E8E8"/>
                 </a:solidFill>
@@ -14266,7 +14783,7 @@
           </a:p>
           <a:p>
             <a:r>
-              <a:rPr sz="1100">
+              <a:rPr sz="1300">
                 <a:solidFill>
                   <a:srgbClr val="E8E8E8"/>
                 </a:solidFill>
@@ -14277,7 +14794,7 @@
           </a:p>
           <a:p>
             <a:r>
-              <a:rPr sz="1100">
+              <a:rPr sz="1300">
                 <a:solidFill>
                   <a:srgbClr val="E8E8E8"/>
                 </a:solidFill>
@@ -14288,7 +14805,7 @@
           </a:p>
           <a:p>
             <a:r>
-              <a:rPr sz="1100">
+              <a:rPr sz="1300">
                 <a:solidFill>
                   <a:srgbClr val="E8E8E8"/>
                 </a:solidFill>
@@ -14299,7 +14816,7 @@
           </a:p>
           <a:p>
             <a:r>
-              <a:rPr sz="1100">
+              <a:rPr sz="1300">
                 <a:solidFill>
                   <a:srgbClr val="E8E8E8"/>
                 </a:solidFill>
@@ -14318,7 +14835,7 @@
         </p:nvSpPr>
         <p:spPr>
           <a:xfrm>
-            <a:off x="6309360" y="4636008"/>
+            <a:off x="6309360" y="4983480"/>
             <a:ext cx="5074920" cy="365760"/>
           </a:xfrm>
           <a:prstGeom prst="rect">
@@ -14338,13 +14855,13 @@
               </a:spcAft>
             </a:pPr>
             <a:r>
-              <a:rPr sz="1200" b="0">
+              <a:rPr sz="1400" b="0">
                 <a:solidFill>
                   <a:srgbClr val="222222"/>
                 </a:solidFill>
                 <a:latin typeface="Arial"/>
               </a:rPr>
-              <a:t>Ferramenta executa a consulta fixa do código e devolve:</a:t>
+              <a:t>Ferramenta executa a consulta fixa e devolve:</a:t>
             </a:r>
           </a:p>
         </p:txBody>
@@ -14357,8 +14874,8 @@
         </p:nvSpPr>
         <p:spPr>
           <a:xfrm>
-            <a:off x="6309360" y="5001768"/>
-            <a:ext cx="5074920" cy="594360"/>
+            <a:off x="6309360" y="5349240"/>
+            <a:ext cx="5074920" cy="548640"/>
           </a:xfrm>
           <a:prstGeom prst="rect">
             <a:avLst/>
@@ -14401,8 +14918,8 @@
         </p:nvSpPr>
         <p:spPr>
           <a:xfrm>
-            <a:off x="6400800" y="5047488"/>
-            <a:ext cx="4892040" cy="502920"/>
+            <a:off x="6400800" y="5394959"/>
+            <a:ext cx="4892040" cy="457200"/>
           </a:xfrm>
           <a:prstGeom prst="rect">
             <a:avLst/>
@@ -14416,7 +14933,7 @@
           <a:lstStyle/>
           <a:p>
             <a:r>
-              <a:rPr sz="1100">
+              <a:rPr sz="1300">
                 <a:solidFill>
                   <a:srgbClr val="E8E8E8"/>
                 </a:solidFill>
@@ -14427,7 +14944,7 @@
           </a:p>
           <a:p>
             <a:r>
-              <a:rPr sz="1100">
+              <a:rPr sz="1300">
                 <a:solidFill>
                   <a:srgbClr val="E8E8E8"/>
                 </a:solidFill>
@@ -14446,8 +14963,8 @@
         </p:nvSpPr>
         <p:spPr>
           <a:xfrm>
-            <a:off x="6309360" y="5715000"/>
-            <a:ext cx="5074920" cy="502920"/>
+            <a:off x="6309360" y="5916168"/>
+            <a:ext cx="5074920" cy="365760"/>
           </a:xfrm>
           <a:prstGeom prst="rect">
             <a:avLst/>
@@ -14466,7 +14983,7 @@
               </a:spcAft>
             </a:pPr>
             <a:r>
-              <a:rPr sz="1300" b="1">
+              <a:rPr sz="1400" b="1">
                 <a:solidFill>
                   <a:srgbClr val="222222"/>
                 </a:solidFill>
@@ -14644,7 +15161,7 @@
                 </a:solidFill>
                 <a:latin typeface="Arial"/>
               </a:rPr>
-              <a:t>Acerto nas 47 perguntas com resposta, uma repetição por pergunta.</a:t>
+              <a:t>Barras de erro: intervalo de Wilson de 95%. Uma repetição por pergunta.</a:t>
             </a:r>
           </a:p>
         </p:txBody>
@@ -14658,7 +15175,7 @@
         <p:spPr>
           <a:xfrm>
             <a:off x="640080" y="1325880"/>
-            <a:ext cx="10881360" cy="822960"/>
+            <a:ext cx="10881360" cy="1005840"/>
           </a:xfrm>
           <a:prstGeom prst="rect">
             <a:avLst/>
@@ -14677,7 +15194,7 @@
               </a:spcAft>
             </a:pPr>
             <a:r>
-              <a:rPr sz="1300" b="0">
+              <a:rPr sz="1400" b="0">
                 <a:solidFill>
                   <a:srgbClr val="666666"/>
                 </a:solidFill>
@@ -14693,13 +15210,13 @@
               </a:spcAft>
             </a:pPr>
             <a:r>
-              <a:rPr sz="1300" b="0">
+              <a:rPr sz="1400" b="0">
                 <a:solidFill>
                   <a:srgbClr val="666666"/>
                 </a:solidFill>
                 <a:latin typeface="Arial"/>
               </a:rPr>
-              <a:t>52 perguntas × 6 abordagens = 312 execuções por modelo, 1 repetição por pergunta. Intervalo de Wilson de 95%; diferenças lidas como indícios.</a:t>
+              <a:t>52 perguntas × 6 abordagens = 312 execuções por modelo, 1 repetição por pergunta. Diferenças lidas como indícios.</a:t>
             </a:r>
           </a:p>
         </p:txBody>
@@ -14713,8 +15230,8 @@
           <p:nvPr/>
         </p:nvGraphicFramePr>
         <p:xfrm>
-          <a:off x="457200" y="2103120"/>
-          <a:ext cx="11247120" cy="4251960"/>
+          <a:off x="457200" y="2286000"/>
+          <a:ext cx="11247120" cy="3703320"/>
         </p:xfrm>
         <a:graphic>
           <a:graphicData uri="http://schemas.openxmlformats.org/drawingml/2006/chart">
@@ -14722,6 +15239,45 @@
           </a:graphicData>
         </a:graphic>
       </p:graphicFrame>
+      <p:sp>
+        <p:nvSpPr>
+          <p:cNvPr id="8" name="TextBox 7"/>
+          <p:cNvSpPr txBox="1"/>
+          <p:nvPr/>
+        </p:nvSpPr>
+        <p:spPr>
+          <a:xfrm>
+            <a:off x="640080" y="5989320"/>
+            <a:ext cx="10881360" cy="365760"/>
+          </a:xfrm>
+          <a:prstGeom prst="rect">
+            <a:avLst/>
+          </a:prstGeom>
+          <a:noFill/>
+        </p:spPr>
+        <p:txBody>
+          <a:bodyPr wrap="square" anchor="t" lIns="45720" rIns="45720">
+            <a:spAutoFit/>
+          </a:bodyPr>
+          <a:lstStyle/>
+          <a:p>
+            <a:pPr algn="l">
+              <a:spcAft>
+                <a:spcPts val="600"/>
+              </a:spcAft>
+            </a:pPr>
+            <a:r>
+              <a:rPr sz="1400" b="0">
+                <a:solidFill>
+                  <a:srgbClr val="222222"/>
+                </a:solidFill>
+                <a:latin typeface="Arial"/>
+              </a:rPr>
+              <a:t>As outras três abordagens não passam de 17% em nenhum modelo (slide 11).</a:t>
+            </a:r>
+          </a:p>
+        </p:txBody>
+      </p:sp>
     </p:spTree>
   </p:cSld>
   <p:clrMapOvr>

</xml_diff>

<commit_message>
Point deck to the new repository
Co-Authored-By: Claude Sonnet 5.5 <noreply@anthropic.com>
Claude-Session: https://claude.ai/code/session_01FjZonbKdsyoySM9nwRFtHf
</commit_message>
<xml_diff>
--- a/apresentacao/apresentacao.pptx
+++ b/apresentacao/apresentacao.pptx
@@ -2683,7 +2683,7 @@
           <a:lstStyle/>
           <a:p>
             <a:r>
-              <a:t>[1:15] Registro real de uma execução em cada abordagem com agente, pergunta a01, Claude Haiku 5.5. Na Consulta escrita pelo modelo, ele chama run_cypher com a consulta Cypher que escreveu, inclusive os filtros de time, ação, sucesso e terço do campo; a ferramenta executa a consulta no grafo e devolve o resultado. Nas Ferramentas sobre o grafo, o modelo escolhe query_actions e preenche os argumentos; a consulta já está no código e a ferramenta a executa com esses filtros. As duas consultam o mesmo grafo, com o mesmo limite de 12 chamadas por pergunta; muda quem escreve a consulta. Nesta pergunta, uma chamada bastou nas duas. As 8 ferramentas: listar jogadores, contar ações, listar ações, contar posses, rede de passes, métrica da rede, ligações da rede e sequências de passes. Diferenças a declarar: a Consulta não tem a biblioteca de algoritmos de grafos nem os nós de padrões prontos, e as ferramentas foram ajustadas olhando erros, enquanto a Consulta é o primeiro contato. A consulta, os argumentos e a resposta vêm de data/benchmark/final_results.jsonl; os valores devolvidos pela ferramenta (24 e 18) estão só no trace e foram copiados da figura do artigo.</a:t>
+              <a:t>[1:15] Registro real de uma execução em cada abordagem com agente, pergunta a01, Claude Haiku 5.5. Na Consulta escrita pelo modelo, ele chama run_cypher com a consulta Cypher que escreveu, inclusive os filtros de time, ação, sucesso e terço do campo; a ferramenta executa a consulta no grafo e devolve o resultado. Nas Ferramentas sobre o grafo, o modelo escolhe query_actions e preenche os argumentos; a consulta já está no código e a ferramenta a executa com esses filtros. As duas consultam o mesmo grafo, com o mesmo limite de 12 chamadas por pergunta; muda quem escreve a consulta. Nesta pergunta, uma chamada bastou nas duas. As 8 ferramentas: listar jogadores, contar ações, listar ações, contar posses, rede de passes, métrica da rede, ligações da rede e sequências de passes. Diferenças a declarar: a Consulta não tem a biblioteca de algoritmos de grafos nem os nós de padrões prontos, e as ferramentas foram ajustadas olhando erros, enquanto a Consulta é o primeiro contato. A consulta, os argumentos e a resposta vêm do registro de execuções do Haiku (data/benchmark/claude-haiku-5.5_results.jsonl no repositório novo); os valores devolvidos pela ferramenta (24 e 18) estão só no trace e foram copiados da figura do artigo.</a:t>
             </a:r>
           </a:p>
         </p:txBody>
@@ -8569,7 +8569,7 @@
                 </a:solidFill>
                 <a:latin typeface="Arial"/>
               </a:rPr>
-              <a:t>github.com/joaowinderfeldbussolotto/football-tactics-knowledge-graph</a:t>
+              <a:t>github.com/joaowinderfeldbussolotto/match-events-qa-benchmark</a:t>
             </a:r>
           </a:p>
         </p:txBody>

</xml_diff>

<commit_message>
Align deck and Q&A with the revised paper
Co-Authored-By: Claude Opus 5.5 <noreply@anthropic.com>
Claude-Session: https://claude.ai/code/session_01FjZonbKdsyoySM9nwRFtHf
</commit_message>
<xml_diff>
--- a/apresentacao/apresentacao.pptx
+++ b/apresentacao/apresentacao.pptx
@@ -1843,7 +1843,7 @@
           <a:lstStyle/>
           <a:p>
             <a:r>
-              <a:t>[1:30] Recorte das 36 perguntas encadeadas (relações na rede de passes, jogadas e antes e depois de uma substituição). Nos modelos menores, Contexto longo e Consulta caem justamente aqui, e Ferramentas se mantêm: a consulta já escrita e o cálculo no código tiram do modelo o trabalho de juntar eventos espalhados. Nos maiores, com raciocínio estendido, as três se aproximam. Ressalva: tamanho e raciocínio vieram juntos, então não dá para separar o efeito de um do outro. A interpretação é compatível com a literatura de contexto longo (informação no meio do contexto, raciocínio composicional) e com a dificuldade de LLMs em gerar Cypher.</a:t>
+              <a:t>[1:30] Recorte das 36 perguntas encadeadas (relações na rede de passes, jogadas e antes e depois de uma substituição). Nos modelos menores, Contexto longo e Consulta caem justamente aqui, e Ferramentas se mantêm: a consulta parametrizada e o cálculo no código tiram do modelo o trabalho de juntar eventos espalhados. Nos maiores, com raciocínio estendido, as três se aproximam. Ressalva: tamanho e raciocínio vieram juntos, então não dá para separar o efeito de um do outro. A interpretação é compatível com a literatura de contexto longo (informação no meio do contexto, raciocínio composicional) e com a dificuldade de LLMs em gerar Cypher.</a:t>
             </a:r>
           </a:p>
         </p:txBody>
@@ -1983,7 +1983,7 @@
           <a:lstStyle/>
           <a:p>
             <a:r>
-              <a:t>[1:15] Mediana por execução das três abordagens que leem os dados. O Contexto longo leva a tabela inteira em cada pergunta, de 82 a 111 mil tokens de entrada. Nos maiores, produz de 4.430 a 12.158 tokens de saída, quase todos de raciocínio, e leva de 37 a 81 segundos. Cuidado ao comparar: Ferramentas não usa cache de prompt e Consulta usa, então a latência mistura as duas condições; no Contexto longo, a maior parte da entrada veio do cache, o que o favorece. Sem preço em dólar, porque os preços mudam.</a:t>
+              <a:t>[1:15] Mediana por execução das três abordagens com acesso a todas as ações. O Contexto longo leva a tabela inteira em cada pergunta, de 82 a 111 mil tokens de entrada. Nos maiores, produz de 4.430 a 12.158 tokens de saída, quase todos de raciocínio, e leva de 37 a 81 segundos. Cuidado ao comparar: Ferramentas não usa cache de prompt e Consulta usa, então a latência mistura as duas condições; no Contexto longo, a maior parte da entrada veio do cache, o que o favorece. Sem preço em dólar, porque os preços mudam.</a:t>
             </a:r>
           </a:p>
         </p:txBody>
@@ -2053,7 +2053,7 @@
           <a:lstStyle/>
           <a:p>
             <a:r>
-              <a:t>[1:15] Conclusão: Ferramentas sobre o grafo foi a única abordagem que manteve o acerto alto nos 4 modelos, 83% a 89%. Consulta e Contexto longo dependem do modelo; nos maiores, com raciocínio estendido, a Consulta chegou ao mesmo nível e o Contexto longo se aproximou, este com mais tokens de saída e tempo. Busca vetorial e Estatísticas resumidas ficaram baixas em todos. Limitações, ditas pelo próprio artigo: uma partida e 1 repetição por pergunta, com 47 perguntas com resposta, então os intervalos são largos; tamanho e raciocínio estendido vieram juntos nos maiores; as ferramentas e as perguntas foram escritas pelos mesmos autores e as ferramentas foram ajustadas olhando erros, então o acerto vale dentro da cobertura delas; o ganho pode vir das ferramentas, do grafo ou dos algoritmos de grafo, e separar isso é trabalho futuro; e as abordagens com agente supõem chamada de ferramenta confiável.</a:t>
+              <a:t>[1:15] Conclusão: Ferramentas sobre o grafo foi a única abordagem que manteve o acerto alto nos 4 modelos, 83% a 89%. Consulta e Contexto longo dependem do modelo; nos maiores, com raciocínio estendido, a Consulta chegou ao mesmo nível e o Contexto longo se aproximou, este com mais tokens de saída e tempo. Busca vetorial e Estatísticas resumidas ficaram baixas em todos. Limitações, ditas pelo próprio artigo: uma partida e 1 repetição por pergunta, com 47 perguntas com resposta, então os intervalos são largos; tamanho e raciocínio estendido vieram juntos nos maiores; as ferramentas e as perguntas foram escritas pelos mesmos autores e as ferramentas foram ajustadas olhando erros, então o acerto vale dentro da cobertura delas; o estudo não separa o efeito do grafo do efeito das ferramentas: uma hipótese não testada é que um banco relacional com as mesmas ferramentas iria bem em busca e contagem e a diferença apareceria nas perguntas de relações; e as abordagens com agente supõem chamada de ferramenta confiável.</a:t>
             </a:r>
           </a:p>
         </p:txBody>
@@ -2123,7 +2123,7 @@
           <a:lstStyle/>
           <a:p>
             <a:r>
-              <a:t>[1:15] Fecho. Três frentes, todas ligadas às limitações. Primeira, mais evidência: repetir as execuções mede a variação entre rodadas e permite testar as diferenças entre abordagens, e estender as perguntas a várias partidas tira a dependência de uma só. Segunda, separar efeitos: avaliar modelos maiores sem raciocínio estendido separa o efeito do tamanho do efeito do raciocínio; aplicar as mesmas ferramentas a uma tabela, sem o grafo, separa o efeito das ferramentas do efeito do grafo; e testar uma busca vetorial em que cada trecho traga também os eventos vizinhos, como em Tzikas et al., responde à lacuna da Busca vetorial. Terceira, outros domínios, entre eles os dados industriais: parte deles tem a forma dos dados de futebol, registros de eventos com agente, momento e local, ligados entre si, como as paradas, os alertas e as movimentações de uma linha de produção ou de uma frota. Testar as mesmas abordagens ali é um próximo passo natural para uma pós em IA aplicada à indústria, mas exige implementação própria: a preparação dos dados, o grafo e as ferramentas dependem das perguntas que se quer responder.</a:t>
+              <a:t>[1:15] Fecho. Três frentes, todas ligadas às limitações. Primeira, mais evidência: repetir as execuções mede a variação entre rodadas e permite testar as diferenças entre abordagens, e estender as perguntas a várias partidas tira a dependência de uma só. Segunda, separar efeitos: avaliar modelos maiores sem raciocínio estendido separa o efeito do tamanho do efeito do raciocínio; aplicar as mesmas ferramentas a um banco relacional (SQL), sem o grafo, separa o efeito das ferramentas do efeito do grafo; e testar uma busca vetorial em que cada trecho traga também os eventos vizinhos, como em Tzikas et al., responde à lacuna da Busca vetorial. Terceira, outros domínios, entre eles os dados industriais: parte deles tem a forma dos dados de futebol, registros de eventos com agente, momento e local, ligados entre si, como as paradas, os alertas e as movimentações de uma linha de produção ou de uma frota. Testar as mesmas abordagens ali é um próximo passo natural para uma pós em IA aplicada à indústria, mas exige implementação própria: a preparação dos dados, o grafo e as ferramentas dependem das perguntas que se quer responder.</a:t>
             </a:r>
           </a:p>
         </p:txBody>
@@ -2263,7 +2263,7 @@
           <a:lstStyle/>
           <a:p>
             <a:r>
-              <a:t>[1:15] Contexto de futebol: a final da Copa de 2022, Argentina contra França, decidida nos pênaltis. Os dados de eventos registram cada ação, com jogador, momento e posição no campo. As três perguntas do slide são do conjunto do trabalho e nenhuma tem a resposta em um único evento: é preciso juntar vários. O modelo precisa receber os dados da partida, e há mais de uma forma de fazer isso. Perguntas de pesquisa: qual abordagem acerta mais, como o acerto muda de um modelo para outro e quanto cada uma custa em tokens e tempo. O aprendizado em contexto é usado em sentido amplo: o modelo não é treinado de novo e o que entra no contexto são os dados. Contribuições: o conjunto de perguntas com gabarito por código e a comparação sob as mesmas perguntas, o mesmo prompt e a mesma saída. Trabalhos relacionados: no esporte, SoccerRAG, SPORTSQL e Tzikas et al. avaliam cada um uma única forma de recuperação; fora do esporte, Li et al. e LOFT comparam formas de recuperação sem dados de futebol. Não foram encontrados trabalhos que comparem formas de recuperação em perguntas encadeadas sobre eventos de futebol, com conferência por código contra um gabarito por código.</a:t>
+              <a:t>[1:15] Contexto de futebol: a final da Copa de 2022, Argentina contra França, decidida nos pênaltis. Os dados de eventos registram cada ação, com jogador, momento e posição no campo. As três perguntas do slide são do conjunto do trabalho e nenhuma tem a resposta em um único evento: é preciso juntar vários. O modelo precisa receber os dados da partida, e há mais de uma forma de fazer isso. Perguntas de pesquisa: qual abordagem acerta mais, como o acerto muda de um modelo para outro e quanto cada uma custa em tokens e tempo. O aprendizado em contexto é usado em sentido amplo: o modelo não é treinado de novo e o que entra no contexto são os dados. Contribuições: a transformação dos eventos em uma tabela de ações e em um grafo, o conjunto de perguntas com gabarito e a comparação sob as mesmas perguntas, o mesmo prompt e a mesma saída. Trabalhos relacionados: no esporte, SoccerRAG, SPORTSQL e Tzikas et al. avaliam cada um uma única forma de recuperação; fora do esporte, Li et al. e LOFT comparam formas de recuperação sem dados de futebol. Não foram encontrados trabalhos que comparem formas de recuperação em perguntas encadeadas sobre eventos de futebol, com conferência por código contra um gabarito por código.</a:t>
             </a:r>
           </a:p>
         </p:txBody>
@@ -2403,7 +2403,7 @@
           <a:lstStyle/>
           <a:p>
             <a:r>
-              <a:t>[1:30] Os eventos da partida, sem a disputa de pênaltis, foram convertidos com a biblioteca socceraction para o formato SPADL, que guarda só as ações com bola, em um vocabulário fechado e com os mesmos campos em todas. Os 4.407 eventos viram 2.585 ações. Sobre essa tabela foram acrescentadas colunas de contexto: direção de ataque, zona em uma grade de 96 zonas, fase de posse (537 fases na final), recebedor do passe, placar e minuto. A figura mostra a grade de 12 por 8 zonas e o passe de Mac Allister para Di María, da zona 74 para a 92, como na Figura 1 do artigo (zonas copiadas dela, não recalculadas). É essa tabela que o Contexto longo entrega ao modelo. O SPADL perde o desfecho da finalização e o cartão sem falta, que foram recuperados do JSON; os rótulos das ações foram traduzidos para o português. Nenhuma etapa usa modelo de linguagem.</a:t>
+              <a:t>[1:30] Os eventos da partida, sem a disputa de pênaltis, foram convertidos com a biblioteca socceraction para o formato SPADL, que guarda só as ações com bola, em um vocabulário fechado e com os mesmos campos em todas. Os 4.407 eventos viram 2.585 ações. Sobre essa tabela foram acrescentadas colunas de contexto: direção de ataque, zona em uma grade de 96 zonas, fase de posse (537 fases na final), recebedor do passe, placar e minuto. A figura mostra a grade de 12 por 8 zonas e o passe de Mac Allister para Di María, da zona 74 para a 92, como na Figura 1 do artigo (zonas copiadas dela, não recalculadas). É essa tabela que o Contexto longo entrega ao modelo. O SPADL perde o desfecho da finalização e o cartão sem falta, que foram recuperados do JSON. Nenhuma etapa usa modelo de linguagem.</a:t>
             </a:r>
           </a:p>
         </p:txBody>
@@ -2473,7 +2473,7 @@
           <a:lstStyle/>
           <a:p>
             <a:r>
-              <a:t>[1:15] A tabela de ações foi carregada em um grafo Neo4j. Cada ação vira uma aresta do jogador para a partida, com as colunas da linha como propriedades; cada passe certo com recebedor vira uma aresta entre dois jogadores. O grafo tem 34 jogadores, 537 fases de posse e 96 zonas. As arestas não acrescentam informação à tabela, só a reorganizam em ligações; já a súmula, com totais por jogador e por time, é calculada: o próprio banco conta os totais a partir das arestas. A abordagem Estatísticas resumidas lê só a súmula; Consulta e Ferramentas leem o grafo. Nenhuma etapa usa modelo de linguagem.</a:t>
+              <a:t>[1:15] A tabela de ações foi carregada em um grafo Neo4j. Cada ação vira uma aresta do jogador para a partida, com as colunas da linha como propriedades; cada passe certo com recebedor vira uma aresta entre dois jogadores. O grafo tem 34 jogadores, 537 fases de posse e 96 zonas. As arestas não acrescentam informação à tabela, só a reorganizam em ligações; já a súmula, com totais por jogador e por time, é calculada: o próprio banco conta os totais a partir das arestas, separando tentativas e acertos. A abordagem Estatísticas resumidas lê só a súmula; Consulta e Ferramentas leem o grafo. Por que grafo: a análise de futebol trata os passes de um time como uma rede, com os jogadores como nós e os passes como arestas (Buldú et al.; Duch et al.). Perguntas sobre essa rede, como qual dupla mais trocou passes ou por qual jogador mais passa a circulação da bola, viram caminhos e métricas sobre o grafo. Uma tabela relacional também guarda a informação, mas, conforme a organização, seguir uma cadeia de passes pode exigir uma junção a cada passe, e métricas como a intermediação dependeriam de implementação própria. Nenhuma etapa usa modelo de linguagem.</a:t>
             </a:r>
           </a:p>
         </p:txBody>
@@ -2543,7 +2543,7 @@
           <a:lstStyle/>
           <a:p>
             <a:r>
-              <a:t>[1:15] Das 52 perguntas, 47 têm resposta nos dados e 5 são de controle: a resposta certa é a ausência de dados, como a distância percorrida por um jogador. As perguntas de busca e contagem são diretas: a resposta sai de um evento ou de uma soma. Os outros três grupos são encadeados: dependem de ligar eventos entre si. As perguntas foram escritas manualmente e o gabarito de cada uma foi calculado por código, sem passar pelo grafo, a partir do JSON bruto e da tabela de ações. A conferência com o gabarito é determinística: a mesma resposta recebe sempre o mesmo veredito.</a:t>
+              <a:t>[1:15] Das 52 perguntas, 47 têm resposta nos dados e 5 são de controle: a resposta certa é a ausência de dados, como a distância percorrida por um jogador. As perguntas de busca e contagem são diretas: a resposta sai de um evento ou de uma soma. Os outros três grupos são encadeados: dependem de ligar eventos entre si. As perguntas foram escritas manualmente e o gabarito de cada uma foi calculado por código, a partir do JSON bruto e da tabela de ações. A conferência com o gabarito é determinística: a mesma resposta recebe sempre o mesmo veredito.</a:t>
             </a:r>
           </a:p>
         </p:txBody>
@@ -2613,7 +2613,7 @@
           <a:lstStyle/>
           <a:p>
             <a:r>
-              <a:t>[1:30] Ordem de complexidade do que existe entre a pergunta e o modelo. Sem dados: só a pergunta, linha de base. Contexto longo: a tabela inteira de 2.585 ações no prompt. Estatísticas resumidas: a súmula, com totais por jogador e por time. Busca vetorial: as 30 linhas mais parecidas com a pergunta, como em geração aumentada por recuperação. Consulta escrita pelo modelo: o modelo recebe o esquema do grafo e escreve a consulta Cypher. Ferramentas sobre o grafo: 8 ferramentas com a consulta já escrita; o modelo só escolhe qual chamar e com quais argumentos. As duas últimas consultam o mesmo grafo e têm o mesmo limite de 12 chamadas por pergunta: muda quem escreve a consulta. Duas diferenças a declarar: a Consulta não tem a biblioteca de algoritmos de grafos nem os nós de padrões prontos, e as ferramentas foram ajustadas olhando erros, enquanto a Consulta é o primeiro contato. Todas usam o mesmo prompt de sistema e a mesma saída estruturada.</a:t>
+              <a:t>[1:30] Sem dados: só a pergunta, linha de base. Contexto longo: a tabela inteira de 2.585 ações no prompt. Estatísticas resumidas: a súmula, com totais por jogador e por time. Busca vetorial: as 30 linhas mais parecidas com a pergunta, como em geração aumentada por recuperação. Consulta escrita pelo modelo: o modelo recebe o esquema do grafo e escreve a consulta Cypher. Ferramentas sobre o grafo: 8 ferramentas com consulta Cypher parametrizada; o modelo só escolhe qual chamar e com quais argumentos. As duas últimas consultam o mesmo grafo e têm o mesmo limite de 12 chamadas por pergunta: muda quem escreve a consulta. Duas diferenças a declarar: a Consulta não tem a biblioteca de algoritmos de grafos nem os nós de padrões prontos, e as ferramentas foram ajustadas olhando erros, enquanto a Consulta é o primeiro contato. Todas usam o mesmo prompt de sistema e a mesma saída estruturada.</a:t>
             </a:r>
           </a:p>
         </p:txBody>
@@ -2683,7 +2683,7 @@
           <a:lstStyle/>
           <a:p>
             <a:r>
-              <a:t>[1:15] Registro real de uma execução em cada abordagem com agente, pergunta a01, Claude Haiku 5.5. Na Consulta escrita pelo modelo, ele chama run_cypher com a consulta Cypher que escreveu, inclusive os filtros de time, ação, sucesso e terço do campo; a ferramenta executa a consulta no grafo e devolve o resultado. Nas Ferramentas sobre o grafo, o modelo escolhe query_actions e preenche os argumentos; a consulta já está no código e a ferramenta a executa com esses filtros. As duas consultam o mesmo grafo, com o mesmo limite de 12 chamadas por pergunta; muda quem escreve a consulta. Nesta pergunta, uma chamada bastou nas duas. As 8 ferramentas: listar jogadores, contar ações, listar ações, contar posses, rede de passes, métrica da rede, ligações da rede e sequências de passes. Diferenças a declarar: a Consulta não tem a biblioteca de algoritmos de grafos nem os nós de padrões prontos, e as ferramentas foram ajustadas olhando erros, enquanto a Consulta é o primeiro contato. A consulta, os argumentos e a resposta vêm do registro de execuções do Haiku (data/benchmark/claude-haiku-5.5_results.jsonl no repositório novo); os valores devolvidos pela ferramenta (24 e 18) estão só no trace e foram copiados da figura do artigo.</a:t>
+              <a:t>[1:15] Registro real de uma execução em cada abordagem com agente, pergunta a01, Claude Haiku 5.5. Na Consulta escrita pelo modelo, ele chama run_cypher com a consulta Cypher que escreveu, inclusive os filtros de time, ação, sucesso e terço do campo; a ferramenta executa a consulta no grafo e devolve o resultado. Nas Ferramentas sobre o grafo, o modelo escolhe query_actions e preenche os argumentos; a consulta parametrizada está no código e a ferramenta a executa com esses filtros. As duas consultam o mesmo grafo, com o mesmo limite de 12 chamadas por pergunta; muda quem escreve a consulta. Nesta pergunta, uma chamada bastou nas duas. As 8 ferramentas: listar jogadores, contar ações, listar ações, contar posses, rede de passes, métrica da rede, ligações da rede e sequências de passes. Diferenças a declarar: a Consulta não tem a biblioteca de algoritmos de grafos nem os nós de padrões prontos, e as ferramentas foram ajustadas olhando erros, enquanto a Consulta é o primeiro contato. A consulta, os argumentos e a resposta vêm do registro de execuções do Haiku (data/benchmark/claude-haiku-5.5_results.jsonl no repositório novo); os valores devolvidos pela ferramenta (24 e 18) estão só no trace e foram copiados da figura do artigo.</a:t>
             </a:r>
           </a:p>
         </p:txBody>
@@ -2753,7 +2753,7 @@
           <a:lstStyle/>
           <a:p>
             <a:r>
-              <a:t>[2:15] Acerto nas 47 perguntas com resposta, das três abordagens que leem os dados, com o intervalo de Wilson de 95%. A barra azul é Ferramentas sobre o grafo: 83% a 89% em todos os modelos. Consulta escrita pelo modelo: 57% a 70% nos menores e 89% a 94% nos maiores. Contexto longo: 40% a 45% nos menores e 72% a 85% nos maiores. As outras três ficam baixas e estão no slide 11: Busca vetorial 9% a 17%, Estatísticas resumidas 0% a 9% e Sem dados 0%, porque se abstém. Nos maiores, Consulta empata com Ferramentas no Sonnet e fica à frente no Kimi; os intervalos se sobrepõem. Setup: quatro modelos, dois menores (Haiku e Qwen, sem raciocínio estendido, temperatura zero) e dois maiores (Sonnet e Kimi, com raciocínio estendido), agrupados pela faixa de preço por token; 52 perguntas em 6 abordagens, 312 execuções por modelo, 1 repetição por pergunta; diferenças lidas como indícios.</a:t>
+              <a:t>[2:15] Acerto nas 47 perguntas com resposta, das três abordagens com acesso a todas as ações, com o intervalo de Wilson de 95%. A barra azul é Ferramentas sobre o grafo: 83% a 89% em todos os modelos. Consulta escrita pelo modelo: 57% a 70% nos menores e 89% a 94% nos maiores. Contexto longo: 40% a 45% nos menores e 72% a 85% nos maiores. As outras três ficam baixas e estão no slide 11: Busca vetorial 9% a 17%, Estatísticas resumidas 0% a 9% e Sem dados 0%, porque se abstém. Nos maiores, Consulta empata com Ferramentas no Sonnet e fica à frente no Kimi; os intervalos se sobrepõem. Setup: quatro modelos, dois menores (Haiku e Qwen, sem raciocínio estendido, temperatura zero) e dois maiores (Sonnet e Kimi, com raciocínio estendido), agrupados pela faixa de preço por token; 52 perguntas em 6 abordagens, 312 execuções por modelo, 1 repetição por pergunta; diferenças lidas como indícios.</a:t>
             </a:r>
           </a:p>
         </p:txBody>
@@ -6215,7 +6215,7 @@
           <a:p>
             <a:pPr algn="l">
               <a:spcAft>
-                <a:spcPts val="1000"/>
+                <a:spcPts val="800"/>
               </a:spcAft>
             </a:pPr>
             <a:r>
@@ -6231,7 +6231,7 @@
           <a:p>
             <a:pPr algn="l">
               <a:spcAft>
-                <a:spcPts val="1000"/>
+                <a:spcPts val="800"/>
               </a:spcAft>
             </a:pPr>
             <a:r>
@@ -6241,13 +6241,13 @@
                 </a:solidFill>
                 <a:latin typeface="Arial"/>
               </a:rPr>
-              <a:t>Ferramentas: a consulta já vem escrita e o cálculo fica no código.</a:t>
+              <a:t>Ferramentas: o modelo escolhe ferramenta e argumentos; o código monta e executa a consulta.</a:t>
             </a:r>
           </a:p>
           <a:p>
             <a:pPr algn="l">
               <a:spcAft>
-                <a:spcPts val="1000"/>
+                <a:spcPts val="800"/>
               </a:spcAft>
             </a:pPr>
             <a:r>
@@ -6257,13 +6257,13 @@
                 </a:solidFill>
                 <a:latin typeface="Arial"/>
               </a:rPr>
-              <a:t>Consulta: o modelo escreve o Cypher; o acerto acompanha essa capacidade.</a:t>
+              <a:t>Consulta: a liberdade de escrever o Cypher só virou acerto nos modelos maiores.</a:t>
             </a:r>
           </a:p>
           <a:p>
             <a:pPr algn="l">
               <a:spcAft>
-                <a:spcPts val="1000"/>
+                <a:spcPts val="800"/>
               </a:spcAft>
             </a:pPr>
             <a:r>
@@ -6274,6 +6274,22 @@
                 <a:latin typeface="Arial"/>
               </a:rPr>
               <a:t>Contexto longo: o modelo acha e combina as linhas certas na tabela inteira.</a:t>
+            </a:r>
+          </a:p>
+          <a:p>
+            <a:pPr algn="l">
+              <a:spcAft>
+                <a:spcPts val="800"/>
+              </a:spcAft>
+            </a:pPr>
+            <a:r>
+              <a:rPr sz="1500" b="1">
+                <a:solidFill>
+                  <a:srgbClr val="222222"/>
+                </a:solidFill>
+                <a:latin typeface="Arial"/>
+              </a:rPr>
+              <a:t>Contrapartida: Ferramentas só respondem ao que as ferramentas cobrem.</a:t>
             </a:r>
           </a:p>
         </p:txBody>
@@ -7700,7 +7716,7 @@
                 </a:solidFill>
                 <a:latin typeface="Arial"/>
               </a:rPr>
-              <a:t>Ferramentas, grafo ou algoritmos de grafo? </a:t>
+              <a:t>Grafo ou banco relacional? </a:t>
             </a:r>
             <a:r>
               <a:rPr sz="1800" b="0">
@@ -7709,7 +7725,7 @@
                 </a:solidFill>
                 <a:latin typeface="Arial"/>
               </a:rPr>
-              <a:t>Separar é trabalho futuro.</a:t>
+              <a:t>Hipótese não testada: a diferença apareceria nas perguntas de relações.</a:t>
             </a:r>
           </a:p>
           <a:p>
@@ -8188,7 +8204,7 @@
                 </a:solidFill>
                 <a:latin typeface="Arial"/>
               </a:rPr>
-              <a:t>As mesmas ferramentas sobre uma tabela, sem o grafo: ferramentas ou grafo?</a:t>
+              <a:t>As mesmas ferramentas sobre um banco relacional (SQL), sem o grafo: ferramentas ou grafo?</a:t>
             </a:r>
           </a:p>
           <a:p>
@@ -8344,7 +8360,7 @@
                 </a:solidFill>
                 <a:latin typeface="Arial"/>
               </a:rPr>
-              <a:t>Dados industriais: registros de eventos com agente, momento e local, como paradas, alertas e movimentações.</a:t>
+              <a:t>Outros registros de eventos, como os de processos industriais.</a:t>
             </a:r>
           </a:p>
           <a:p>
@@ -8369,7 +8385,7 @@
                 </a:solidFill>
                 <a:latin typeface="Arial"/>
               </a:rPr>
-              <a:t>Exige preparação dos dados, grafo e ferramentas próprios do domínio.</a:t>
+              <a:t>Com a preparação dos dados, o grafo e as ferramentas feitos para as perguntas do domínio.</a:t>
             </a:r>
           </a:p>
         </p:txBody>
@@ -8852,8 +8868,8 @@
         </p:nvSpPr>
         <p:spPr>
           <a:xfrm>
-            <a:off x="640080" y="4114800"/>
-            <a:ext cx="5120640" cy="1600200"/>
+            <a:off x="640080" y="3931920"/>
+            <a:ext cx="5120640" cy="1810512"/>
           </a:xfrm>
           <a:prstGeom prst="rect">
             <a:avLst/>
@@ -8896,8 +8912,8 @@
         </p:nvSpPr>
         <p:spPr>
           <a:xfrm>
-            <a:off x="777240" y="4142232"/>
-            <a:ext cx="4846320" cy="1554480"/>
+            <a:off x="777240" y="3950208"/>
+            <a:ext cx="4846320" cy="1783080"/>
           </a:xfrm>
           <a:prstGeom prst="rect">
             <a:avLst/>
@@ -8912,7 +8928,7 @@
           <a:p>
             <a:pPr algn="l">
               <a:spcAft>
-                <a:spcPts val="500"/>
+                <a:spcPts val="300"/>
               </a:spcAft>
             </a:pPr>
             <a:r>
@@ -8928,27 +8944,43 @@
           <a:p>
             <a:pPr algn="l">
               <a:spcAft>
-                <a:spcPts val="500"/>
+                <a:spcPts val="300"/>
               </a:spcAft>
             </a:pPr>
             <a:r>
-              <a:rPr sz="1500" b="0">
+              <a:rPr sz="1400" b="0">
                 <a:solidFill>
                   <a:srgbClr val="222222"/>
                 </a:solidFill>
                 <a:latin typeface="Arial"/>
               </a:rPr>
-              <a:t>52 perguntas com gabarito calculado por código.</a:t>
+              <a:t>Eventos transformados em tabela de ações, com contexto, e em grafo.</a:t>
             </a:r>
           </a:p>
           <a:p>
             <a:pPr algn="l">
               <a:spcAft>
-                <a:spcPts val="500"/>
+                <a:spcPts val="300"/>
               </a:spcAft>
             </a:pPr>
             <a:r>
-              <a:rPr sz="1500" b="0">
+              <a:rPr sz="1400" b="0">
+                <a:solidFill>
+                  <a:srgbClr val="222222"/>
+                </a:solidFill>
+                <a:latin typeface="Arial"/>
+              </a:rPr>
+              <a:t>52 perguntas com gabarito.</a:t>
+            </a:r>
+          </a:p>
+          <a:p>
+            <a:pPr algn="l">
+              <a:spcAft>
+                <a:spcPts val="300"/>
+              </a:spcAft>
+            </a:pPr>
+            <a:r>
+              <a:rPr sz="1400" b="0">
                 <a:solidFill>
                   <a:srgbClr val="222222"/>
                 </a:solidFill>
@@ -10377,8 +10409,8 @@
           <p:nvPr/>
         </p:nvGraphicFramePr>
         <p:xfrm>
-          <a:off x="640080" y="2468880"/>
-          <a:ext cx="6675120" cy="3291840"/>
+          <a:off x="640080" y="2423160"/>
+          <a:ext cx="6766560" cy="3749039"/>
         </p:xfrm>
         <a:graphic>
           <a:graphicData uri="http://schemas.openxmlformats.org/drawingml/2006/table">
@@ -10387,10 +10419,10 @@
                 <a:tableStyleId>{5C22544A-7EE6-4342-B048-85BDC9FD1C3A}</a:tableStyleId>
               </a:tblPr>
               <a:tblGrid>
-                <a:gridCol w="2377440"/>
-                <a:gridCol w="4297680"/>
+                <a:gridCol w="2514600"/>
+                <a:gridCol w="4251960"/>
               </a:tblGrid>
-              <a:tr h="548640">
+              <a:tr h="535577">
                 <a:tc>
                   <a:txBody>
                     <a:bodyPr wrap="square"/>
@@ -10398,7 +10430,7 @@
                     <a:p>
                       <a:pPr algn="l"/>
                       <a:r>
-                        <a:rPr sz="1600" b="1">
+                        <a:rPr sz="1500" b="1">
                           <a:solidFill>
                             <a:srgbClr val="FFFFFF"/>
                           </a:solidFill>
@@ -10421,7 +10453,7 @@
                     <a:p>
                       <a:pPr algn="l"/>
                       <a:r>
-                        <a:rPr sz="1600" b="1">
+                        <a:rPr sz="1500" b="1">
                           <a:solidFill>
                             <a:srgbClr val="FFFFFF"/>
                           </a:solidFill>
@@ -10438,7 +10470,7 @@
                   </a:tcPr>
                 </a:tc>
               </a:tr>
-              <a:tr h="548640">
+              <a:tr h="535577">
                 <a:tc>
                   <a:txBody>
                     <a:bodyPr wrap="square"/>
@@ -10446,7 +10478,7 @@
                     <a:p>
                       <a:pPr algn="l"/>
                       <a:r>
-                        <a:rPr sz="1600" b="1">
+                        <a:rPr sz="1500" b="1">
                           <a:solidFill>
                             <a:srgbClr val="222222"/>
                           </a:solidFill>
@@ -10469,13 +10501,13 @@
                     <a:p>
                       <a:pPr algn="l"/>
                       <a:r>
-                        <a:rPr sz="1600" b="0">
+                        <a:rPr sz="1500" b="0">
                           <a:solidFill>
                             <a:srgbClr val="222222"/>
                           </a:solidFill>
                           <a:latin typeface="Arial"/>
                         </a:rPr>
-                        <a:t>toda ação ataca da esquerda para a direita</a:t>
+                        <a:t>toda ação ataca da esquerda para a direita, nos dois times</a:t>
                       </a:r>
                     </a:p>
                   </a:txBody>
@@ -10486,7 +10518,7 @@
                   </a:tcPr>
                 </a:tc>
               </a:tr>
-              <a:tr h="548640">
+              <a:tr h="535577">
                 <a:tc>
                   <a:txBody>
                     <a:bodyPr wrap="square"/>
@@ -10494,13 +10526,13 @@
                     <a:p>
                       <a:pPr algn="l"/>
                       <a:r>
-                        <a:rPr sz="1600" b="1">
+                        <a:rPr sz="1500" b="1">
                           <a:solidFill>
                             <a:srgbClr val="222222"/>
                           </a:solidFill>
                           <a:latin typeface="Arial"/>
                         </a:rPr>
-                        <a:t>Zona do campo</a:t>
+                        <a:t>Zona, terço e corredor</a:t>
                       </a:r>
                     </a:p>
                   </a:txBody>
@@ -10517,13 +10549,13 @@
                     <a:p>
                       <a:pPr algn="l"/>
                       <a:r>
-                        <a:rPr sz="1600" b="0">
+                        <a:rPr sz="1500" b="0">
                           <a:solidFill>
                             <a:srgbClr val="222222"/>
                           </a:solidFill>
                           <a:latin typeface="Arial"/>
                         </a:rPr>
-                        <a:t>situa o início e o fim de cada ação</a:t>
+                        <a:t>situa o início e o fim de cada ação no campo</a:t>
                       </a:r>
                     </a:p>
                   </a:txBody>
@@ -10534,7 +10566,7 @@
                   </a:tcPr>
                 </a:tc>
               </a:tr>
-              <a:tr h="548640">
+              <a:tr h="535577">
                 <a:tc>
                   <a:txBody>
                     <a:bodyPr wrap="square"/>
@@ -10542,7 +10574,7 @@
                     <a:p>
                       <a:pPr algn="l"/>
                       <a:r>
-                        <a:rPr sz="1600" b="1">
+                        <a:rPr sz="1500" b="1">
                           <a:solidFill>
                             <a:srgbClr val="222222"/>
                           </a:solidFill>
@@ -10565,7 +10597,7 @@
                     <a:p>
                       <a:pPr algn="l"/>
                       <a:r>
-                        <a:rPr sz="1600" b="0">
+                        <a:rPr sz="1500" b="0">
                           <a:solidFill>
                             <a:srgbClr val="222222"/>
                           </a:solidFill>
@@ -10582,7 +10614,7 @@
                   </a:tcPr>
                 </a:tc>
               </a:tr>
-              <a:tr h="548640">
+              <a:tr h="535577">
                 <a:tc>
                   <a:txBody>
                     <a:bodyPr wrap="square"/>
@@ -10590,7 +10622,7 @@
                     <a:p>
                       <a:pPr algn="l"/>
                       <a:r>
-                        <a:rPr sz="1600" b="1">
+                        <a:rPr sz="1500" b="1">
                           <a:solidFill>
                             <a:srgbClr val="222222"/>
                           </a:solidFill>
@@ -10613,13 +10645,13 @@
                     <a:p>
                       <a:pPr algn="l"/>
                       <a:r>
-                        <a:rPr sz="1600" b="0">
+                        <a:rPr sz="1500" b="0">
                           <a:solidFill>
                             <a:srgbClr val="222222"/>
                           </a:solidFill>
                           <a:latin typeface="Arial"/>
                         </a:rPr>
-                        <a:t>agrupa as ações seguidas do mesmo time</a:t>
+                        <a:t>agrupa em jogadas as ações seguidas do mesmo time</a:t>
                       </a:r>
                     </a:p>
                   </a:txBody>
@@ -10630,7 +10662,7 @@
                   </a:tcPr>
                 </a:tc>
               </a:tr>
-              <a:tr h="548640">
+              <a:tr h="535577">
                 <a:tc>
                   <a:txBody>
                     <a:bodyPr wrap="square"/>
@@ -10638,13 +10670,13 @@
                     <a:p>
                       <a:pPr algn="l"/>
                       <a:r>
-                        <a:rPr sz="1600" b="1">
+                        <a:rPr sz="1500" b="1">
                           <a:solidFill>
                             <a:srgbClr val="222222"/>
                           </a:solidFill>
                           <a:latin typeface="Arial"/>
                         </a:rPr>
-                        <a:t>Placar e minuto</a:t>
+                        <a:t>Placar, minuto e período</a:t>
                       </a:r>
                     </a:p>
                   </a:txBody>
@@ -10661,19 +10693,67 @@
                     <a:p>
                       <a:pPr algn="l"/>
                       <a:r>
-                        <a:rPr sz="1600" b="0">
+                        <a:rPr sz="1500" b="0">
                           <a:solidFill>
                             <a:srgbClr val="222222"/>
                           </a:solidFill>
                           <a:latin typeface="Arial"/>
                         </a:rPr>
-                        <a:t>placar antes de cada ação; minuto da transmissão</a:t>
+                        <a:t>placar antes de cada ação e minuto da transmissão</a:t>
                       </a:r>
                     </a:p>
                   </a:txBody>
                   <a:tcPr anchor="ctr">
                     <a:solidFill>
                       <a:srgbClr val="FFFFFF"/>
+                    </a:solidFill>
+                  </a:tcPr>
+                </a:tc>
+              </a:tr>
+              <a:tr h="535577">
+                <a:tc>
+                  <a:txBody>
+                    <a:bodyPr wrap="square"/>
+                    <a:lstStyle/>
+                    <a:p>
+                      <a:pPr algn="l"/>
+                      <a:r>
+                        <a:rPr sz="1500" b="1">
+                          <a:solidFill>
+                            <a:srgbClr val="222222"/>
+                          </a:solidFill>
+                          <a:latin typeface="Arial"/>
+                        </a:rPr>
+                        <a:t>Dados recuperados do JSON</a:t>
+                      </a:r>
+                    </a:p>
+                  </a:txBody>
+                  <a:tcPr anchor="ctr">
+                    <a:solidFill>
+                      <a:srgbClr val="F2F2F2"/>
+                    </a:solidFill>
+                  </a:tcPr>
+                </a:tc>
+                <a:tc>
+                  <a:txBody>
+                    <a:bodyPr wrap="square"/>
+                    <a:lstStyle/>
+                    <a:p>
+                      <a:pPr algn="l"/>
+                      <a:r>
+                        <a:rPr sz="1500" b="0">
+                          <a:solidFill>
+                            <a:srgbClr val="222222"/>
+                          </a:solidFill>
+                          <a:latin typeface="Arial"/>
+                        </a:rPr>
+                        <a:t>desfecho da finalização e cartão sem falta</a:t>
+                      </a:r>
+                    </a:p>
+                  </a:txBody>
+                  <a:tcPr anchor="ctr">
+                    <a:solidFill>
+                      <a:srgbClr val="F2F2F2"/>
                     </a:solidFill>
                   </a:tcPr>
                 </a:tc>
@@ -12694,7 +12774,7 @@
                 </a:solidFill>
                 <a:latin typeface="Arial"/>
               </a:rPr>
-              <a:t>A súmula é calculada: </a:t>
+              <a:t>Súmula: </a:t>
             </a:r>
             <a:r>
               <a:rPr sz="1600" b="0">
@@ -12703,7 +12783,7 @@
                 </a:solidFill>
                 <a:latin typeface="Arial"/>
               </a:rPr>
-              <a:t>o próprio banco conta os totais por jogador e por time.</a:t>
+              <a:t>uma consulta no banco conta, por jogador e por time, tentativas e acertos de cada tipo de ação.</a:t>
             </a:r>
           </a:p>
           <a:p>
@@ -12728,7 +12808,7 @@
                 </a:solidFill>
                 <a:latin typeface="Arial"/>
               </a:rPr>
-              <a:t>Nenhuma etapa usa modelo de linguagem; </a:t>
+              <a:t>Por que grafo: </a:t>
             </a:r>
             <a:r>
               <a:rPr sz="1600" b="0">
@@ -12737,7 +12817,7 @@
                 </a:solidFill>
                 <a:latin typeface="Arial"/>
               </a:rPr>
-              <a:t>só o benchmark chama modelos.</a:t>
+              <a:t>a análise de futebol trata os passes como rede; caminhos e métricas de rede viram consultas no grafo.</a:t>
             </a:r>
           </a:p>
         </p:txBody>
@@ -13362,7 +13442,7 @@
                 </a:solidFill>
                 <a:latin typeface="Arial"/>
               </a:rPr>
-              <a:t>47 perguntas com resposta e 5 de controle. Gabarito calculado por código, fora do grafo, a partir do JSON bruto e da tabela de ações.</a:t>
+              <a:t>47 perguntas com resposta e 5 de controle. Gabarito calculado por código, a partir do JSON bruto e da tabela de ações.</a:t>
             </a:r>
           </a:p>
         </p:txBody>
@@ -13413,7 +13493,7 @@
                 </a:solidFill>
                 <a:latin typeface="Arial"/>
               </a:rPr>
-              <a:t>Seis abordagens, da ausência de dados à consulta ao grafo</a:t>
+              <a:t>Seis abordagens para dar os dados ao modelo</a:t>
             </a:r>
           </a:p>
         </p:txBody>
@@ -13847,7 +13927,7 @@
                           </a:solidFill>
                           <a:latin typeface="Arial"/>
                         </a:rPr>
-                        <a:t>o resultado de 8 ferramentas com consulta fixa, que o modelo chama</a:t>
+                        <a:t>o resultado de 8 ferramentas com consulta parametrizada, que o modelo chama</a:t>
                       </a:r>
                     </a:p>
                   </a:txBody>
@@ -14861,7 +14941,7 @@
                 </a:solidFill>
                 <a:latin typeface="Arial"/>
               </a:rPr>
-              <a:t>Ferramenta executa a consulta fixa e devolve:</a:t>
+              <a:t>Ferramenta executa a consulta parametrizada e devolve:</a:t>
             </a:r>
           </a:p>
         </p:txBody>

</xml_diff>

<commit_message>
Add related-work slide; move Q&A call to the last slide
Co-Authored-By: Claude Opus 5.5 <noreply@anthropic.com>
Claude-Session: https://claude.ai/code/session_01FjZonbKdsyoySM9nwRFtHf
</commit_message>
<xml_diff>
--- a/apresentacao/apresentacao.pptx
+++ b/apresentacao/apresentacao.pptx
@@ -1843,7 +1843,7 @@
           <a:lstStyle/>
           <a:p>
             <a:r>
-              <a:t>[1:30] Recorte das 36 perguntas encadeadas (relações na rede de passes, jogadas e antes e depois de uma substituição). Nos modelos menores, Contexto longo e Consulta caem justamente aqui, e Ferramentas se mantêm: a consulta parametrizada e o cálculo no código tiram do modelo o trabalho de juntar eventos espalhados. Nos maiores, com raciocínio estendido, as três se aproximam. Ressalva: tamanho e raciocínio vieram juntos, então não dá para separar o efeito de um do outro. A interpretação é compatível com a literatura de contexto longo (informação no meio do contexto, raciocínio composicional) e com a dificuldade de LLMs em gerar Cypher.</a:t>
+              <a:t>[2:15] Acerto nas 47 perguntas com resposta, das três abordagens com acesso a todas as ações, com o intervalo de Wilson de 95%. A barra azul é Ferramentas sobre o grafo: 83% a 89% em todos os modelos. Consulta escrita pelo modelo: 57% a 70% nos menores e 89% a 94% nos maiores. Contexto longo: 40% a 45% nos menores e 72% a 85% nos maiores. As outras três ficam baixas e estão no slide 12: Busca vetorial 9% a 17%, Estatísticas resumidas 0% a 9% e Sem dados 0%, porque se abstém. Nos maiores, Consulta empata com Ferramentas no Sonnet e fica à frente no Kimi; os intervalos se sobrepõem. Setup: quatro modelos, dois menores (Haiku e Qwen, sem raciocínio estendido, temperatura zero) e dois maiores (Sonnet e Kimi, com raciocínio estendido), agrupados pela faixa de preço por token; 52 perguntas em 6 abordagens, 312 execuções por modelo, 1 repetição por pergunta; diferenças lidas como indícios.</a:t>
             </a:r>
           </a:p>
         </p:txBody>
@@ -1913,7 +1913,7 @@
           <a:lstStyle/>
           <a:p>
             <a:r>
-              <a:t>[1:00] Busca vetorial (9% a 17%): traz as 30 linhas mais parecidas com a pergunta, de 2.585. Parecer com a pergunta não é servir para respondê-la; contar exige todas as linhas de um tipo e ligar eventos exige as linhas vizinhas. Erra por abstenção e por resposta errada, conforme o modelo. Estatísticas resumidas (0% a 9%): a súmula tem só totais da partida inteira, sem recorte de tempo ou de campo e sem quem passou para quem; como o prompt pede para indicar ausência de dados, os modelos se abstêm. Sem dados: 0 de 47 com resposta, por obediência ao prompt, que proíbe responder de memória; o 0% mede obediência, não ignorância. Nas perguntas de controle, Sem dados acerta as 5.</a:t>
+              <a:t>[1:30] Recorte das 36 perguntas encadeadas (relações na rede de passes, jogadas e antes e depois de uma substituição). Nos modelos menores, Contexto longo e Consulta caem justamente aqui, e Ferramentas se mantêm: a consulta parametrizada e o cálculo no código tiram do modelo o trabalho de juntar eventos espalhados. Nos maiores, com raciocínio estendido, as três se aproximam. Ressalva: tamanho e raciocínio vieram juntos, então não dá para separar o efeito de um do outro. A interpretação é compatível com a literatura de contexto longo (informação no meio do contexto, raciocínio composicional) e com a dificuldade de LLMs em gerar Cypher.</a:t>
             </a:r>
           </a:p>
         </p:txBody>
@@ -1983,7 +1983,7 @@
           <a:lstStyle/>
           <a:p>
             <a:r>
-              <a:t>[1:15] Mediana por execução das três abordagens com acesso a todas as ações. O Contexto longo leva a tabela inteira em cada pergunta, de 82 a 111 mil tokens de entrada. Nos maiores, produz de 4.430 a 12.158 tokens de saída, quase todos de raciocínio, e leva de 37 a 81 segundos. Cuidado ao comparar: Ferramentas não usa cache de prompt e Consulta usa, então a latência mistura as duas condições; no Contexto longo, a maior parte da entrada veio do cache, o que o favorece. Sem preço em dólar, porque os preços mudam.</a:t>
+              <a:t>[1:00] Busca vetorial (9% a 17%): traz as 30 linhas mais parecidas com a pergunta, de 2.585. Parecer com a pergunta não é servir para respondê-la; contar exige todas as linhas de um tipo e ligar eventos exige as linhas vizinhas. Erra por abstenção e por resposta errada, conforme o modelo. Estatísticas resumidas (0% a 9%): a súmula tem só totais da partida inteira, sem recorte de tempo ou de campo e sem quem passou para quem; como o prompt pede para indicar ausência de dados, os modelos se abstêm. Sem dados: 0 de 47 com resposta, por obediência ao prompt, que proíbe responder de memória; o 0% mede obediência, não ignorância. Nas perguntas de controle, Sem dados acerta as 5.</a:t>
             </a:r>
           </a:p>
         </p:txBody>
@@ -2053,7 +2053,7 @@
           <a:lstStyle/>
           <a:p>
             <a:r>
-              <a:t>[1:15] Conclusão: Ferramentas sobre o grafo foi a única abordagem que manteve o acerto alto nos 4 modelos, 83% a 89%. Consulta e Contexto longo dependem do modelo; nos maiores, com raciocínio estendido, a Consulta chegou ao mesmo nível e o Contexto longo se aproximou, este com mais tokens de saída e tempo. Busca vetorial e Estatísticas resumidas ficaram baixas em todos. Limitações, ditas pelo próprio artigo: uma partida e 1 repetição por pergunta, com 47 perguntas com resposta, então os intervalos são largos; tamanho e raciocínio estendido vieram juntos nos maiores; as ferramentas e as perguntas foram escritas pelos mesmos autores e as ferramentas foram ajustadas olhando erros, então o acerto vale dentro da cobertura delas; o estudo não separa o efeito do grafo do efeito das ferramentas: uma hipótese não testada é que um banco relacional com as mesmas ferramentas iria bem em busca e contagem e a diferença apareceria nas perguntas de relações; e as abordagens com agente supõem chamada de ferramenta confiável.</a:t>
+              <a:t>[1:15] Mediana por execução das três abordagens com acesso a todas as ações. O Contexto longo leva a tabela inteira em cada pergunta, de 82 a 111 mil tokens de entrada. Nos maiores, produz de 4.430 a 12.158 tokens de saída, quase todos de raciocínio, e leva de 37 a 81 segundos. Cuidado ao comparar: Ferramentas não usa cache de prompt e Consulta usa, então a latência mistura as duas condições; no Contexto longo, a maior parte da entrada veio do cache, o que o favorece. Sem preço em dólar, porque os preços mudam.</a:t>
             </a:r>
           </a:p>
         </p:txBody>
@@ -2123,7 +2123,7 @@
           <a:lstStyle/>
           <a:p>
             <a:r>
-              <a:t>[1:15] Fecho. Três frentes, todas ligadas às limitações. Primeira, mais evidência: repetir as execuções mede a variação entre rodadas e permite testar as diferenças entre abordagens, e estender as perguntas a várias partidas tira a dependência de uma só. Segunda, separar efeitos: avaliar modelos maiores sem raciocínio estendido separa o efeito do tamanho do efeito do raciocínio; aplicar as mesmas ferramentas a um banco relacional (SQL), sem o grafo, separa o efeito das ferramentas do efeito do grafo; e testar uma busca vetorial em que cada trecho traga também os eventos vizinhos, como em Tzikas et al., responde à lacuna da Busca vetorial. Terceira, outros domínios, entre eles os dados industriais: parte deles tem a forma dos dados de futebol, registros de eventos com agente, momento e local, ligados entre si, como as paradas, os alertas e as movimentações de uma linha de produção ou de uma frota. Testar as mesmas abordagens ali é um próximo passo natural para uma pós em IA aplicada à indústria, mas exige implementação própria: a preparação dos dados, o grafo e as ferramentas dependem das perguntas que se quer responder.</a:t>
+              <a:t>[1:15] Conclusão: Ferramentas sobre o grafo foi a única abordagem que manteve o acerto alto nos 4 modelos, 83% a 89%. Consulta e Contexto longo dependem do modelo; nos maiores, com raciocínio estendido, a Consulta chegou ao mesmo nível e o Contexto longo se aproximou, este com mais tokens de saída e tempo. Busca vetorial e Estatísticas resumidas ficaram baixas em todos. Limitações, ditas pelo próprio artigo: uma partida e 1 repetição por pergunta, com 47 perguntas com resposta, então os intervalos são largos; tamanho e raciocínio estendido vieram juntos nos maiores; as ferramentas e as perguntas foram escritas pelos mesmos autores e as ferramentas foram ajustadas olhando erros, então o acerto vale dentro da cobertura delas; o estudo não separa o efeito do grafo do efeito das ferramentas: uma hipótese não testada é que um banco relacional com as mesmas ferramentas iria bem em busca e contagem e a diferença apareceria nas perguntas de relações; e as abordagens com agente supõem chamada de ferramenta confiável.</a:t>
             </a:r>
           </a:p>
         </p:txBody>
@@ -2193,7 +2193,7 @@
           <a:lstStyle/>
           <a:p>
             <a:r>
-              <a:t>Slides de apoio não foram incluídos para respeitar o limite de 15. As respostas às perguntas prováveis estão em apresentacao/perguntas-banca.md.</a:t>
+              <a:t>[1:15] Fecho. Três frentes, todas ligadas às limitações. Primeira, mais evidência: repetir as execuções mede a variação entre rodadas e permite testar as diferenças entre abordagens, e estender as perguntas a várias partidas tira a dependência de uma só. Segunda, separar efeitos: avaliar modelos maiores sem raciocínio estendido separa o efeito do tamanho do efeito do raciocínio; aplicar as mesmas ferramentas a um banco relacional (SQL), sem o grafo, separa o efeito das ferramentas do efeito do grafo; e testar uma busca vetorial em que cada trecho traga também os eventos vizinhos, como em Tzikas et al., responde à lacuna da Busca vetorial. Terceira, outros domínios, entre eles os dados industriais: parte deles tem a forma dos dados de futebol, registros de eventos com agente, momento e local, ligados entre si, como as paradas, os alertas e as movimentações de uma linha de produção ou de uma frota. Testar as mesmas abordagens ali é um próximo passo natural para uma pós em IA aplicada à indústria, mas exige implementação própria: a preparação dos dados, o grafo e as ferramentas dependem das perguntas que se quer responder. Em seguida, abrir para as perguntas; as respostas prováveis estão em apresentacao/perguntas-banca.md.</a:t>
             </a:r>
           </a:p>
         </p:txBody>
@@ -2263,7 +2263,7 @@
           <a:lstStyle/>
           <a:p>
             <a:r>
-              <a:t>[1:15] Contexto de futebol: a final da Copa de 2022, Argentina contra França, decidida nos pênaltis. Os dados de eventos registram cada ação, com jogador, momento e posição no campo. As três perguntas do slide são do conjunto do trabalho e nenhuma tem a resposta em um único evento: é preciso juntar vários. O modelo precisa receber os dados da partida, e há mais de uma forma de fazer isso. Perguntas de pesquisa: qual abordagem acerta mais, como o acerto muda de um modelo para outro e quanto cada uma custa em tokens e tempo. O aprendizado em contexto é usado em sentido amplo: o modelo não é treinado de novo e o que entra no contexto são os dados. Contribuições: a transformação dos eventos em uma tabela de ações e em um grafo, o conjunto de perguntas com gabarito e a comparação sob as mesmas perguntas, o mesmo prompt e a mesma saída. Trabalhos relacionados: no esporte, SoccerRAG, SPORTSQL e Tzikas et al. avaliam cada um uma única forma de recuperação; fora do esporte, Li et al. e LOFT comparam formas de recuperação sem dados de futebol. Não foram encontrados trabalhos que comparem formas de recuperação em perguntas encadeadas sobre eventos de futebol, com conferência por código contra um gabarito por código.</a:t>
+              <a:t>[1:00] Contexto de futebol: a final da Copa de 2022, Argentina contra França, decidida nos pênaltis. Os dados de eventos registram cada ação, com jogador, momento e posição no campo. As três perguntas do slide são do conjunto do trabalho e nenhuma tem a resposta em um único evento: é preciso juntar vários. O modelo precisa receber os dados da partida, e há mais de uma forma de fazer isso. Perguntas de pesquisa: qual abordagem acerta mais, como o acerto muda de um modelo para outro e quanto cada uma custa em tokens e tempo. O aprendizado em contexto é usado em sentido amplo: o modelo não é treinado de novo e o que entra no contexto são os dados. Contribuições: a transformação dos eventos em uma tabela de ações e em um grafo, o conjunto de perguntas com gabarito e a comparação sob as mesmas perguntas, o mesmo prompt e a mesma saída. Trabalhos relacionados: no esporte, SoccerRAG, SPORTSQL e Tzikas et al. avaliam cada um uma única forma de recuperação; fora do esporte, Li et al. e LOFT comparam formas de recuperação sem dados de futebol. Não foram encontrados trabalhos que comparem formas de recuperação em perguntas encadeadas sobre eventos de futebol, com conferência por código contra um gabarito por código.</a:t>
             </a:r>
           </a:p>
         </p:txBody>
@@ -2333,7 +2333,7 @@
           <a:lstStyle/>
           <a:p>
             <a:r>
-              <a:t>[1:30] Os dados são os eventos abertos da StatsBomb: dois arquivos, a lista de eventos da partida, em ordem, e as escalações, com nome completo e apelido de cada jogador. São 4.407 eventos no JSON bruto. O exemplo é o gol de Di María e o passe de Mac Allister que o precede, resumidos aos campos principais (valores de docs/02 e da Figura 1 do artigo, não recalculados nesta sessão). Três coisas que importam depois: cada tipo de evento tem campos próprios, então o JSON é rico e irregular; a mesma informação pode estar em lugares diferentes, como o cartão amarelo, que vem dentro da falta ou, sem falta, em um evento de comportamento; e o nome é o de registro, não o apelido, e o minuto é decorrido, então o gol aos 35 aparece como 36 na transmissão.</a:t>
+              <a:t>[1:00] Tabela de posicionamento do artigo. No esporte, os primeiros conjuntos (SportQA) medem o que o modelo sabe, sem dados de uma partida, com múltipla escolha. SoccerAgent usa um agente com ferramentas sobre uma base de conhecimento. SoccerRAG e SPORTSQL escrevem SQL, sobre anotações de partidas e sobre estatísticas de jogadores; Tzikas et al. usam recuperação vetorial sobre eventos, com um LLM como juiz. Cada um avalia uma única forma de recuperação. Fora do esporte, Li et al. e LOFT comparam recuperação e contexto longo, mas sem dados esportivos. A última linha não está na tabela do artigo: resume a lacuna que o artigo aponta no fim da seção, a de que não foram encontrados trabalhos que comparem formas de recuperação em perguntas encadeadas sobre eventos de futebol, com conferência por código contra um gabarito calculado por código.</a:t>
             </a:r>
           </a:p>
         </p:txBody>
@@ -2403,7 +2403,7 @@
           <a:lstStyle/>
           <a:p>
             <a:r>
-              <a:t>[1:30] Os eventos da partida, sem a disputa de pênaltis, foram convertidos com a biblioteca socceraction para o formato SPADL, que guarda só as ações com bola, em um vocabulário fechado e com os mesmos campos em todas. Os 4.407 eventos viram 2.585 ações. Sobre essa tabela foram acrescentadas colunas de contexto: direção de ataque, zona em uma grade de 96 zonas, fase de posse (537 fases na final), recebedor do passe, placar e minuto. A figura mostra a grade de 12 por 8 zonas e o passe de Mac Allister para Di María, da zona 74 para a 92, como na Figura 1 do artigo (zonas copiadas dela, não recalculadas). É essa tabela que o Contexto longo entrega ao modelo. O SPADL perde o desfecho da finalização e o cartão sem falta, que foram recuperados do JSON. Nenhuma etapa usa modelo de linguagem.</a:t>
+              <a:t>[1:30] Os dados são os eventos abertos da StatsBomb: dois arquivos, a lista de eventos da partida, em ordem, e as escalações, com nome completo e apelido de cada jogador. São 4.407 eventos no JSON bruto. O exemplo é o gol de Di María e o passe de Mac Allister que o precede, resumidos aos campos principais (valores de docs/02 e da Figura 1 do artigo, não recalculados nesta sessão). Três coisas que importam depois: cada tipo de evento tem campos próprios, então o JSON é rico e irregular; a mesma informação pode estar em lugares diferentes, como o cartão amarelo, que vem dentro da falta ou, sem falta, em um evento de comportamento; e o nome é o de registro, não o apelido, e o minuto é decorrido, então o gol aos 35 aparece como 36 na transmissão.</a:t>
             </a:r>
           </a:p>
         </p:txBody>
@@ -2473,7 +2473,7 @@
           <a:lstStyle/>
           <a:p>
             <a:r>
-              <a:t>[1:15] A tabela de ações foi carregada em um grafo Neo4j. Cada ação vira uma aresta do jogador para a partida, com as colunas da linha como propriedades; cada passe certo com recebedor vira uma aresta entre dois jogadores. O grafo tem 34 jogadores, 537 fases de posse e 96 zonas. As arestas não acrescentam informação à tabela, só a reorganizam em ligações; já a súmula, com totais por jogador e por time, é calculada: o próprio banco conta os totais a partir das arestas, separando tentativas e acertos. A abordagem Estatísticas resumidas lê só a súmula; Consulta e Ferramentas leem o grafo. Por que grafo: a análise de futebol trata os passes de um time como uma rede, com os jogadores como nós e os passes como arestas (Buldú et al.; Duch et al.). Perguntas sobre essa rede, como qual dupla mais trocou passes ou por qual jogador mais passa a circulação da bola, viram caminhos e métricas sobre o grafo. Uma tabela relacional também guarda a informação, mas, conforme a organização, seguir uma cadeia de passes pode exigir uma junção a cada passe, e métricas como a intermediação dependeriam de implementação própria. Nenhuma etapa usa modelo de linguagem.</a:t>
+              <a:t>[1:30] Os eventos da partida, sem a disputa de pênaltis, foram convertidos com a biblioteca socceraction para o formato SPADL, que guarda só as ações com bola, em um vocabulário fechado e com os mesmos campos em todas. Os 4.407 eventos viram 2.585 ações. Sobre essa tabela foram acrescentadas colunas de contexto: direção de ataque, zona em uma grade de 96 zonas, fase de posse (537 fases na final), recebedor do passe, placar e minuto. A figura mostra a grade de 12 por 8 zonas e o passe de Mac Allister para Di María, da zona 74 para a 92, como na Figura 1 do artigo (zonas copiadas dela, não recalculadas). É essa tabela que o Contexto longo entrega ao modelo. O SPADL perde o desfecho da finalização e o cartão sem falta, que foram recuperados do JSON. Nenhuma etapa usa modelo de linguagem.</a:t>
             </a:r>
           </a:p>
         </p:txBody>
@@ -2543,7 +2543,7 @@
           <a:lstStyle/>
           <a:p>
             <a:r>
-              <a:t>[1:15] Das 52 perguntas, 47 têm resposta nos dados e 5 são de controle: a resposta certa é a ausência de dados, como a distância percorrida por um jogador. As perguntas de busca e contagem são diretas: a resposta sai de um evento ou de uma soma. Os outros três grupos são encadeados: dependem de ligar eventos entre si. As perguntas foram escritas manualmente e o gabarito de cada uma foi calculado por código, a partir do JSON bruto e da tabela de ações. A conferência com o gabarito é determinística: a mesma resposta recebe sempre o mesmo veredito.</a:t>
+              <a:t>[1:15] A tabela de ações foi carregada em um grafo Neo4j. Cada ação vira uma aresta do jogador para a partida, com as colunas da linha como propriedades; cada passe certo com recebedor vira uma aresta entre dois jogadores. O grafo tem 34 jogadores, 537 fases de posse e 96 zonas. As arestas não acrescentam informação à tabela, só a reorganizam em ligações; já a súmula, com totais por jogador e por time, é calculada: o próprio banco conta os totais a partir das arestas, separando tentativas e acertos. A abordagem Estatísticas resumidas lê só a súmula; Consulta e Ferramentas leem o grafo. Por que grafo: a análise de futebol trata os passes de um time como uma rede, com os jogadores como nós e os passes como arestas (Buldú et al.; Duch et al.). Perguntas sobre essa rede, como qual dupla mais trocou passes ou por qual jogador mais passa a circulação da bola, viram caminhos e métricas sobre o grafo. Uma tabela relacional também guarda a informação, mas, conforme a organização, seguir uma cadeia de passes pode exigir uma junção a cada passe, e métricas como a intermediação dependeriam de implementação própria. Nenhuma etapa usa modelo de linguagem.</a:t>
             </a:r>
           </a:p>
         </p:txBody>
@@ -2613,7 +2613,7 @@
           <a:lstStyle/>
           <a:p>
             <a:r>
-              <a:t>[1:30] Sem dados: só a pergunta, linha de base. Contexto longo: a tabela inteira de 2.585 ações no prompt. Estatísticas resumidas: a súmula, com totais por jogador e por time. Busca vetorial: as 30 linhas mais parecidas com a pergunta, como em geração aumentada por recuperação. Consulta escrita pelo modelo: o modelo recebe o esquema do grafo e escreve a consulta Cypher. Ferramentas sobre o grafo: 8 ferramentas com consulta Cypher parametrizada; o modelo só escolhe qual chamar e com quais argumentos. As duas últimas consultam o mesmo grafo e têm o mesmo limite de 12 chamadas por pergunta: muda quem escreve a consulta. Duas diferenças a declarar: a Consulta não tem a biblioteca de algoritmos de grafos nem os nós de padrões prontos, e as ferramentas foram ajustadas olhando erros, enquanto a Consulta é o primeiro contato. Todas usam o mesmo prompt de sistema e a mesma saída estruturada.</a:t>
+              <a:t>[1:15] Das 52 perguntas, 47 têm resposta nos dados e 5 são de controle: a resposta certa é a ausência de dados, como a distância percorrida por um jogador. As perguntas de busca e contagem são diretas: a resposta sai de um evento ou de uma soma. Os outros três grupos são encadeados: dependem de ligar eventos entre si. As perguntas foram escritas manualmente e o gabarito de cada uma foi calculado por código, a partir do JSON bruto e da tabela de ações. A conferência com o gabarito é determinística: a mesma resposta recebe sempre o mesmo veredito.</a:t>
             </a:r>
           </a:p>
         </p:txBody>
@@ -2683,7 +2683,7 @@
           <a:lstStyle/>
           <a:p>
             <a:r>
-              <a:t>[1:15] Registro real de uma execução em cada abordagem com agente, pergunta a01, Claude Haiku 5.5. Na Consulta escrita pelo modelo, ele chama run_cypher com a consulta Cypher que escreveu, inclusive os filtros de time, ação, sucesso e terço do campo; a ferramenta executa a consulta no grafo e devolve o resultado. Nas Ferramentas sobre o grafo, o modelo escolhe query_actions e preenche os argumentos; a consulta parametrizada está no código e a ferramenta a executa com esses filtros. As duas consultam o mesmo grafo, com o mesmo limite de 12 chamadas por pergunta; muda quem escreve a consulta. Nesta pergunta, uma chamada bastou nas duas. As 8 ferramentas: listar jogadores, contar ações, listar ações, contar posses, rede de passes, métrica da rede, ligações da rede e sequências de passes. Diferenças a declarar: a Consulta não tem a biblioteca de algoritmos de grafos nem os nós de padrões prontos, e as ferramentas foram ajustadas olhando erros, enquanto a Consulta é o primeiro contato. A consulta, os argumentos e a resposta vêm do registro de execuções do Haiku (data/benchmark/claude-haiku-5.5_results.jsonl no repositório novo); os valores devolvidos pela ferramenta (24 e 18) estão só no trace e foram copiados da figura do artigo.</a:t>
+              <a:t>[1:30] Sem dados: só a pergunta, linha de base. Contexto longo: a tabela inteira de 2.585 ações no prompt. Estatísticas resumidas: a súmula, com totais por jogador e por time. Busca vetorial: as 30 linhas mais parecidas com a pergunta, como em geração aumentada por recuperação. Consulta escrita pelo modelo: o modelo recebe o esquema do grafo e escreve a consulta Cypher. Ferramentas sobre o grafo: 8 ferramentas com consulta Cypher parametrizada; o modelo só escolhe qual chamar e com quais argumentos. As duas últimas consultam o mesmo grafo e têm o mesmo limite de 12 chamadas por pergunta: muda quem escreve a consulta. Duas diferenças a declarar: a Consulta não tem a biblioteca de algoritmos de grafos nem os nós de padrões prontos, e as ferramentas foram ajustadas olhando erros, enquanto a Consulta é o primeiro contato. Todas usam o mesmo prompt de sistema e a mesma saída estruturada.</a:t>
             </a:r>
           </a:p>
         </p:txBody>
@@ -2753,7 +2753,7 @@
           <a:lstStyle/>
           <a:p>
             <a:r>
-              <a:t>[2:15] Acerto nas 47 perguntas com resposta, das três abordagens com acesso a todas as ações, com o intervalo de Wilson de 95%. A barra azul é Ferramentas sobre o grafo: 83% a 89% em todos os modelos. Consulta escrita pelo modelo: 57% a 70% nos menores e 89% a 94% nos maiores. Contexto longo: 40% a 45% nos menores e 72% a 85% nos maiores. As outras três ficam baixas e estão no slide 11: Busca vetorial 9% a 17%, Estatísticas resumidas 0% a 9% e Sem dados 0%, porque se abstém. Nos maiores, Consulta empata com Ferramentas no Sonnet e fica à frente no Kimi; os intervalos se sobrepõem. Setup: quatro modelos, dois menores (Haiku e Qwen, sem raciocínio estendido, temperatura zero) e dois maiores (Sonnet e Kimi, com raciocínio estendido), agrupados pela faixa de preço por token; 52 perguntas em 6 abordagens, 312 execuções por modelo, 1 repetição por pergunta; diferenças lidas como indícios.</a:t>
+              <a:t>[1:15] Registro real de uma execução em cada abordagem com agente, pergunta a01, Claude Haiku 5.5. Na Consulta escrita pelo modelo, ele chama run_cypher com a consulta Cypher que escreveu, inclusive os filtros de time, ação, sucesso e terço do campo; a ferramenta executa a consulta no grafo e devolve o resultado. Nas Ferramentas sobre o grafo, o modelo escolhe query_actions e preenche os argumentos; a consulta parametrizada está no código e a ferramenta a executa com esses filtros. As duas consultam o mesmo grafo, com o mesmo limite de 12 chamadas por pergunta; muda quem escreve a consulta. Nesta pergunta, uma chamada bastou nas duas. As 8 ferramentas: listar jogadores, contar ações, listar ações, contar posses, rede de passes, métrica da rede, ligações da rede e sequências de passes. Diferenças a declarar: a Consulta não tem a biblioteca de algoritmos de grafos nem os nós de padrões prontos, e as ferramentas foram ajustadas olhando erros, enquanto a Consulta é o primeiro contato. A consulta, os argumentos e a resposta vêm do registro de execuções do Haiku (data/benchmark/claude-haiku-5.5_results.jsonl no repositório novo); os valores devolvidos pela ferramenta (24 e 18) estão só no trace e foram copiados da figura do artigo.</a:t>
             </a:r>
           </a:p>
         </p:txBody>
@@ -6003,7 +6003,7 @@
                 </a:solidFill>
                 <a:latin typeface="Arial"/>
               </a:rPr>
-              <a:t>Nas perguntas encadeadas, Consulta e Contexto longo dependem do modelo</a:t>
+              <a:t>Ferramentas sobre o grafo: 83% a 89% de acerto nos 4 modelos</a:t>
             </a:r>
           </a:p>
         </p:txBody>
@@ -6086,6 +6086,290 @@
                 <a:latin typeface="Arial"/>
               </a:rPr>
               <a:t>10 / 15</a:t>
+            </a:r>
+          </a:p>
+        </p:txBody>
+      </p:sp>
+      <p:sp>
+        <p:nvSpPr>
+          <p:cNvPr id="5" name="TextBox 4"/>
+          <p:cNvSpPr txBox="1"/>
+          <p:nvPr/>
+        </p:nvSpPr>
+        <p:spPr>
+          <a:xfrm>
+            <a:off x="640080" y="6400800"/>
+            <a:ext cx="9144000" cy="320040"/>
+          </a:xfrm>
+          <a:prstGeom prst="rect">
+            <a:avLst/>
+          </a:prstGeom>
+          <a:noFill/>
+        </p:spPr>
+        <p:txBody>
+          <a:bodyPr wrap="square" anchor="t" lIns="45720" rIns="45720">
+            <a:spAutoFit/>
+          </a:bodyPr>
+          <a:lstStyle/>
+          <a:p>
+            <a:pPr algn="l">
+              <a:spcAft>
+                <a:spcPts val="600"/>
+              </a:spcAft>
+            </a:pPr>
+            <a:r>
+              <a:rPr sz="1200" b="0">
+                <a:solidFill>
+                  <a:srgbClr val="666666"/>
+                </a:solidFill>
+                <a:latin typeface="Arial"/>
+              </a:rPr>
+              <a:t>Barras de erro: intervalo de Wilson de 95%. Uma repetição por pergunta.</a:t>
+            </a:r>
+          </a:p>
+        </p:txBody>
+      </p:sp>
+      <p:sp>
+        <p:nvSpPr>
+          <p:cNvPr id="6" name="TextBox 5"/>
+          <p:cNvSpPr txBox="1"/>
+          <p:nvPr/>
+        </p:nvSpPr>
+        <p:spPr>
+          <a:xfrm>
+            <a:off x="640080" y="1325880"/>
+            <a:ext cx="10881360" cy="1005840"/>
+          </a:xfrm>
+          <a:prstGeom prst="rect">
+            <a:avLst/>
+          </a:prstGeom>
+          <a:noFill/>
+        </p:spPr>
+        <p:txBody>
+          <a:bodyPr wrap="square" anchor="t" lIns="45720" rIns="45720">
+            <a:spAutoFit/>
+          </a:bodyPr>
+          <a:lstStyle/>
+          <a:p>
+            <a:pPr algn="l">
+              <a:spcAft>
+                <a:spcPts val="200"/>
+              </a:spcAft>
+            </a:pPr>
+            <a:r>
+              <a:rPr sz="1400" b="0">
+                <a:solidFill>
+                  <a:srgbClr val="666666"/>
+                </a:solidFill>
+                <a:latin typeface="Arial"/>
+              </a:rPr>
+              <a:t>4 modelos: Claude Haiku 5.5 e Qwen3.8-flash (menores, sem raciocínio estendido, temperatura zero); Claude Sonnet 4.6 e Kimi K3 (maiores, com raciocínio estendido).</a:t>
+            </a:r>
+          </a:p>
+          <a:p>
+            <a:pPr algn="l">
+              <a:spcAft>
+                <a:spcPts val="200"/>
+              </a:spcAft>
+            </a:pPr>
+            <a:r>
+              <a:rPr sz="1400" b="0">
+                <a:solidFill>
+                  <a:srgbClr val="666666"/>
+                </a:solidFill>
+                <a:latin typeface="Arial"/>
+              </a:rPr>
+              <a:t>52 perguntas × 6 abordagens = 312 execuções por modelo, 1 repetição por pergunta. Diferenças lidas como indícios.</a:t>
+            </a:r>
+          </a:p>
+        </p:txBody>
+      </p:sp>
+      <p:graphicFrame>
+        <p:nvGraphicFramePr>
+          <p:cNvPr id="7" name="Chart 6"/>
+          <p:cNvGraphicFramePr>
+            <a:graphicFrameLocks noGrp="1"/>
+          </p:cNvGraphicFramePr>
+          <p:nvPr/>
+        </p:nvGraphicFramePr>
+        <p:xfrm>
+          <a:off x="457200" y="2286000"/>
+          <a:ext cx="11247120" cy="3703320"/>
+        </p:xfrm>
+        <a:graphic>
+          <a:graphicData uri="http://schemas.openxmlformats.org/drawingml/2006/chart">
+            <c:chart xmlns:c="http://schemas.openxmlformats.org/drawingml/2006/chart" r:id="rId3"/>
+          </a:graphicData>
+        </a:graphic>
+      </p:graphicFrame>
+      <p:sp>
+        <p:nvSpPr>
+          <p:cNvPr id="8" name="TextBox 7"/>
+          <p:cNvSpPr txBox="1"/>
+          <p:nvPr/>
+        </p:nvSpPr>
+        <p:spPr>
+          <a:xfrm>
+            <a:off x="640080" y="5989320"/>
+            <a:ext cx="10881360" cy="365760"/>
+          </a:xfrm>
+          <a:prstGeom prst="rect">
+            <a:avLst/>
+          </a:prstGeom>
+          <a:noFill/>
+        </p:spPr>
+        <p:txBody>
+          <a:bodyPr wrap="square" anchor="t" lIns="45720" rIns="45720">
+            <a:spAutoFit/>
+          </a:bodyPr>
+          <a:lstStyle/>
+          <a:p>
+            <a:pPr algn="l">
+              <a:spcAft>
+                <a:spcPts val="600"/>
+              </a:spcAft>
+            </a:pPr>
+            <a:r>
+              <a:rPr sz="1400" b="0">
+                <a:solidFill>
+                  <a:srgbClr val="222222"/>
+                </a:solidFill>
+                <a:latin typeface="Arial"/>
+              </a:rPr>
+              <a:t>As outras três abordagens não passam de 17% em nenhum modelo (slide 12).</a:t>
+            </a:r>
+          </a:p>
+        </p:txBody>
+      </p:sp>
+    </p:spTree>
+  </p:cSld>
+  <p:clrMapOvr>
+    <a:masterClrMapping/>
+  </p:clrMapOvr>
+</p:sld>
+</file>
+
+<file path=ppt/slides/slide11.xml><?xml version="1.0" encoding="utf-8"?>
+<p:sld xmlns:a="http://schemas.openxmlformats.org/drawingml/2006/main" xmlns:p="http://schemas.openxmlformats.org/presentationml/2006/main" xmlns:r="http://schemas.openxmlformats.org/officeDocument/2006/relationships">
+  <p:cSld>
+    <p:spTree>
+      <p:nvGrpSpPr>
+        <p:cNvPr id="1" name=""/>
+        <p:cNvGrpSpPr/>
+        <p:nvPr/>
+      </p:nvGrpSpPr>
+      <p:grpSpPr/>
+      <p:sp>
+        <p:nvSpPr>
+          <p:cNvPr id="2" name="Title 1"/>
+          <p:cNvSpPr>
+            <a:spLocks noGrp="1"/>
+          </p:cNvSpPr>
+          <p:nvPr>
+            <p:ph type="title"/>
+          </p:nvPr>
+        </p:nvSpPr>
+        <p:spPr>
+          <a:xfrm>
+            <a:off x="640080" y="365760"/>
+            <a:ext cx="10881360" cy="1005840"/>
+          </a:xfrm>
+        </p:spPr>
+        <p:txBody>
+          <a:bodyPr wrap="square" anchor="t"/>
+          <a:lstStyle/>
+          <a:p>
+            <a:pPr algn="l"/>
+            <a:r>
+              <a:rPr sz="3000" b="1">
+                <a:solidFill>
+                  <a:srgbClr val="222222"/>
+                </a:solidFill>
+                <a:latin typeface="Arial"/>
+              </a:rPr>
+              <a:t>Nas perguntas encadeadas, Consulta e Contexto longo dependem do modelo</a:t>
+            </a:r>
+          </a:p>
+        </p:txBody>
+      </p:sp>
+      <p:sp>
+        <p:nvSpPr>
+          <p:cNvPr id="3" name="Rectangle 2"/>
+          <p:cNvSpPr/>
+          <p:nvPr/>
+        </p:nvSpPr>
+        <p:spPr>
+          <a:xfrm>
+            <a:off x="0" y="365760"/>
+            <a:ext cx="256032" cy="822960"/>
+          </a:xfrm>
+          <a:prstGeom prst="rect">
+            <a:avLst/>
+          </a:prstGeom>
+          <a:solidFill>
+            <a:srgbClr val="1F5C99"/>
+          </a:solidFill>
+          <a:ln>
+            <a:noFill/>
+          </a:ln>
+        </p:spPr>
+        <p:style>
+          <a:lnRef idx="1">
+            <a:schemeClr val="accent1"/>
+          </a:lnRef>
+          <a:fillRef idx="3">
+            <a:schemeClr val="accent1"/>
+          </a:fillRef>
+          <a:effectRef idx="2">
+            <a:schemeClr val="accent1"/>
+          </a:effectRef>
+          <a:fontRef idx="minor">
+            <a:schemeClr val="lt1"/>
+          </a:fontRef>
+        </p:style>
+        <p:txBody>
+          <a:bodyPr rtlCol="0" anchor="ctr"/>
+          <a:lstStyle/>
+          <a:p>
+            <a:pPr algn="ctr"/>
+          </a:p>
+        </p:txBody>
+      </p:sp>
+      <p:sp>
+        <p:nvSpPr>
+          <p:cNvPr id="4" name="TextBox 3"/>
+          <p:cNvSpPr txBox="1"/>
+          <p:nvPr/>
+        </p:nvSpPr>
+        <p:spPr>
+          <a:xfrm>
+            <a:off x="10881360" y="6400800"/>
+            <a:ext cx="1097280" cy="320040"/>
+          </a:xfrm>
+          <a:prstGeom prst="rect">
+            <a:avLst/>
+          </a:prstGeom>
+          <a:noFill/>
+        </p:spPr>
+        <p:txBody>
+          <a:bodyPr wrap="square" anchor="t" lIns="45720" rIns="45720">
+            <a:spAutoFit/>
+          </a:bodyPr>
+          <a:lstStyle/>
+          <a:p>
+            <a:pPr algn="r">
+              <a:spcAft>
+                <a:spcPts val="600"/>
+              </a:spcAft>
+            </a:pPr>
+            <a:r>
+              <a:rPr sz="1200" b="0">
+                <a:solidFill>
+                  <a:srgbClr val="666666"/>
+                </a:solidFill>
+                <a:latin typeface="Arial"/>
+              </a:rPr>
+              <a:t>11 / 15</a:t>
             </a:r>
           </a:p>
         </p:txBody>
@@ -6302,7 +6586,7 @@
 </p:sld>
 </file>
 
-<file path=ppt/slides/slide11.xml><?xml version="1.0" encoding="utf-8"?>
+<file path=ppt/slides/slide12.xml><?xml version="1.0" encoding="utf-8"?>
 <p:sld xmlns:a="http://schemas.openxmlformats.org/drawingml/2006/main" xmlns:p="http://schemas.openxmlformats.org/presentationml/2006/main" xmlns:r="http://schemas.openxmlformats.org/officeDocument/2006/relationships">
   <p:cSld>
     <p:spTree>
@@ -6422,7 +6706,7 @@
                 </a:solidFill>
                 <a:latin typeface="Arial"/>
               </a:rPr>
-              <a:t>11 / 15</a:t>
+              <a:t>12 / 15</a:t>
             </a:r>
           </a:p>
         </p:txBody>
@@ -6828,7 +7112,7 @@
 </p:sld>
 </file>
 
-<file path=ppt/slides/slide12.xml><?xml version="1.0" encoding="utf-8"?>
+<file path=ppt/slides/slide13.xml><?xml version="1.0" encoding="utf-8"?>
 <p:sld xmlns:a="http://schemas.openxmlformats.org/drawingml/2006/main" xmlns:p="http://schemas.openxmlformats.org/presentationml/2006/main" xmlns:r="http://schemas.openxmlformats.org/officeDocument/2006/relationships">
   <p:cSld>
     <p:spTree>
@@ -6948,7 +7232,7 @@
                 </a:solidFill>
                 <a:latin typeface="Arial"/>
               </a:rPr>
-              <a:t>12 / 15</a:t>
+              <a:t>13 / 15</a:t>
             </a:r>
           </a:p>
         </p:txBody>
@@ -7209,569 +7493,6 @@
 </p:sld>
 </file>
 
-<file path=ppt/slides/slide13.xml><?xml version="1.0" encoding="utf-8"?>
-<p:sld xmlns:a="http://schemas.openxmlformats.org/drawingml/2006/main" xmlns:p="http://schemas.openxmlformats.org/presentationml/2006/main" xmlns:r="http://schemas.openxmlformats.org/officeDocument/2006/relationships">
-  <p:cSld>
-    <p:spTree>
-      <p:nvGrpSpPr>
-        <p:cNvPr id="1" name=""/>
-        <p:cNvGrpSpPr/>
-        <p:nvPr/>
-      </p:nvGrpSpPr>
-      <p:grpSpPr/>
-      <p:sp>
-        <p:nvSpPr>
-          <p:cNvPr id="2" name="Title 1"/>
-          <p:cNvSpPr>
-            <a:spLocks noGrp="1"/>
-          </p:cNvSpPr>
-          <p:nvPr>
-            <p:ph type="title"/>
-          </p:nvPr>
-        </p:nvSpPr>
-        <p:spPr>
-          <a:xfrm>
-            <a:off x="640080" y="365760"/>
-            <a:ext cx="10881360" cy="1005840"/>
-          </a:xfrm>
-        </p:spPr>
-        <p:txBody>
-          <a:bodyPr wrap="square" anchor="t"/>
-          <a:lstStyle/>
-          <a:p>
-            <a:pPr algn="l"/>
-            <a:r>
-              <a:rPr sz="3000" b="1">
-                <a:solidFill>
-                  <a:srgbClr val="222222"/>
-                </a:solidFill>
-                <a:latin typeface="Arial"/>
-              </a:rPr>
-              <a:t>Ferramentas mantiveram o acerto alto, com limites claros</a:t>
-            </a:r>
-          </a:p>
-        </p:txBody>
-      </p:sp>
-      <p:sp>
-        <p:nvSpPr>
-          <p:cNvPr id="3" name="Rectangle 2"/>
-          <p:cNvSpPr/>
-          <p:nvPr/>
-        </p:nvSpPr>
-        <p:spPr>
-          <a:xfrm>
-            <a:off x="0" y="365760"/>
-            <a:ext cx="256032" cy="822960"/>
-          </a:xfrm>
-          <a:prstGeom prst="rect">
-            <a:avLst/>
-          </a:prstGeom>
-          <a:solidFill>
-            <a:srgbClr val="1F5C99"/>
-          </a:solidFill>
-          <a:ln>
-            <a:noFill/>
-          </a:ln>
-        </p:spPr>
-        <p:style>
-          <a:lnRef idx="1">
-            <a:schemeClr val="accent1"/>
-          </a:lnRef>
-          <a:fillRef idx="3">
-            <a:schemeClr val="accent1"/>
-          </a:fillRef>
-          <a:effectRef idx="2">
-            <a:schemeClr val="accent1"/>
-          </a:effectRef>
-          <a:fontRef idx="minor">
-            <a:schemeClr val="lt1"/>
-          </a:fontRef>
-        </p:style>
-        <p:txBody>
-          <a:bodyPr rtlCol="0" anchor="ctr"/>
-          <a:lstStyle/>
-          <a:p>
-            <a:pPr algn="ctr"/>
-          </a:p>
-        </p:txBody>
-      </p:sp>
-      <p:sp>
-        <p:nvSpPr>
-          <p:cNvPr id="4" name="TextBox 3"/>
-          <p:cNvSpPr txBox="1"/>
-          <p:nvPr/>
-        </p:nvSpPr>
-        <p:spPr>
-          <a:xfrm>
-            <a:off x="10881360" y="6400800"/>
-            <a:ext cx="1097280" cy="320040"/>
-          </a:xfrm>
-          <a:prstGeom prst="rect">
-            <a:avLst/>
-          </a:prstGeom>
-          <a:noFill/>
-        </p:spPr>
-        <p:txBody>
-          <a:bodyPr wrap="square" anchor="t" lIns="45720" rIns="45720">
-            <a:spAutoFit/>
-          </a:bodyPr>
-          <a:lstStyle/>
-          <a:p>
-            <a:pPr algn="r">
-              <a:spcAft>
-                <a:spcPts val="600"/>
-              </a:spcAft>
-            </a:pPr>
-            <a:r>
-              <a:rPr sz="1200" b="0">
-                <a:solidFill>
-                  <a:srgbClr val="666666"/>
-                </a:solidFill>
-                <a:latin typeface="Arial"/>
-              </a:rPr>
-              <a:t>13 / 15</a:t>
-            </a:r>
-          </a:p>
-        </p:txBody>
-      </p:sp>
-      <p:sp>
-        <p:nvSpPr>
-          <p:cNvPr id="5" name="TextBox 4"/>
-          <p:cNvSpPr txBox="1"/>
-          <p:nvPr/>
-        </p:nvSpPr>
-        <p:spPr>
-          <a:xfrm>
-            <a:off x="640080" y="1463040"/>
-            <a:ext cx="5394960" cy="457200"/>
-          </a:xfrm>
-          <a:prstGeom prst="rect">
-            <a:avLst/>
-          </a:prstGeom>
-          <a:noFill/>
-        </p:spPr>
-        <p:txBody>
-          <a:bodyPr wrap="square" anchor="t" lIns="45720" rIns="45720">
-            <a:spAutoFit/>
-          </a:bodyPr>
-          <a:lstStyle/>
-          <a:p>
-            <a:pPr algn="l">
-              <a:spcAft>
-                <a:spcPts val="600"/>
-              </a:spcAft>
-            </a:pPr>
-            <a:r>
-              <a:rPr sz="2200" b="1">
-                <a:solidFill>
-                  <a:srgbClr val="1F5C99"/>
-                </a:solidFill>
-                <a:latin typeface="Arial"/>
-              </a:rPr>
-              <a:t>Conclusão</a:t>
-            </a:r>
-          </a:p>
-        </p:txBody>
-      </p:sp>
-      <p:sp>
-        <p:nvSpPr>
-          <p:cNvPr id="6" name="TextBox 5"/>
-          <p:cNvSpPr txBox="1"/>
-          <p:nvPr/>
-        </p:nvSpPr>
-        <p:spPr>
-          <a:xfrm>
-            <a:off x="640080" y="2011680"/>
-            <a:ext cx="5394960" cy="4206240"/>
-          </a:xfrm>
-          <a:prstGeom prst="rect">
-            <a:avLst/>
-          </a:prstGeom>
-          <a:noFill/>
-        </p:spPr>
-        <p:txBody>
-          <a:bodyPr wrap="square">
-            <a:spAutoFit/>
-          </a:bodyPr>
-          <a:lstStyle/>
-          <a:p>
-            <a:pPr>
-              <a:spcAft>
-                <a:spcPts val="1200"/>
-              </a:spcAft>
-            </a:pPr>
-            <a:r>
-              <a:rPr sz="1800" b="1">
-                <a:solidFill>
-                  <a:srgbClr val="1F5C99"/>
-                </a:solidFill>
-                <a:latin typeface="Arial"/>
-              </a:rPr>
-              <a:t>• </a:t>
-            </a:r>
-            <a:r>
-              <a:rPr sz="1800" b="1">
-                <a:solidFill>
-                  <a:srgbClr val="222222"/>
-                </a:solidFill>
-                <a:latin typeface="Arial"/>
-              </a:rPr>
-              <a:t>Ferramentas sobre o grafo: </a:t>
-            </a:r>
-            <a:r>
-              <a:rPr sz="1800" b="0">
-                <a:solidFill>
-                  <a:srgbClr val="222222"/>
-                </a:solidFill>
-                <a:latin typeface="Arial"/>
-              </a:rPr>
-              <a:t>83% a 89% em todos os modelos.</a:t>
-            </a:r>
-          </a:p>
-          <a:p>
-            <a:pPr>
-              <a:spcAft>
-                <a:spcPts val="1200"/>
-              </a:spcAft>
-            </a:pPr>
-            <a:r>
-              <a:rPr sz="1800" b="1">
-                <a:solidFill>
-                  <a:srgbClr val="1F5C99"/>
-                </a:solidFill>
-                <a:latin typeface="Arial"/>
-              </a:rPr>
-              <a:t>• </a:t>
-            </a:r>
-            <a:r>
-              <a:rPr sz="1800" b="1">
-                <a:solidFill>
-                  <a:srgbClr val="222222"/>
-                </a:solidFill>
-                <a:latin typeface="Arial"/>
-              </a:rPr>
-              <a:t>Consulta: </a:t>
-            </a:r>
-            <a:r>
-              <a:rPr sz="1800" b="0">
-                <a:solidFill>
-                  <a:srgbClr val="222222"/>
-                </a:solidFill>
-                <a:latin typeface="Arial"/>
-              </a:rPr>
-              <a:t>57% a 70% nos menores; 89% a 94% nos maiores.</a:t>
-            </a:r>
-          </a:p>
-          <a:p>
-            <a:pPr>
-              <a:spcAft>
-                <a:spcPts val="1200"/>
-              </a:spcAft>
-            </a:pPr>
-            <a:r>
-              <a:rPr sz="1800" b="1">
-                <a:solidFill>
-                  <a:srgbClr val="1F5C99"/>
-                </a:solidFill>
-                <a:latin typeface="Arial"/>
-              </a:rPr>
-              <a:t>• </a:t>
-            </a:r>
-            <a:r>
-              <a:rPr sz="1800" b="1">
-                <a:solidFill>
-                  <a:srgbClr val="222222"/>
-                </a:solidFill>
-                <a:latin typeface="Arial"/>
-              </a:rPr>
-              <a:t>Contexto longo: </a:t>
-            </a:r>
-            <a:r>
-              <a:rPr sz="1800" b="0">
-                <a:solidFill>
-                  <a:srgbClr val="222222"/>
-                </a:solidFill>
-                <a:latin typeface="Arial"/>
-              </a:rPr>
-              <a:t>40% a 45% nos menores; 72% a 85% nos maiores, com mais tokens de saída e tempo.</a:t>
-            </a:r>
-          </a:p>
-          <a:p>
-            <a:pPr>
-              <a:spcAft>
-                <a:spcPts val="1200"/>
-              </a:spcAft>
-            </a:pPr>
-            <a:r>
-              <a:rPr sz="1800" b="1">
-                <a:solidFill>
-                  <a:srgbClr val="1F5C99"/>
-                </a:solidFill>
-                <a:latin typeface="Arial"/>
-              </a:rPr>
-              <a:t>• </a:t>
-            </a:r>
-            <a:r>
-              <a:rPr sz="1800" b="1">
-                <a:solidFill>
-                  <a:srgbClr val="222222"/>
-                </a:solidFill>
-                <a:latin typeface="Arial"/>
-              </a:rPr>
-              <a:t>Busca vetorial e Estatísticas resumidas: </a:t>
-            </a:r>
-            <a:r>
-              <a:rPr sz="1800" b="0">
-                <a:solidFill>
-                  <a:srgbClr val="222222"/>
-                </a:solidFill>
-                <a:latin typeface="Arial"/>
-              </a:rPr>
-              <a:t>9% a 17% e 0% a 9%.</a:t>
-            </a:r>
-          </a:p>
-        </p:txBody>
-      </p:sp>
-      <p:sp>
-        <p:nvSpPr>
-          <p:cNvPr id="7" name="TextBox 6"/>
-          <p:cNvSpPr txBox="1"/>
-          <p:nvPr/>
-        </p:nvSpPr>
-        <p:spPr>
-          <a:xfrm>
-            <a:off x="6400800" y="1463040"/>
-            <a:ext cx="5120640" cy="457200"/>
-          </a:xfrm>
-          <a:prstGeom prst="rect">
-            <a:avLst/>
-          </a:prstGeom>
-          <a:noFill/>
-        </p:spPr>
-        <p:txBody>
-          <a:bodyPr wrap="square" anchor="t" lIns="45720" rIns="45720">
-            <a:spAutoFit/>
-          </a:bodyPr>
-          <a:lstStyle/>
-          <a:p>
-            <a:pPr algn="l">
-              <a:spcAft>
-                <a:spcPts val="600"/>
-              </a:spcAft>
-            </a:pPr>
-            <a:r>
-              <a:rPr sz="2200" b="1">
-                <a:solidFill>
-                  <a:srgbClr val="1F5C99"/>
-                </a:solidFill>
-                <a:latin typeface="Arial"/>
-              </a:rPr>
-              <a:t>Limitações</a:t>
-            </a:r>
-          </a:p>
-        </p:txBody>
-      </p:sp>
-      <p:sp>
-        <p:nvSpPr>
-          <p:cNvPr id="8" name="TextBox 7"/>
-          <p:cNvSpPr txBox="1"/>
-          <p:nvPr/>
-        </p:nvSpPr>
-        <p:spPr>
-          <a:xfrm>
-            <a:off x="6400800" y="2011680"/>
-            <a:ext cx="5120640" cy="4206240"/>
-          </a:xfrm>
-          <a:prstGeom prst="rect">
-            <a:avLst/>
-          </a:prstGeom>
-          <a:noFill/>
-        </p:spPr>
-        <p:txBody>
-          <a:bodyPr wrap="square">
-            <a:spAutoFit/>
-          </a:bodyPr>
-          <a:lstStyle/>
-          <a:p>
-            <a:pPr>
-              <a:spcAft>
-                <a:spcPts val="1200"/>
-              </a:spcAft>
-            </a:pPr>
-            <a:r>
-              <a:rPr sz="1800" b="1">
-                <a:solidFill>
-                  <a:srgbClr val="1F5C99"/>
-                </a:solidFill>
-                <a:latin typeface="Arial"/>
-              </a:rPr>
-              <a:t>• </a:t>
-            </a:r>
-            <a:r>
-              <a:rPr sz="1800" b="1">
-                <a:solidFill>
-                  <a:srgbClr val="222222"/>
-                </a:solidFill>
-                <a:latin typeface="Arial"/>
-              </a:rPr>
-              <a:t>Uma partida e 1 repetição </a:t>
-            </a:r>
-            <a:r>
-              <a:rPr sz="1800" b="0">
-                <a:solidFill>
-                  <a:srgbClr val="222222"/>
-                </a:solidFill>
-                <a:latin typeface="Arial"/>
-              </a:rPr>
-              <a:t>por pergunta; 47 perguntas com resposta e intervalos largos.</a:t>
-            </a:r>
-          </a:p>
-          <a:p>
-            <a:pPr>
-              <a:spcAft>
-                <a:spcPts val="1200"/>
-              </a:spcAft>
-            </a:pPr>
-            <a:r>
-              <a:rPr sz="1800" b="1">
-                <a:solidFill>
-                  <a:srgbClr val="1F5C99"/>
-                </a:solidFill>
-                <a:latin typeface="Arial"/>
-              </a:rPr>
-              <a:t>• </a:t>
-            </a:r>
-            <a:r>
-              <a:rPr sz="1800" b="1">
-                <a:solidFill>
-                  <a:srgbClr val="222222"/>
-                </a:solidFill>
-                <a:latin typeface="Arial"/>
-              </a:rPr>
-              <a:t>Tamanho e raciocínio </a:t>
-            </a:r>
-            <a:r>
-              <a:rPr sz="1800" b="0">
-                <a:solidFill>
-                  <a:srgbClr val="222222"/>
-                </a:solidFill>
-                <a:latin typeface="Arial"/>
-              </a:rPr>
-              <a:t>vieram juntos nos modelos maiores.</a:t>
-            </a:r>
-          </a:p>
-          <a:p>
-            <a:pPr>
-              <a:spcAft>
-                <a:spcPts val="1200"/>
-              </a:spcAft>
-            </a:pPr>
-            <a:r>
-              <a:rPr sz="1800" b="1">
-                <a:solidFill>
-                  <a:srgbClr val="1F5C99"/>
-                </a:solidFill>
-                <a:latin typeface="Arial"/>
-              </a:rPr>
-              <a:t>• </a:t>
-            </a:r>
-            <a:r>
-              <a:rPr sz="1800" b="1">
-                <a:solidFill>
-                  <a:srgbClr val="222222"/>
-                </a:solidFill>
-                <a:latin typeface="Arial"/>
-              </a:rPr>
-              <a:t>Ferramentas e perguntas dos mesmos autores: </a:t>
-            </a:r>
-            <a:r>
-              <a:rPr sz="1800" b="0">
-                <a:solidFill>
-                  <a:srgbClr val="222222"/>
-                </a:solidFill>
-                <a:latin typeface="Arial"/>
-              </a:rPr>
-              <a:t>o acerto vale dentro da cobertura das ferramentas.</a:t>
-            </a:r>
-          </a:p>
-          <a:p>
-            <a:pPr>
-              <a:spcAft>
-                <a:spcPts val="1200"/>
-              </a:spcAft>
-            </a:pPr>
-            <a:r>
-              <a:rPr sz="1800" b="1">
-                <a:solidFill>
-                  <a:srgbClr val="1F5C99"/>
-                </a:solidFill>
-                <a:latin typeface="Arial"/>
-              </a:rPr>
-              <a:t>• </a:t>
-            </a:r>
-            <a:r>
-              <a:rPr sz="1800" b="1">
-                <a:solidFill>
-                  <a:srgbClr val="222222"/>
-                </a:solidFill>
-                <a:latin typeface="Arial"/>
-              </a:rPr>
-              <a:t>Grafo ou banco relacional? </a:t>
-            </a:r>
-            <a:r>
-              <a:rPr sz="1800" b="0">
-                <a:solidFill>
-                  <a:srgbClr val="222222"/>
-                </a:solidFill>
-                <a:latin typeface="Arial"/>
-              </a:rPr>
-              <a:t>Hipótese não testada: a diferença apareceria nas perguntas de relações.</a:t>
-            </a:r>
-          </a:p>
-          <a:p>
-            <a:pPr>
-              <a:spcAft>
-                <a:spcPts val="1200"/>
-              </a:spcAft>
-            </a:pPr>
-            <a:r>
-              <a:rPr sz="1800" b="1">
-                <a:solidFill>
-                  <a:srgbClr val="1F5C99"/>
-                </a:solidFill>
-                <a:latin typeface="Arial"/>
-              </a:rPr>
-              <a:t>• </a:t>
-            </a:r>
-            <a:r>
-              <a:rPr sz="1800" b="1">
-                <a:solidFill>
-                  <a:srgbClr val="222222"/>
-                </a:solidFill>
-                <a:latin typeface="Arial"/>
-              </a:rPr>
-              <a:t>Agentes </a:t>
-            </a:r>
-            <a:r>
-              <a:rPr sz="1800" b="0">
-                <a:solidFill>
-                  <a:srgbClr val="222222"/>
-                </a:solidFill>
-                <a:latin typeface="Arial"/>
-              </a:rPr>
-              <a:t>supõem chamada de ferramenta confiável.</a:t>
-            </a:r>
-          </a:p>
-        </p:txBody>
-      </p:sp>
-    </p:spTree>
-  </p:cSld>
-  <p:clrMapOvr>
-    <a:masterClrMapping/>
-  </p:clrMapOvr>
-</p:sld>
-</file>
-
 <file path=ppt/slides/slide14.xml><?xml version="1.0" encoding="utf-8"?>
 <p:sld xmlns:a="http://schemas.openxmlformats.org/drawingml/2006/main" xmlns:p="http://schemas.openxmlformats.org/presentationml/2006/main" xmlns:r="http://schemas.openxmlformats.org/officeDocument/2006/relationships">
   <p:cSld>
@@ -7810,7 +7531,7 @@
                 </a:solidFill>
                 <a:latin typeface="Arial"/>
               </a:rPr>
-              <a:t>Próximos passos: mais evidência, efeitos separados e outros domínios</a:t>
+              <a:t>Ferramentas mantiveram o acerto alto, com limites claros</a:t>
             </a:r>
           </a:p>
         </p:txBody>
@@ -7899,58 +7620,14 @@
       </p:sp>
       <p:sp>
         <p:nvSpPr>
-          <p:cNvPr id="5" name="Rectangle 4"/>
-          <p:cNvSpPr/>
-          <p:nvPr/>
-        </p:nvSpPr>
-        <p:spPr>
-          <a:xfrm>
-            <a:off x="640080" y="1554480"/>
-            <a:ext cx="3474720" cy="4206240"/>
-          </a:xfrm>
-          <a:prstGeom prst="rect">
-            <a:avLst/>
-          </a:prstGeom>
-          <a:solidFill>
-            <a:srgbClr val="F2F2F2"/>
-          </a:solidFill>
-          <a:ln>
-            <a:noFill/>
-          </a:ln>
-          <a:effectLst/>
-        </p:spPr>
-        <p:style>
-          <a:lnRef idx="1">
-            <a:schemeClr val="accent1"/>
-          </a:lnRef>
-          <a:fillRef idx="3">
-            <a:schemeClr val="accent1"/>
-          </a:fillRef>
-          <a:effectRef idx="2">
-            <a:schemeClr val="accent1"/>
-          </a:effectRef>
-          <a:fontRef idx="minor">
-            <a:schemeClr val="lt1"/>
-          </a:fontRef>
-        </p:style>
-        <p:txBody>
-          <a:bodyPr rtlCol="0" anchor="ctr"/>
-          <a:lstStyle/>
-          <a:p>
-            <a:pPr algn="ctr"/>
-          </a:p>
-        </p:txBody>
-      </p:sp>
-      <p:sp>
-        <p:nvSpPr>
-          <p:cNvPr id="6" name="TextBox 5"/>
+          <p:cNvPr id="5" name="TextBox 4"/>
           <p:cNvSpPr txBox="1"/>
           <p:nvPr/>
         </p:nvSpPr>
         <p:spPr>
           <a:xfrm>
-            <a:off x="777240" y="1645920"/>
-            <a:ext cx="3200400" cy="457200"/>
+            <a:off x="640080" y="1463040"/>
+            <a:ext cx="5394960" cy="457200"/>
           </a:xfrm>
           <a:prstGeom prst="rect">
             <a:avLst/>
@@ -7969,27 +7646,27 @@
               </a:spcAft>
             </a:pPr>
             <a:r>
-              <a:rPr sz="2000" b="1">
+              <a:rPr sz="2200" b="1">
                 <a:solidFill>
                   <a:srgbClr val="1F5C99"/>
                 </a:solidFill>
                 <a:latin typeface="Arial"/>
               </a:rPr>
-              <a:t>Mais evidência</a:t>
-            </a:r>
-          </a:p>
-        </p:txBody>
-      </p:sp>
-      <p:sp>
-        <p:nvSpPr>
-          <p:cNvPr id="7" name="TextBox 6"/>
+              <a:t>Conclusão</a:t>
+            </a:r>
+          </a:p>
+        </p:txBody>
+      </p:sp>
+      <p:sp>
+        <p:nvSpPr>
+          <p:cNvPr id="6" name="TextBox 5"/>
           <p:cNvSpPr txBox="1"/>
           <p:nvPr/>
         </p:nvSpPr>
         <p:spPr>
           <a:xfrm>
-            <a:off x="777240" y="2240280"/>
-            <a:ext cx="3200400" cy="3474720"/>
+            <a:off x="640080" y="2011680"/>
+            <a:ext cx="5394960" cy="4206240"/>
           </a:xfrm>
           <a:prstGeom prst="rect">
             <a:avLst/>
@@ -8004,7 +7681,7 @@
           <a:p>
             <a:pPr>
               <a:spcAft>
-                <a:spcPts val="1400"/>
+                <a:spcPts val="1200"/>
               </a:spcAft>
             </a:pPr>
             <a:r>
@@ -8017,19 +7694,28 @@
               <a:t>• </a:t>
             </a:r>
             <a:r>
+              <a:rPr sz="1800" b="1">
+                <a:solidFill>
+                  <a:srgbClr val="222222"/>
+                </a:solidFill>
+                <a:latin typeface="Arial"/>
+              </a:rPr>
+              <a:t>Ferramentas sobre o grafo: </a:t>
+            </a:r>
+            <a:r>
               <a:rPr sz="1800" b="0">
                 <a:solidFill>
                   <a:srgbClr val="222222"/>
                 </a:solidFill>
                 <a:latin typeface="Arial"/>
               </a:rPr>
-              <a:t>Repetir as execuções: medir a variação entre rodadas e testar as diferenças entre abordagens.</a:t>
+              <a:t>83% a 89% em todos os modelos.</a:t>
             </a:r>
           </a:p>
           <a:p>
             <a:pPr>
               <a:spcAft>
-                <a:spcPts val="1400"/>
+                <a:spcPts val="1200"/>
               </a:spcAft>
             </a:pPr>
             <a:r>
@@ -8042,71 +7728,104 @@
               <a:t>• </a:t>
             </a:r>
             <a:r>
+              <a:rPr sz="1800" b="1">
+                <a:solidFill>
+                  <a:srgbClr val="222222"/>
+                </a:solidFill>
+                <a:latin typeface="Arial"/>
+              </a:rPr>
+              <a:t>Consulta: </a:t>
+            </a:r>
+            <a:r>
               <a:rPr sz="1800" b="0">
                 <a:solidFill>
                   <a:srgbClr val="222222"/>
                 </a:solidFill>
                 <a:latin typeface="Arial"/>
               </a:rPr>
-              <a:t>Estender as perguntas a várias partidas.</a:t>
-            </a:r>
-          </a:p>
-        </p:txBody>
-      </p:sp>
-      <p:sp>
-        <p:nvSpPr>
-          <p:cNvPr id="8" name="Rectangle 7"/>
-          <p:cNvSpPr/>
-          <p:nvPr/>
-        </p:nvSpPr>
-        <p:spPr>
-          <a:xfrm>
-            <a:off x="4343400" y="1554480"/>
-            <a:ext cx="3474720" cy="4206240"/>
-          </a:xfrm>
-          <a:prstGeom prst="rect">
-            <a:avLst/>
-          </a:prstGeom>
-          <a:solidFill>
-            <a:srgbClr val="F2F2F2"/>
-          </a:solidFill>
-          <a:ln>
-            <a:noFill/>
-          </a:ln>
-          <a:effectLst/>
-        </p:spPr>
-        <p:style>
-          <a:lnRef idx="1">
-            <a:schemeClr val="accent1"/>
-          </a:lnRef>
-          <a:fillRef idx="3">
-            <a:schemeClr val="accent1"/>
-          </a:fillRef>
-          <a:effectRef idx="2">
-            <a:schemeClr val="accent1"/>
-          </a:effectRef>
-          <a:fontRef idx="minor">
-            <a:schemeClr val="lt1"/>
-          </a:fontRef>
-        </p:style>
-        <p:txBody>
-          <a:bodyPr rtlCol="0" anchor="ctr"/>
-          <a:lstStyle/>
-          <a:p>
-            <a:pPr algn="ctr"/>
-          </a:p>
-        </p:txBody>
-      </p:sp>
-      <p:sp>
-        <p:nvSpPr>
-          <p:cNvPr id="9" name="TextBox 8"/>
+              <a:t>57% a 70% nos menores; 89% a 94% nos maiores.</a:t>
+            </a:r>
+          </a:p>
+          <a:p>
+            <a:pPr>
+              <a:spcAft>
+                <a:spcPts val="1200"/>
+              </a:spcAft>
+            </a:pPr>
+            <a:r>
+              <a:rPr sz="1800" b="1">
+                <a:solidFill>
+                  <a:srgbClr val="1F5C99"/>
+                </a:solidFill>
+                <a:latin typeface="Arial"/>
+              </a:rPr>
+              <a:t>• </a:t>
+            </a:r>
+            <a:r>
+              <a:rPr sz="1800" b="1">
+                <a:solidFill>
+                  <a:srgbClr val="222222"/>
+                </a:solidFill>
+                <a:latin typeface="Arial"/>
+              </a:rPr>
+              <a:t>Contexto longo: </a:t>
+            </a:r>
+            <a:r>
+              <a:rPr sz="1800" b="0">
+                <a:solidFill>
+                  <a:srgbClr val="222222"/>
+                </a:solidFill>
+                <a:latin typeface="Arial"/>
+              </a:rPr>
+              <a:t>40% a 45% nos menores; 72% a 85% nos maiores, com mais tokens de saída e tempo.</a:t>
+            </a:r>
+          </a:p>
+          <a:p>
+            <a:pPr>
+              <a:spcAft>
+                <a:spcPts val="1200"/>
+              </a:spcAft>
+            </a:pPr>
+            <a:r>
+              <a:rPr sz="1800" b="1">
+                <a:solidFill>
+                  <a:srgbClr val="1F5C99"/>
+                </a:solidFill>
+                <a:latin typeface="Arial"/>
+              </a:rPr>
+              <a:t>• </a:t>
+            </a:r>
+            <a:r>
+              <a:rPr sz="1800" b="1">
+                <a:solidFill>
+                  <a:srgbClr val="222222"/>
+                </a:solidFill>
+                <a:latin typeface="Arial"/>
+              </a:rPr>
+              <a:t>Busca vetorial e Estatísticas resumidas: </a:t>
+            </a:r>
+            <a:r>
+              <a:rPr sz="1800" b="0">
+                <a:solidFill>
+                  <a:srgbClr val="222222"/>
+                </a:solidFill>
+                <a:latin typeface="Arial"/>
+              </a:rPr>
+              <a:t>9% a 17% e 0% a 9%.</a:t>
+            </a:r>
+          </a:p>
+        </p:txBody>
+      </p:sp>
+      <p:sp>
+        <p:nvSpPr>
+          <p:cNvPr id="7" name="TextBox 6"/>
           <p:cNvSpPr txBox="1"/>
           <p:nvPr/>
         </p:nvSpPr>
         <p:spPr>
           <a:xfrm>
-            <a:off x="4480560" y="1645920"/>
-            <a:ext cx="3200400" cy="457200"/>
+            <a:off x="6400800" y="1463040"/>
+            <a:ext cx="5120640" cy="457200"/>
           </a:xfrm>
           <a:prstGeom prst="rect">
             <a:avLst/>
@@ -8125,27 +7844,27 @@
               </a:spcAft>
             </a:pPr>
             <a:r>
-              <a:rPr sz="2000" b="1">
+              <a:rPr sz="2200" b="1">
                 <a:solidFill>
                   <a:srgbClr val="1F5C99"/>
                 </a:solidFill>
                 <a:latin typeface="Arial"/>
               </a:rPr>
-              <a:t>Separar os efeitos</a:t>
-            </a:r>
-          </a:p>
-        </p:txBody>
-      </p:sp>
-      <p:sp>
-        <p:nvSpPr>
-          <p:cNvPr id="10" name="TextBox 9"/>
+              <a:t>Limitações</a:t>
+            </a:r>
+          </a:p>
+        </p:txBody>
+      </p:sp>
+      <p:sp>
+        <p:nvSpPr>
+          <p:cNvPr id="8" name="TextBox 7"/>
           <p:cNvSpPr txBox="1"/>
           <p:nvPr/>
         </p:nvSpPr>
         <p:spPr>
           <a:xfrm>
-            <a:off x="4480560" y="2240280"/>
-            <a:ext cx="3200400" cy="3474720"/>
+            <a:off x="6400800" y="2011680"/>
+            <a:ext cx="5120640" cy="4206240"/>
           </a:xfrm>
           <a:prstGeom prst="rect">
             <a:avLst/>
@@ -8160,7 +7879,7 @@
           <a:p>
             <a:pPr>
               <a:spcAft>
-                <a:spcPts val="1400"/>
+                <a:spcPts val="1200"/>
               </a:spcAft>
             </a:pPr>
             <a:r>
@@ -8173,19 +7892,28 @@
               <a:t>• </a:t>
             </a:r>
             <a:r>
+              <a:rPr sz="1800" b="1">
+                <a:solidFill>
+                  <a:srgbClr val="222222"/>
+                </a:solidFill>
+                <a:latin typeface="Arial"/>
+              </a:rPr>
+              <a:t>Uma partida e 1 repetição </a:t>
+            </a:r>
+            <a:r>
               <a:rPr sz="1800" b="0">
                 <a:solidFill>
                   <a:srgbClr val="222222"/>
                 </a:solidFill>
                 <a:latin typeface="Arial"/>
               </a:rPr>
-              <a:t>Modelos maiores sem raciocínio estendido: tamanho ou raciocínio?</a:t>
+              <a:t>por pergunta; 47 perguntas com resposta e intervalos largos.</a:t>
             </a:r>
           </a:p>
           <a:p>
             <a:pPr>
               <a:spcAft>
-                <a:spcPts val="1400"/>
+                <a:spcPts val="1200"/>
               </a:spcAft>
             </a:pPr>
             <a:r>
@@ -8198,19 +7926,28 @@
               <a:t>• </a:t>
             </a:r>
             <a:r>
+              <a:rPr sz="1800" b="1">
+                <a:solidFill>
+                  <a:srgbClr val="222222"/>
+                </a:solidFill>
+                <a:latin typeface="Arial"/>
+              </a:rPr>
+              <a:t>Tamanho e raciocínio </a:t>
+            </a:r>
+            <a:r>
               <a:rPr sz="1800" b="0">
                 <a:solidFill>
                   <a:srgbClr val="222222"/>
                 </a:solidFill>
                 <a:latin typeface="Arial"/>
               </a:rPr>
-              <a:t>As mesmas ferramentas sobre um banco relacional (SQL), sem o grafo: ferramentas ou grafo?</a:t>
+              <a:t>vieram juntos nos modelos maiores.</a:t>
             </a:r>
           </a:p>
           <a:p>
             <a:pPr>
               <a:spcAft>
-                <a:spcPts val="1400"/>
+                <a:spcPts val="1200"/>
               </a:spcAft>
             </a:pPr>
             <a:r>
@@ -8223,125 +7960,62 @@
               <a:t>• </a:t>
             </a:r>
             <a:r>
+              <a:rPr sz="1800" b="1">
+                <a:solidFill>
+                  <a:srgbClr val="222222"/>
+                </a:solidFill>
+                <a:latin typeface="Arial"/>
+              </a:rPr>
+              <a:t>Ferramentas e perguntas dos mesmos autores: </a:t>
+            </a:r>
+            <a:r>
               <a:rPr sz="1800" b="0">
                 <a:solidFill>
                   <a:srgbClr val="222222"/>
                 </a:solidFill>
                 <a:latin typeface="Arial"/>
               </a:rPr>
-              <a:t>Busca vetorial com os eventos vizinhos em cada trecho.</a:t>
-            </a:r>
-          </a:p>
-        </p:txBody>
-      </p:sp>
-      <p:sp>
-        <p:nvSpPr>
-          <p:cNvPr id="11" name="Rectangle 10"/>
-          <p:cNvSpPr/>
-          <p:nvPr/>
-        </p:nvSpPr>
-        <p:spPr>
-          <a:xfrm>
-            <a:off x="8046720" y="1554480"/>
-            <a:ext cx="3474720" cy="4206240"/>
-          </a:xfrm>
-          <a:prstGeom prst="rect">
-            <a:avLst/>
-          </a:prstGeom>
-          <a:solidFill>
-            <a:srgbClr val="E6EEF6"/>
-          </a:solidFill>
-          <a:ln>
-            <a:noFill/>
-          </a:ln>
-          <a:effectLst/>
-        </p:spPr>
-        <p:style>
-          <a:lnRef idx="1">
-            <a:schemeClr val="accent1"/>
-          </a:lnRef>
-          <a:fillRef idx="3">
-            <a:schemeClr val="accent1"/>
-          </a:fillRef>
-          <a:effectRef idx="2">
-            <a:schemeClr val="accent1"/>
-          </a:effectRef>
-          <a:fontRef idx="minor">
-            <a:schemeClr val="lt1"/>
-          </a:fontRef>
-        </p:style>
-        <p:txBody>
-          <a:bodyPr rtlCol="0" anchor="ctr"/>
-          <a:lstStyle/>
-          <a:p>
-            <a:pPr algn="ctr"/>
-          </a:p>
-        </p:txBody>
-      </p:sp>
-      <p:sp>
-        <p:nvSpPr>
-          <p:cNvPr id="12" name="TextBox 11"/>
-          <p:cNvSpPr txBox="1"/>
-          <p:nvPr/>
-        </p:nvSpPr>
-        <p:spPr>
-          <a:xfrm>
-            <a:off x="8183880" y="1645920"/>
-            <a:ext cx="3200400" cy="457200"/>
-          </a:xfrm>
-          <a:prstGeom prst="rect">
-            <a:avLst/>
-          </a:prstGeom>
-          <a:noFill/>
-        </p:spPr>
-        <p:txBody>
-          <a:bodyPr wrap="square" anchor="t" lIns="45720" rIns="45720">
-            <a:spAutoFit/>
-          </a:bodyPr>
-          <a:lstStyle/>
-          <a:p>
-            <a:pPr algn="l">
+              <a:t>o acerto vale dentro da cobertura das ferramentas.</a:t>
+            </a:r>
+          </a:p>
+          <a:p>
+            <a:pPr>
               <a:spcAft>
-                <a:spcPts val="600"/>
+                <a:spcPts val="1200"/>
               </a:spcAft>
             </a:pPr>
             <a:r>
-              <a:rPr sz="2000" b="1">
+              <a:rPr sz="1800" b="1">
                 <a:solidFill>
                   <a:srgbClr val="1F5C99"/>
                 </a:solidFill>
                 <a:latin typeface="Arial"/>
               </a:rPr>
-              <a:t>Outros domínios</a:t>
-            </a:r>
-          </a:p>
-        </p:txBody>
-      </p:sp>
-      <p:sp>
-        <p:nvSpPr>
-          <p:cNvPr id="13" name="TextBox 12"/>
-          <p:cNvSpPr txBox="1"/>
-          <p:nvPr/>
-        </p:nvSpPr>
-        <p:spPr>
-          <a:xfrm>
-            <a:off x="8183880" y="2240280"/>
-            <a:ext cx="3200400" cy="3474720"/>
-          </a:xfrm>
-          <a:prstGeom prst="rect">
-            <a:avLst/>
-          </a:prstGeom>
-          <a:noFill/>
-        </p:spPr>
-        <p:txBody>
-          <a:bodyPr wrap="square">
-            <a:spAutoFit/>
-          </a:bodyPr>
-          <a:lstStyle/>
+              <a:t>• </a:t>
+            </a:r>
+            <a:r>
+              <a:rPr sz="1800" b="1">
+                <a:solidFill>
+                  <a:srgbClr val="222222"/>
+                </a:solidFill>
+                <a:latin typeface="Arial"/>
+              </a:rPr>
+              <a:t>Grafo ou banco relacional? </a:t>
+            </a:r>
+            <a:r>
+              <a:rPr sz="1800" b="0">
+                <a:solidFill>
+                  <a:srgbClr val="222222"/>
+                </a:solidFill>
+                <a:latin typeface="Arial"/>
+              </a:rPr>
+              <a:t>Hipótese não testada: a diferença apareceria nas perguntas de relações.</a:t>
+            </a:r>
+          </a:p>
           <a:p>
             <a:pPr>
               <a:spcAft>
-                <a:spcPts val="1400"/>
+                <a:spcPts val="1200"/>
               </a:spcAft>
             </a:pPr>
             <a:r>
@@ -8354,38 +8028,22 @@
               <a:t>• </a:t>
             </a:r>
             <a:r>
+              <a:rPr sz="1800" b="1">
+                <a:solidFill>
+                  <a:srgbClr val="222222"/>
+                </a:solidFill>
+                <a:latin typeface="Arial"/>
+              </a:rPr>
+              <a:t>Agentes </a:t>
+            </a:r>
+            <a:r>
               <a:rPr sz="1800" b="0">
                 <a:solidFill>
                   <a:srgbClr val="222222"/>
                 </a:solidFill>
                 <a:latin typeface="Arial"/>
               </a:rPr>
-              <a:t>Outros registros de eventos, como os de processos industriais.</a:t>
-            </a:r>
-          </a:p>
-          <a:p>
-            <a:pPr>
-              <a:spcAft>
-                <a:spcPts val="1400"/>
-              </a:spcAft>
-            </a:pPr>
-            <a:r>
-              <a:rPr sz="1800" b="1">
-                <a:solidFill>
-                  <a:srgbClr val="1F5C99"/>
-                </a:solidFill>
-                <a:latin typeface="Arial"/>
-              </a:rPr>
-              <a:t>• </a:t>
-            </a:r>
-            <a:r>
-              <a:rPr sz="1800" b="0">
-                <a:solidFill>
-                  <a:srgbClr val="222222"/>
-                </a:solidFill>
-                <a:latin typeface="Arial"/>
-              </a:rPr>
-              <a:t>Com a preparação dos dados, o grafo e as ferramentas feitos para as perguntas do domínio.</a:t>
+              <a:t>supõem chamada de ferramenta confiável.</a:t>
             </a:r>
           </a:p>
         </p:txBody>
@@ -8410,14 +8068,622 @@
       <p:grpSpPr/>
       <p:sp>
         <p:nvSpPr>
-          <p:cNvPr id="2" name="Rectangle 1"/>
+          <p:cNvPr id="2" name="Title 1"/>
+          <p:cNvSpPr>
+            <a:spLocks noGrp="1"/>
+          </p:cNvSpPr>
+          <p:nvPr>
+            <p:ph type="title"/>
+          </p:nvPr>
+        </p:nvSpPr>
+        <p:spPr>
+          <a:xfrm>
+            <a:off x="640080" y="365760"/>
+            <a:ext cx="10881360" cy="1005840"/>
+          </a:xfrm>
+        </p:spPr>
+        <p:txBody>
+          <a:bodyPr wrap="square" anchor="t"/>
+          <a:lstStyle/>
+          <a:p>
+            <a:pPr algn="l"/>
+            <a:r>
+              <a:rPr sz="3000" b="1">
+                <a:solidFill>
+                  <a:srgbClr val="222222"/>
+                </a:solidFill>
+                <a:latin typeface="Arial"/>
+              </a:rPr>
+              <a:t>Próximos passos: mais evidência, efeitos separados e outros domínios</a:t>
+            </a:r>
+          </a:p>
+        </p:txBody>
+      </p:sp>
+      <p:sp>
+        <p:nvSpPr>
+          <p:cNvPr id="3" name="Rectangle 2"/>
           <p:cNvSpPr/>
           <p:nvPr/>
         </p:nvSpPr>
         <p:spPr>
           <a:xfrm>
-            <a:off x="0" y="0"/>
-            <a:ext cx="12191695" cy="6858000"/>
+            <a:off x="0" y="365760"/>
+            <a:ext cx="256032" cy="822960"/>
+          </a:xfrm>
+          <a:prstGeom prst="rect">
+            <a:avLst/>
+          </a:prstGeom>
+          <a:solidFill>
+            <a:srgbClr val="1F5C99"/>
+          </a:solidFill>
+          <a:ln>
+            <a:noFill/>
+          </a:ln>
+        </p:spPr>
+        <p:style>
+          <a:lnRef idx="1">
+            <a:schemeClr val="accent1"/>
+          </a:lnRef>
+          <a:fillRef idx="3">
+            <a:schemeClr val="accent1"/>
+          </a:fillRef>
+          <a:effectRef idx="2">
+            <a:schemeClr val="accent1"/>
+          </a:effectRef>
+          <a:fontRef idx="minor">
+            <a:schemeClr val="lt1"/>
+          </a:fontRef>
+        </p:style>
+        <p:txBody>
+          <a:bodyPr rtlCol="0" anchor="ctr"/>
+          <a:lstStyle/>
+          <a:p>
+            <a:pPr algn="ctr"/>
+          </a:p>
+        </p:txBody>
+      </p:sp>
+      <p:sp>
+        <p:nvSpPr>
+          <p:cNvPr id="4" name="TextBox 3"/>
+          <p:cNvSpPr txBox="1"/>
+          <p:nvPr/>
+        </p:nvSpPr>
+        <p:spPr>
+          <a:xfrm>
+            <a:off x="10881360" y="6400800"/>
+            <a:ext cx="1097280" cy="320040"/>
+          </a:xfrm>
+          <a:prstGeom prst="rect">
+            <a:avLst/>
+          </a:prstGeom>
+          <a:noFill/>
+        </p:spPr>
+        <p:txBody>
+          <a:bodyPr wrap="square" anchor="t" lIns="45720" rIns="45720">
+            <a:spAutoFit/>
+          </a:bodyPr>
+          <a:lstStyle/>
+          <a:p>
+            <a:pPr algn="r">
+              <a:spcAft>
+                <a:spcPts val="600"/>
+              </a:spcAft>
+            </a:pPr>
+            <a:r>
+              <a:rPr sz="1200" b="0">
+                <a:solidFill>
+                  <a:srgbClr val="666666"/>
+                </a:solidFill>
+                <a:latin typeface="Arial"/>
+              </a:rPr>
+              <a:t>15 / 15</a:t>
+            </a:r>
+          </a:p>
+        </p:txBody>
+      </p:sp>
+      <p:sp>
+        <p:nvSpPr>
+          <p:cNvPr id="5" name="Rectangle 4"/>
+          <p:cNvSpPr/>
+          <p:nvPr/>
+        </p:nvSpPr>
+        <p:spPr>
+          <a:xfrm>
+            <a:off x="640080" y="1508760"/>
+            <a:ext cx="3474720" cy="3520440"/>
+          </a:xfrm>
+          <a:prstGeom prst="rect">
+            <a:avLst/>
+          </a:prstGeom>
+          <a:solidFill>
+            <a:srgbClr val="F2F2F2"/>
+          </a:solidFill>
+          <a:ln>
+            <a:noFill/>
+          </a:ln>
+          <a:effectLst/>
+        </p:spPr>
+        <p:style>
+          <a:lnRef idx="1">
+            <a:schemeClr val="accent1"/>
+          </a:lnRef>
+          <a:fillRef idx="3">
+            <a:schemeClr val="accent1"/>
+          </a:fillRef>
+          <a:effectRef idx="2">
+            <a:schemeClr val="accent1"/>
+          </a:effectRef>
+          <a:fontRef idx="minor">
+            <a:schemeClr val="lt1"/>
+          </a:fontRef>
+        </p:style>
+        <p:txBody>
+          <a:bodyPr rtlCol="0" anchor="ctr"/>
+          <a:lstStyle/>
+          <a:p>
+            <a:pPr algn="ctr"/>
+          </a:p>
+        </p:txBody>
+      </p:sp>
+      <p:sp>
+        <p:nvSpPr>
+          <p:cNvPr id="6" name="TextBox 5"/>
+          <p:cNvSpPr txBox="1"/>
+          <p:nvPr/>
+        </p:nvSpPr>
+        <p:spPr>
+          <a:xfrm>
+            <a:off x="777240" y="1572768"/>
+            <a:ext cx="3200400" cy="457200"/>
+          </a:xfrm>
+          <a:prstGeom prst="rect">
+            <a:avLst/>
+          </a:prstGeom>
+          <a:noFill/>
+        </p:spPr>
+        <p:txBody>
+          <a:bodyPr wrap="square" anchor="t" lIns="45720" rIns="45720">
+            <a:spAutoFit/>
+          </a:bodyPr>
+          <a:lstStyle/>
+          <a:p>
+            <a:pPr algn="l">
+              <a:spcAft>
+                <a:spcPts val="600"/>
+              </a:spcAft>
+            </a:pPr>
+            <a:r>
+              <a:rPr sz="2000" b="1">
+                <a:solidFill>
+                  <a:srgbClr val="1F5C99"/>
+                </a:solidFill>
+                <a:latin typeface="Arial"/>
+              </a:rPr>
+              <a:t>Mais evidência</a:t>
+            </a:r>
+          </a:p>
+        </p:txBody>
+      </p:sp>
+      <p:sp>
+        <p:nvSpPr>
+          <p:cNvPr id="7" name="TextBox 6"/>
+          <p:cNvSpPr txBox="1"/>
+          <p:nvPr/>
+        </p:nvSpPr>
+        <p:spPr>
+          <a:xfrm>
+            <a:off x="777240" y="2103120"/>
+            <a:ext cx="3200400" cy="2880360"/>
+          </a:xfrm>
+          <a:prstGeom prst="rect">
+            <a:avLst/>
+          </a:prstGeom>
+          <a:noFill/>
+        </p:spPr>
+        <p:txBody>
+          <a:bodyPr wrap="square">
+            <a:spAutoFit/>
+          </a:bodyPr>
+          <a:lstStyle/>
+          <a:p>
+            <a:pPr>
+              <a:spcAft>
+                <a:spcPts val="1000"/>
+              </a:spcAft>
+            </a:pPr>
+            <a:r>
+              <a:rPr sz="1600" b="1">
+                <a:solidFill>
+                  <a:srgbClr val="1F5C99"/>
+                </a:solidFill>
+                <a:latin typeface="Arial"/>
+              </a:rPr>
+              <a:t>• </a:t>
+            </a:r>
+            <a:r>
+              <a:rPr sz="1600" b="0">
+                <a:solidFill>
+                  <a:srgbClr val="222222"/>
+                </a:solidFill>
+                <a:latin typeface="Arial"/>
+              </a:rPr>
+              <a:t>Repetir as execuções: medir a variação entre rodadas e testar as diferenças entre abordagens.</a:t>
+            </a:r>
+          </a:p>
+          <a:p>
+            <a:pPr>
+              <a:spcAft>
+                <a:spcPts val="1000"/>
+              </a:spcAft>
+            </a:pPr>
+            <a:r>
+              <a:rPr sz="1600" b="1">
+                <a:solidFill>
+                  <a:srgbClr val="1F5C99"/>
+                </a:solidFill>
+                <a:latin typeface="Arial"/>
+              </a:rPr>
+              <a:t>• </a:t>
+            </a:r>
+            <a:r>
+              <a:rPr sz="1600" b="0">
+                <a:solidFill>
+                  <a:srgbClr val="222222"/>
+                </a:solidFill>
+                <a:latin typeface="Arial"/>
+              </a:rPr>
+              <a:t>Estender as perguntas a várias partidas.</a:t>
+            </a:r>
+          </a:p>
+        </p:txBody>
+      </p:sp>
+      <p:sp>
+        <p:nvSpPr>
+          <p:cNvPr id="8" name="Rectangle 7"/>
+          <p:cNvSpPr/>
+          <p:nvPr/>
+        </p:nvSpPr>
+        <p:spPr>
+          <a:xfrm>
+            <a:off x="4343400" y="1508760"/>
+            <a:ext cx="3474720" cy="3520440"/>
+          </a:xfrm>
+          <a:prstGeom prst="rect">
+            <a:avLst/>
+          </a:prstGeom>
+          <a:solidFill>
+            <a:srgbClr val="F2F2F2"/>
+          </a:solidFill>
+          <a:ln>
+            <a:noFill/>
+          </a:ln>
+          <a:effectLst/>
+        </p:spPr>
+        <p:style>
+          <a:lnRef idx="1">
+            <a:schemeClr val="accent1"/>
+          </a:lnRef>
+          <a:fillRef idx="3">
+            <a:schemeClr val="accent1"/>
+          </a:fillRef>
+          <a:effectRef idx="2">
+            <a:schemeClr val="accent1"/>
+          </a:effectRef>
+          <a:fontRef idx="minor">
+            <a:schemeClr val="lt1"/>
+          </a:fontRef>
+        </p:style>
+        <p:txBody>
+          <a:bodyPr rtlCol="0" anchor="ctr"/>
+          <a:lstStyle/>
+          <a:p>
+            <a:pPr algn="ctr"/>
+          </a:p>
+        </p:txBody>
+      </p:sp>
+      <p:sp>
+        <p:nvSpPr>
+          <p:cNvPr id="9" name="TextBox 8"/>
+          <p:cNvSpPr txBox="1"/>
+          <p:nvPr/>
+        </p:nvSpPr>
+        <p:spPr>
+          <a:xfrm>
+            <a:off x="4480560" y="1572768"/>
+            <a:ext cx="3200400" cy="457200"/>
+          </a:xfrm>
+          <a:prstGeom prst="rect">
+            <a:avLst/>
+          </a:prstGeom>
+          <a:noFill/>
+        </p:spPr>
+        <p:txBody>
+          <a:bodyPr wrap="square" anchor="t" lIns="45720" rIns="45720">
+            <a:spAutoFit/>
+          </a:bodyPr>
+          <a:lstStyle/>
+          <a:p>
+            <a:pPr algn="l">
+              <a:spcAft>
+                <a:spcPts val="600"/>
+              </a:spcAft>
+            </a:pPr>
+            <a:r>
+              <a:rPr sz="2000" b="1">
+                <a:solidFill>
+                  <a:srgbClr val="1F5C99"/>
+                </a:solidFill>
+                <a:latin typeface="Arial"/>
+              </a:rPr>
+              <a:t>Separar os efeitos</a:t>
+            </a:r>
+          </a:p>
+        </p:txBody>
+      </p:sp>
+      <p:sp>
+        <p:nvSpPr>
+          <p:cNvPr id="10" name="TextBox 9"/>
+          <p:cNvSpPr txBox="1"/>
+          <p:nvPr/>
+        </p:nvSpPr>
+        <p:spPr>
+          <a:xfrm>
+            <a:off x="4480560" y="2103120"/>
+            <a:ext cx="3200400" cy="2880360"/>
+          </a:xfrm>
+          <a:prstGeom prst="rect">
+            <a:avLst/>
+          </a:prstGeom>
+          <a:noFill/>
+        </p:spPr>
+        <p:txBody>
+          <a:bodyPr wrap="square">
+            <a:spAutoFit/>
+          </a:bodyPr>
+          <a:lstStyle/>
+          <a:p>
+            <a:pPr>
+              <a:spcAft>
+                <a:spcPts val="1000"/>
+              </a:spcAft>
+            </a:pPr>
+            <a:r>
+              <a:rPr sz="1600" b="1">
+                <a:solidFill>
+                  <a:srgbClr val="1F5C99"/>
+                </a:solidFill>
+                <a:latin typeface="Arial"/>
+              </a:rPr>
+              <a:t>• </a:t>
+            </a:r>
+            <a:r>
+              <a:rPr sz="1600" b="0">
+                <a:solidFill>
+                  <a:srgbClr val="222222"/>
+                </a:solidFill>
+                <a:latin typeface="Arial"/>
+              </a:rPr>
+              <a:t>Modelos maiores sem raciocínio estendido: tamanho ou raciocínio?</a:t>
+            </a:r>
+          </a:p>
+          <a:p>
+            <a:pPr>
+              <a:spcAft>
+                <a:spcPts val="1000"/>
+              </a:spcAft>
+            </a:pPr>
+            <a:r>
+              <a:rPr sz="1600" b="1">
+                <a:solidFill>
+                  <a:srgbClr val="1F5C99"/>
+                </a:solidFill>
+                <a:latin typeface="Arial"/>
+              </a:rPr>
+              <a:t>• </a:t>
+            </a:r>
+            <a:r>
+              <a:rPr sz="1600" b="0">
+                <a:solidFill>
+                  <a:srgbClr val="222222"/>
+                </a:solidFill>
+                <a:latin typeface="Arial"/>
+              </a:rPr>
+              <a:t>As mesmas ferramentas sobre um banco relacional (SQL), sem o grafo: ferramentas ou grafo?</a:t>
+            </a:r>
+          </a:p>
+          <a:p>
+            <a:pPr>
+              <a:spcAft>
+                <a:spcPts val="1000"/>
+              </a:spcAft>
+            </a:pPr>
+            <a:r>
+              <a:rPr sz="1600" b="1">
+                <a:solidFill>
+                  <a:srgbClr val="1F5C99"/>
+                </a:solidFill>
+                <a:latin typeface="Arial"/>
+              </a:rPr>
+              <a:t>• </a:t>
+            </a:r>
+            <a:r>
+              <a:rPr sz="1600" b="0">
+                <a:solidFill>
+                  <a:srgbClr val="222222"/>
+                </a:solidFill>
+                <a:latin typeface="Arial"/>
+              </a:rPr>
+              <a:t>Busca vetorial com os eventos vizinhos em cada trecho.</a:t>
+            </a:r>
+          </a:p>
+        </p:txBody>
+      </p:sp>
+      <p:sp>
+        <p:nvSpPr>
+          <p:cNvPr id="11" name="Rectangle 10"/>
+          <p:cNvSpPr/>
+          <p:nvPr/>
+        </p:nvSpPr>
+        <p:spPr>
+          <a:xfrm>
+            <a:off x="8046720" y="1508760"/>
+            <a:ext cx="3474720" cy="3520440"/>
+          </a:xfrm>
+          <a:prstGeom prst="rect">
+            <a:avLst/>
+          </a:prstGeom>
+          <a:solidFill>
+            <a:srgbClr val="E6EEF6"/>
+          </a:solidFill>
+          <a:ln>
+            <a:noFill/>
+          </a:ln>
+          <a:effectLst/>
+        </p:spPr>
+        <p:style>
+          <a:lnRef idx="1">
+            <a:schemeClr val="accent1"/>
+          </a:lnRef>
+          <a:fillRef idx="3">
+            <a:schemeClr val="accent1"/>
+          </a:fillRef>
+          <a:effectRef idx="2">
+            <a:schemeClr val="accent1"/>
+          </a:effectRef>
+          <a:fontRef idx="minor">
+            <a:schemeClr val="lt1"/>
+          </a:fontRef>
+        </p:style>
+        <p:txBody>
+          <a:bodyPr rtlCol="0" anchor="ctr"/>
+          <a:lstStyle/>
+          <a:p>
+            <a:pPr algn="ctr"/>
+          </a:p>
+        </p:txBody>
+      </p:sp>
+      <p:sp>
+        <p:nvSpPr>
+          <p:cNvPr id="12" name="TextBox 11"/>
+          <p:cNvSpPr txBox="1"/>
+          <p:nvPr/>
+        </p:nvSpPr>
+        <p:spPr>
+          <a:xfrm>
+            <a:off x="8183880" y="1572768"/>
+            <a:ext cx="3200400" cy="457200"/>
+          </a:xfrm>
+          <a:prstGeom prst="rect">
+            <a:avLst/>
+          </a:prstGeom>
+          <a:noFill/>
+        </p:spPr>
+        <p:txBody>
+          <a:bodyPr wrap="square" anchor="t" lIns="45720" rIns="45720">
+            <a:spAutoFit/>
+          </a:bodyPr>
+          <a:lstStyle/>
+          <a:p>
+            <a:pPr algn="l">
+              <a:spcAft>
+                <a:spcPts val="600"/>
+              </a:spcAft>
+            </a:pPr>
+            <a:r>
+              <a:rPr sz="2000" b="1">
+                <a:solidFill>
+                  <a:srgbClr val="1F5C99"/>
+                </a:solidFill>
+                <a:latin typeface="Arial"/>
+              </a:rPr>
+              <a:t>Outros domínios</a:t>
+            </a:r>
+          </a:p>
+        </p:txBody>
+      </p:sp>
+      <p:sp>
+        <p:nvSpPr>
+          <p:cNvPr id="13" name="TextBox 12"/>
+          <p:cNvSpPr txBox="1"/>
+          <p:nvPr/>
+        </p:nvSpPr>
+        <p:spPr>
+          <a:xfrm>
+            <a:off x="8183880" y="2103120"/>
+            <a:ext cx="3200400" cy="2880360"/>
+          </a:xfrm>
+          <a:prstGeom prst="rect">
+            <a:avLst/>
+          </a:prstGeom>
+          <a:noFill/>
+        </p:spPr>
+        <p:txBody>
+          <a:bodyPr wrap="square">
+            <a:spAutoFit/>
+          </a:bodyPr>
+          <a:lstStyle/>
+          <a:p>
+            <a:pPr>
+              <a:spcAft>
+                <a:spcPts val="1000"/>
+              </a:spcAft>
+            </a:pPr>
+            <a:r>
+              <a:rPr sz="1600" b="1">
+                <a:solidFill>
+                  <a:srgbClr val="1F5C99"/>
+                </a:solidFill>
+                <a:latin typeface="Arial"/>
+              </a:rPr>
+              <a:t>• </a:t>
+            </a:r>
+            <a:r>
+              <a:rPr sz="1600" b="0">
+                <a:solidFill>
+                  <a:srgbClr val="222222"/>
+                </a:solidFill>
+                <a:latin typeface="Arial"/>
+              </a:rPr>
+              <a:t>Outros registros de eventos, como os de processos industriais.</a:t>
+            </a:r>
+          </a:p>
+          <a:p>
+            <a:pPr>
+              <a:spcAft>
+                <a:spcPts val="1000"/>
+              </a:spcAft>
+            </a:pPr>
+            <a:r>
+              <a:rPr sz="1600" b="1">
+                <a:solidFill>
+                  <a:srgbClr val="1F5C99"/>
+                </a:solidFill>
+                <a:latin typeface="Arial"/>
+              </a:rPr>
+              <a:t>• </a:t>
+            </a:r>
+            <a:r>
+              <a:rPr sz="1600" b="0">
+                <a:solidFill>
+                  <a:srgbClr val="222222"/>
+                </a:solidFill>
+                <a:latin typeface="Arial"/>
+              </a:rPr>
+              <a:t>Com a preparação dos dados, o grafo e as ferramentas feitos para as perguntas do domínio.</a:t>
+            </a:r>
+          </a:p>
+        </p:txBody>
+      </p:sp>
+      <p:sp>
+        <p:nvSpPr>
+          <p:cNvPr id="14" name="Rectangle 13"/>
+          <p:cNvSpPr/>
+          <p:nvPr/>
+        </p:nvSpPr>
+        <p:spPr>
+          <a:xfrm>
+            <a:off x="640080" y="5212080"/>
+            <a:ext cx="10881360" cy="1097280"/>
           </a:xfrm>
           <a:prstGeom prst="rect">
             <a:avLst/>
@@ -8454,14 +8720,14 @@
       </p:sp>
       <p:sp>
         <p:nvSpPr>
-          <p:cNvPr id="3" name="Rectangle 2"/>
+          <p:cNvPr id="15" name="Rectangle 14"/>
           <p:cNvSpPr/>
           <p:nvPr/>
         </p:nvSpPr>
         <p:spPr>
           <a:xfrm>
-            <a:off x="640080" y="2194560"/>
-            <a:ext cx="109728" cy="1463040"/>
+            <a:off x="640080" y="5212080"/>
+            <a:ext cx="109728" cy="1097280"/>
           </a:xfrm>
           <a:prstGeom prst="rect">
             <a:avLst/>
@@ -8498,14 +8764,14 @@
       </p:sp>
       <p:sp>
         <p:nvSpPr>
-          <p:cNvPr id="4" name="TextBox 3"/>
+          <p:cNvPr id="16" name="TextBox 15"/>
           <p:cNvSpPr txBox="1"/>
           <p:nvPr/>
         </p:nvSpPr>
         <p:spPr>
           <a:xfrm>
-            <a:off x="1005840" y="2103120"/>
-            <a:ext cx="10058400" cy="1645920"/>
+            <a:off x="914400" y="5257800"/>
+            <a:ext cx="2926080" cy="1005840"/>
           </a:xfrm>
           <a:prstGeom prst="rect">
             <a:avLst/>
@@ -8513,7 +8779,7 @@
           <a:noFill/>
         </p:spPr>
         <p:txBody>
-          <a:bodyPr wrap="square" anchor="t" lIns="45720" rIns="45720">
+          <a:bodyPr wrap="square" anchor="ctr" lIns="45720" rIns="45720">
             <a:spAutoFit/>
           </a:bodyPr>
           <a:lstStyle/>
@@ -8524,7 +8790,7 @@
               </a:spcAft>
             </a:pPr>
             <a:r>
-              <a:rPr sz="5400" b="1">
+              <a:rPr sz="3600" b="1">
                 <a:solidFill>
                   <a:srgbClr val="FFFFFF"/>
                 </a:solidFill>
@@ -8537,14 +8803,14 @@
       </p:sp>
       <p:sp>
         <p:nvSpPr>
-          <p:cNvPr id="5" name="TextBox 4"/>
+          <p:cNvPr id="17" name="TextBox 16"/>
           <p:cNvSpPr txBox="1"/>
           <p:nvPr/>
         </p:nvSpPr>
         <p:spPr>
           <a:xfrm>
-            <a:off x="1005840" y="4023360"/>
-            <a:ext cx="10058400" cy="1645920"/>
+            <a:off x="3931920" y="5303520"/>
+            <a:ext cx="7498079" cy="914400"/>
           </a:xfrm>
           <a:prstGeom prst="rect">
             <a:avLst/>
@@ -8552,18 +8818,18 @@
           <a:noFill/>
         </p:spPr>
         <p:txBody>
-          <a:bodyPr wrap="square" anchor="t" lIns="45720" rIns="45720">
+          <a:bodyPr wrap="square" anchor="ctr" lIns="45720" rIns="45720">
             <a:spAutoFit/>
           </a:bodyPr>
           <a:lstStyle/>
           <a:p>
             <a:pPr algn="l">
               <a:spcAft>
-                <a:spcPts val="600"/>
+                <a:spcPts val="200"/>
               </a:spcAft>
             </a:pPr>
             <a:r>
-              <a:rPr sz="1800" b="0">
+              <a:rPr sz="1500" b="0">
                 <a:solidFill>
                   <a:srgbClr val="BBBBBB"/>
                 </a:solidFill>
@@ -8575,11 +8841,11 @@
           <a:p>
             <a:pPr algn="l">
               <a:spcAft>
-                <a:spcPts val="600"/>
+                <a:spcPts val="200"/>
               </a:spcAft>
             </a:pPr>
             <a:r>
-              <a:rPr sz="2000" b="0">
+              <a:rPr sz="1800" b="0">
                 <a:solidFill>
                   <a:srgbClr val="FFFFFF"/>
                 </a:solidFill>
@@ -8868,8 +9134,8 @@
         </p:nvSpPr>
         <p:spPr>
           <a:xfrm>
-            <a:off x="640080" y="3931920"/>
-            <a:ext cx="5120640" cy="1810512"/>
+            <a:off x="640080" y="4023360"/>
+            <a:ext cx="5120640" cy="2103120"/>
           </a:xfrm>
           <a:prstGeom prst="rect">
             <a:avLst/>
@@ -8912,8 +9178,8 @@
         </p:nvSpPr>
         <p:spPr>
           <a:xfrm>
-            <a:off x="777240" y="3950208"/>
-            <a:ext cx="4846320" cy="1783080"/>
+            <a:off x="777240" y="4069080"/>
+            <a:ext cx="4846320" cy="2011680"/>
           </a:xfrm>
           <a:prstGeom prst="rect">
             <a:avLst/>
@@ -8928,7 +9194,7 @@
           <a:p>
             <a:pPr algn="l">
               <a:spcAft>
-                <a:spcPts val="300"/>
+                <a:spcPts val="500"/>
               </a:spcAft>
             </a:pPr>
             <a:r>
@@ -8944,11 +9210,11 @@
           <a:p>
             <a:pPr algn="l">
               <a:spcAft>
-                <a:spcPts val="300"/>
+                <a:spcPts val="500"/>
               </a:spcAft>
             </a:pPr>
             <a:r>
-              <a:rPr sz="1400" b="0">
+              <a:rPr sz="1500" b="0">
                 <a:solidFill>
                   <a:srgbClr val="222222"/>
                 </a:solidFill>
@@ -8960,11 +9226,11 @@
           <a:p>
             <a:pPr algn="l">
               <a:spcAft>
-                <a:spcPts val="300"/>
+                <a:spcPts val="500"/>
               </a:spcAft>
             </a:pPr>
             <a:r>
-              <a:rPr sz="1400" b="0">
+              <a:rPr sz="1500" b="0">
                 <a:solidFill>
                   <a:srgbClr val="222222"/>
                 </a:solidFill>
@@ -8976,11 +9242,11 @@
           <a:p>
             <a:pPr algn="l">
               <a:spcAft>
-                <a:spcPts val="300"/>
+                <a:spcPts val="500"/>
               </a:spcAft>
             </a:pPr>
             <a:r>
-              <a:rPr sz="1400" b="0">
+              <a:rPr sz="1500" b="0">
                 <a:solidFill>
                   <a:srgbClr val="222222"/>
                 </a:solidFill>
@@ -9323,89 +9589,6 @@
                 <a:latin typeface="Arial"/>
               </a:rPr>
               <a:t>Depois que Dembélé foi substituído no primeiro tempo, qual companheiro mais passou a bola para Mbappé?</a:t>
-            </a:r>
-          </a:p>
-        </p:txBody>
-      </p:sp>
-      <p:sp>
-        <p:nvSpPr>
-          <p:cNvPr id="16" name="Rectangle 15"/>
-          <p:cNvSpPr/>
-          <p:nvPr/>
-        </p:nvSpPr>
-        <p:spPr>
-          <a:xfrm>
-            <a:off x="640080" y="5806440"/>
-            <a:ext cx="10881360" cy="566928"/>
-          </a:xfrm>
-          <a:prstGeom prst="rect">
-            <a:avLst/>
-          </a:prstGeom>
-          <a:solidFill>
-            <a:srgbClr val="F2F2F2"/>
-          </a:solidFill>
-          <a:ln>
-            <a:noFill/>
-          </a:ln>
-          <a:effectLst/>
-        </p:spPr>
-        <p:style>
-          <a:lnRef idx="1">
-            <a:schemeClr val="accent1"/>
-          </a:lnRef>
-          <a:fillRef idx="3">
-            <a:schemeClr val="accent1"/>
-          </a:fillRef>
-          <a:effectRef idx="2">
-            <a:schemeClr val="accent1"/>
-          </a:effectRef>
-          <a:fontRef idx="minor">
-            <a:schemeClr val="lt1"/>
-          </a:fontRef>
-        </p:style>
-        <p:txBody>
-          <a:bodyPr rtlCol="0" anchor="ctr"/>
-          <a:lstStyle/>
-          <a:p>
-            <a:pPr algn="ctr"/>
-          </a:p>
-        </p:txBody>
-      </p:sp>
-      <p:sp>
-        <p:nvSpPr>
-          <p:cNvPr id="17" name="TextBox 16"/>
-          <p:cNvSpPr txBox="1"/>
-          <p:nvPr/>
-        </p:nvSpPr>
-        <p:spPr>
-          <a:xfrm>
-            <a:off x="777240" y="5824728"/>
-            <a:ext cx="10607040" cy="530352"/>
-          </a:xfrm>
-          <a:prstGeom prst="rect">
-            <a:avLst/>
-          </a:prstGeom>
-          <a:noFill/>
-        </p:spPr>
-        <p:txBody>
-          <a:bodyPr wrap="square" anchor="ctr" lIns="45720" rIns="45720">
-            <a:spAutoFit/>
-          </a:bodyPr>
-          <a:lstStyle/>
-          <a:p>
-            <a:pPr algn="l">
-              <a:spcAft>
-                <a:spcPts val="600"/>
-              </a:spcAft>
-            </a:pPr>
-            <a:r>
-              <a:rPr sz="1400" b="0">
-                <a:solidFill>
-                  <a:srgbClr val="222222"/>
-                </a:solidFill>
-                <a:latin typeface="Arial"/>
-              </a:rPr>
-              <a:t>Relacionados: no esporte, cada trabalho avalia uma única forma de recuperação (SoccerRAG, SPORTSQL, Tzikas et al.); fora dele, as formas são comparadas sem dados de futebol (Li et al., LOFT).</a:t>
             </a:r>
           </a:p>
         </p:txBody>
@@ -9456,7 +9639,7 @@
                 </a:solidFill>
                 <a:latin typeface="Arial"/>
               </a:rPr>
-              <a:t>Os dados: eventos da StatsBomb da final de 2022, em JSON</a:t>
+              <a:t>Trabalhos relacionados: cada um avalia uma forma de recuperação por vez</a:t>
             </a:r>
           </a:p>
         </p:txBody>
@@ -9543,415 +9726,880 @@
           </a:p>
         </p:txBody>
       </p:sp>
-      <p:sp>
-        <p:nvSpPr>
-          <p:cNvPr id="5" name="TextBox 4"/>
-          <p:cNvSpPr txBox="1"/>
+      <p:graphicFrame>
+        <p:nvGraphicFramePr>
+          <p:cNvPr id="5" name="Table 4"/>
+          <p:cNvGraphicFramePr>
+            <a:graphicFrameLocks noGrp="1"/>
+          </p:cNvGraphicFramePr>
           <p:nvPr/>
-        </p:nvSpPr>
-        <p:spPr>
-          <a:xfrm>
-            <a:off x="640080" y="6400800"/>
-            <a:ext cx="9144000" cy="320040"/>
-          </a:xfrm>
-          <a:prstGeom prst="rect">
-            <a:avLst/>
-          </a:prstGeom>
-          <a:noFill/>
-        </p:spPr>
-        <p:txBody>
-          <a:bodyPr wrap="square" anchor="t" lIns="45720" rIns="45720">
-            <a:spAutoFit/>
-          </a:bodyPr>
-          <a:lstStyle/>
-          <a:p>
-            <a:pPr algn="l">
-              <a:spcAft>
-                <a:spcPts val="600"/>
-              </a:spcAft>
-            </a:pPr>
-            <a:r>
-              <a:rPr sz="1200" b="0">
-                <a:solidFill>
-                  <a:srgbClr val="666666"/>
-                </a:solidFill>
-                <a:latin typeface="Arial"/>
-              </a:rPr>
-              <a:t>Exemplo resumido: o passe de Mac Allister e o gol de Di María (docs/02 e Figura 1 do artigo).</a:t>
-            </a:r>
-          </a:p>
-        </p:txBody>
-      </p:sp>
-      <p:sp>
-        <p:nvSpPr>
-          <p:cNvPr id="6" name="Rectangle 5"/>
-          <p:cNvSpPr/>
-          <p:nvPr/>
-        </p:nvSpPr>
-        <p:spPr>
-          <a:xfrm>
-            <a:off x="640080" y="1554480"/>
-            <a:ext cx="6492240" cy="3017520"/>
-          </a:xfrm>
-          <a:prstGeom prst="rect">
-            <a:avLst/>
-          </a:prstGeom>
-          <a:solidFill>
-            <a:srgbClr val="2B2B2B"/>
-          </a:solidFill>
-          <a:ln>
-            <a:noFill/>
-          </a:ln>
-          <a:effectLst/>
-        </p:spPr>
-        <p:style>
-          <a:lnRef idx="1">
-            <a:schemeClr val="accent1"/>
-          </a:lnRef>
-          <a:fillRef idx="3">
-            <a:schemeClr val="accent1"/>
-          </a:fillRef>
-          <a:effectRef idx="2">
-            <a:schemeClr val="accent1"/>
-          </a:effectRef>
-          <a:fontRef idx="minor">
-            <a:schemeClr val="lt1"/>
-          </a:fontRef>
-        </p:style>
-        <p:txBody>
-          <a:bodyPr rtlCol="0" anchor="ctr"/>
-          <a:lstStyle/>
-          <a:p>
-            <a:pPr algn="ctr"/>
-          </a:p>
-        </p:txBody>
-      </p:sp>
-      <p:sp>
-        <p:nvSpPr>
-          <p:cNvPr id="7" name="TextBox 6"/>
-          <p:cNvSpPr txBox="1"/>
-          <p:nvPr/>
-        </p:nvSpPr>
-        <p:spPr>
-          <a:xfrm>
-            <a:off x="822960" y="1691640"/>
-            <a:ext cx="6217920" cy="3200400"/>
-          </a:xfrm>
-          <a:prstGeom prst="rect">
-            <a:avLst/>
-          </a:prstGeom>
-          <a:noFill/>
-        </p:spPr>
-        <p:txBody>
-          <a:bodyPr wrap="square">
-            <a:spAutoFit/>
-          </a:bodyPr>
-          <a:lstStyle/>
-          <a:p>
-            <a:r>
-              <a:rPr sz="1400">
-                <a:solidFill>
-                  <a:srgbClr val="E8E8E8"/>
-                </a:solidFill>
-                <a:latin typeface="Courier New"/>
-              </a:rPr>
-              <a:t>{ "type": "Pass", "minute": 35, "second": 20,</a:t>
-            </a:r>
-          </a:p>
-          <a:p>
-            <a:r>
-              <a:rPr sz="1400">
-                <a:solidFill>
-                  <a:srgbClr val="E8E8E8"/>
-                </a:solidFill>
-                <a:latin typeface="Courier New"/>
-              </a:rPr>
-              <a:t>  "player": "Alexis Mac Allister",</a:t>
-            </a:r>
-          </a:p>
-          <a:p>
-            <a:r>
-              <a:rPr sz="1400">
-                <a:solidFill>
-                  <a:srgbClr val="E8E8E8"/>
-                </a:solidFill>
-                <a:latin typeface="Courier New"/>
-              </a:rPr>
-              <a:t>  "pass": { "recipient": "Ángel Fabián Di María",</a:t>
-            </a:r>
-          </a:p>
-          <a:p>
-            <a:r>
-              <a:rPr sz="1400">
-                <a:solidFill>
-                  <a:srgbClr val="E8E8E8"/>
-                </a:solidFill>
-                <a:latin typeface="Courier New"/>
-              </a:rPr>
-              <a:t>            "goal_assist": true } }</a:t>
-            </a:r>
-          </a:p>
-          <a:p>
-            <a:r>
-              <a:rPr sz="1400">
-                <a:solidFill>
-                  <a:srgbClr val="E8E8E8"/>
-                </a:solidFill>
-                <a:latin typeface="Courier New"/>
-              </a:rPr>
-              <a:t> </a:t>
-            </a:r>
-          </a:p>
-          <a:p>
-            <a:r>
-              <a:rPr sz="1400">
-                <a:solidFill>
-                  <a:srgbClr val="E8E8E8"/>
-                </a:solidFill>
-                <a:latin typeface="Courier New"/>
-              </a:rPr>
-              <a:t>{ "type": "Shot", "minute": 35, "second": 22,</a:t>
-            </a:r>
-          </a:p>
-          <a:p>
-            <a:r>
-              <a:rPr sz="1400">
-                <a:solidFill>
-                  <a:srgbClr val="E8E8E8"/>
-                </a:solidFill>
-                <a:latin typeface="Courier New"/>
-              </a:rPr>
-              <a:t>  "team": "Argentina",</a:t>
-            </a:r>
-          </a:p>
-          <a:p>
-            <a:r>
-              <a:rPr sz="1400">
-                <a:solidFill>
-                  <a:srgbClr val="E8E8E8"/>
-                </a:solidFill>
-                <a:latin typeface="Courier New"/>
-              </a:rPr>
-              <a:t>  "player": "Ángel Fabián Di María",</a:t>
-            </a:r>
-          </a:p>
-          <a:p>
-            <a:r>
-              <a:rPr sz="1400">
-                <a:solidFill>
-                  <a:srgbClr val="E8E8E8"/>
-                </a:solidFill>
-                <a:latin typeface="Courier New"/>
-              </a:rPr>
-              <a:t>  "shot": { "outcome": "Goal",</a:t>
-            </a:r>
-          </a:p>
-          <a:p>
-            <a:r>
-              <a:rPr sz="1400">
-                <a:solidFill>
-                  <a:srgbClr val="E8E8E8"/>
-                </a:solidFill>
-                <a:latin typeface="Courier New"/>
-              </a:rPr>
-              <a:t>            "body_part": "Left Foot" } }</a:t>
-            </a:r>
-          </a:p>
-        </p:txBody>
-      </p:sp>
-      <p:sp>
-        <p:nvSpPr>
-          <p:cNvPr id="8" name="TextBox 7"/>
-          <p:cNvSpPr txBox="1"/>
-          <p:nvPr/>
-        </p:nvSpPr>
-        <p:spPr>
-          <a:xfrm>
-            <a:off x="7406640" y="1554480"/>
-            <a:ext cx="4206240" cy="4572000"/>
-          </a:xfrm>
-          <a:prstGeom prst="rect">
-            <a:avLst/>
-          </a:prstGeom>
-          <a:noFill/>
-        </p:spPr>
-        <p:txBody>
-          <a:bodyPr wrap="square">
-            <a:spAutoFit/>
-          </a:bodyPr>
-          <a:lstStyle/>
-          <a:p>
-            <a:pPr>
-              <a:spcAft>
-                <a:spcPts val="1000"/>
-              </a:spcAft>
-            </a:pPr>
-            <a:r>
-              <a:rPr sz="1600" b="1">
-                <a:solidFill>
-                  <a:srgbClr val="1F5C99"/>
-                </a:solidFill>
-                <a:latin typeface="Arial"/>
-              </a:rPr>
-              <a:t>• </a:t>
-            </a:r>
-            <a:r>
-              <a:rPr sz="1600" b="1">
-                <a:solidFill>
-                  <a:srgbClr val="222222"/>
-                </a:solidFill>
-                <a:latin typeface="Arial"/>
-              </a:rPr>
-              <a:t>Fonte: </a:t>
-            </a:r>
-            <a:r>
-              <a:rPr sz="1600" b="0">
-                <a:solidFill>
-                  <a:srgbClr val="222222"/>
-                </a:solidFill>
-                <a:latin typeface="Arial"/>
-              </a:rPr>
-              <a:t>StatsBomb Open Data, lista de eventos e escalações da partida.</a:t>
-            </a:r>
-          </a:p>
-          <a:p>
-            <a:pPr>
-              <a:spcAft>
-                <a:spcPts val="1000"/>
-              </a:spcAft>
-            </a:pPr>
-            <a:r>
-              <a:rPr sz="1600" b="1">
-                <a:solidFill>
-                  <a:srgbClr val="1F5C99"/>
-                </a:solidFill>
-                <a:latin typeface="Arial"/>
-              </a:rPr>
-              <a:t>• </a:t>
-            </a:r>
-            <a:r>
-              <a:rPr sz="1600" b="1">
-                <a:solidFill>
-                  <a:srgbClr val="222222"/>
-                </a:solidFill>
-                <a:latin typeface="Arial"/>
-              </a:rPr>
-              <a:t>4.407 eventos, </a:t>
-            </a:r>
-            <a:r>
-              <a:rPr sz="1600" b="0">
-                <a:solidFill>
-                  <a:srgbClr val="222222"/>
-                </a:solidFill>
-                <a:latin typeface="Arial"/>
-              </a:rPr>
-              <a:t>cada um com tipo, tempo, time, jogador e posição.</a:t>
-            </a:r>
-          </a:p>
-          <a:p>
-            <a:pPr>
-              <a:spcAft>
-                <a:spcPts val="1000"/>
-              </a:spcAft>
-            </a:pPr>
-            <a:r>
-              <a:rPr sz="1600" b="1">
-                <a:solidFill>
-                  <a:srgbClr val="1F5C99"/>
-                </a:solidFill>
-                <a:latin typeface="Arial"/>
-              </a:rPr>
-              <a:t>• </a:t>
-            </a:r>
-            <a:r>
-              <a:rPr sz="1600" b="1">
-                <a:solidFill>
-                  <a:srgbClr val="222222"/>
-                </a:solidFill>
-                <a:latin typeface="Arial"/>
-              </a:rPr>
-              <a:t>Campos próprios por tipo: </a:t>
-            </a:r>
-            <a:r>
-              <a:rPr sz="1600" b="0">
-                <a:solidFill>
-                  <a:srgbClr val="222222"/>
-                </a:solidFill>
-                <a:latin typeface="Arial"/>
-              </a:rPr>
-              <a:t>o passe traz o recebedor; a finalização, o resultado.</a:t>
-            </a:r>
-          </a:p>
-          <a:p>
-            <a:pPr>
-              <a:spcAft>
-                <a:spcPts val="1000"/>
-              </a:spcAft>
-            </a:pPr>
-            <a:r>
-              <a:rPr sz="1600" b="1">
-                <a:solidFill>
-                  <a:srgbClr val="1F5C99"/>
-                </a:solidFill>
-                <a:latin typeface="Arial"/>
-              </a:rPr>
-              <a:t>• </a:t>
-            </a:r>
-            <a:r>
-              <a:rPr sz="1600" b="1">
-                <a:solidFill>
-                  <a:srgbClr val="222222"/>
-                </a:solidFill>
-                <a:latin typeface="Arial"/>
-              </a:rPr>
-              <a:t>Mesma informação em lugares diferentes: </a:t>
-            </a:r>
-            <a:r>
-              <a:rPr sz="1600" b="0">
-                <a:solidFill>
-                  <a:srgbClr val="222222"/>
-                </a:solidFill>
-                <a:latin typeface="Arial"/>
-              </a:rPr>
-              <a:t>o cartão amarelo vem na falta ou em outro evento.</a:t>
-            </a:r>
-          </a:p>
-          <a:p>
-            <a:pPr>
-              <a:spcAft>
-                <a:spcPts val="1000"/>
-              </a:spcAft>
-            </a:pPr>
-            <a:r>
-              <a:rPr sz="1600" b="1">
-                <a:solidFill>
-                  <a:srgbClr val="1F5C99"/>
-                </a:solidFill>
-                <a:latin typeface="Arial"/>
-              </a:rPr>
-              <a:t>• </a:t>
-            </a:r>
-            <a:r>
-              <a:rPr sz="1600" b="1">
-                <a:solidFill>
-                  <a:srgbClr val="222222"/>
-                </a:solidFill>
-                <a:latin typeface="Arial"/>
-              </a:rPr>
-              <a:t>Nome de registro e minuto decorrido: </a:t>
-            </a:r>
-            <a:r>
-              <a:rPr sz="1600" b="0">
-                <a:solidFill>
-                  <a:srgbClr val="222222"/>
-                </a:solidFill>
-                <a:latin typeface="Arial"/>
-              </a:rPr>
-              <a:t>o gol aos 35 aparece como 36 na transmissão.</a:t>
-            </a:r>
-          </a:p>
-        </p:txBody>
-      </p:sp>
+        </p:nvGraphicFramePr>
+        <p:xfrm>
+          <a:off x="640080" y="1463040"/>
+          <a:ext cx="10881360" cy="4754880"/>
+        </p:xfrm>
+        <a:graphic>
+          <a:graphicData uri="http://schemas.openxmlformats.org/drawingml/2006/table">
+            <a:tbl>
+              <a:tblPr firstRow="0" bandRow="0">
+                <a:tableStyleId>{5C22544A-7EE6-4342-B048-85BDC9FD1C3A}</a:tableStyleId>
+              </a:tblPr>
+              <a:tblGrid>
+                <a:gridCol w="2103120"/>
+                <a:gridCol w="3017520"/>
+                <a:gridCol w="2926080"/>
+                <a:gridCol w="2834640"/>
+              </a:tblGrid>
+              <a:tr h="528320">
+                <a:tc>
+                  <a:txBody>
+                    <a:bodyPr wrap="square"/>
+                    <a:lstStyle/>
+                    <a:p>
+                      <a:pPr algn="l"/>
+                      <a:r>
+                        <a:rPr sz="1400" b="1">
+                          <a:solidFill>
+                            <a:srgbClr val="FFFFFF"/>
+                          </a:solidFill>
+                          <a:latin typeface="Arial"/>
+                        </a:rPr>
+                        <a:t>Trabalho</a:t>
+                      </a:r>
+                    </a:p>
+                  </a:txBody>
+                  <a:tcPr anchor="ctr">
+                    <a:solidFill>
+                      <a:srgbClr val="222222"/>
+                    </a:solidFill>
+                  </a:tcPr>
+                </a:tc>
+                <a:tc>
+                  <a:txBody>
+                    <a:bodyPr wrap="square"/>
+                    <a:lstStyle/>
+                    <a:p>
+                      <a:pPr algn="l"/>
+                      <a:r>
+                        <a:rPr sz="1400" b="1">
+                          <a:solidFill>
+                            <a:srgbClr val="FFFFFF"/>
+                          </a:solidFill>
+                          <a:latin typeface="Arial"/>
+                        </a:rPr>
+                        <a:t>Dados</a:t>
+                      </a:r>
+                    </a:p>
+                  </a:txBody>
+                  <a:tcPr anchor="ctr">
+                    <a:solidFill>
+                      <a:srgbClr val="222222"/>
+                    </a:solidFill>
+                  </a:tcPr>
+                </a:tc>
+                <a:tc>
+                  <a:txBody>
+                    <a:bodyPr wrap="square"/>
+                    <a:lstStyle/>
+                    <a:p>
+                      <a:pPr algn="l"/>
+                      <a:r>
+                        <a:rPr sz="1400" b="1">
+                          <a:solidFill>
+                            <a:srgbClr val="FFFFFF"/>
+                          </a:solidFill>
+                          <a:latin typeface="Arial"/>
+                        </a:rPr>
+                        <a:t>Formas de recuperação</a:t>
+                      </a:r>
+                    </a:p>
+                  </a:txBody>
+                  <a:tcPr anchor="ctr">
+                    <a:solidFill>
+                      <a:srgbClr val="222222"/>
+                    </a:solidFill>
+                  </a:tcPr>
+                </a:tc>
+                <a:tc>
+                  <a:txBody>
+                    <a:bodyPr wrap="square"/>
+                    <a:lstStyle/>
+                    <a:p>
+                      <a:pPr algn="l"/>
+                      <a:r>
+                        <a:rPr sz="1400" b="1">
+                          <a:solidFill>
+                            <a:srgbClr val="FFFFFF"/>
+                          </a:solidFill>
+                          <a:latin typeface="Arial"/>
+                        </a:rPr>
+                        <a:t>Conferência</a:t>
+                      </a:r>
+                    </a:p>
+                  </a:txBody>
+                  <a:tcPr anchor="ctr">
+                    <a:solidFill>
+                      <a:srgbClr val="222222"/>
+                    </a:solidFill>
+                  </a:tcPr>
+                </a:tc>
+              </a:tr>
+              <a:tr h="528320">
+                <a:tc>
+                  <a:txBody>
+                    <a:bodyPr wrap="square"/>
+                    <a:lstStyle/>
+                    <a:p>
+                      <a:pPr algn="l"/>
+                      <a:r>
+                        <a:rPr sz="1400" b="1">
+                          <a:solidFill>
+                            <a:srgbClr val="222222"/>
+                          </a:solidFill>
+                          <a:latin typeface="Arial"/>
+                        </a:rPr>
+                        <a:t>SportQA</a:t>
+                      </a:r>
+                    </a:p>
+                  </a:txBody>
+                  <a:tcPr anchor="ctr">
+                    <a:solidFill>
+                      <a:srgbClr val="FFFFFF"/>
+                    </a:solidFill>
+                  </a:tcPr>
+                </a:tc>
+                <a:tc>
+                  <a:txBody>
+                    <a:bodyPr wrap="square"/>
+                    <a:lstStyle/>
+                    <a:p>
+                      <a:pPr algn="l"/>
+                      <a:r>
+                        <a:rPr sz="1400" b="0">
+                          <a:solidFill>
+                            <a:srgbClr val="222222"/>
+                          </a:solidFill>
+                          <a:latin typeface="Arial"/>
+                        </a:rPr>
+                        <a:t>nenhum (memória do modelo)</a:t>
+                      </a:r>
+                    </a:p>
+                  </a:txBody>
+                  <a:tcPr anchor="ctr">
+                    <a:solidFill>
+                      <a:srgbClr val="FFFFFF"/>
+                    </a:solidFill>
+                  </a:tcPr>
+                </a:tc>
+                <a:tc>
+                  <a:txBody>
+                    <a:bodyPr wrap="square"/>
+                    <a:lstStyle/>
+                    <a:p>
+                      <a:pPr algn="l"/>
+                      <a:r>
+                        <a:rPr sz="1400" b="0">
+                          <a:solidFill>
+                            <a:srgbClr val="222222"/>
+                          </a:solidFill>
+                          <a:latin typeface="Arial"/>
+                        </a:rPr>
+                        <a:t>nenhuma</a:t>
+                      </a:r>
+                    </a:p>
+                  </a:txBody>
+                  <a:tcPr anchor="ctr">
+                    <a:solidFill>
+                      <a:srgbClr val="FFFFFF"/>
+                    </a:solidFill>
+                  </a:tcPr>
+                </a:tc>
+                <a:tc>
+                  <a:txBody>
+                    <a:bodyPr wrap="square"/>
+                    <a:lstStyle/>
+                    <a:p>
+                      <a:pPr algn="l"/>
+                      <a:r>
+                        <a:rPr sz="1400" b="0">
+                          <a:solidFill>
+                            <a:srgbClr val="222222"/>
+                          </a:solidFill>
+                          <a:latin typeface="Arial"/>
+                        </a:rPr>
+                        <a:t>múltipla escolha</a:t>
+                      </a:r>
+                    </a:p>
+                  </a:txBody>
+                  <a:tcPr anchor="ctr">
+                    <a:solidFill>
+                      <a:srgbClr val="FFFFFF"/>
+                    </a:solidFill>
+                  </a:tcPr>
+                </a:tc>
+              </a:tr>
+              <a:tr h="528320">
+                <a:tc>
+                  <a:txBody>
+                    <a:bodyPr wrap="square"/>
+                    <a:lstStyle/>
+                    <a:p>
+                      <a:pPr algn="l"/>
+                      <a:r>
+                        <a:rPr sz="1400" b="1">
+                          <a:solidFill>
+                            <a:srgbClr val="222222"/>
+                          </a:solidFill>
+                          <a:latin typeface="Arial"/>
+                        </a:rPr>
+                        <a:t>SoccerAgent</a:t>
+                      </a:r>
+                    </a:p>
+                  </a:txBody>
+                  <a:tcPr anchor="ctr">
+                    <a:solidFill>
+                      <a:srgbClr val="F2F2F2"/>
+                    </a:solidFill>
+                  </a:tcPr>
+                </a:tc>
+                <a:tc>
+                  <a:txBody>
+                    <a:bodyPr wrap="square"/>
+                    <a:lstStyle/>
+                    <a:p>
+                      <a:pPr algn="l"/>
+                      <a:r>
+                        <a:rPr sz="1400" b="0">
+                          <a:solidFill>
+                            <a:srgbClr val="222222"/>
+                          </a:solidFill>
+                          <a:latin typeface="Arial"/>
+                        </a:rPr>
+                        <a:t>base de conhecimento, imagens e vídeos</a:t>
+                      </a:r>
+                    </a:p>
+                  </a:txBody>
+                  <a:tcPr anchor="ctr">
+                    <a:solidFill>
+                      <a:srgbClr val="F2F2F2"/>
+                    </a:solidFill>
+                  </a:tcPr>
+                </a:tc>
+                <a:tc>
+                  <a:txBody>
+                    <a:bodyPr wrap="square"/>
+                    <a:lstStyle/>
+                    <a:p>
+                      <a:pPr algn="l"/>
+                      <a:r>
+                        <a:rPr sz="1400" b="0">
+                          <a:solidFill>
+                            <a:srgbClr val="222222"/>
+                          </a:solidFill>
+                          <a:latin typeface="Arial"/>
+                        </a:rPr>
+                        <a:t>uma (agente com ferramentas)</a:t>
+                      </a:r>
+                    </a:p>
+                  </a:txBody>
+                  <a:tcPr anchor="ctr">
+                    <a:solidFill>
+                      <a:srgbClr val="F2F2F2"/>
+                    </a:solidFill>
+                  </a:tcPr>
+                </a:tc>
+                <a:tc>
+                  <a:txBody>
+                    <a:bodyPr wrap="square"/>
+                    <a:lstStyle/>
+                    <a:p>
+                      <a:pPr algn="l"/>
+                      <a:r>
+                        <a:rPr sz="1400" b="0">
+                          <a:solidFill>
+                            <a:srgbClr val="222222"/>
+                          </a:solidFill>
+                          <a:latin typeface="Arial"/>
+                        </a:rPr>
+                        <a:t>múltipla escolha</a:t>
+                      </a:r>
+                    </a:p>
+                  </a:txBody>
+                  <a:tcPr anchor="ctr">
+                    <a:solidFill>
+                      <a:srgbClr val="F2F2F2"/>
+                    </a:solidFill>
+                  </a:tcPr>
+                </a:tc>
+              </a:tr>
+              <a:tr h="528320">
+                <a:tc>
+                  <a:txBody>
+                    <a:bodyPr wrap="square"/>
+                    <a:lstStyle/>
+                    <a:p>
+                      <a:pPr algn="l"/>
+                      <a:r>
+                        <a:rPr sz="1400" b="1">
+                          <a:solidFill>
+                            <a:srgbClr val="222222"/>
+                          </a:solidFill>
+                          <a:latin typeface="Arial"/>
+                        </a:rPr>
+                        <a:t>SoccerRAG</a:t>
+                      </a:r>
+                    </a:p>
+                  </a:txBody>
+                  <a:tcPr anchor="ctr">
+                    <a:solidFill>
+                      <a:srgbClr val="FFFFFF"/>
+                    </a:solidFill>
+                  </a:tcPr>
+                </a:tc>
+                <a:tc>
+                  <a:txBody>
+                    <a:bodyPr wrap="square"/>
+                    <a:lstStyle/>
+                    <a:p>
+                      <a:pPr algn="l"/>
+                      <a:r>
+                        <a:rPr sz="1400" b="0">
+                          <a:solidFill>
+                            <a:srgbClr val="222222"/>
+                          </a:solidFill>
+                          <a:latin typeface="Arial"/>
+                        </a:rPr>
+                        <a:t>anotações e comentários de partidas</a:t>
+                      </a:r>
+                    </a:p>
+                  </a:txBody>
+                  <a:tcPr anchor="ctr">
+                    <a:solidFill>
+                      <a:srgbClr val="FFFFFF"/>
+                    </a:solidFill>
+                  </a:tcPr>
+                </a:tc>
+                <a:tc>
+                  <a:txBody>
+                    <a:bodyPr wrap="square"/>
+                    <a:lstStyle/>
+                    <a:p>
+                      <a:pPr algn="l"/>
+                      <a:r>
+                        <a:rPr sz="1400" b="0">
+                          <a:solidFill>
+                            <a:srgbClr val="222222"/>
+                          </a:solidFill>
+                          <a:latin typeface="Arial"/>
+                        </a:rPr>
+                        <a:t>uma (SQL), em seis configurações</a:t>
+                      </a:r>
+                    </a:p>
+                  </a:txBody>
+                  <a:tcPr anchor="ctr">
+                    <a:solidFill>
+                      <a:srgbClr val="FFFFFF"/>
+                    </a:solidFill>
+                  </a:tcPr>
+                </a:tc>
+                <a:tc>
+                  <a:txBody>
+                    <a:bodyPr wrap="square"/>
+                    <a:lstStyle/>
+                    <a:p>
+                      <a:pPr algn="l"/>
+                      <a:r>
+                        <a:rPr sz="1400" b="0">
+                          <a:solidFill>
+                            <a:srgbClr val="222222"/>
+                          </a:solidFill>
+                          <a:latin typeface="Arial"/>
+                        </a:rPr>
+                        <a:t>manual, contra SQL escrito à mão</a:t>
+                      </a:r>
+                    </a:p>
+                  </a:txBody>
+                  <a:tcPr anchor="ctr">
+                    <a:solidFill>
+                      <a:srgbClr val="FFFFFF"/>
+                    </a:solidFill>
+                  </a:tcPr>
+                </a:tc>
+              </a:tr>
+              <a:tr h="528320">
+                <a:tc>
+                  <a:txBody>
+                    <a:bodyPr wrap="square"/>
+                    <a:lstStyle/>
+                    <a:p>
+                      <a:pPr algn="l"/>
+                      <a:r>
+                        <a:rPr sz="1400" b="1">
+                          <a:solidFill>
+                            <a:srgbClr val="222222"/>
+                          </a:solidFill>
+                          <a:latin typeface="Arial"/>
+                        </a:rPr>
+                        <a:t>SPORTSQL</a:t>
+                      </a:r>
+                    </a:p>
+                  </a:txBody>
+                  <a:tcPr anchor="ctr">
+                    <a:solidFill>
+                      <a:srgbClr val="F2F2F2"/>
+                    </a:solidFill>
+                  </a:tcPr>
+                </a:tc>
+                <a:tc>
+                  <a:txBody>
+                    <a:bodyPr wrap="square"/>
+                    <a:lstStyle/>
+                    <a:p>
+                      <a:pPr algn="l"/>
+                      <a:r>
+                        <a:rPr sz="1400" b="0">
+                          <a:solidFill>
+                            <a:srgbClr val="222222"/>
+                          </a:solidFill>
+                          <a:latin typeface="Arial"/>
+                        </a:rPr>
+                        <a:t>estatísticas de jogadores e times</a:t>
+                      </a:r>
+                    </a:p>
+                  </a:txBody>
+                  <a:tcPr anchor="ctr">
+                    <a:solidFill>
+                      <a:srgbClr val="F2F2F2"/>
+                    </a:solidFill>
+                  </a:tcPr>
+                </a:tc>
+                <a:tc>
+                  <a:txBody>
+                    <a:bodyPr wrap="square"/>
+                    <a:lstStyle/>
+                    <a:p>
+                      <a:pPr algn="l"/>
+                      <a:r>
+                        <a:rPr sz="1400" b="0">
+                          <a:solidFill>
+                            <a:srgbClr val="222222"/>
+                          </a:solidFill>
+                          <a:latin typeface="Arial"/>
+                        </a:rPr>
+                        <a:t>uma (SQL)</a:t>
+                      </a:r>
+                    </a:p>
+                  </a:txBody>
+                  <a:tcPr anchor="ctr">
+                    <a:solidFill>
+                      <a:srgbClr val="F2F2F2"/>
+                    </a:solidFill>
+                  </a:tcPr>
+                </a:tc>
+                <a:tc>
+                  <a:txBody>
+                    <a:bodyPr wrap="square"/>
+                    <a:lstStyle/>
+                    <a:p>
+                      <a:pPr algn="l"/>
+                      <a:r>
+                        <a:rPr sz="1400" b="0">
+                          <a:solidFill>
+                            <a:srgbClr val="222222"/>
+                          </a:solidFill>
+                          <a:latin typeface="Arial"/>
+                        </a:rPr>
+                        <a:t>resposta de referência e LLM como juiz</a:t>
+                      </a:r>
+                    </a:p>
+                  </a:txBody>
+                  <a:tcPr anchor="ctr">
+                    <a:solidFill>
+                      <a:srgbClr val="F2F2F2"/>
+                    </a:solidFill>
+                  </a:tcPr>
+                </a:tc>
+              </a:tr>
+              <a:tr h="528320">
+                <a:tc>
+                  <a:txBody>
+                    <a:bodyPr wrap="square"/>
+                    <a:lstStyle/>
+                    <a:p>
+                      <a:pPr algn="l"/>
+                      <a:r>
+                        <a:rPr sz="1400" b="1">
+                          <a:solidFill>
+                            <a:srgbClr val="222222"/>
+                          </a:solidFill>
+                          <a:latin typeface="Arial"/>
+                        </a:rPr>
+                        <a:t>Tzikas et al.</a:t>
+                      </a:r>
+                    </a:p>
+                  </a:txBody>
+                  <a:tcPr anchor="ctr">
+                    <a:solidFill>
+                      <a:srgbClr val="FFFFFF"/>
+                    </a:solidFill>
+                  </a:tcPr>
+                </a:tc>
+                <a:tc>
+                  <a:txBody>
+                    <a:bodyPr wrap="square"/>
+                    <a:lstStyle/>
+                    <a:p>
+                      <a:pPr algn="l"/>
+                      <a:r>
+                        <a:rPr sz="1400" b="0">
+                          <a:solidFill>
+                            <a:srgbClr val="222222"/>
+                          </a:solidFill>
+                          <a:latin typeface="Arial"/>
+                        </a:rPr>
+                        <a:t>eventos de partidas</a:t>
+                      </a:r>
+                    </a:p>
+                  </a:txBody>
+                  <a:tcPr anchor="ctr">
+                    <a:solidFill>
+                      <a:srgbClr val="FFFFFF"/>
+                    </a:solidFill>
+                  </a:tcPr>
+                </a:tc>
+                <a:tc>
+                  <a:txBody>
+                    <a:bodyPr wrap="square"/>
+                    <a:lstStyle/>
+                    <a:p>
+                      <a:pPr algn="l"/>
+                      <a:r>
+                        <a:rPr sz="1400" b="0">
+                          <a:solidFill>
+                            <a:srgbClr val="222222"/>
+                          </a:solidFill>
+                          <a:latin typeface="Arial"/>
+                        </a:rPr>
+                        <a:t>uma (recuperação vetorial)</a:t>
+                      </a:r>
+                    </a:p>
+                  </a:txBody>
+                  <a:tcPr anchor="ctr">
+                    <a:solidFill>
+                      <a:srgbClr val="FFFFFF"/>
+                    </a:solidFill>
+                  </a:tcPr>
+                </a:tc>
+                <a:tc>
+                  <a:txBody>
+                    <a:bodyPr wrap="square"/>
+                    <a:lstStyle/>
+                    <a:p>
+                      <a:pPr algn="l"/>
+                      <a:r>
+                        <a:rPr sz="1400" b="0">
+                          <a:solidFill>
+                            <a:srgbClr val="222222"/>
+                          </a:solidFill>
+                          <a:latin typeface="Arial"/>
+                        </a:rPr>
+                        <a:t>LLM como juiz</a:t>
+                      </a:r>
+                    </a:p>
+                  </a:txBody>
+                  <a:tcPr anchor="ctr">
+                    <a:solidFill>
+                      <a:srgbClr val="FFFFFF"/>
+                    </a:solidFill>
+                  </a:tcPr>
+                </a:tc>
+              </a:tr>
+              <a:tr h="528320">
+                <a:tc>
+                  <a:txBody>
+                    <a:bodyPr wrap="square"/>
+                    <a:lstStyle/>
+                    <a:p>
+                      <a:pPr algn="l"/>
+                      <a:r>
+                        <a:rPr sz="1400" b="1">
+                          <a:solidFill>
+                            <a:srgbClr val="222222"/>
+                          </a:solidFill>
+                          <a:latin typeface="Arial"/>
+                        </a:rPr>
+                        <a:t>Li et al.</a:t>
+                      </a:r>
+                    </a:p>
+                  </a:txBody>
+                  <a:tcPr anchor="ctr">
+                    <a:solidFill>
+                      <a:srgbClr val="F2F2F2"/>
+                    </a:solidFill>
+                  </a:tcPr>
+                </a:tc>
+                <a:tc>
+                  <a:txBody>
+                    <a:bodyPr wrap="square"/>
+                    <a:lstStyle/>
+                    <a:p>
+                      <a:pPr algn="l"/>
+                      <a:r>
+                        <a:rPr sz="1400" b="0">
+                          <a:solidFill>
+                            <a:srgbClr val="222222"/>
+                          </a:solidFill>
+                          <a:latin typeface="Arial"/>
+                        </a:rPr>
+                        <a:t>textos gerais</a:t>
+                      </a:r>
+                    </a:p>
+                  </a:txBody>
+                  <a:tcPr anchor="ctr">
+                    <a:solidFill>
+                      <a:srgbClr val="F2F2F2"/>
+                    </a:solidFill>
+                  </a:tcPr>
+                </a:tc>
+                <a:tc>
+                  <a:txBody>
+                    <a:bodyPr wrap="square"/>
+                    <a:lstStyle/>
+                    <a:p>
+                      <a:pPr algn="l"/>
+                      <a:r>
+                        <a:rPr sz="1400" b="0">
+                          <a:solidFill>
+                            <a:srgbClr val="222222"/>
+                          </a:solidFill>
+                          <a:latin typeface="Arial"/>
+                        </a:rPr>
+                        <a:t>duas (recuperação e contexto longo)</a:t>
+                      </a:r>
+                    </a:p>
+                  </a:txBody>
+                  <a:tcPr anchor="ctr">
+                    <a:solidFill>
+                      <a:srgbClr val="F2F2F2"/>
+                    </a:solidFill>
+                  </a:tcPr>
+                </a:tc>
+                <a:tc>
+                  <a:txBody>
+                    <a:bodyPr wrap="square"/>
+                    <a:lstStyle/>
+                    <a:p>
+                      <a:pPr algn="l"/>
+                      <a:r>
+                        <a:rPr sz="1400" b="0">
+                          <a:solidFill>
+                            <a:srgbClr val="222222"/>
+                          </a:solidFill>
+                          <a:latin typeface="Arial"/>
+                        </a:rPr>
+                        <a:t>métricas dos conjuntos</a:t>
+                      </a:r>
+                    </a:p>
+                  </a:txBody>
+                  <a:tcPr anchor="ctr">
+                    <a:solidFill>
+                      <a:srgbClr val="F2F2F2"/>
+                    </a:solidFill>
+                  </a:tcPr>
+                </a:tc>
+              </a:tr>
+              <a:tr h="528320">
+                <a:tc>
+                  <a:txBody>
+                    <a:bodyPr wrap="square"/>
+                    <a:lstStyle/>
+                    <a:p>
+                      <a:pPr algn="l"/>
+                      <a:r>
+                        <a:rPr sz="1400" b="1">
+                          <a:solidFill>
+                            <a:srgbClr val="222222"/>
+                          </a:solidFill>
+                          <a:latin typeface="Arial"/>
+                        </a:rPr>
+                        <a:t>LOFT</a:t>
+                      </a:r>
+                    </a:p>
+                  </a:txBody>
+                  <a:tcPr anchor="ctr">
+                    <a:solidFill>
+                      <a:srgbClr val="FFFFFF"/>
+                    </a:solidFill>
+                  </a:tcPr>
+                </a:tc>
+                <a:tc>
+                  <a:txBody>
+                    <a:bodyPr wrap="square"/>
+                    <a:lstStyle/>
+                    <a:p>
+                      <a:pPr algn="l"/>
+                      <a:r>
+                        <a:rPr sz="1400" b="0">
+                          <a:solidFill>
+                            <a:srgbClr val="222222"/>
+                          </a:solidFill>
+                          <a:latin typeface="Arial"/>
+                        </a:rPr>
+                        <a:t>textos, tabelas, imagens e áudio</a:t>
+                      </a:r>
+                    </a:p>
+                  </a:txBody>
+                  <a:tcPr anchor="ctr">
+                    <a:solidFill>
+                      <a:srgbClr val="FFFFFF"/>
+                    </a:solidFill>
+                  </a:tcPr>
+                </a:tc>
+                <a:tc>
+                  <a:txBody>
+                    <a:bodyPr wrap="square"/>
+                    <a:lstStyle/>
+                    <a:p>
+                      <a:pPr algn="l"/>
+                      <a:r>
+                        <a:rPr sz="1400" b="0">
+                          <a:solidFill>
+                            <a:srgbClr val="222222"/>
+                          </a:solidFill>
+                          <a:latin typeface="Arial"/>
+                        </a:rPr>
+                        <a:t>contexto longo contra sistemas especializados</a:t>
+                      </a:r>
+                    </a:p>
+                  </a:txBody>
+                  <a:tcPr anchor="ctr">
+                    <a:solidFill>
+                      <a:srgbClr val="FFFFFF"/>
+                    </a:solidFill>
+                  </a:tcPr>
+                </a:tc>
+                <a:tc>
+                  <a:txBody>
+                    <a:bodyPr wrap="square"/>
+                    <a:lstStyle/>
+                    <a:p>
+                      <a:pPr algn="l"/>
+                      <a:r>
+                        <a:rPr sz="1400" b="0">
+                          <a:solidFill>
+                            <a:srgbClr val="222222"/>
+                          </a:solidFill>
+                          <a:latin typeface="Arial"/>
+                        </a:rPr>
+                        <a:t>métricas dos conjuntos</a:t>
+                      </a:r>
+                    </a:p>
+                  </a:txBody>
+                  <a:tcPr anchor="ctr">
+                    <a:solidFill>
+                      <a:srgbClr val="FFFFFF"/>
+                    </a:solidFill>
+                  </a:tcPr>
+                </a:tc>
+              </a:tr>
+              <a:tr h="528320">
+                <a:tc>
+                  <a:txBody>
+                    <a:bodyPr wrap="square"/>
+                    <a:lstStyle/>
+                    <a:p>
+                      <a:pPr algn="l"/>
+                      <a:r>
+                        <a:rPr sz="1400" b="1">
+                          <a:solidFill>
+                            <a:srgbClr val="222222"/>
+                          </a:solidFill>
+                          <a:latin typeface="Arial"/>
+                        </a:rPr>
+                        <a:t>Este trabalho</a:t>
+                      </a:r>
+                    </a:p>
+                  </a:txBody>
+                  <a:tcPr anchor="ctr">
+                    <a:solidFill>
+                      <a:srgbClr val="E6EEF6"/>
+                    </a:solidFill>
+                  </a:tcPr>
+                </a:tc>
+                <a:tc>
+                  <a:txBody>
+                    <a:bodyPr wrap="square"/>
+                    <a:lstStyle/>
+                    <a:p>
+                      <a:pPr algn="l"/>
+                      <a:r>
+                        <a:rPr sz="1400" b="0">
+                          <a:solidFill>
+                            <a:srgbClr val="222222"/>
+                          </a:solidFill>
+                          <a:latin typeface="Arial"/>
+                        </a:rPr>
+                        <a:t>eventos de uma partida</a:t>
+                      </a:r>
+                    </a:p>
+                  </a:txBody>
+                  <a:tcPr anchor="ctr">
+                    <a:solidFill>
+                      <a:srgbClr val="E6EEF6"/>
+                    </a:solidFill>
+                  </a:tcPr>
+                </a:tc>
+                <a:tc>
+                  <a:txBody>
+                    <a:bodyPr wrap="square"/>
+                    <a:lstStyle/>
+                    <a:p>
+                      <a:pPr algn="l"/>
+                      <a:r>
+                        <a:rPr sz="1400" b="0">
+                          <a:solidFill>
+                            <a:srgbClr val="222222"/>
+                          </a:solidFill>
+                          <a:latin typeface="Arial"/>
+                        </a:rPr>
+                        <a:t>6 abordagens, com as mesmas perguntas</a:t>
+                      </a:r>
+                    </a:p>
+                  </a:txBody>
+                  <a:tcPr anchor="ctr">
+                    <a:solidFill>
+                      <a:srgbClr val="E6EEF6"/>
+                    </a:solidFill>
+                  </a:tcPr>
+                </a:tc>
+                <a:tc>
+                  <a:txBody>
+                    <a:bodyPr wrap="square"/>
+                    <a:lstStyle/>
+                    <a:p>
+                      <a:pPr algn="l"/>
+                      <a:r>
+                        <a:rPr sz="1400" b="0">
+                          <a:solidFill>
+                            <a:srgbClr val="222222"/>
+                          </a:solidFill>
+                          <a:latin typeface="Arial"/>
+                        </a:rPr>
+                        <a:t>por código, contra gabarito calculado por código</a:t>
+                      </a:r>
+                    </a:p>
+                  </a:txBody>
+                  <a:tcPr anchor="ctr">
+                    <a:solidFill>
+                      <a:srgbClr val="E6EEF6"/>
+                    </a:solidFill>
+                  </a:tcPr>
+                </a:tc>
+              </a:tr>
+            </a:tbl>
+          </a:graphicData>
+        </a:graphic>
+      </p:graphicFrame>
     </p:spTree>
   </p:cSld>
   <p:clrMapOvr>
@@ -9998,7 +10646,7 @@
                 </a:solidFill>
                 <a:latin typeface="Arial"/>
               </a:rPr>
-              <a:t>Do JSON à tabela de ações: um vocabulário fechado, com contexto acrescentado</a:t>
+              <a:t>Os dados: eventos da StatsBomb da final de 2022, em JSON</a:t>
             </a:r>
           </a:p>
         </p:txBody>
@@ -10081,6 +10729,548 @@
                 <a:latin typeface="Arial"/>
               </a:rPr>
               <a:t>4 / 15</a:t>
+            </a:r>
+          </a:p>
+        </p:txBody>
+      </p:sp>
+      <p:sp>
+        <p:nvSpPr>
+          <p:cNvPr id="5" name="TextBox 4"/>
+          <p:cNvSpPr txBox="1"/>
+          <p:nvPr/>
+        </p:nvSpPr>
+        <p:spPr>
+          <a:xfrm>
+            <a:off x="640080" y="6400800"/>
+            <a:ext cx="9144000" cy="320040"/>
+          </a:xfrm>
+          <a:prstGeom prst="rect">
+            <a:avLst/>
+          </a:prstGeom>
+          <a:noFill/>
+        </p:spPr>
+        <p:txBody>
+          <a:bodyPr wrap="square" anchor="t" lIns="45720" rIns="45720">
+            <a:spAutoFit/>
+          </a:bodyPr>
+          <a:lstStyle/>
+          <a:p>
+            <a:pPr algn="l">
+              <a:spcAft>
+                <a:spcPts val="600"/>
+              </a:spcAft>
+            </a:pPr>
+            <a:r>
+              <a:rPr sz="1200" b="0">
+                <a:solidFill>
+                  <a:srgbClr val="666666"/>
+                </a:solidFill>
+                <a:latin typeface="Arial"/>
+              </a:rPr>
+              <a:t>Exemplo resumido: o passe de Mac Allister e o gol de Di María (docs/02 e Figura 1 do artigo).</a:t>
+            </a:r>
+          </a:p>
+        </p:txBody>
+      </p:sp>
+      <p:sp>
+        <p:nvSpPr>
+          <p:cNvPr id="6" name="Rectangle 5"/>
+          <p:cNvSpPr/>
+          <p:nvPr/>
+        </p:nvSpPr>
+        <p:spPr>
+          <a:xfrm>
+            <a:off x="640080" y="1554480"/>
+            <a:ext cx="6492240" cy="3017520"/>
+          </a:xfrm>
+          <a:prstGeom prst="rect">
+            <a:avLst/>
+          </a:prstGeom>
+          <a:solidFill>
+            <a:srgbClr val="2B2B2B"/>
+          </a:solidFill>
+          <a:ln>
+            <a:noFill/>
+          </a:ln>
+          <a:effectLst/>
+        </p:spPr>
+        <p:style>
+          <a:lnRef idx="1">
+            <a:schemeClr val="accent1"/>
+          </a:lnRef>
+          <a:fillRef idx="3">
+            <a:schemeClr val="accent1"/>
+          </a:fillRef>
+          <a:effectRef idx="2">
+            <a:schemeClr val="accent1"/>
+          </a:effectRef>
+          <a:fontRef idx="minor">
+            <a:schemeClr val="lt1"/>
+          </a:fontRef>
+        </p:style>
+        <p:txBody>
+          <a:bodyPr rtlCol="0" anchor="ctr"/>
+          <a:lstStyle/>
+          <a:p>
+            <a:pPr algn="ctr"/>
+          </a:p>
+        </p:txBody>
+      </p:sp>
+      <p:sp>
+        <p:nvSpPr>
+          <p:cNvPr id="7" name="TextBox 6"/>
+          <p:cNvSpPr txBox="1"/>
+          <p:nvPr/>
+        </p:nvSpPr>
+        <p:spPr>
+          <a:xfrm>
+            <a:off x="822960" y="1691640"/>
+            <a:ext cx="6217920" cy="3200400"/>
+          </a:xfrm>
+          <a:prstGeom prst="rect">
+            <a:avLst/>
+          </a:prstGeom>
+          <a:noFill/>
+        </p:spPr>
+        <p:txBody>
+          <a:bodyPr wrap="square">
+            <a:spAutoFit/>
+          </a:bodyPr>
+          <a:lstStyle/>
+          <a:p>
+            <a:r>
+              <a:rPr sz="1400">
+                <a:solidFill>
+                  <a:srgbClr val="E8E8E8"/>
+                </a:solidFill>
+                <a:latin typeface="Courier New"/>
+              </a:rPr>
+              <a:t>{ "type": "Pass", "minute": 35, "second": 20,</a:t>
+            </a:r>
+          </a:p>
+          <a:p>
+            <a:r>
+              <a:rPr sz="1400">
+                <a:solidFill>
+                  <a:srgbClr val="E8E8E8"/>
+                </a:solidFill>
+                <a:latin typeface="Courier New"/>
+              </a:rPr>
+              <a:t>  "player": "Alexis Mac Allister",</a:t>
+            </a:r>
+          </a:p>
+          <a:p>
+            <a:r>
+              <a:rPr sz="1400">
+                <a:solidFill>
+                  <a:srgbClr val="E8E8E8"/>
+                </a:solidFill>
+                <a:latin typeface="Courier New"/>
+              </a:rPr>
+              <a:t>  "pass": { "recipient": "Ángel Fabián Di María",</a:t>
+            </a:r>
+          </a:p>
+          <a:p>
+            <a:r>
+              <a:rPr sz="1400">
+                <a:solidFill>
+                  <a:srgbClr val="E8E8E8"/>
+                </a:solidFill>
+                <a:latin typeface="Courier New"/>
+              </a:rPr>
+              <a:t>            "goal_assist": true } }</a:t>
+            </a:r>
+          </a:p>
+          <a:p>
+            <a:r>
+              <a:rPr sz="1400">
+                <a:solidFill>
+                  <a:srgbClr val="E8E8E8"/>
+                </a:solidFill>
+                <a:latin typeface="Courier New"/>
+              </a:rPr>
+              <a:t> </a:t>
+            </a:r>
+          </a:p>
+          <a:p>
+            <a:r>
+              <a:rPr sz="1400">
+                <a:solidFill>
+                  <a:srgbClr val="E8E8E8"/>
+                </a:solidFill>
+                <a:latin typeface="Courier New"/>
+              </a:rPr>
+              <a:t>{ "type": "Shot", "minute": 35, "second": 22,</a:t>
+            </a:r>
+          </a:p>
+          <a:p>
+            <a:r>
+              <a:rPr sz="1400">
+                <a:solidFill>
+                  <a:srgbClr val="E8E8E8"/>
+                </a:solidFill>
+                <a:latin typeface="Courier New"/>
+              </a:rPr>
+              <a:t>  "team": "Argentina",</a:t>
+            </a:r>
+          </a:p>
+          <a:p>
+            <a:r>
+              <a:rPr sz="1400">
+                <a:solidFill>
+                  <a:srgbClr val="E8E8E8"/>
+                </a:solidFill>
+                <a:latin typeface="Courier New"/>
+              </a:rPr>
+              <a:t>  "player": "Ángel Fabián Di María",</a:t>
+            </a:r>
+          </a:p>
+          <a:p>
+            <a:r>
+              <a:rPr sz="1400">
+                <a:solidFill>
+                  <a:srgbClr val="E8E8E8"/>
+                </a:solidFill>
+                <a:latin typeface="Courier New"/>
+              </a:rPr>
+              <a:t>  "shot": { "outcome": "Goal",</a:t>
+            </a:r>
+          </a:p>
+          <a:p>
+            <a:r>
+              <a:rPr sz="1400">
+                <a:solidFill>
+                  <a:srgbClr val="E8E8E8"/>
+                </a:solidFill>
+                <a:latin typeface="Courier New"/>
+              </a:rPr>
+              <a:t>            "body_part": "Left Foot" } }</a:t>
+            </a:r>
+          </a:p>
+        </p:txBody>
+      </p:sp>
+      <p:sp>
+        <p:nvSpPr>
+          <p:cNvPr id="8" name="TextBox 7"/>
+          <p:cNvSpPr txBox="1"/>
+          <p:nvPr/>
+        </p:nvSpPr>
+        <p:spPr>
+          <a:xfrm>
+            <a:off x="7406640" y="1554480"/>
+            <a:ext cx="4206240" cy="4572000"/>
+          </a:xfrm>
+          <a:prstGeom prst="rect">
+            <a:avLst/>
+          </a:prstGeom>
+          <a:noFill/>
+        </p:spPr>
+        <p:txBody>
+          <a:bodyPr wrap="square">
+            <a:spAutoFit/>
+          </a:bodyPr>
+          <a:lstStyle/>
+          <a:p>
+            <a:pPr>
+              <a:spcAft>
+                <a:spcPts val="1000"/>
+              </a:spcAft>
+            </a:pPr>
+            <a:r>
+              <a:rPr sz="1600" b="1">
+                <a:solidFill>
+                  <a:srgbClr val="1F5C99"/>
+                </a:solidFill>
+                <a:latin typeface="Arial"/>
+              </a:rPr>
+              <a:t>• </a:t>
+            </a:r>
+            <a:r>
+              <a:rPr sz="1600" b="1">
+                <a:solidFill>
+                  <a:srgbClr val="222222"/>
+                </a:solidFill>
+                <a:latin typeface="Arial"/>
+              </a:rPr>
+              <a:t>Fonte: </a:t>
+            </a:r>
+            <a:r>
+              <a:rPr sz="1600" b="0">
+                <a:solidFill>
+                  <a:srgbClr val="222222"/>
+                </a:solidFill>
+                <a:latin typeface="Arial"/>
+              </a:rPr>
+              <a:t>StatsBomb Open Data, lista de eventos e escalações da partida.</a:t>
+            </a:r>
+          </a:p>
+          <a:p>
+            <a:pPr>
+              <a:spcAft>
+                <a:spcPts val="1000"/>
+              </a:spcAft>
+            </a:pPr>
+            <a:r>
+              <a:rPr sz="1600" b="1">
+                <a:solidFill>
+                  <a:srgbClr val="1F5C99"/>
+                </a:solidFill>
+                <a:latin typeface="Arial"/>
+              </a:rPr>
+              <a:t>• </a:t>
+            </a:r>
+            <a:r>
+              <a:rPr sz="1600" b="1">
+                <a:solidFill>
+                  <a:srgbClr val="222222"/>
+                </a:solidFill>
+                <a:latin typeface="Arial"/>
+              </a:rPr>
+              <a:t>4.407 eventos, </a:t>
+            </a:r>
+            <a:r>
+              <a:rPr sz="1600" b="0">
+                <a:solidFill>
+                  <a:srgbClr val="222222"/>
+                </a:solidFill>
+                <a:latin typeface="Arial"/>
+              </a:rPr>
+              <a:t>cada um com tipo, tempo, time, jogador e posição.</a:t>
+            </a:r>
+          </a:p>
+          <a:p>
+            <a:pPr>
+              <a:spcAft>
+                <a:spcPts val="1000"/>
+              </a:spcAft>
+            </a:pPr>
+            <a:r>
+              <a:rPr sz="1600" b="1">
+                <a:solidFill>
+                  <a:srgbClr val="1F5C99"/>
+                </a:solidFill>
+                <a:latin typeface="Arial"/>
+              </a:rPr>
+              <a:t>• </a:t>
+            </a:r>
+            <a:r>
+              <a:rPr sz="1600" b="1">
+                <a:solidFill>
+                  <a:srgbClr val="222222"/>
+                </a:solidFill>
+                <a:latin typeface="Arial"/>
+              </a:rPr>
+              <a:t>Campos próprios por tipo: </a:t>
+            </a:r>
+            <a:r>
+              <a:rPr sz="1600" b="0">
+                <a:solidFill>
+                  <a:srgbClr val="222222"/>
+                </a:solidFill>
+                <a:latin typeface="Arial"/>
+              </a:rPr>
+              <a:t>o passe traz o recebedor; a finalização, o resultado.</a:t>
+            </a:r>
+          </a:p>
+          <a:p>
+            <a:pPr>
+              <a:spcAft>
+                <a:spcPts val="1000"/>
+              </a:spcAft>
+            </a:pPr>
+            <a:r>
+              <a:rPr sz="1600" b="1">
+                <a:solidFill>
+                  <a:srgbClr val="1F5C99"/>
+                </a:solidFill>
+                <a:latin typeface="Arial"/>
+              </a:rPr>
+              <a:t>• </a:t>
+            </a:r>
+            <a:r>
+              <a:rPr sz="1600" b="1">
+                <a:solidFill>
+                  <a:srgbClr val="222222"/>
+                </a:solidFill>
+                <a:latin typeface="Arial"/>
+              </a:rPr>
+              <a:t>Mesma informação em lugares diferentes: </a:t>
+            </a:r>
+            <a:r>
+              <a:rPr sz="1600" b="0">
+                <a:solidFill>
+                  <a:srgbClr val="222222"/>
+                </a:solidFill>
+                <a:latin typeface="Arial"/>
+              </a:rPr>
+              <a:t>o cartão amarelo vem na falta ou em outro evento.</a:t>
+            </a:r>
+          </a:p>
+          <a:p>
+            <a:pPr>
+              <a:spcAft>
+                <a:spcPts val="1000"/>
+              </a:spcAft>
+            </a:pPr>
+            <a:r>
+              <a:rPr sz="1600" b="1">
+                <a:solidFill>
+                  <a:srgbClr val="1F5C99"/>
+                </a:solidFill>
+                <a:latin typeface="Arial"/>
+              </a:rPr>
+              <a:t>• </a:t>
+            </a:r>
+            <a:r>
+              <a:rPr sz="1600" b="1">
+                <a:solidFill>
+                  <a:srgbClr val="222222"/>
+                </a:solidFill>
+                <a:latin typeface="Arial"/>
+              </a:rPr>
+              <a:t>Nome de registro e minuto decorrido: </a:t>
+            </a:r>
+            <a:r>
+              <a:rPr sz="1600" b="0">
+                <a:solidFill>
+                  <a:srgbClr val="222222"/>
+                </a:solidFill>
+                <a:latin typeface="Arial"/>
+              </a:rPr>
+              <a:t>o gol aos 35 aparece como 36 na transmissão.</a:t>
+            </a:r>
+          </a:p>
+        </p:txBody>
+      </p:sp>
+    </p:spTree>
+  </p:cSld>
+  <p:clrMapOvr>
+    <a:masterClrMapping/>
+  </p:clrMapOvr>
+</p:sld>
+</file>
+
+<file path=ppt/slides/slide5.xml><?xml version="1.0" encoding="utf-8"?>
+<p:sld xmlns:a="http://schemas.openxmlformats.org/drawingml/2006/main" xmlns:p="http://schemas.openxmlformats.org/presentationml/2006/main" xmlns:r="http://schemas.openxmlformats.org/officeDocument/2006/relationships">
+  <p:cSld>
+    <p:spTree>
+      <p:nvGrpSpPr>
+        <p:cNvPr id="1" name=""/>
+        <p:cNvGrpSpPr/>
+        <p:nvPr/>
+      </p:nvGrpSpPr>
+      <p:grpSpPr/>
+      <p:sp>
+        <p:nvSpPr>
+          <p:cNvPr id="2" name="Title 1"/>
+          <p:cNvSpPr>
+            <a:spLocks noGrp="1"/>
+          </p:cNvSpPr>
+          <p:nvPr>
+            <p:ph type="title"/>
+          </p:nvPr>
+        </p:nvSpPr>
+        <p:spPr>
+          <a:xfrm>
+            <a:off x="640080" y="365760"/>
+            <a:ext cx="10881360" cy="1005840"/>
+          </a:xfrm>
+        </p:spPr>
+        <p:txBody>
+          <a:bodyPr wrap="square" anchor="t"/>
+          <a:lstStyle/>
+          <a:p>
+            <a:pPr algn="l"/>
+            <a:r>
+              <a:rPr sz="3000" b="1">
+                <a:solidFill>
+                  <a:srgbClr val="222222"/>
+                </a:solidFill>
+                <a:latin typeface="Arial"/>
+              </a:rPr>
+              <a:t>Do JSON à tabela de ações: um vocabulário fechado, com contexto acrescentado</a:t>
+            </a:r>
+          </a:p>
+        </p:txBody>
+      </p:sp>
+      <p:sp>
+        <p:nvSpPr>
+          <p:cNvPr id="3" name="Rectangle 2"/>
+          <p:cNvSpPr/>
+          <p:nvPr/>
+        </p:nvSpPr>
+        <p:spPr>
+          <a:xfrm>
+            <a:off x="0" y="365760"/>
+            <a:ext cx="256032" cy="822960"/>
+          </a:xfrm>
+          <a:prstGeom prst="rect">
+            <a:avLst/>
+          </a:prstGeom>
+          <a:solidFill>
+            <a:srgbClr val="1F5C99"/>
+          </a:solidFill>
+          <a:ln>
+            <a:noFill/>
+          </a:ln>
+        </p:spPr>
+        <p:style>
+          <a:lnRef idx="1">
+            <a:schemeClr val="accent1"/>
+          </a:lnRef>
+          <a:fillRef idx="3">
+            <a:schemeClr val="accent1"/>
+          </a:fillRef>
+          <a:effectRef idx="2">
+            <a:schemeClr val="accent1"/>
+          </a:effectRef>
+          <a:fontRef idx="minor">
+            <a:schemeClr val="lt1"/>
+          </a:fontRef>
+        </p:style>
+        <p:txBody>
+          <a:bodyPr rtlCol="0" anchor="ctr"/>
+          <a:lstStyle/>
+          <a:p>
+            <a:pPr algn="ctr"/>
+          </a:p>
+        </p:txBody>
+      </p:sp>
+      <p:sp>
+        <p:nvSpPr>
+          <p:cNvPr id="4" name="TextBox 3"/>
+          <p:cNvSpPr txBox="1"/>
+          <p:nvPr/>
+        </p:nvSpPr>
+        <p:spPr>
+          <a:xfrm>
+            <a:off x="10881360" y="6400800"/>
+            <a:ext cx="1097280" cy="320040"/>
+          </a:xfrm>
+          <a:prstGeom prst="rect">
+            <a:avLst/>
+          </a:prstGeom>
+          <a:noFill/>
+        </p:spPr>
+        <p:txBody>
+          <a:bodyPr wrap="square" anchor="t" lIns="45720" rIns="45720">
+            <a:spAutoFit/>
+          </a:bodyPr>
+          <a:lstStyle/>
+          <a:p>
+            <a:pPr algn="r">
+              <a:spcAft>
+                <a:spcPts val="600"/>
+              </a:spcAft>
+            </a:pPr>
+            <a:r>
+              <a:rPr sz="1200" b="0">
+                <a:solidFill>
+                  <a:srgbClr val="666666"/>
+                </a:solidFill>
+                <a:latin typeface="Arial"/>
+              </a:rPr>
+              <a:t>5 / 15</a:t>
             </a:r>
           </a:p>
         </p:txBody>
@@ -11652,7 +12842,7 @@
 </p:sld>
 </file>
 
-<file path=ppt/slides/slide5.xml><?xml version="1.0" encoding="utf-8"?>
+<file path=ppt/slides/slide6.xml><?xml version="1.0" encoding="utf-8"?>
 <p:sld xmlns:a="http://schemas.openxmlformats.org/drawingml/2006/main" xmlns:p="http://schemas.openxmlformats.org/presentationml/2006/main" xmlns:r="http://schemas.openxmlformats.org/officeDocument/2006/relationships">
   <p:cSld>
     <p:spTree>
@@ -11772,7 +12962,7 @@
                 </a:solidFill>
                 <a:latin typeface="Arial"/>
               </a:rPr>
-              <a:t>5 / 15</a:t>
+              <a:t>6 / 15</a:t>
             </a:r>
           </a:p>
         </p:txBody>
@@ -12830,7 +14020,7 @@
 </p:sld>
 </file>
 
-<file path=ppt/slides/slide6.xml><?xml version="1.0" encoding="utf-8"?>
+<file path=ppt/slides/slide7.xml><?xml version="1.0" encoding="utf-8"?>
 <p:sld xmlns:a="http://schemas.openxmlformats.org/drawingml/2006/main" xmlns:p="http://schemas.openxmlformats.org/presentationml/2006/main" xmlns:r="http://schemas.openxmlformats.org/officeDocument/2006/relationships">
   <p:cSld>
     <p:spTree>
@@ -12950,7 +14140,7 @@
                 </a:solidFill>
                 <a:latin typeface="Arial"/>
               </a:rPr>
-              <a:t>6 / 15</a:t>
+              <a:t>7 / 15</a:t>
             </a:r>
           </a:p>
         </p:txBody>
@@ -13455,7 +14645,7 @@
 </p:sld>
 </file>
 
-<file path=ppt/slides/slide7.xml><?xml version="1.0" encoding="utf-8"?>
+<file path=ppt/slides/slide8.xml><?xml version="1.0" encoding="utf-8"?>
 <p:sld xmlns:a="http://schemas.openxmlformats.org/drawingml/2006/main" xmlns:p="http://schemas.openxmlformats.org/presentationml/2006/main" xmlns:r="http://schemas.openxmlformats.org/officeDocument/2006/relationships">
   <p:cSld>
     <p:spTree>
@@ -13575,7 +14765,7 @@
                 </a:solidFill>
                 <a:latin typeface="Arial"/>
               </a:rPr>
-              <a:t>7 / 15</a:t>
+              <a:t>8 / 15</a:t>
             </a:r>
           </a:p>
         </p:txBody>
@@ -13950,7 +15140,7 @@
 </p:sld>
 </file>
 
-<file path=ppt/slides/slide8.xml><?xml version="1.0" encoding="utf-8"?>
+<file path=ppt/slides/slide9.xml><?xml version="1.0" encoding="utf-8"?>
 <p:sld xmlns:a="http://schemas.openxmlformats.org/drawingml/2006/main" xmlns:p="http://schemas.openxmlformats.org/presentationml/2006/main" xmlns:r="http://schemas.openxmlformats.org/officeDocument/2006/relationships">
   <p:cSld>
     <p:spTree>
@@ -14070,7 +15260,7 @@
                 </a:solidFill>
                 <a:latin typeface="Arial"/>
               </a:rPr>
-              <a:t>8 / 15</a:t>
+              <a:t>9 / 15</a:t>
             </a:r>
           </a:p>
         </p:txBody>
@@ -15070,290 +16260,6 @@
                 <a:latin typeface="Arial"/>
               </a:rPr>
               <a:t>Modelo responde: Lionel Andrés Messi Cuccittini</a:t>
-            </a:r>
-          </a:p>
-        </p:txBody>
-      </p:sp>
-    </p:spTree>
-  </p:cSld>
-  <p:clrMapOvr>
-    <a:masterClrMapping/>
-  </p:clrMapOvr>
-</p:sld>
-</file>
-
-<file path=ppt/slides/slide9.xml><?xml version="1.0" encoding="utf-8"?>
-<p:sld xmlns:a="http://schemas.openxmlformats.org/drawingml/2006/main" xmlns:p="http://schemas.openxmlformats.org/presentationml/2006/main" xmlns:r="http://schemas.openxmlformats.org/officeDocument/2006/relationships">
-  <p:cSld>
-    <p:spTree>
-      <p:nvGrpSpPr>
-        <p:cNvPr id="1" name=""/>
-        <p:cNvGrpSpPr/>
-        <p:nvPr/>
-      </p:nvGrpSpPr>
-      <p:grpSpPr/>
-      <p:sp>
-        <p:nvSpPr>
-          <p:cNvPr id="2" name="Title 1"/>
-          <p:cNvSpPr>
-            <a:spLocks noGrp="1"/>
-          </p:cNvSpPr>
-          <p:nvPr>
-            <p:ph type="title"/>
-          </p:nvPr>
-        </p:nvSpPr>
-        <p:spPr>
-          <a:xfrm>
-            <a:off x="640080" y="365760"/>
-            <a:ext cx="10881360" cy="1005840"/>
-          </a:xfrm>
-        </p:spPr>
-        <p:txBody>
-          <a:bodyPr wrap="square" anchor="t"/>
-          <a:lstStyle/>
-          <a:p>
-            <a:pPr algn="l"/>
-            <a:r>
-              <a:rPr sz="3000" b="1">
-                <a:solidFill>
-                  <a:srgbClr val="222222"/>
-                </a:solidFill>
-                <a:latin typeface="Arial"/>
-              </a:rPr>
-              <a:t>Ferramentas sobre o grafo: 83% a 89% de acerto nos 4 modelos</a:t>
-            </a:r>
-          </a:p>
-        </p:txBody>
-      </p:sp>
-      <p:sp>
-        <p:nvSpPr>
-          <p:cNvPr id="3" name="Rectangle 2"/>
-          <p:cNvSpPr/>
-          <p:nvPr/>
-        </p:nvSpPr>
-        <p:spPr>
-          <a:xfrm>
-            <a:off x="0" y="365760"/>
-            <a:ext cx="256032" cy="822960"/>
-          </a:xfrm>
-          <a:prstGeom prst="rect">
-            <a:avLst/>
-          </a:prstGeom>
-          <a:solidFill>
-            <a:srgbClr val="1F5C99"/>
-          </a:solidFill>
-          <a:ln>
-            <a:noFill/>
-          </a:ln>
-        </p:spPr>
-        <p:style>
-          <a:lnRef idx="1">
-            <a:schemeClr val="accent1"/>
-          </a:lnRef>
-          <a:fillRef idx="3">
-            <a:schemeClr val="accent1"/>
-          </a:fillRef>
-          <a:effectRef idx="2">
-            <a:schemeClr val="accent1"/>
-          </a:effectRef>
-          <a:fontRef idx="minor">
-            <a:schemeClr val="lt1"/>
-          </a:fontRef>
-        </p:style>
-        <p:txBody>
-          <a:bodyPr rtlCol="0" anchor="ctr"/>
-          <a:lstStyle/>
-          <a:p>
-            <a:pPr algn="ctr"/>
-          </a:p>
-        </p:txBody>
-      </p:sp>
-      <p:sp>
-        <p:nvSpPr>
-          <p:cNvPr id="4" name="TextBox 3"/>
-          <p:cNvSpPr txBox="1"/>
-          <p:nvPr/>
-        </p:nvSpPr>
-        <p:spPr>
-          <a:xfrm>
-            <a:off x="10881360" y="6400800"/>
-            <a:ext cx="1097280" cy="320040"/>
-          </a:xfrm>
-          <a:prstGeom prst="rect">
-            <a:avLst/>
-          </a:prstGeom>
-          <a:noFill/>
-        </p:spPr>
-        <p:txBody>
-          <a:bodyPr wrap="square" anchor="t" lIns="45720" rIns="45720">
-            <a:spAutoFit/>
-          </a:bodyPr>
-          <a:lstStyle/>
-          <a:p>
-            <a:pPr algn="r">
-              <a:spcAft>
-                <a:spcPts val="600"/>
-              </a:spcAft>
-            </a:pPr>
-            <a:r>
-              <a:rPr sz="1200" b="0">
-                <a:solidFill>
-                  <a:srgbClr val="666666"/>
-                </a:solidFill>
-                <a:latin typeface="Arial"/>
-              </a:rPr>
-              <a:t>9 / 15</a:t>
-            </a:r>
-          </a:p>
-        </p:txBody>
-      </p:sp>
-      <p:sp>
-        <p:nvSpPr>
-          <p:cNvPr id="5" name="TextBox 4"/>
-          <p:cNvSpPr txBox="1"/>
-          <p:nvPr/>
-        </p:nvSpPr>
-        <p:spPr>
-          <a:xfrm>
-            <a:off x="640080" y="6400800"/>
-            <a:ext cx="9144000" cy="320040"/>
-          </a:xfrm>
-          <a:prstGeom prst="rect">
-            <a:avLst/>
-          </a:prstGeom>
-          <a:noFill/>
-        </p:spPr>
-        <p:txBody>
-          <a:bodyPr wrap="square" anchor="t" lIns="45720" rIns="45720">
-            <a:spAutoFit/>
-          </a:bodyPr>
-          <a:lstStyle/>
-          <a:p>
-            <a:pPr algn="l">
-              <a:spcAft>
-                <a:spcPts val="600"/>
-              </a:spcAft>
-            </a:pPr>
-            <a:r>
-              <a:rPr sz="1200" b="0">
-                <a:solidFill>
-                  <a:srgbClr val="666666"/>
-                </a:solidFill>
-                <a:latin typeface="Arial"/>
-              </a:rPr>
-              <a:t>Barras de erro: intervalo de Wilson de 95%. Uma repetição por pergunta.</a:t>
-            </a:r>
-          </a:p>
-        </p:txBody>
-      </p:sp>
-      <p:sp>
-        <p:nvSpPr>
-          <p:cNvPr id="6" name="TextBox 5"/>
-          <p:cNvSpPr txBox="1"/>
-          <p:nvPr/>
-        </p:nvSpPr>
-        <p:spPr>
-          <a:xfrm>
-            <a:off x="640080" y="1325880"/>
-            <a:ext cx="10881360" cy="1005840"/>
-          </a:xfrm>
-          <a:prstGeom prst="rect">
-            <a:avLst/>
-          </a:prstGeom>
-          <a:noFill/>
-        </p:spPr>
-        <p:txBody>
-          <a:bodyPr wrap="square" anchor="t" lIns="45720" rIns="45720">
-            <a:spAutoFit/>
-          </a:bodyPr>
-          <a:lstStyle/>
-          <a:p>
-            <a:pPr algn="l">
-              <a:spcAft>
-                <a:spcPts val="200"/>
-              </a:spcAft>
-            </a:pPr>
-            <a:r>
-              <a:rPr sz="1400" b="0">
-                <a:solidFill>
-                  <a:srgbClr val="666666"/>
-                </a:solidFill>
-                <a:latin typeface="Arial"/>
-              </a:rPr>
-              <a:t>4 modelos: Claude Haiku 5.5 e Qwen3.8-flash (menores, sem raciocínio estendido, temperatura zero); Claude Sonnet 4.6 e Kimi K3 (maiores, com raciocínio estendido).</a:t>
-            </a:r>
-          </a:p>
-          <a:p>
-            <a:pPr algn="l">
-              <a:spcAft>
-                <a:spcPts val="200"/>
-              </a:spcAft>
-            </a:pPr>
-            <a:r>
-              <a:rPr sz="1400" b="0">
-                <a:solidFill>
-                  <a:srgbClr val="666666"/>
-                </a:solidFill>
-                <a:latin typeface="Arial"/>
-              </a:rPr>
-              <a:t>52 perguntas × 6 abordagens = 312 execuções por modelo, 1 repetição por pergunta. Diferenças lidas como indícios.</a:t>
-            </a:r>
-          </a:p>
-        </p:txBody>
-      </p:sp>
-      <p:graphicFrame>
-        <p:nvGraphicFramePr>
-          <p:cNvPr id="7" name="Chart 6"/>
-          <p:cNvGraphicFramePr>
-            <a:graphicFrameLocks noGrp="1"/>
-          </p:cNvGraphicFramePr>
-          <p:nvPr/>
-        </p:nvGraphicFramePr>
-        <p:xfrm>
-          <a:off x="457200" y="2286000"/>
-          <a:ext cx="11247120" cy="3703320"/>
-        </p:xfrm>
-        <a:graphic>
-          <a:graphicData uri="http://schemas.openxmlformats.org/drawingml/2006/chart">
-            <c:chart xmlns:c="http://schemas.openxmlformats.org/drawingml/2006/chart" r:id="rId3"/>
-          </a:graphicData>
-        </a:graphic>
-      </p:graphicFrame>
-      <p:sp>
-        <p:nvSpPr>
-          <p:cNvPr id="8" name="TextBox 7"/>
-          <p:cNvSpPr txBox="1"/>
-          <p:nvPr/>
-        </p:nvSpPr>
-        <p:spPr>
-          <a:xfrm>
-            <a:off x="640080" y="5989320"/>
-            <a:ext cx="10881360" cy="365760"/>
-          </a:xfrm>
-          <a:prstGeom prst="rect">
-            <a:avLst/>
-          </a:prstGeom>
-          <a:noFill/>
-        </p:spPr>
-        <p:txBody>
-          <a:bodyPr wrap="square" anchor="t" lIns="45720" rIns="45720">
-            <a:spAutoFit/>
-          </a:bodyPr>
-          <a:lstStyle/>
-          <a:p>
-            <a:pPr algn="l">
-              <a:spcAft>
-                <a:spcPts val="600"/>
-              </a:spcAft>
-            </a:pPr>
-            <a:r>
-              <a:rPr sz="1400" b="0">
-                <a:solidFill>
-                  <a:srgbClr val="222222"/>
-                </a:solidFill>
-                <a:latin typeface="Arial"/>
-              </a:rPr>
-              <a:t>As outras três abordagens não passam de 17% em nenhum modelo (slide 11).</a:t>
             </a:r>
           </a:p>
         </p:txBody>

</xml_diff>

<commit_message>
Follow the paper: 'three most accurate' group and other ranges
Co-Authored-By: Claude Opus 5.5 <noreply@anthropic.com>
Claude-Session: https://claude.ai/code/session_01FjZonbKdsyoySM9nwRFtHf
</commit_message>
<xml_diff>
--- a/apresentacao/apresentacao.pptx
+++ b/apresentacao/apresentacao.pptx
@@ -1843,7 +1843,7 @@
           <a:lstStyle/>
           <a:p>
             <a:r>
-              <a:t>[2:15] Acerto nas 47 perguntas com resposta, das três abordagens com acesso a todas as ações, com o intervalo de Wilson de 95%. A barra azul é Ferramentas sobre o grafo: 83% a 89% em todos os modelos. Consulta escrita pelo modelo: 57% a 70% nos menores e 89% a 94% nos maiores. Contexto longo: 40% a 45% nos menores e 72% a 85% nos maiores. As outras três ficam baixas e estão no slide 12: Busca vetorial 9% a 17%, Estatísticas resumidas 0% a 9% e Sem dados 0%, porque se abstém. Nos maiores, Consulta empata com Ferramentas no Sonnet e fica à frente no Kimi; os intervalos se sobrepõem. Setup: quatro modelos, dois menores (Haiku e Qwen, sem raciocínio estendido, temperatura zero) e dois maiores (Sonnet e Kimi, com raciocínio estendido), agrupados pela faixa de preço por token; 52 perguntas em 6 abordagens, 312 execuções por modelo, 1 repetição por pergunta; diferenças lidas como indícios.</a:t>
+              <a:t>[2:15] Acerto nas 47 perguntas com resposta, das três abordagens que mais acertaram, com o intervalo de Wilson de 95%. A barra azul é Ferramentas sobre o grafo: 83% a 89% em todos os modelos. Consulta escrita pelo modelo: 57% a 70% nos menores e 89% a 94% nos maiores. Contexto longo: 40% a 45% nos menores e 72% a 85% nos maiores. As outras três ficam baixas e estão no slide 12: Busca vetorial 9% a 17%, Estatísticas resumidas 0% a 9% e Sem dados 0%, porque se abstém. Nos maiores, Consulta empata com Ferramentas no Sonnet e fica à frente no Kimi; os intervalos se sobrepõem. Setup: quatro modelos, dois menores (Haiku e Qwen, sem raciocínio estendido, temperatura zero) e dois maiores (Sonnet e Kimi, com raciocínio estendido), agrupados pela faixa de preço por token; 52 perguntas em 6 abordagens, 312 execuções por modelo, 1 repetição por pergunta; diferenças lidas como indícios.</a:t>
             </a:r>
           </a:p>
         </p:txBody>
@@ -1913,7 +1913,7 @@
           <a:lstStyle/>
           <a:p>
             <a:r>
-              <a:t>[1:30] Recorte das 36 perguntas encadeadas (relações na rede de passes, jogadas e antes e depois de uma substituição). Nos modelos menores, Contexto longo e Consulta caem justamente aqui, e Ferramentas se mantêm: a consulta parametrizada e o cálculo no código tiram do modelo o trabalho de juntar eventos espalhados. Nos maiores, com raciocínio estendido, as três se aproximam. Ressalva: tamanho e raciocínio vieram juntos, então não dá para separar o efeito de um do outro. A interpretação é compatível com a literatura de contexto longo (informação no meio do contexto, raciocínio composicional) e com a dificuldade de LLMs em gerar Cypher.</a:t>
+              <a:t>[1:30] Recorte das 36 perguntas encadeadas (relações na rede de passes, jogadas e antes e depois de uma substituição). Nos modelos menores, Contexto longo e Consulta caem justamente aqui, e Ferramentas se mantêm: a consulta parametrizada e o cálculo no código tiram do modelo o trabalho de juntar eventos espalhados. Nos maiores, com raciocínio estendido, as três se aproximam. O Contexto longo superou a Busca vetorial em todos os modelos, mas, diante da consulta ao grafo, só chegou perto nos maiores, com raciocínio estendido e muito mais custo (slide 13). Ressalva: tamanho e raciocínio vieram juntos, então não dá para separar o efeito de um do outro. A interpretação é compatível com a literatura de contexto longo (informação no meio do contexto, raciocínio composicional) e com a dificuldade de LLMs em gerar Cypher.</a:t>
             </a:r>
           </a:p>
         </p:txBody>
@@ -2053,7 +2053,7 @@
           <a:lstStyle/>
           <a:p>
             <a:r>
-              <a:t>[1:15] Mediana por execução das três abordagens com acesso a todas as ações. O Contexto longo leva a tabela inteira em cada pergunta, de 82 a 111 mil tokens de entrada. Nos maiores, produz de 4.430 a 12.158 tokens de saída, quase todos de raciocínio, e leva de 37 a 81 segundos. Cuidado ao comparar: Ferramentas não usa cache de prompt e Consulta usa, então a latência mistura as duas condições; no Contexto longo, a maior parte da entrada veio do cache, o que o favorece. Sem preço em dólar, porque os preços mudam.</a:t>
+              <a:t>[1:15] O custo considera só as três abordagens que mais acertaram; nas outras, que não passaram de 17%, o custo pouco importa. Mediana por execução. O Contexto longo leva a tabela inteira em cada pergunta, de 82 a 111 mil tokens de entrada. Nos maiores, produz de 4.430 a 12.158 tokens de saída, quase todos de raciocínio, e leva de 37 a 81 segundos. Cuidado ao comparar: Ferramentas não usa cache de prompt e Consulta usa, então a latência mistura as duas condições; no Contexto longo, a maior parte da entrada veio do cache, o que o favorece. Sem preço em dólar, porque os preços mudam.</a:t>
             </a:r>
           </a:p>
         </p:txBody>
@@ -6236,7 +6236,7 @@
                 </a:solidFill>
                 <a:latin typeface="Arial"/>
               </a:rPr>
-              <a:t>As outras três abordagens não passam de 17% em nenhum modelo (slide 12).</a:t>
+              <a:t>As outras três acertaram pouco: Busca vetorial 9% a 17%, Estatísticas resumidas 0% a 9%, Sem dados 0% (slide 12).</a:t>
             </a:r>
           </a:p>
         </p:txBody>
@@ -7485,6 +7485,45 @@
           </a:graphicData>
         </a:graphic>
       </p:graphicFrame>
+      <p:sp>
+        <p:nvSpPr>
+          <p:cNvPr id="10" name="TextBox 9"/>
+          <p:cNvSpPr txBox="1"/>
+          <p:nvPr/>
+        </p:nvSpPr>
+        <p:spPr>
+          <a:xfrm>
+            <a:off x="640080" y="5989320"/>
+            <a:ext cx="3840480" cy="365760"/>
+          </a:xfrm>
+          <a:prstGeom prst="rect">
+            <a:avLst/>
+          </a:prstGeom>
+          <a:noFill/>
+        </p:spPr>
+        <p:txBody>
+          <a:bodyPr wrap="square" anchor="t" lIns="45720" rIns="45720">
+            <a:spAutoFit/>
+          </a:bodyPr>
+          <a:lstStyle/>
+          <a:p>
+            <a:pPr algn="l">
+              <a:spcAft>
+                <a:spcPts val="600"/>
+              </a:spcAft>
+            </a:pPr>
+            <a:r>
+              <a:rPr sz="1400" b="0">
+                <a:solidFill>
+                  <a:srgbClr val="666666"/>
+                </a:solidFill>
+                <a:latin typeface="Arial"/>
+              </a:rPr>
+              <a:t>Custo só das três que mais acertaram.</a:t>
+            </a:r>
+          </a:p>
+        </p:txBody>
+      </p:sp>
     </p:spTree>
   </p:cSld>
   <p:clrMapOvr>

</xml_diff>

<commit_message>
Add approved speaking script; use it as notes for slides 8-15
Co-Authored-By: Claude Opus 5.5 <noreply@anthropic.com>
Claude-Session: https://claude.ai/code/session_01FjZonbKdsyoySM9nwRFtHf
</commit_message>
<xml_diff>
--- a/apresentacao/apresentacao.pptx
+++ b/apresentacao/apresentacao.pptx
@@ -1843,7 +1843,31 @@
           <a:lstStyle/>
           <a:p>
             <a:r>
-              <a:t>[2:15] Acerto nas 47 perguntas com resposta, das três abordagens que mais acertaram, com o intervalo de Wilson de 95%. A barra azul é Ferramentas sobre o grafo: 83% a 89% em todos os modelos. Consulta escrita pelo modelo: 57% a 70% nos menores e 89% a 94% nos maiores. Contexto longo: 40% a 45% nos menores e 72% a 85% nos maiores. As outras três ficam baixas e estão no slide 12: Busca vetorial 9% a 17%, Estatísticas resumidas 0% a 9% e Sem dados 0%, porque se abstém. Nos maiores, Consulta empata com Ferramentas no Sonnet e fica à frente no Kimi; os intervalos se sobrepõem. Setup: quatro modelos, dois menores (Haiku e Qwen, sem raciocínio estendido, temperatura zero) e dois maiores (Sonnet e Kimi, com raciocínio estendido), agrupados pela faixa de preço por token; 52 perguntas em 6 abordagens, 312 execuções por modelo, 1 repetição por pergunta; diferenças lidas como indícios.</a:t>
+              <a:t>[1:55] Agora os resultados. A gente testou em quatro modelos, em dois grupos. Os menores são o Claude Haiku 5.5 e o Qwen3.8-flash, e os maiores, o Claude Sonnet 4.6 e o Kimi K3. Em cada grupo tem um modelo proprietário e um de pesos abertos, então o Haiku e o Sonnet, da Anthropic, representando os fechados, e o Qwen e o Kimi, os de pesos abertos. Os maiores rodaram com o raciocínio estendido ligado.</a:t>
+            </a:r>
+          </a:p>
+          <a:p/>
+          <a:p>
+            <a:r>
+              <a:t>O que está em azul é a abordagem com ferramentas, e ela ficou entre 83 e 89% em todos os modelos, então o tamanho do modelo quase não fez diferença nessa abordagem.</a:t>
+            </a:r>
+          </a:p>
+          <a:p/>
+          <a:p>
+            <a:r>
+              <a:t>A consulta escrita pelo modelo fica bem abaixo nos menores e sobe até empatar com as ferramentas nos maiores. O contexto longo faz o mesmo caminho, só que sempre um degrau abaixo. E isso já aparece na literatura, porque trabalhar com um contexto muito longo exige um modelo maior, e escrever código também, seja uma consulta em Cypher, em SQL ou até, sei lá, em Python.</a:t>
+            </a:r>
+          </a:p>
+          <a:p/>
+          <a:p>
+            <a:r>
+              <a:t>As outras três acertaram pouco em todos, e eu já explico por quê.</a:t>
+            </a:r>
+          </a:p>
+          <a:p/>
+          <a:p>
+            <a:r>
+              <a:t>[pausa] Só um cuidado. Esses risquinhos são o intervalo de confiança, e como foi uma repetição só, eles são largos. Então nos modelos maiores a gente não consegue separar a consulta das ferramentas, e por isso a gente lê essas diferenças como indício, e não como prova.</a:t>
             </a:r>
           </a:p>
         </p:txBody>
@@ -1913,7 +1937,31 @@
           <a:lstStyle/>
           <a:p>
             <a:r>
-              <a:t>[1:30] Recorte das 36 perguntas encadeadas (relações na rede de passes, jogadas e antes e depois de uma substituição). Nos modelos menores, Contexto longo e Consulta caem justamente aqui, e Ferramentas se mantêm: a consulta parametrizada e o cálculo no código tiram do modelo o trabalho de juntar eventos espalhados. Nos maiores, com raciocínio estendido, as três se aproximam. O Contexto longo superou a Busca vetorial em todos os modelos, mas, diante da consulta ao grafo, só chegou perto nos maiores, com raciocínio estendido e muito mais custo (slide 13). Ressalva: tamanho e raciocínio vieram juntos, então não dá para separar o efeito de um do outro. A interpretação é compatível com a literatura de contexto longo (informação no meio do contexto, raciocínio composicional) e com a dificuldade de LLMs em gerar Cypher.</a:t>
+              <a:t>[1:25] Esse gráfico não está no artigo, a gente trouxe só pra ilustrar. São só as perguntas encadeadas, em que você precisa ligar um evento ao outro, tipo quem passou pra quem ou o que mudou depois de uma substituição.</a:t>
+            </a:r>
+          </a:p>
+          <a:p/>
+          <a:p>
+            <a:r>
+              <a:t>É aqui que a diferença aparece, tá. Nos modelos menores, o contexto longo e a consulta caem bastante, e a abordagem com ferramentas segura. Nos maiores, as três ficam bem mais próximas.</a:t>
+            </a:r>
+          </a:p>
+          <a:p/>
+          <a:p>
+            <a:r>
+              <a:t>E dá pra entender o porquê olhando o que cada uma exige do modelo. Nas ferramentas, quem faz o trabalho pesado é a implementação dentro da ferramenta, que conta os passes ou percorre a jogada, e o modelo só escolhe a ferramenta certa, com os parâmetros certos.</a:t>
+            </a:r>
+          </a:p>
+          <a:p/>
+          <a:p>
+            <a:r>
+              <a:t>Já na consulta, o modelo menor erra ao escrever o Cypher e precisa de várias tentativas até chegar numa consulta que funciona. E no contexto longo, ele tem que achar e juntar eventos espalhados pela tabela inteira, que é justamente o que um modelo menor faz pior.</a:t>
+            </a:r>
+          </a:p>
+          <a:p/>
+          <a:p>
+            <a:r>
+              <a:t>[pausa] Mas isso tem uma contrapartida, porque a abordagem com ferramentas acaba sendo mais restritiva. O que eu quero dizer com isso é que, no contexto longo, a gente tá dando ao modelo todos os dados que ele precisa pra responder. Na consulta, a gente dá a liberdade pro modelo navegar pelos dados usando a linguagem Cypher. Já nas ferramentas, o modelo só vai recuperar, e consequentemente só vai responder, aquilo que as ferramentas permitem que ele recupere.</a:t>
             </a:r>
           </a:p>
         </p:txBody>
@@ -1983,7 +2031,31 @@
           <a:lstStyle/>
           <a:p>
             <a:r>
-              <a:t>[1:00] Busca vetorial (9% a 17%): traz as 30 linhas mais parecidas com a pergunta, de 2.585. Parecer com a pergunta não é servir para respondê-la; contar exige todas as linhas de um tipo e ligar eventos exige as linhas vizinhas. Erra por abstenção e por resposta errada, conforme o modelo. Estatísticas resumidas (0% a 9%): a súmula tem só totais da partida inteira, sem recorte de tempo ou de campo e sem quem passou para quem; como o prompt pede para indicar ausência de dados, os modelos se abstêm. Sem dados: 0 de 47 com resposta, por obediência ao prompt, que proíbe responder de memória; o 0% mede obediência, não ignorância. Nas perguntas de controle, Sem dados acerta as 5.</a:t>
+              <a:t>[1:15] Voltando nas três que foram mal.</a:t>
+            </a:r>
+          </a:p>
+          <a:p/>
+          <a:p>
+            <a:r>
+              <a:t>A busca vetorial traz as 30 linhas mais parecidas com a pergunta, mas parecer não é o mesmo que ser útil pra responder. Pra contar ou ligar eventos, você vai acabar precisando de mais do que isso. Numa pergunta sobre a Argentina sem o Enzo Fernández, por exemplo, ela trouxe justamente as ações do Enzo.</a:t>
+            </a:r>
+          </a:p>
+          <a:p/>
+          <a:p>
+            <a:r>
+              <a:t>E muitas vezes essas linhas pareciam suficientes, então o modelo respondia errado em vez de dizer que não tinha os dados. E dizer que não tem os dados, ou seja, a abstenção, já conta como um erro, né, porque a gente está avaliando num conjunto em que sabe que toda pergunta tem resposta. Mas responder errado com cara de certo pode ser pior.</a:t>
+            </a:r>
+          </a:p>
+          <a:p/>
+          <a:p>
+            <a:r>
+              <a:t>A abordagem com estatísticas só tem o total do jogo, sem tempo, sem lugar do campo e sem quem passou pra quem, então o modelo dizia que não tinha os dados. É um resultado esperado.</a:t>
+            </a:r>
+          </a:p>
+          <a:p/>
+          <a:p>
+            <a:r>
+              <a:t>E o sem dados zerou porque o prompt proíbe responder de memória. Ou seja, os LLMs que a gente avaliou obedeceram a instrução, o que já é comum nos modelos atuais.</a:t>
             </a:r>
           </a:p>
         </p:txBody>
@@ -2053,7 +2125,13 @@
           <a:lstStyle/>
           <a:p>
             <a:r>
-              <a:t>[1:15] O custo considera só as três abordagens que mais acertaram; nas outras, que não passaram de 17%, o custo pouco importa. Mediana por execução. O Contexto longo leva a tabela inteira em cada pergunta, de 82 a 111 mil tokens de entrada. Nos maiores, produz de 4.430 a 12.158 tokens de saída, quase todos de raciocínio, e leva de 37 a 81 segundos. Cuidado ao comparar: Ferramentas não usa cache de prompt e Consulta usa, então a latência mistura as duas condições; no Contexto longo, a maior parte da entrada veio do cache, o que o favorece. Sem preço em dólar, porque os preços mudam.</a:t>
+              <a:t>[1:00] No custo, vamos olhar aqui só as abordagens que mais acertaram. O que pesa é o contexto longo nos modelos maiores, que gera milhares de tokens de raciocínio. No Kimi, ele levou 81 segundos por pergunta, e esse valor é a mediana, contra 15 da abordagem com ferramentas. Então ele chega perto no acerto, mas paga bem mais caro em tempo e em tokens.</a:t>
+            </a:r>
+          </a:p>
+          <a:p/>
+          <a:p>
+            <a:r>
+              <a:t>Mas cada uma tem vantagens e desvantagens. O contexto longo acaba sendo mais barato em termos de implementação, porque não precisa de banco de grafos nem de um agente chamando ferramenta, mas ele tem o custo do modelo.</a:t>
             </a:r>
           </a:p>
         </p:txBody>
@@ -2123,7 +2201,19 @@
           <a:lstStyle/>
           <a:p>
             <a:r>
-              <a:t>[1:15] Conclusão: Ferramentas sobre o grafo foi a única abordagem que manteve o acerto alto nos 4 modelos, 83% a 89%. Consulta e Contexto longo dependem do modelo; nos maiores, com raciocínio estendido, a Consulta chegou ao mesmo nível e o Contexto longo se aproximou, este com mais tokens de saída e tempo. Busca vetorial e Estatísticas resumidas ficaram baixas em todos. Limitações, ditas pelo próprio artigo: uma partida e 1 repetição por pergunta, com 47 perguntas com resposta, então os intervalos são largos; tamanho e raciocínio estendido vieram juntos nos maiores; as ferramentas e as perguntas foram escritas pelos mesmos autores e as ferramentas foram ajustadas olhando erros, então o acerto vale dentro da cobertura delas; o estudo não separa o efeito do grafo do efeito das ferramentas: uma hipótese não testada é que um banco relacional com as mesmas ferramentas iria bem em busca e contagem e a diferença apareceria nas perguntas de relações; e as abordagens com agente supõem chamada de ferramenta confiável.</a:t>
+              <a:t>[1:20] Pra concluir, a abordagem com ferramentas sobre o grafo foi a única com acerto alto em todos os modelos, entre 83 e 89%. A consulta e o contexto longo dependem da capacidade do modelo, e o contexto longo ainda custa mais.</a:t>
+            </a:r>
+          </a:p>
+          <a:p/>
+          <a:p>
+            <a:r>
+              <a:t>E as limitações. É uma partida só, com uma repetição, então os intervalos são largos. Nos modelos maiores, tamanho e raciocínio vieram juntos. As ferramentas e as perguntas foram feitas por nós, então o resultado vale pro que as ferramentas cobrem.</a:t>
+            </a:r>
+          </a:p>
+          <a:p/>
+          <a:p>
+            <a:r>
+              <a:t>E a gente não separou o efeito do grafo do efeito de agentes com ferramentas. A nossa hipótese é que, num banco relacional com as mesmas ferramentas, as perguntas de contagem iriam bem, e a diferença ia aparecer nas perguntas de relação entre jogadores, que são mais complicadas de modelar num banco relacional. Seguir uma cadeia de passes ali exigiria um JOIN pra cada passe, então provavelmente não é a ferramenta ideal pra isso.</a:t>
             </a:r>
           </a:p>
         </p:txBody>
@@ -2193,7 +2283,19 @@
           <a:lstStyle/>
           <a:p>
             <a:r>
-              <a:t>[1:15] Fecho. Três frentes, todas ligadas às limitações. Primeira, mais evidência: repetir as execuções mede a variação entre rodadas e permite testar as diferenças entre abordagens, e estender as perguntas a várias partidas tira a dependência de uma só. Segunda, separar efeitos: avaliar modelos maiores sem raciocínio estendido separa o efeito do tamanho do efeito do raciocínio; aplicar as mesmas ferramentas a um banco relacional (SQL), sem o grafo, separa o efeito das ferramentas do efeito do grafo; e testar uma busca vetorial em que cada trecho traga também os eventos vizinhos, como em Tzikas et al., responde à lacuna da Busca vetorial. Terceira, outros domínios, entre eles os dados industriais: parte deles tem a forma dos dados de futebol, registros de eventos com agente, momento e local, ligados entre si, como as paradas, os alertas e as movimentações de uma linha de produção ou de uma frota. Testar as mesmas abordagens ali é um próximo passo natural para uma pós em IA aplicada à indústria, mas exige implementação própria: a preparação dos dados, o grafo e as ferramentas dependem das perguntas que se quer responder. Em seguida, abrir para as perguntas; as respostas prováveis estão em apresentacao/perguntas-banca.md.</a:t>
+              <a:t>[1:25] Como próximos passos, a gente quer ter mais evidência, com mais repetições e mais partidas. Quer separar os efeitos, testando modelos grandes sem raciocínio e as mesmas ferramentas num banco SQL, sem grafo. E quer levar isso pra outros domínios, como processos industriais. Numa linha de produção, por exemplo, cada parada de máquina, cada alerta e cada movimentação de peça é um evento, com quem fez, quando e onde, e muitas vezes um evento puxa o outro, do mesmo jeito que, sei lá, um passe puxa uma finalização. Dá pra testar as mesmas abordagens nesses dados, montando a tabela, o grafo e as ferramentas pras perguntas daquele contexto.</a:t>
+            </a:r>
+          </a:p>
+          <a:p/>
+          <a:p>
+            <a:r>
+              <a:t>[pausa] Então, resumindo, não existe uma abordagem que seja a melhor pra tudo. A escolha depende do orçamento, da latência e do acerto que se precisa. Com modelo pequeno, a abordagem com ferramentas segura o acerto. Com modelo grande, a consulta escrita pelo modelo chega no mesmo nível e é mais flexível. E o contexto longo funciona, é mais fácil de implementar e de manter, mas custa caro.</a:t>
+            </a:r>
+          </a:p>
+          <a:p/>
+          <a:p>
+            <a:r>
+              <a:t>[pausa] Era isso. O código está nesse repositório. Muito obrigado, e a gente fica aberto pras perguntas.</a:t>
             </a:r>
           </a:p>
         </p:txBody>
@@ -2683,7 +2785,49 @@
           <a:lstStyle/>
           <a:p>
             <a:r>
-              <a:t>[1:30] Sem dados: só a pergunta, linha de base. Contexto longo: a tabela inteira de 2.585 ações no prompt. Estatísticas resumidas: a súmula, com totais por jogador e por time. Busca vetorial: as 30 linhas mais parecidas com a pergunta, como em geração aumentada por recuperação. Consulta escrita pelo modelo: o modelo recebe o esquema do grafo e escreve a consulta Cypher. Ferramentas sobre o grafo: 8 ferramentas com consulta Cypher parametrizada; o modelo só escolhe qual chamar e com quais argumentos. As duas últimas consultam o mesmo grafo e têm o mesmo limite de 12 chamadas por pergunta: muda quem escreve a consulta. Duas diferenças a declarar: a Consulta não tem a biblioteca de algoritmos de grafos nem os nós de padrões prontos, e as ferramentas foram ajustadas olhando erros, enquanto a Consulta é o primeiro contato. Todas usam o mesmo prompt de sistema e a mesma saída estruturada.</a:t>
+              <a:t>[1:30] Valeu, Daniel. Boa noite, pessoal, eu vou continuar a partir daqui.</a:t>
+            </a:r>
+          </a:p>
+          <a:p/>
+          <a:p>
+            <a:r>
+              <a:t>Então, com os dados e as perguntas prontas, a gente comparou seis jeitos de entregar esses dados pro modelo. Ou seja, a gente está usando aprendizado em contexto, alimentando o modelo com os dados na hora da pergunta, sem treinar ele de novo.</a:t>
+            </a:r>
+          </a:p>
+          <a:p/>
+          <a:p>
+            <a:r>
+              <a:t>A primeira é sem dados, então só a pergunta vai pro modelo. É a nossa linha de base.</a:t>
+            </a:r>
+          </a:p>
+          <a:p/>
+          <a:p>
+            <a:r>
+              <a:t>A segunda é o contexto longo, em que a tabela inteira de ações vai direto no prompt.</a:t>
+            </a:r>
+          </a:p>
+          <a:p/>
+          <a:p>
+            <a:r>
+              <a:t>A terceira são as estatísticas resumidas, em que vai só a súmula, com os totais por jogador e por time.</a:t>
+            </a:r>
+          </a:p>
+          <a:p/>
+          <a:p>
+            <a:r>
+              <a:t>A quarta é a busca vetorial, o RAG tradicional. As linhas da tabela e a pergunta viram embeddings, que são vetores que representam o texto, e uma busca por similaridade manda pro prompt só as linhas mais parecidas com a pergunta.</a:t>
+            </a:r>
+          </a:p>
+          <a:p/>
+          <a:p>
+            <a:r>
+              <a:t>E as duas em azul são agentes que consultam o grafo. Isso quer dizer que o modelo não responde de uma vez. Ele chama uma ferramenta, vê o resultado e decide se chama de novo ou se já responde. Na consulta escrita pelo modelo, ele escreve a consulta sozinho, em Cypher. Nas ferramentas sobre o grafo, ele só escolhe uma ferramenta pronta e passa os argumentos.</a:t>
+            </a:r>
+          </a:p>
+          <a:p/>
+          <a:p>
+            <a:r>
+              <a:t>Em cada modelo, as seis abordagens usam o mesmo prompt e o mesmo formato de resposta, então a única coisa que muda é a forma como os dados chegam até a janela de contexto do LLM.</a:t>
             </a:r>
           </a:p>
         </p:txBody>
@@ -2753,7 +2897,25 @@
           <a:lstStyle/>
           <a:p>
             <a:r>
-              <a:t>[1:15] Registro real de uma execução em cada abordagem com agente, pergunta a01, Claude Haiku 5.5. Na Consulta escrita pelo modelo, ele chama run_cypher com a consulta Cypher que escreveu, inclusive os filtros de time, ação, sucesso e terço do campo; a ferramenta executa a consulta no grafo e devolve o resultado. Nas Ferramentas sobre o grafo, o modelo escolhe query_actions e preenche os argumentos; a consulta parametrizada está no código e a ferramenta a executa com esses filtros. As duas consultam o mesmo grafo, com o mesmo limite de 12 chamadas por pergunta; muda quem escreve a consulta. Nesta pergunta, uma chamada bastou nas duas. As 8 ferramentas: listar jogadores, contar ações, listar ações, contar posses, rede de passes, métrica da rede, ligações da rede e sequências de passes. Diferenças a declarar: a Consulta não tem a biblioteca de algoritmos de grafos nem os nós de padrões prontos, e as ferramentas foram ajustadas olhando erros, enquanto a Consulta é o primeiro contato. A consulta, os argumentos e a resposta vêm do registro de execuções do Haiku (data/benchmark/claude-haiku-5.5_results.jsonl no repositório novo); os valores devolvidos pela ferramenta (24 e 18) estão só no trace e foram copiados da figura do artigo.</a:t>
+              <a:t>[1:00] Aqui tem um exemplo real desses dois agentes. A pergunta é quem deu mais passes certos no terço final pela Argentina.</a:t>
+            </a:r>
+          </a:p>
+          <a:p/>
+          <a:p>
+            <a:r>
+              <a:t>Nos dois casos o modelo chama uma ferramenta, mas o que ele passa pra ela é bem diferente. Na esquerda, o parâmetro da ferramenta é a própria consulta em Cypher, escrita pelo modelo, com todos os filtros dentro, time, passe certo e terço de ataque. Na direita, o modelo não escreve consulta nenhuma. Ele passa só os argumentos, como o time, o tipo de ação e o terço do campo, e esses argumentos preenchem uma consulta parametrizada que já está implementada dentro da ferramenta. No fim, os dois chegaram no Messi.</a:t>
+            </a:r>
+          </a:p>
+          <a:p/>
+          <a:p>
+            <a:r>
+              <a:t>Essa ferramenta da direita, que conta ações, é uma das 8 ferramentas, e as outras seguem a mesma ideia, contando ou listando ações e trabalhando com a rede de passes.</a:t>
+            </a:r>
+          </a:p>
+          <a:p/>
+          <a:p>
+            <a:r>
+              <a:t>[pausa] Então os dois agentes usam o mesmo grafo, e o que muda é quem escreve a consulta, se é o próprio modelo ou a implementação dentro da ferramenta.</a:t>
             </a:r>
           </a:p>
         </p:txBody>

</xml_diff>

<commit_message>
Script and speaker notes for slides 1-7
Co-Authored-By: Claude Opus 5.5 <noreply@anthropic.com>
Claude-Session: https://claude.ai/code/session_01FjZonbKdsyoySM9nwRFtHf
</commit_message>
<xml_diff>
--- a/apresentacao/apresentacao.pptx
+++ b/apresentacao/apresentacao.pptx
@@ -1773,7 +1773,7 @@
           <a:lstStyle/>
           <a:p>
             <a:r>
-              <a:t>[0:15] Apresentação dos autores e do título. Em uma frase: o trabalho compara seis maneiras de dar a um modelo de linguagem acesso aos dados de uma partida e mede qual delas acerta mais.</a:t>
+              <a:t>[0:20] Boa noite a todos. Eu sou o Daniel, e esse é o João Victor. A gente vai apresentar o nosso trabalho, que compara seis formas de entregar os dados de uma partida de futebol pra um modelo de linguagem responder perguntas sobre ela.</a:t>
             </a:r>
           </a:p>
         </p:txBody>
@@ -2365,7 +2365,19 @@
           <a:lstStyle/>
           <a:p>
             <a:r>
-              <a:t>[1:00] Contexto de futebol: a final da Copa de 2022, Argentina contra França, decidida nos pênaltis. Os dados de eventos registram cada ação, com jogador, momento e posição no campo. As três perguntas do slide são do conjunto do trabalho e nenhuma tem a resposta em um único evento: é preciso juntar vários. O modelo precisa receber os dados da partida, e há mais de uma forma de fazer isso. Perguntas de pesquisa: qual abordagem acerta mais, como o acerto muda de um modelo para outro e quanto cada uma custa em tokens e tempo. O aprendizado em contexto é usado em sentido amplo: o modelo não é treinado de novo e o que entra no contexto são os dados. Contribuições: a transformação dos eventos em uma tabela de ações e em um grafo, o conjunto de perguntas com gabarito e a comparação sob as mesmas perguntas, o mesmo prompt e a mesma saída. Trabalhos relacionados: no esporte, SoccerRAG, SPORTSQL e Tzikas et al. avaliam cada um uma única forma de recuperação; fora do esporte, Li et al. e LOFT comparam formas de recuperação sem dados de futebol. Não foram encontrados trabalhos que comparem formas de recuperação em perguntas encadeadas sobre eventos de futebol, com conferência por código contra um gabarito por código.</a:t>
+              <a:t>[1:30] Hoje, um modelo de linguagem consegue responder perguntas em linguagem natural, mas pra falar de uma partida específica ele precisa receber os dados dela. E pergunta de análise de futebol quase nunca tem a resposta num lance só. Por exemplo, qual dupla da França mais trocou passes, ou, depois que o Dembélé saiu, quem mais passou a bola pro Mbappé. Pra responder isso, você precisa ligar vários eventos entre si.</a:t>
+            </a:r>
+          </a:p>
+          <a:p/>
+          <a:p>
+            <a:r>
+              <a:t>[pausa] Então a nossa pergunta foi qual é a melhor forma de levar esses dados até o modelo. A gente quis saber qual abordagem acerta mais, se isso muda de um modelo pra outro e quanto cada uma custa em tokens e em tempo.</a:t>
+            </a:r>
+          </a:p>
+          <a:p/>
+          <a:p>
+            <a:r>
+              <a:t>E o trabalho entrega três coisas. Uma transformação dos eventos da partida numa tabela de ações e num grafo, um conjunto de 52 perguntas com gabarito, e a comparação de seis abordagens em quatro modelos, todas com as mesmas perguntas, o mesmo prompt e o mesmo formato de resposta.</a:t>
             </a:r>
           </a:p>
         </p:txBody>
@@ -2435,7 +2447,19 @@
           <a:lstStyle/>
           <a:p>
             <a:r>
-              <a:t>[1:00] Tabela de posicionamento do artigo. No esporte, os primeiros conjuntos (SportQA) medem o que o modelo sabe, sem dados de uma partida, com múltipla escolha. SoccerAgent usa um agente com ferramentas sobre uma base de conhecimento. SoccerRAG e SPORTSQL escrevem SQL, sobre anotações de partidas e sobre estatísticas de jogadores; Tzikas et al. usam recuperação vetorial sobre eventos, com um LLM como juiz. Cada um avalia uma única forma de recuperação. Fora do esporte, Li et al. e LOFT comparam recuperação e contexto longo, mas sem dados esportivos. A última linha não está na tabela do artigo: resume a lacuna que o artigo aponta no fim da seção, a de que não foram encontrados trabalhos que comparem formas de recuperação em perguntas encadeadas sobre eventos de futebol, com conferência por código contra um gabarito calculado por código.</a:t>
+              <a:t>[1:10] Antes de entrar nos dados, rapidinho sobre os trabalhos relacionados. Essa tabela resume o que a gente encontrou. No esporte, tem conjuntos que só testam o que o modelo já sabe, com múltipla escolha, como o SportQA. E tem sistemas que ligam o modelo a dados de partidas, como o SoccerRAG e o SPORTSQL, que escrevem SQL, e o trabalho do Tzikas, que usa busca vetorial sobre eventos. Só que cada um testa uma forma de recuperação por vez.</a:t>
+            </a:r>
+          </a:p>
+          <a:p/>
+          <a:p>
+            <a:r>
+              <a:t>Fora do esporte, trabalhos como o LOFT e o do Li comparam contexto longo com recuperação, mas sem dados de futebol.</a:t>
+            </a:r>
+          </a:p>
+          <a:p/>
+          <a:p>
+            <a:r>
+              <a:t>[pausa] Então a lacuna que a gente viu é essa última linha. Comparar várias formas de recuperação, com as mesmas perguntas, em eventos de futebol, e com a correção feita por código, sem um LLM dando nota.</a:t>
             </a:r>
           </a:p>
         </p:txBody>
@@ -2505,7 +2529,19 @@
           <a:lstStyle/>
           <a:p>
             <a:r>
-              <a:t>[1:30] Os dados são os eventos abertos da StatsBomb: dois arquivos, a lista de eventos da partida, em ordem, e as escalações, com nome completo e apelido de cada jogador. São 4.407 eventos no JSON bruto. O exemplo é o gol de Di María e o passe de Mac Allister que o precede, resumidos aos campos principais (valores de docs/02 e da Figura 1 do artigo, não recalculados nesta sessão). Três coisas que importam depois: cada tipo de evento tem campos próprios, então o JSON é rico e irregular; a mesma informação pode estar em lugares diferentes, como o cartão amarelo, que vem dentro da falta ou, sem falta, em um evento de comportamento; e o nome é o de registro, não o apelido, e o minuto é decorrido, então o gol aos 35 aparece como 36 na transmissão.</a:t>
+              <a:t>[1:20] Os dados são da StatsBomb, que publica de graça os eventos de várias partidas. A gente usou a final da Copa de 2022, Argentina e França. São dois arquivos, a lista de eventos em ordem e as escalações.</a:t>
+            </a:r>
+          </a:p>
+          <a:p/>
+          <a:p>
+            <a:r>
+              <a:t>O JSON bruto tem mais de 4.400 eventos, e cada evento tem o tipo, o tempo, o time, o jogador e a posição no campo. Esse exemplo aqui é o passe do Mac Allister e o gol do Di María, logo em seguida.</a:t>
+            </a:r>
+          </a:p>
+          <a:p/>
+          <a:p>
+            <a:r>
+              <a:t>E esse formato tem algumas armadilhas. Cada tipo de evento tem campos próprios, então o passe traz o recebedor e o chute traz o resultado. A mesma informação pode estar em lugares diferentes, como o cartão amarelo, que às vezes vem dentro da falta e às vezes num evento separado. E o nome é o de registro, não o apelido, e o minuto conta o tempo decorrido. Então esse gol, que aparece no minuto 35 do JSON, na transmissão foi aos 36.</a:t>
             </a:r>
           </a:p>
         </p:txBody>
@@ -2575,7 +2611,19 @@
           <a:lstStyle/>
           <a:p>
             <a:r>
-              <a:t>[1:30] Os eventos da partida, sem a disputa de pênaltis, foram convertidos com a biblioteca socceraction para o formato SPADL, que guarda só as ações com bola, em um vocabulário fechado e com os mesmos campos em todas. Os 4.407 eventos viram 2.585 ações. Sobre essa tabela foram acrescentadas colunas de contexto: direção de ataque, zona em uma grade de 96 zonas, fase de posse (537 fases na final), recebedor do passe, placar e minuto. A figura mostra a grade de 12 por 8 zonas e o passe de Mac Allister para Di María, da zona 74 para a 92, como na Figura 1 do artigo (zonas copiadas dela, não recalculadas). É essa tabela que o Contexto longo entrega ao modelo. O SPADL perde o desfecho da finalização e o cartão sem falta, que foram recuperados do JSON. Nenhuma etapa usa modelo de linguagem.</a:t>
+              <a:t>[1:30] Por isso, o primeiro passo foi transformar esses eventos numa tabela. A gente usou a biblioteca socceraction, que converte os eventos pro formato SPADL. Esse formato guarda só as ações com bola, num vocabulário fechado, e todas com os mesmos campos. Os eventos viraram 2.585 ações.</a:t>
+            </a:r>
+          </a:p>
+          <a:p/>
+          <a:p>
+            <a:r>
+              <a:t>Em cima disso, a gente acrescentou colunas de contexto. Todas as ações passam a atacar da esquerda pra direita, pros dois times. Cada ação ganha a zona do campo onde começou e onde terminou. O passe ganha o recebedor, que é o jogador do mesmo time que age em seguida. As ações são agrupadas em fases de posse, que é como a gente identifica as jogadas. E cada linha tem o placar e o minuto da transmissão. Além disso, a gente recuperou do JSON o que o SPADL perde, como o desfecho do chute e o cartão sem falta.</a:t>
+            </a:r>
+          </a:p>
+          <a:p/>
+          <a:p>
+            <a:r>
+              <a:t>[pausa] Esse campo do lado mostra a grade de zonas, e o passe do Mac Allister pro Di María sai de uma zona e termina na outra, já perto do gol. E é essa tabela, inteira, que a abordagem de contexto longo entrega pro modelo.</a:t>
             </a:r>
           </a:p>
         </p:txBody>
@@ -2645,7 +2693,19 @@
           <a:lstStyle/>
           <a:p>
             <a:r>
-              <a:t>[1:15] A tabela de ações foi carregada em um grafo Neo4j. Cada ação vira uma aresta do jogador para a partida, com as colunas da linha como propriedades; cada passe certo com recebedor vira uma aresta entre dois jogadores. O grafo tem 34 jogadores, 537 fases de posse e 96 zonas. As arestas não acrescentam informação à tabela, só a reorganizam em ligações; já a súmula, com totais por jogador e por time, é calculada: o próprio banco conta os totais a partir das arestas, separando tentativas e acertos. A abordagem Estatísticas resumidas lê só a súmula; Consulta e Ferramentas leem o grafo. Por que grafo: a análise de futebol trata os passes de um time como uma rede, com os jogadores como nós e os passes como arestas (Buldú et al.; Duch et al.). Perguntas sobre essa rede, como qual dupla mais trocou passes ou por qual jogador mais passa a circulação da bola, viram caminhos e métricas sobre o grafo. Uma tabela relacional também guarda a informação, mas, conforme a organização, seguir uma cadeia de passes pode exigir uma junção a cada passe, e métricas como a intermediação dependeriam de implementação própria. Nenhuma etapa usa modelo de linguagem.</a:t>
+              <a:t>[1:20] Depois, essa tabela foi carregada num grafo, no Neo4j. Cada ação vira uma ligação do jogador pra partida, com as colunas da tabela, e cada passe certo com recebedor vira uma ligação de um jogador pro outro. Os outros nós são os times, as fases de posse e as zonas do campo.</a:t>
+            </a:r>
+          </a:p>
+          <a:p/>
+          <a:p>
+            <a:r>
+              <a:t>Essas ligações não acrescentam informação, elas só reorganizam a tabela. A única coisa calculada é a súmula, que o próprio banco conta, com os totais de cada jogador e de cada time, separando o que foi tentado e o que deu certo.</a:t>
+            </a:r>
+          </a:p>
+          <a:p/>
+          <a:p>
+            <a:r>
+              <a:t>[pausa] E por que um grafo? Porque a análise de futebol já trata os passes de um time como uma rede, com os jogadores ligados pelos passes. Então perguntas como qual dupla mais trocou passes, ou por qual jogador a bola mais circula, viram caminhos e métricas nesse grafo.</a:t>
             </a:r>
           </a:p>
         </p:txBody>
@@ -2715,7 +2775,25 @@
           <a:lstStyle/>
           <a:p>
             <a:r>
-              <a:t>[1:15] Das 52 perguntas, 47 têm resposta nos dados e 5 são de controle: a resposta certa é a ausência de dados, como a distância percorrida por um jogador. As perguntas de busca e contagem são diretas: a resposta sai de um evento ou de uma soma. Os outros três grupos são encadeados: dependem de ligar eventos entre si. As perguntas foram escritas manualmente e o gabarito de cada uma foi calculado por código, a partir do JSON bruto e da tabela de ações. A conferência com o gabarito é determinística: a mesma resposta recebe sempre o mesmo veredito.</a:t>
+              <a:t>[1:20] Com os dados prontos, a gente escreveu as perguntas. São 52, divididas em cinco grupos. Busca e contagem são as mais diretas, como quem recebeu o primeiro cartão amarelo. Relações na rede de passes, jogadas e sequências, e antes e depois de uma substituição são as encadeadas, em que você precisa ligar um evento ao outro.</a:t>
+            </a:r>
+          </a:p>
+          <a:p/>
+          <a:p>
+            <a:r>
+              <a:t>E tem o grupo de controle, com perguntas que não têm resposta nesses dados, como a distância que o De Paul percorreu. Aí a resposta certa é o modelo dizer que não tem a informação.</a:t>
+            </a:r>
+          </a:p>
+          <a:p/>
+          <a:p>
+            <a:r>
+              <a:t>[pausa] O gabarito de cada pergunta foi calculado por código, a partir do JSON e da tabela de ações, e as perguntas que davam margem pra mais de uma leitura saíram do conjunto. A correção também é por código, então a mesma resposta sempre recebe a mesma nota.</a:t>
+            </a:r>
+          </a:p>
+          <a:p/>
+          <a:p>
+            <a:r>
+              <a:t>Agora o João Victor vai mostrar as seis abordagens que a gente comparou e os resultados.</a:t>
             </a:r>
           </a:p>
         </p:txBody>

</xml_diff>